<commit_message>
Keep desktop tabs aligned and refresh illustrated manual
Clear the theme's selected-tab padding override and use a consistent flat
border with a lavender selection highlight. Refresh the two course-dialog
captures, matching PowerPoint pages, usage instructions, and validation notes.
</commit_message>
<xml_diff>
--- a/docs/manual/AssignmentHub_사용자_매뉴얼.pptx
+++ b/docs/manual/AssignmentHub_사용자_매뉴얼.pptx
@@ -2,39 +2,39 @@
 <file path=ppt/presentation.xml><?xml version="1.0" encoding="utf-8"?>
 <p:presentation xmlns:p="http://schemas.openxmlformats.org/presentationml/2006/main">
   <p:sldMasterIdLst>
-    <p:sldMasterId xmlns:r="http://schemas.openxmlformats.org/officeDocument/2006/relationships" id="2147483648" r:id="R58e489e7d94e4519"/>
+    <p:sldMasterId xmlns:r="http://schemas.openxmlformats.org/officeDocument/2006/relationships" id="2147483648" r:id="Rb90b8857c575471d"/>
   </p:sldMasterIdLst>
   <p:notesMasterIdLst>
-    <p:notesMasterId xmlns:r="http://schemas.openxmlformats.org/officeDocument/2006/relationships" r:id="R7cea361655cd40a8"/>
+    <p:notesMasterId xmlns:r="http://schemas.openxmlformats.org/officeDocument/2006/relationships" r:id="R2f3d9e2de7f44cf2"/>
   </p:notesMasterIdLst>
   <p:sldIdLst>
-    <p:sldId xmlns:r="http://schemas.openxmlformats.org/officeDocument/2006/relationships" id="256" r:id="R4dfc84463e754737"/>
-    <p:sldId xmlns:r="http://schemas.openxmlformats.org/officeDocument/2006/relationships" id="257" r:id="R054a7111e0da43bc"/>
-    <p:sldId xmlns:r="http://schemas.openxmlformats.org/officeDocument/2006/relationships" id="258" r:id="R3490888ff3304206"/>
-    <p:sldId xmlns:r="http://schemas.openxmlformats.org/officeDocument/2006/relationships" id="259" r:id="Rc353d10cc1bf4d6e"/>
-    <p:sldId xmlns:r="http://schemas.openxmlformats.org/officeDocument/2006/relationships" id="260" r:id="Re374f80fd4a6429b"/>
-    <p:sldId xmlns:r="http://schemas.openxmlformats.org/officeDocument/2006/relationships" id="261" r:id="R6dd0a187fc274762"/>
-    <p:sldId xmlns:r="http://schemas.openxmlformats.org/officeDocument/2006/relationships" id="262" r:id="R0fe2c7c4f192426f"/>
-    <p:sldId xmlns:r="http://schemas.openxmlformats.org/officeDocument/2006/relationships" id="263" r:id="R4beb0abff4424b24"/>
-    <p:sldId xmlns:r="http://schemas.openxmlformats.org/officeDocument/2006/relationships" id="264" r:id="Rc562cf7ec39549e6"/>
-    <p:sldId xmlns:r="http://schemas.openxmlformats.org/officeDocument/2006/relationships" id="265" r:id="Rca23cd738a794b5b"/>
-    <p:sldId xmlns:r="http://schemas.openxmlformats.org/officeDocument/2006/relationships" id="266" r:id="Ra2a3db2962ec4d60"/>
-    <p:sldId xmlns:r="http://schemas.openxmlformats.org/officeDocument/2006/relationships" id="267" r:id="Rfee13941c9a14596"/>
-    <p:sldId xmlns:r="http://schemas.openxmlformats.org/officeDocument/2006/relationships" id="268" r:id="R009ca9a6546b4d15"/>
-    <p:sldId xmlns:r="http://schemas.openxmlformats.org/officeDocument/2006/relationships" id="269" r:id="Ra0342602a1914845"/>
-    <p:sldId xmlns:r="http://schemas.openxmlformats.org/officeDocument/2006/relationships" id="270" r:id="Rdec65a782df244f4"/>
-    <p:sldId xmlns:r="http://schemas.openxmlformats.org/officeDocument/2006/relationships" id="271" r:id="Ra88680797ddf4ad7"/>
-    <p:sldId xmlns:r="http://schemas.openxmlformats.org/officeDocument/2006/relationships" id="272" r:id="R4884acbfa8e64347"/>
-    <p:sldId xmlns:r="http://schemas.openxmlformats.org/officeDocument/2006/relationships" id="273" r:id="Rf4c6bc24a1b347b3"/>
-    <p:sldId xmlns:r="http://schemas.openxmlformats.org/officeDocument/2006/relationships" id="274" r:id="Re273ef8896054fae"/>
-    <p:sldId xmlns:r="http://schemas.openxmlformats.org/officeDocument/2006/relationships" id="275" r:id="R0a96d257ad744c05"/>
-    <p:sldId xmlns:r="http://schemas.openxmlformats.org/officeDocument/2006/relationships" id="276" r:id="Rf37e046f0cd14fac"/>
-    <p:sldId xmlns:r="http://schemas.openxmlformats.org/officeDocument/2006/relationships" id="277" r:id="R46edc721118640bb"/>
-    <p:sldId xmlns:r="http://schemas.openxmlformats.org/officeDocument/2006/relationships" id="278" r:id="Rb1da8d7d3b304881"/>
-    <p:sldId xmlns:r="http://schemas.openxmlformats.org/officeDocument/2006/relationships" id="279" r:id="R07b8f200ad704dbf"/>
-    <p:sldId xmlns:r="http://schemas.openxmlformats.org/officeDocument/2006/relationships" id="280" r:id="R5b123e17e5a94b9b"/>
-    <p:sldId xmlns:r="http://schemas.openxmlformats.org/officeDocument/2006/relationships" id="281" r:id="R275b00b3f28d440c"/>
-    <p:sldId xmlns:r="http://schemas.openxmlformats.org/officeDocument/2006/relationships" id="282" r:id="R08f06b9db51840aa"/>
+    <p:sldId xmlns:r="http://schemas.openxmlformats.org/officeDocument/2006/relationships" id="256" r:id="Rdafcaed8643c4791"/>
+    <p:sldId xmlns:r="http://schemas.openxmlformats.org/officeDocument/2006/relationships" id="257" r:id="Rbebdc1d9dbdf4587"/>
+    <p:sldId xmlns:r="http://schemas.openxmlformats.org/officeDocument/2006/relationships" id="258" r:id="Rb77653f791784966"/>
+    <p:sldId xmlns:r="http://schemas.openxmlformats.org/officeDocument/2006/relationships" id="259" r:id="Re4cd5ddc5dcc4758"/>
+    <p:sldId xmlns:r="http://schemas.openxmlformats.org/officeDocument/2006/relationships" id="260" r:id="Rd09a41405e124caa"/>
+    <p:sldId xmlns:r="http://schemas.openxmlformats.org/officeDocument/2006/relationships" id="261" r:id="R8b21135e0f7e4ead"/>
+    <p:sldId xmlns:r="http://schemas.openxmlformats.org/officeDocument/2006/relationships" id="262" r:id="Rb89b3c9707144cb6"/>
+    <p:sldId xmlns:r="http://schemas.openxmlformats.org/officeDocument/2006/relationships" id="263" r:id="Rc20b48b6efdc4265"/>
+    <p:sldId xmlns:r="http://schemas.openxmlformats.org/officeDocument/2006/relationships" id="264" r:id="R239985c5590545ff"/>
+    <p:sldId xmlns:r="http://schemas.openxmlformats.org/officeDocument/2006/relationships" id="265" r:id="Rc244a45d31fb45f4"/>
+    <p:sldId xmlns:r="http://schemas.openxmlformats.org/officeDocument/2006/relationships" id="266" r:id="Rd71961683c4d4ba1"/>
+    <p:sldId xmlns:r="http://schemas.openxmlformats.org/officeDocument/2006/relationships" id="267" r:id="R85285deb68b04f6f"/>
+    <p:sldId xmlns:r="http://schemas.openxmlformats.org/officeDocument/2006/relationships" id="268" r:id="Rb0ec26ef4a47490d"/>
+    <p:sldId xmlns:r="http://schemas.openxmlformats.org/officeDocument/2006/relationships" id="269" r:id="Recfaaf1345c048e2"/>
+    <p:sldId xmlns:r="http://schemas.openxmlformats.org/officeDocument/2006/relationships" id="270" r:id="R0cddd67093b04933"/>
+    <p:sldId xmlns:r="http://schemas.openxmlformats.org/officeDocument/2006/relationships" id="271" r:id="R2b24a766d90049ad"/>
+    <p:sldId xmlns:r="http://schemas.openxmlformats.org/officeDocument/2006/relationships" id="272" r:id="R9543a747c71a4c3d"/>
+    <p:sldId xmlns:r="http://schemas.openxmlformats.org/officeDocument/2006/relationships" id="273" r:id="R6dfe3e5870da4f41"/>
+    <p:sldId xmlns:r="http://schemas.openxmlformats.org/officeDocument/2006/relationships" id="274" r:id="R5bf27fbe1039458e"/>
+    <p:sldId xmlns:r="http://schemas.openxmlformats.org/officeDocument/2006/relationships" id="275" r:id="R528422b6d0cf4c69"/>
+    <p:sldId xmlns:r="http://schemas.openxmlformats.org/officeDocument/2006/relationships" id="276" r:id="R3583bce40b184ca9"/>
+    <p:sldId xmlns:r="http://schemas.openxmlformats.org/officeDocument/2006/relationships" id="277" r:id="R08004528e0e44804"/>
+    <p:sldId xmlns:r="http://schemas.openxmlformats.org/officeDocument/2006/relationships" id="278" r:id="Rf03aa78b9a00448e"/>
+    <p:sldId xmlns:r="http://schemas.openxmlformats.org/officeDocument/2006/relationships" id="279" r:id="R0e642e9deebd4f24"/>
+    <p:sldId xmlns:r="http://schemas.openxmlformats.org/officeDocument/2006/relationships" id="280" r:id="R07f70276adc548b1"/>
+    <p:sldId xmlns:r="http://schemas.openxmlformats.org/officeDocument/2006/relationships" id="281" r:id="R3b575efd020b4d8d"/>
+    <p:sldId xmlns:r="http://schemas.openxmlformats.org/officeDocument/2006/relationships" id="282" r:id="R6dc7b823ed444e49"/>
   </p:sldIdLst>
   <p:sldSz cx="15240000" cy="8572500"/>
   <p:notesSz cx="6858000" cy="9144000"/>
@@ -2503,7 +2503,7 @@
           </a:p>
           <a:p xmlns:a="http://schemas.openxmlformats.org/drawingml/2006/main">
             <a:r>
-              <a:t>과정명과 저장 폴더를 정합니다. 과정별로 ID, 포트, 저장 폴더를 구분합니다.</a:t>
+              <a:t>과정마다 이름, ID, 포트와 저장 폴더를 정합니다. 상단의 연보라색 탭이 현재 선택한 화면입니다.</a:t>
             </a:r>
           </a:p>
           <a:p xmlns:a="http://schemas.openxmlformats.org/drawingml/2006/main">
@@ -2603,7 +2603,7 @@
           </a:p>
           <a:p xmlns:a="http://schemas.openxmlformats.org/drawingml/2006/main">
             <a:r>
-              <a:t>파일당 2 GiB, 학생별 누적 10 GiB, 최소 여유 공간 5 GiB가 기본값입니다.</a:t>
+              <a:t>‘용량·전송 설정’ 탭을 선택합니다. 기본값은 파일당 2 GiB, 학생별 누적 10 GiB, 최소 여유 5 GiB입니다.</a:t>
             </a:r>
           </a:p>
           <a:p xmlns:a="http://schemas.openxmlformats.org/drawingml/2006/main">
@@ -3196,7 +3196,7 @@
   </p:cSld>
   <p:clrMap bg1="lt1" tx1="dk1" bg2="lt2" tx2="dk2" accent1="accent1" accent2="accent2" accent3="accent3" accent4="accent4" accent5="accent5" accent6="accent6" hlink="hlink" folHlink="folHlink"/>
   <p:sldLayoutIdLst>
-    <p:sldLayoutId xmlns:r="http://schemas.openxmlformats.org/officeDocument/2006/relationships" id="2147483649" r:id="R48485984e62e4ed6"/>
+    <p:sldLayoutId xmlns:r="http://schemas.openxmlformats.org/officeDocument/2006/relationships" id="2147483649" r:id="R40e68676d3784906"/>
   </p:sldLayoutIdLst>
   <p:txStyles>
     <p:titleStyle>
@@ -3747,7 +3747,7 @@
           <p:cNvPr id="5" name="">
             <a:extLst xmlns:a="http://schemas.openxmlformats.org/drawingml/2006/main">
               <a:ext uri="{FF2B5EF4-FFF2-40B4-BE49-F238E27FC236}">
-                <a16:creationId xmlns:a16="http://schemas.microsoft.com/office/drawing/2014/main" id="{F798DC95-5B3E-4B32-AEC3-26922AC0A1F5}"/>
+                <a16:creationId xmlns:a16="http://schemas.microsoft.com/office/drawing/2014/main" id="{8B1EBFBF-8671-4C77-A9B3-63866EE74A3A}"/>
               </a:ext>
             </a:extLst>
           </p:cNvPr>
@@ -3804,7 +3804,7 @@
           <p:cNvPr id="2" name="">
             <a:extLst xmlns:a="http://schemas.openxmlformats.org/drawingml/2006/main">
               <a:ext uri="{FF2B5EF4-FFF2-40B4-BE49-F238E27FC236}">
-                <a16:creationId xmlns:a16="http://schemas.microsoft.com/office/drawing/2014/main" id="{1DFC3D34-7F21-4A74-BE10-C044898E47B9}"/>
+                <a16:creationId xmlns:a16="http://schemas.microsoft.com/office/drawing/2014/main" id="{3FA4B0E5-475E-48D7-8CBF-9869DACDF8E3}"/>
               </a:ext>
             </a:extLst>
           </p:cNvPr>
@@ -3861,7 +3861,7 @@
           <p:cNvPr id="3" name="">
             <a:extLst xmlns:a="http://schemas.openxmlformats.org/drawingml/2006/main">
               <a:ext uri="{FF2B5EF4-FFF2-40B4-BE49-F238E27FC236}">
-                <a16:creationId xmlns:a16="http://schemas.microsoft.com/office/drawing/2014/main" id="{FE8DD963-CD5A-4DA9-BD49-BA5A2ACEB9EE}"/>
+                <a16:creationId xmlns:a16="http://schemas.microsoft.com/office/drawing/2014/main" id="{6FE09921-F178-4DF6-96A4-1F279D3BE709}"/>
               </a:ext>
             </a:extLst>
           </p:cNvPr>
@@ -3918,7 +3918,7 @@
           <p:cNvPr id="4" name="">
             <a:extLst xmlns:a="http://schemas.openxmlformats.org/drawingml/2006/main">
               <a:ext uri="{FF2B5EF4-FFF2-40B4-BE49-F238E27FC236}">
-                <a16:creationId xmlns:a16="http://schemas.microsoft.com/office/drawing/2014/main" id="{06EAE3FA-B2C4-4FB4-BFA4-199185FA959D}"/>
+                <a16:creationId xmlns:a16="http://schemas.microsoft.com/office/drawing/2014/main" id="{7827606C-5758-43B6-9815-51A8596A5035}"/>
               </a:ext>
             </a:extLst>
           </p:cNvPr>
@@ -3996,7 +3996,7 @@
     </p:spTree>
     <p:extLst>
       <p:ext uri="{BB962C8B-B14F-4D97-AF65-F5344CB8AC3E}">
-        <p14:creationId xmlns:p14="http://schemas.microsoft.com/office/powerpoint/2010/main" val="74822999"/>
+        <p14:creationId xmlns:p14="http://schemas.microsoft.com/office/powerpoint/2010/main" val="1279102114"/>
       </p:ext>
     </p:extLst>
   </p:cSld>
@@ -4027,7 +4027,7 @@
           <p:cNvPr id="9" name="">
             <a:extLst xmlns:a="http://schemas.openxmlformats.org/drawingml/2006/main">
               <a:ext uri="{FF2B5EF4-FFF2-40B4-BE49-F238E27FC236}">
-                <a16:creationId xmlns:a16="http://schemas.microsoft.com/office/drawing/2014/main" id="{82344A80-5A53-4FD8-BA87-814C0026F659}"/>
+                <a16:creationId xmlns:a16="http://schemas.microsoft.com/office/drawing/2014/main" id="{E0EEA62C-7D05-4912-A94B-E4C4685177B5}"/>
               </a:ext>
             </a:extLst>
           </p:cNvPr>
@@ -4084,7 +4084,7 @@
           <p:cNvPr id="2" name="">
             <a:extLst xmlns:a="http://schemas.openxmlformats.org/drawingml/2006/main">
               <a:ext uri="{FF2B5EF4-FFF2-40B4-BE49-F238E27FC236}">
-                <a16:creationId xmlns:a16="http://schemas.microsoft.com/office/drawing/2014/main" id="{8DAEFAF1-1DC6-4413-B776-3403359BC6D0}"/>
+                <a16:creationId xmlns:a16="http://schemas.microsoft.com/office/drawing/2014/main" id="{4FB4D892-37FA-44A4-A353-0F4250E2627B}"/>
               </a:ext>
             </a:extLst>
           </p:cNvPr>
@@ -4141,7 +4141,7 @@
           <p:cNvPr id="3" name="">
             <a:extLst xmlns:a="http://schemas.openxmlformats.org/drawingml/2006/main">
               <a:ext uri="{FF2B5EF4-FFF2-40B4-BE49-F238E27FC236}">
-                <a16:creationId xmlns:a16="http://schemas.microsoft.com/office/drawing/2014/main" id="{9D075FF2-CA3C-4CEF-9062-1527AE53BEAE}"/>
+                <a16:creationId xmlns:a16="http://schemas.microsoft.com/office/drawing/2014/main" id="{3E2A6309-5977-405C-B476-B7A3D9B9EE7A}"/>
               </a:ext>
             </a:extLst>
           </p:cNvPr>
@@ -4198,7 +4198,7 @@
           <p:cNvPr id="4" name="">
             <a:extLst xmlns:a="http://schemas.openxmlformats.org/drawingml/2006/main">
               <a:ext uri="{FF2B5EF4-FFF2-40B4-BE49-F238E27FC236}">
-                <a16:creationId xmlns:a16="http://schemas.microsoft.com/office/drawing/2014/main" id="{61ADBC22-665E-42D9-9AD3-26F6D2D24AA8}"/>
+                <a16:creationId xmlns:a16="http://schemas.microsoft.com/office/drawing/2014/main" id="{0F6CB187-B91F-40E0-ABA7-BA29EAD4FCB4}"/>
               </a:ext>
             </a:extLst>
           </p:cNvPr>
@@ -4347,7 +4347,7 @@
           <p:cNvPr id="5" name="">
             <a:extLst xmlns:a="http://schemas.openxmlformats.org/drawingml/2006/main">
               <a:ext uri="{FF2B5EF4-FFF2-40B4-BE49-F238E27FC236}">
-                <a16:creationId xmlns:a16="http://schemas.microsoft.com/office/drawing/2014/main" id="{343A1DA3-3F96-4DB7-8C9C-C718988FC997}"/>
+                <a16:creationId xmlns:a16="http://schemas.microsoft.com/office/drawing/2014/main" id="{5B89F76C-ED61-4BE2-8F64-7345698783C6}"/>
               </a:ext>
             </a:extLst>
           </p:cNvPr>
@@ -4404,7 +4404,7 @@
           <p:cNvPr id="6" name="">
             <a:extLst xmlns:a="http://schemas.openxmlformats.org/drawingml/2006/main">
               <a:ext uri="{FF2B5EF4-FFF2-40B4-BE49-F238E27FC236}">
-                <a16:creationId xmlns:a16="http://schemas.microsoft.com/office/drawing/2014/main" id="{F1DCDBFD-C605-4BFE-9D3E-9F1BD77CC40F}"/>
+                <a16:creationId xmlns:a16="http://schemas.microsoft.com/office/drawing/2014/main" id="{ACD10F34-7135-4E1F-9DE7-8C72BD97BE3A}"/>
               </a:ext>
             </a:extLst>
           </p:cNvPr>
@@ -4534,7 +4534,7 @@
           <p:nvPr/>
         </p:nvPicPr>
         <p:blipFill>
-          <a:blip xmlns:r="http://schemas.openxmlformats.org/officeDocument/2006/relationships" xmlns:a="http://schemas.openxmlformats.org/drawingml/2006/main" r:embed="Raebd96202e96495d"/>
+          <a:blip xmlns:r="http://schemas.openxmlformats.org/officeDocument/2006/relationships" xmlns:a="http://schemas.openxmlformats.org/drawingml/2006/main" r:embed="R92c322763575463f"/>
           <a:stretch xmlns:a="http://schemas.openxmlformats.org/drawingml/2006/main"/>
         </p:blipFill>
         <p:spPr>
@@ -4552,7 +4552,7 @@
           <p:cNvPr id="8" name="">
             <a:extLst xmlns:a="http://schemas.openxmlformats.org/drawingml/2006/main">
               <a:ext uri="{FF2B5EF4-FFF2-40B4-BE49-F238E27FC236}">
-                <a16:creationId xmlns:a16="http://schemas.microsoft.com/office/drawing/2014/main" id="{BEAC4420-BF0F-4D43-BD1C-CEA1A14F9359}"/>
+                <a16:creationId xmlns:a16="http://schemas.microsoft.com/office/drawing/2014/main" id="{9C106E23-1BBA-4437-9F10-8D321FA7F90A}"/>
               </a:ext>
             </a:extLst>
           </p:cNvPr>
@@ -4607,7 +4607,7 @@
     </p:spTree>
     <p:extLst>
       <p:ext uri="{BB962C8B-B14F-4D97-AF65-F5344CB8AC3E}">
-        <p14:creationId xmlns:p14="http://schemas.microsoft.com/office/powerpoint/2010/main" val="1808947810"/>
+        <p14:creationId xmlns:p14="http://schemas.microsoft.com/office/powerpoint/2010/main" val="1476003718"/>
       </p:ext>
     </p:extLst>
   </p:cSld>
@@ -4638,7 +4638,7 @@
           <p:cNvPr id="9" name="">
             <a:extLst xmlns:a="http://schemas.openxmlformats.org/drawingml/2006/main">
               <a:ext uri="{FF2B5EF4-FFF2-40B4-BE49-F238E27FC236}">
-                <a16:creationId xmlns:a16="http://schemas.microsoft.com/office/drawing/2014/main" id="{5003F56E-9BD5-4F26-BD82-D81DCFF9B1C4}"/>
+                <a16:creationId xmlns:a16="http://schemas.microsoft.com/office/drawing/2014/main" id="{45B4F6F8-9D15-40D6-987B-569A22CA3DE5}"/>
               </a:ext>
             </a:extLst>
           </p:cNvPr>
@@ -4695,7 +4695,7 @@
           <p:cNvPr id="2" name="">
             <a:extLst xmlns:a="http://schemas.openxmlformats.org/drawingml/2006/main">
               <a:ext uri="{FF2B5EF4-FFF2-40B4-BE49-F238E27FC236}">
-                <a16:creationId xmlns:a16="http://schemas.microsoft.com/office/drawing/2014/main" id="{7607EA5B-FAD9-4EFD-BBE0-4B03422E715A}"/>
+                <a16:creationId xmlns:a16="http://schemas.microsoft.com/office/drawing/2014/main" id="{4887B855-353E-4522-B638-9974062D309A}"/>
               </a:ext>
             </a:extLst>
           </p:cNvPr>
@@ -4752,7 +4752,7 @@
           <p:cNvPr id="3" name="">
             <a:extLst xmlns:a="http://schemas.openxmlformats.org/drawingml/2006/main">
               <a:ext uri="{FF2B5EF4-FFF2-40B4-BE49-F238E27FC236}">
-                <a16:creationId xmlns:a16="http://schemas.microsoft.com/office/drawing/2014/main" id="{F986A71F-6BA6-4242-BDC6-3894FF76A6A5}"/>
+                <a16:creationId xmlns:a16="http://schemas.microsoft.com/office/drawing/2014/main" id="{3BEC662E-DB80-4CC4-8559-5C6ECCC18DAA}"/>
               </a:ext>
             </a:extLst>
           </p:cNvPr>
@@ -4809,7 +4809,7 @@
           <p:cNvPr id="4" name="">
             <a:extLst xmlns:a="http://schemas.openxmlformats.org/drawingml/2006/main">
               <a:ext uri="{FF2B5EF4-FFF2-40B4-BE49-F238E27FC236}">
-                <a16:creationId xmlns:a16="http://schemas.microsoft.com/office/drawing/2014/main" id="{5B9C0CEA-D582-4E37-9F51-078731755D3F}"/>
+                <a16:creationId xmlns:a16="http://schemas.microsoft.com/office/drawing/2014/main" id="{6BA7FE8C-48FC-45EB-B372-B0BB5FDC3C3C}"/>
               </a:ext>
             </a:extLst>
           </p:cNvPr>
@@ -4912,7 +4912,7 @@
           <p:cNvPr id="5" name="">
             <a:extLst xmlns:a="http://schemas.openxmlformats.org/drawingml/2006/main">
               <a:ext uri="{FF2B5EF4-FFF2-40B4-BE49-F238E27FC236}">
-                <a16:creationId xmlns:a16="http://schemas.microsoft.com/office/drawing/2014/main" id="{F802EF69-5CB2-4A31-9FC0-FB33DE647EC1}"/>
+                <a16:creationId xmlns:a16="http://schemas.microsoft.com/office/drawing/2014/main" id="{74D3C4DA-B6E3-495E-96E2-8CA9FD119E32}"/>
               </a:ext>
             </a:extLst>
           </p:cNvPr>
@@ -4969,7 +4969,7 @@
           <p:cNvPr id="6" name="">
             <a:extLst xmlns:a="http://schemas.openxmlformats.org/drawingml/2006/main">
               <a:ext uri="{FF2B5EF4-FFF2-40B4-BE49-F238E27FC236}">
-                <a16:creationId xmlns:a16="http://schemas.microsoft.com/office/drawing/2014/main" id="{6282EBDB-9ACE-411D-A27A-31DE760C49E7}"/>
+                <a16:creationId xmlns:a16="http://schemas.microsoft.com/office/drawing/2014/main" id="{6F6C3C90-3EFE-4E63-85CA-F1623AA4184E}"/>
               </a:ext>
             </a:extLst>
           </p:cNvPr>
@@ -5076,7 +5076,7 @@
           <p:nvPr/>
         </p:nvPicPr>
         <p:blipFill>
-          <a:blip xmlns:r="http://schemas.openxmlformats.org/officeDocument/2006/relationships" xmlns:a="http://schemas.openxmlformats.org/drawingml/2006/main" r:embed="R7e6eda3a0c254290"/>
+          <a:blip xmlns:r="http://schemas.openxmlformats.org/officeDocument/2006/relationships" xmlns:a="http://schemas.openxmlformats.org/drawingml/2006/main" r:embed="R4382b802c35c4b31"/>
           <a:stretch xmlns:a="http://schemas.openxmlformats.org/drawingml/2006/main"/>
         </p:blipFill>
         <p:spPr>
@@ -5094,7 +5094,7 @@
           <p:cNvPr id="8" name="">
             <a:extLst xmlns:a="http://schemas.openxmlformats.org/drawingml/2006/main">
               <a:ext uri="{FF2B5EF4-FFF2-40B4-BE49-F238E27FC236}">
-                <a16:creationId xmlns:a16="http://schemas.microsoft.com/office/drawing/2014/main" id="{67E630A1-D27C-4E70-87B6-C8CB0DF57DAC}"/>
+                <a16:creationId xmlns:a16="http://schemas.microsoft.com/office/drawing/2014/main" id="{B0EE0519-D89C-47A5-9D41-E78D36954817}"/>
               </a:ext>
             </a:extLst>
           </p:cNvPr>
@@ -5149,7 +5149,7 @@
     </p:spTree>
     <p:extLst>
       <p:ext uri="{BB962C8B-B14F-4D97-AF65-F5344CB8AC3E}">
-        <p14:creationId xmlns:p14="http://schemas.microsoft.com/office/powerpoint/2010/main" val="361729834"/>
+        <p14:creationId xmlns:p14="http://schemas.microsoft.com/office/powerpoint/2010/main" val="2033120927"/>
       </p:ext>
     </p:extLst>
   </p:cSld>
@@ -5180,7 +5180,7 @@
           <p:cNvPr id="9" name="">
             <a:extLst xmlns:a="http://schemas.openxmlformats.org/drawingml/2006/main">
               <a:ext uri="{FF2B5EF4-FFF2-40B4-BE49-F238E27FC236}">
-                <a16:creationId xmlns:a16="http://schemas.microsoft.com/office/drawing/2014/main" id="{D3650562-F61F-4C82-AC57-30B8F2F17655}"/>
+                <a16:creationId xmlns:a16="http://schemas.microsoft.com/office/drawing/2014/main" id="{7AB4AF69-53AD-48BB-BBE8-CE5446DC95F9}"/>
               </a:ext>
             </a:extLst>
           </p:cNvPr>
@@ -5237,7 +5237,7 @@
           <p:cNvPr id="2" name="">
             <a:extLst xmlns:a="http://schemas.openxmlformats.org/drawingml/2006/main">
               <a:ext uri="{FF2B5EF4-FFF2-40B4-BE49-F238E27FC236}">
-                <a16:creationId xmlns:a16="http://schemas.microsoft.com/office/drawing/2014/main" id="{CBDAFA75-6ACA-4C73-8CDD-F9014ADC7AC5}"/>
+                <a16:creationId xmlns:a16="http://schemas.microsoft.com/office/drawing/2014/main" id="{14F312EE-D2E3-4329-8CBD-6964BD4E0598}"/>
               </a:ext>
             </a:extLst>
           </p:cNvPr>
@@ -5294,7 +5294,7 @@
           <p:cNvPr id="3" name="">
             <a:extLst xmlns:a="http://schemas.openxmlformats.org/drawingml/2006/main">
               <a:ext uri="{FF2B5EF4-FFF2-40B4-BE49-F238E27FC236}">
-                <a16:creationId xmlns:a16="http://schemas.microsoft.com/office/drawing/2014/main" id="{182797DC-3087-44E7-AA54-A338CD1150B6}"/>
+                <a16:creationId xmlns:a16="http://schemas.microsoft.com/office/drawing/2014/main" id="{AE4A6DC7-B0A8-4BDA-AA31-189BC1FB85A8}"/>
               </a:ext>
             </a:extLst>
           </p:cNvPr>
@@ -5351,7 +5351,7 @@
           <p:cNvPr id="4" name="">
             <a:extLst xmlns:a="http://schemas.openxmlformats.org/drawingml/2006/main">
               <a:ext uri="{FF2B5EF4-FFF2-40B4-BE49-F238E27FC236}">
-                <a16:creationId xmlns:a16="http://schemas.microsoft.com/office/drawing/2014/main" id="{33AB46FF-BE9F-4918-823F-0C30BA524ED5}"/>
+                <a16:creationId xmlns:a16="http://schemas.microsoft.com/office/drawing/2014/main" id="{A5BE18D5-72E6-4BC3-B9F7-50887DBA96C9}"/>
               </a:ext>
             </a:extLst>
           </p:cNvPr>
@@ -5477,7 +5477,7 @@
           <p:cNvPr id="5" name="">
             <a:extLst xmlns:a="http://schemas.openxmlformats.org/drawingml/2006/main">
               <a:ext uri="{FF2B5EF4-FFF2-40B4-BE49-F238E27FC236}">
-                <a16:creationId xmlns:a16="http://schemas.microsoft.com/office/drawing/2014/main" id="{B2854FAA-2474-485C-9E4D-354EE8BBD50F}"/>
+                <a16:creationId xmlns:a16="http://schemas.microsoft.com/office/drawing/2014/main" id="{F1BA104E-FD28-4BC2-B5D8-313CB4CB72E1}"/>
               </a:ext>
             </a:extLst>
           </p:cNvPr>
@@ -5534,7 +5534,7 @@
           <p:cNvPr id="6" name="">
             <a:extLst xmlns:a="http://schemas.openxmlformats.org/drawingml/2006/main">
               <a:ext uri="{FF2B5EF4-FFF2-40B4-BE49-F238E27FC236}">
-                <a16:creationId xmlns:a16="http://schemas.microsoft.com/office/drawing/2014/main" id="{68B27F5D-AFAB-4C15-92CD-6D9FEF1E5179}"/>
+                <a16:creationId xmlns:a16="http://schemas.microsoft.com/office/drawing/2014/main" id="{7794259A-105E-4DD2-8EC1-FF5D52BA2F90}"/>
               </a:ext>
             </a:extLst>
           </p:cNvPr>
@@ -5664,7 +5664,7 @@
           <p:nvPr/>
         </p:nvPicPr>
         <p:blipFill>
-          <a:blip xmlns:r="http://schemas.openxmlformats.org/officeDocument/2006/relationships" xmlns:a="http://schemas.openxmlformats.org/drawingml/2006/main" r:embed="R6e214e70e7914f5b"/>
+          <a:blip xmlns:r="http://schemas.openxmlformats.org/officeDocument/2006/relationships" xmlns:a="http://schemas.openxmlformats.org/drawingml/2006/main" r:embed="R2a7a13ca37cf4ee9"/>
           <a:stretch xmlns:a="http://schemas.openxmlformats.org/drawingml/2006/main"/>
         </p:blipFill>
         <p:spPr>
@@ -5682,7 +5682,7 @@
           <p:cNvPr id="8" name="">
             <a:extLst xmlns:a="http://schemas.openxmlformats.org/drawingml/2006/main">
               <a:ext uri="{FF2B5EF4-FFF2-40B4-BE49-F238E27FC236}">
-                <a16:creationId xmlns:a16="http://schemas.microsoft.com/office/drawing/2014/main" id="{039E1BC7-93FC-4785-AC8B-3F1FC0EA911A}"/>
+                <a16:creationId xmlns:a16="http://schemas.microsoft.com/office/drawing/2014/main" id="{73E331A2-5666-417D-899D-A08DA5CF0950}"/>
               </a:ext>
             </a:extLst>
           </p:cNvPr>
@@ -5737,7 +5737,7 @@
     </p:spTree>
     <p:extLst>
       <p:ext uri="{BB962C8B-B14F-4D97-AF65-F5344CB8AC3E}">
-        <p14:creationId xmlns:p14="http://schemas.microsoft.com/office/powerpoint/2010/main" val="1855125280"/>
+        <p14:creationId xmlns:p14="http://schemas.microsoft.com/office/powerpoint/2010/main" val="804987649"/>
       </p:ext>
     </p:extLst>
   </p:cSld>
@@ -5768,7 +5768,7 @@
           <p:cNvPr id="9" name="">
             <a:extLst xmlns:a="http://schemas.openxmlformats.org/drawingml/2006/main">
               <a:ext uri="{FF2B5EF4-FFF2-40B4-BE49-F238E27FC236}">
-                <a16:creationId xmlns:a16="http://schemas.microsoft.com/office/drawing/2014/main" id="{519BFBC7-EF88-42D3-B10E-924667245F80}"/>
+                <a16:creationId xmlns:a16="http://schemas.microsoft.com/office/drawing/2014/main" id="{542FB352-2C3E-4327-BE3C-3850DECB1064}"/>
               </a:ext>
             </a:extLst>
           </p:cNvPr>
@@ -5825,7 +5825,7 @@
           <p:cNvPr id="2" name="">
             <a:extLst xmlns:a="http://schemas.openxmlformats.org/drawingml/2006/main">
               <a:ext uri="{FF2B5EF4-FFF2-40B4-BE49-F238E27FC236}">
-                <a16:creationId xmlns:a16="http://schemas.microsoft.com/office/drawing/2014/main" id="{3916B4FA-2BE9-4A33-9F09-5F2D294C1538}"/>
+                <a16:creationId xmlns:a16="http://schemas.microsoft.com/office/drawing/2014/main" id="{AAEEDBCC-577B-495B-85C8-012CCD1FB6A5}"/>
               </a:ext>
             </a:extLst>
           </p:cNvPr>
@@ -5882,7 +5882,7 @@
           <p:cNvPr id="3" name="">
             <a:extLst xmlns:a="http://schemas.openxmlformats.org/drawingml/2006/main">
               <a:ext uri="{FF2B5EF4-FFF2-40B4-BE49-F238E27FC236}">
-                <a16:creationId xmlns:a16="http://schemas.microsoft.com/office/drawing/2014/main" id="{57BEBF41-5B17-4F57-8A5B-AE556A7AD4B9}"/>
+                <a16:creationId xmlns:a16="http://schemas.microsoft.com/office/drawing/2014/main" id="{F0C0AC80-9DFF-46CE-B9C2-6C9DDFA816CC}"/>
               </a:ext>
             </a:extLst>
           </p:cNvPr>
@@ -5939,7 +5939,7 @@
           <p:cNvPr id="4" name="">
             <a:extLst xmlns:a="http://schemas.openxmlformats.org/drawingml/2006/main">
               <a:ext uri="{FF2B5EF4-FFF2-40B4-BE49-F238E27FC236}">
-                <a16:creationId xmlns:a16="http://schemas.microsoft.com/office/drawing/2014/main" id="{570241E4-6AEE-479F-95D3-A8F22281629E}"/>
+                <a16:creationId xmlns:a16="http://schemas.microsoft.com/office/drawing/2014/main" id="{112FB029-4B3F-4424-9506-F50DC840172F}"/>
               </a:ext>
             </a:extLst>
           </p:cNvPr>
@@ -6019,7 +6019,7 @@
           <p:cNvPr id="5" name="">
             <a:extLst xmlns:a="http://schemas.openxmlformats.org/drawingml/2006/main">
               <a:ext uri="{FF2B5EF4-FFF2-40B4-BE49-F238E27FC236}">
-                <a16:creationId xmlns:a16="http://schemas.microsoft.com/office/drawing/2014/main" id="{D5D4C40B-9DF6-4089-BB08-82CFD5893A66}"/>
+                <a16:creationId xmlns:a16="http://schemas.microsoft.com/office/drawing/2014/main" id="{607009D3-EB60-4A21-8055-33051483ECA8}"/>
               </a:ext>
             </a:extLst>
           </p:cNvPr>
@@ -6076,7 +6076,7 @@
           <p:cNvPr id="6" name="">
             <a:extLst xmlns:a="http://schemas.openxmlformats.org/drawingml/2006/main">
               <a:ext uri="{FF2B5EF4-FFF2-40B4-BE49-F238E27FC236}">
-                <a16:creationId xmlns:a16="http://schemas.microsoft.com/office/drawing/2014/main" id="{0B04A30C-F771-4E0E-9C22-BCB01D09569B}"/>
+                <a16:creationId xmlns:a16="http://schemas.microsoft.com/office/drawing/2014/main" id="{CB692F76-FC24-46E2-9703-558443D1A872}"/>
               </a:ext>
             </a:extLst>
           </p:cNvPr>
@@ -6206,7 +6206,7 @@
           <p:nvPr/>
         </p:nvPicPr>
         <p:blipFill>
-          <a:blip xmlns:r="http://schemas.openxmlformats.org/officeDocument/2006/relationships" xmlns:a="http://schemas.openxmlformats.org/drawingml/2006/main" r:embed="Rbb0bd5127f0940c4"/>
+          <a:blip xmlns:r="http://schemas.openxmlformats.org/officeDocument/2006/relationships" xmlns:a="http://schemas.openxmlformats.org/drawingml/2006/main" r:embed="R365e9e0d27f3421e"/>
           <a:stretch xmlns:a="http://schemas.openxmlformats.org/drawingml/2006/main"/>
         </p:blipFill>
         <p:spPr>
@@ -6224,7 +6224,7 @@
           <p:cNvPr id="8" name="">
             <a:extLst xmlns:a="http://schemas.openxmlformats.org/drawingml/2006/main">
               <a:ext uri="{FF2B5EF4-FFF2-40B4-BE49-F238E27FC236}">
-                <a16:creationId xmlns:a16="http://schemas.microsoft.com/office/drawing/2014/main" id="{2012DB03-AA93-4118-9B94-450BC4F84260}"/>
+                <a16:creationId xmlns:a16="http://schemas.microsoft.com/office/drawing/2014/main" id="{0BD1F396-69A6-4624-8035-D597FFD82D9D}"/>
               </a:ext>
             </a:extLst>
           </p:cNvPr>
@@ -6279,7 +6279,7 @@
     </p:spTree>
     <p:extLst>
       <p:ext uri="{BB962C8B-B14F-4D97-AF65-F5344CB8AC3E}">
-        <p14:creationId xmlns:p14="http://schemas.microsoft.com/office/powerpoint/2010/main" val="510607562"/>
+        <p14:creationId xmlns:p14="http://schemas.microsoft.com/office/powerpoint/2010/main" val="1972790853"/>
       </p:ext>
     </p:extLst>
   </p:cSld>
@@ -6310,7 +6310,7 @@
           <p:cNvPr id="9" name="">
             <a:extLst xmlns:a="http://schemas.openxmlformats.org/drawingml/2006/main">
               <a:ext uri="{FF2B5EF4-FFF2-40B4-BE49-F238E27FC236}">
-                <a16:creationId xmlns:a16="http://schemas.microsoft.com/office/drawing/2014/main" id="{6DFB4BE5-561B-4883-9156-7AC992F77B3B}"/>
+                <a16:creationId xmlns:a16="http://schemas.microsoft.com/office/drawing/2014/main" id="{3DA2E2E9-6475-4CB3-8358-46989B31D019}"/>
               </a:ext>
             </a:extLst>
           </p:cNvPr>
@@ -6367,7 +6367,7 @@
           <p:cNvPr id="2" name="">
             <a:extLst xmlns:a="http://schemas.openxmlformats.org/drawingml/2006/main">
               <a:ext uri="{FF2B5EF4-FFF2-40B4-BE49-F238E27FC236}">
-                <a16:creationId xmlns:a16="http://schemas.microsoft.com/office/drawing/2014/main" id="{C790D5A9-A68F-433D-AB6F-2ED5D184C074}"/>
+                <a16:creationId xmlns:a16="http://schemas.microsoft.com/office/drawing/2014/main" id="{467522AA-218E-4B8E-98F7-B494C2D2DF03}"/>
               </a:ext>
             </a:extLst>
           </p:cNvPr>
@@ -6424,7 +6424,7 @@
           <p:cNvPr id="3" name="">
             <a:extLst xmlns:a="http://schemas.openxmlformats.org/drawingml/2006/main">
               <a:ext uri="{FF2B5EF4-FFF2-40B4-BE49-F238E27FC236}">
-                <a16:creationId xmlns:a16="http://schemas.microsoft.com/office/drawing/2014/main" id="{CC44F342-004F-43AB-A462-5560E271F608}"/>
+                <a16:creationId xmlns:a16="http://schemas.microsoft.com/office/drawing/2014/main" id="{37567118-E062-4B65-A682-BF0E1252B071}"/>
               </a:ext>
             </a:extLst>
           </p:cNvPr>
@@ -6481,7 +6481,7 @@
           <p:cNvPr id="4" name="">
             <a:extLst xmlns:a="http://schemas.openxmlformats.org/drawingml/2006/main">
               <a:ext uri="{FF2B5EF4-FFF2-40B4-BE49-F238E27FC236}">
-                <a16:creationId xmlns:a16="http://schemas.microsoft.com/office/drawing/2014/main" id="{982B014E-2F68-42AF-A9DA-DDE0B78B373A}"/>
+                <a16:creationId xmlns:a16="http://schemas.microsoft.com/office/drawing/2014/main" id="{D74FA4C2-5BDB-43A2-B844-797AAFE71BE5}"/>
               </a:ext>
             </a:extLst>
           </p:cNvPr>
@@ -6561,7 +6561,7 @@
           <p:cNvPr id="5" name="">
             <a:extLst xmlns:a="http://schemas.openxmlformats.org/drawingml/2006/main">
               <a:ext uri="{FF2B5EF4-FFF2-40B4-BE49-F238E27FC236}">
-                <a16:creationId xmlns:a16="http://schemas.microsoft.com/office/drawing/2014/main" id="{12522650-908F-4EC3-BF05-5C5D25FE0D66}"/>
+                <a16:creationId xmlns:a16="http://schemas.microsoft.com/office/drawing/2014/main" id="{A942C0A8-5F1A-4E9F-88DE-15897A197F61}"/>
               </a:ext>
             </a:extLst>
           </p:cNvPr>
@@ -6618,7 +6618,7 @@
           <p:cNvPr id="6" name="">
             <a:extLst xmlns:a="http://schemas.openxmlformats.org/drawingml/2006/main">
               <a:ext uri="{FF2B5EF4-FFF2-40B4-BE49-F238E27FC236}">
-                <a16:creationId xmlns:a16="http://schemas.microsoft.com/office/drawing/2014/main" id="{88409B39-759C-44B6-A9A1-7D8081722B11}"/>
+                <a16:creationId xmlns:a16="http://schemas.microsoft.com/office/drawing/2014/main" id="{0F912AAC-7457-4493-8772-E0A9A6D64E3A}"/>
               </a:ext>
             </a:extLst>
           </p:cNvPr>
@@ -6748,7 +6748,7 @@
           <p:nvPr/>
         </p:nvPicPr>
         <p:blipFill>
-          <a:blip xmlns:r="http://schemas.openxmlformats.org/officeDocument/2006/relationships" xmlns:a="http://schemas.openxmlformats.org/drawingml/2006/main" r:embed="Rddec0bacabd04b7b"/>
+          <a:blip xmlns:r="http://schemas.openxmlformats.org/officeDocument/2006/relationships" xmlns:a="http://schemas.openxmlformats.org/drawingml/2006/main" r:embed="Re581ebff8cbd479a"/>
           <a:stretch xmlns:a="http://schemas.openxmlformats.org/drawingml/2006/main"/>
         </p:blipFill>
         <p:spPr>
@@ -6766,7 +6766,7 @@
           <p:cNvPr id="8" name="">
             <a:extLst xmlns:a="http://schemas.openxmlformats.org/drawingml/2006/main">
               <a:ext uri="{FF2B5EF4-FFF2-40B4-BE49-F238E27FC236}">
-                <a16:creationId xmlns:a16="http://schemas.microsoft.com/office/drawing/2014/main" id="{EC3ABCED-C9D3-41A7-B3DD-61AE483152DB}"/>
+                <a16:creationId xmlns:a16="http://schemas.microsoft.com/office/drawing/2014/main" id="{2CE0D46C-BDD6-4EE6-92CB-4C9AF4CC4270}"/>
               </a:ext>
             </a:extLst>
           </p:cNvPr>
@@ -6821,7 +6821,7 @@
     </p:spTree>
     <p:extLst>
       <p:ext uri="{BB962C8B-B14F-4D97-AF65-F5344CB8AC3E}">
-        <p14:creationId xmlns:p14="http://schemas.microsoft.com/office/powerpoint/2010/main" val="2053020436"/>
+        <p14:creationId xmlns:p14="http://schemas.microsoft.com/office/powerpoint/2010/main" val="47080113"/>
       </p:ext>
     </p:extLst>
   </p:cSld>
@@ -6852,7 +6852,7 @@
           <p:cNvPr id="9" name="">
             <a:extLst xmlns:a="http://schemas.openxmlformats.org/drawingml/2006/main">
               <a:ext uri="{FF2B5EF4-FFF2-40B4-BE49-F238E27FC236}">
-                <a16:creationId xmlns:a16="http://schemas.microsoft.com/office/drawing/2014/main" id="{FBF29CBE-1FC7-4105-93BD-E243A81377FE}"/>
+                <a16:creationId xmlns:a16="http://schemas.microsoft.com/office/drawing/2014/main" id="{C586F1CC-3791-4EB8-8AAB-67EE6F260905}"/>
               </a:ext>
             </a:extLst>
           </p:cNvPr>
@@ -6909,7 +6909,7 @@
           <p:cNvPr id="2" name="">
             <a:extLst xmlns:a="http://schemas.openxmlformats.org/drawingml/2006/main">
               <a:ext uri="{FF2B5EF4-FFF2-40B4-BE49-F238E27FC236}">
-                <a16:creationId xmlns:a16="http://schemas.microsoft.com/office/drawing/2014/main" id="{F8993367-15E8-4606-B215-5B5B8D4FD86C}"/>
+                <a16:creationId xmlns:a16="http://schemas.microsoft.com/office/drawing/2014/main" id="{5C1B099B-E1B1-4102-BDE7-6280599D15A7}"/>
               </a:ext>
             </a:extLst>
           </p:cNvPr>
@@ -6966,7 +6966,7 @@
           <p:cNvPr id="3" name="">
             <a:extLst xmlns:a="http://schemas.openxmlformats.org/drawingml/2006/main">
               <a:ext uri="{FF2B5EF4-FFF2-40B4-BE49-F238E27FC236}">
-                <a16:creationId xmlns:a16="http://schemas.microsoft.com/office/drawing/2014/main" id="{56837E1D-5B04-4D3A-9FBF-A9DC6961CF92}"/>
+                <a16:creationId xmlns:a16="http://schemas.microsoft.com/office/drawing/2014/main" id="{D30260DB-5146-4917-99D5-507D7199241A}"/>
               </a:ext>
             </a:extLst>
           </p:cNvPr>
@@ -7023,7 +7023,7 @@
           <p:cNvPr id="4" name="">
             <a:extLst xmlns:a="http://schemas.openxmlformats.org/drawingml/2006/main">
               <a:ext uri="{FF2B5EF4-FFF2-40B4-BE49-F238E27FC236}">
-                <a16:creationId xmlns:a16="http://schemas.microsoft.com/office/drawing/2014/main" id="{D3502F60-9AD3-4A9E-9B79-5789A1F0E0BA}"/>
+                <a16:creationId xmlns:a16="http://schemas.microsoft.com/office/drawing/2014/main" id="{43197438-C1EE-4178-AE2D-6D7BD20F0AA7}"/>
               </a:ext>
             </a:extLst>
           </p:cNvPr>
@@ -7103,7 +7103,7 @@
           <p:cNvPr id="5" name="">
             <a:extLst xmlns:a="http://schemas.openxmlformats.org/drawingml/2006/main">
               <a:ext uri="{FF2B5EF4-FFF2-40B4-BE49-F238E27FC236}">
-                <a16:creationId xmlns:a16="http://schemas.microsoft.com/office/drawing/2014/main" id="{DFF9C084-E9A9-4DEA-B7BA-13F88B4F6C8B}"/>
+                <a16:creationId xmlns:a16="http://schemas.microsoft.com/office/drawing/2014/main" id="{60FED1DD-D31A-4A43-B7B0-16F313ADB236}"/>
               </a:ext>
             </a:extLst>
           </p:cNvPr>
@@ -7160,7 +7160,7 @@
           <p:cNvPr id="6" name="">
             <a:extLst xmlns:a="http://schemas.openxmlformats.org/drawingml/2006/main">
               <a:ext uri="{FF2B5EF4-FFF2-40B4-BE49-F238E27FC236}">
-                <a16:creationId xmlns:a16="http://schemas.microsoft.com/office/drawing/2014/main" id="{B6C735B4-9451-4A3E-B3C9-9A9CCC9A9339}"/>
+                <a16:creationId xmlns:a16="http://schemas.microsoft.com/office/drawing/2014/main" id="{A791789E-70A7-4405-B3AF-2A7282424BAB}"/>
               </a:ext>
             </a:extLst>
           </p:cNvPr>
@@ -7290,7 +7290,7 @@
           <p:nvPr/>
         </p:nvPicPr>
         <p:blipFill>
-          <a:blip xmlns:r="http://schemas.openxmlformats.org/officeDocument/2006/relationships" xmlns:a="http://schemas.openxmlformats.org/drawingml/2006/main" r:embed="R23e75b7ee4564c56"/>
+          <a:blip xmlns:r="http://schemas.openxmlformats.org/officeDocument/2006/relationships" xmlns:a="http://schemas.openxmlformats.org/drawingml/2006/main" r:embed="R8df6900fd27c45f7"/>
           <a:stretch xmlns:a="http://schemas.openxmlformats.org/drawingml/2006/main"/>
         </p:blipFill>
         <p:spPr>
@@ -7308,7 +7308,7 @@
           <p:cNvPr id="8" name="">
             <a:extLst xmlns:a="http://schemas.openxmlformats.org/drawingml/2006/main">
               <a:ext uri="{FF2B5EF4-FFF2-40B4-BE49-F238E27FC236}">
-                <a16:creationId xmlns:a16="http://schemas.microsoft.com/office/drawing/2014/main" id="{B0D756EF-4275-4EFA-BBB7-83E4351C29B5}"/>
+                <a16:creationId xmlns:a16="http://schemas.microsoft.com/office/drawing/2014/main" id="{7564B336-9206-4BBF-B5BE-08269D535906}"/>
               </a:ext>
             </a:extLst>
           </p:cNvPr>
@@ -7363,7 +7363,7 @@
     </p:spTree>
     <p:extLst>
       <p:ext uri="{BB962C8B-B14F-4D97-AF65-F5344CB8AC3E}">
-        <p14:creationId xmlns:p14="http://schemas.microsoft.com/office/powerpoint/2010/main" val="1750080791"/>
+        <p14:creationId xmlns:p14="http://schemas.microsoft.com/office/powerpoint/2010/main" val="836310924"/>
       </p:ext>
     </p:extLst>
   </p:cSld>
@@ -7394,7 +7394,7 @@
           <p:cNvPr id="9" name="">
             <a:extLst xmlns:a="http://schemas.openxmlformats.org/drawingml/2006/main">
               <a:ext uri="{FF2B5EF4-FFF2-40B4-BE49-F238E27FC236}">
-                <a16:creationId xmlns:a16="http://schemas.microsoft.com/office/drawing/2014/main" id="{DFC1C303-C36B-48ED-B67F-9B987BE1FB28}"/>
+                <a16:creationId xmlns:a16="http://schemas.microsoft.com/office/drawing/2014/main" id="{C9BD02EF-9719-403A-90A5-3BBDAF1AFCF6}"/>
               </a:ext>
             </a:extLst>
           </p:cNvPr>
@@ -7451,7 +7451,7 @@
           <p:cNvPr id="2" name="">
             <a:extLst xmlns:a="http://schemas.openxmlformats.org/drawingml/2006/main">
               <a:ext uri="{FF2B5EF4-FFF2-40B4-BE49-F238E27FC236}">
-                <a16:creationId xmlns:a16="http://schemas.microsoft.com/office/drawing/2014/main" id="{9117F060-D94E-481E-9576-385498992DA0}"/>
+                <a16:creationId xmlns:a16="http://schemas.microsoft.com/office/drawing/2014/main" id="{FB4F1F45-59B5-4290-AD44-FAF85CAC0EE5}"/>
               </a:ext>
             </a:extLst>
           </p:cNvPr>
@@ -7508,7 +7508,7 @@
           <p:cNvPr id="3" name="">
             <a:extLst xmlns:a="http://schemas.openxmlformats.org/drawingml/2006/main">
               <a:ext uri="{FF2B5EF4-FFF2-40B4-BE49-F238E27FC236}">
-                <a16:creationId xmlns:a16="http://schemas.microsoft.com/office/drawing/2014/main" id="{254CAD71-3E5D-4214-B3D3-34E9293BC53F}"/>
+                <a16:creationId xmlns:a16="http://schemas.microsoft.com/office/drawing/2014/main" id="{855E0E5E-03B8-4CDF-B723-6BB531AA0B61}"/>
               </a:ext>
             </a:extLst>
           </p:cNvPr>
@@ -7565,7 +7565,7 @@
           <p:cNvPr id="4" name="">
             <a:extLst xmlns:a="http://schemas.openxmlformats.org/drawingml/2006/main">
               <a:ext uri="{FF2B5EF4-FFF2-40B4-BE49-F238E27FC236}">
-                <a16:creationId xmlns:a16="http://schemas.microsoft.com/office/drawing/2014/main" id="{CE9EA8DA-7EFB-4A79-93B1-26989A0267B3}"/>
+                <a16:creationId xmlns:a16="http://schemas.microsoft.com/office/drawing/2014/main" id="{2A89CFFB-9D79-495F-854D-B4D09BA64A5A}"/>
               </a:ext>
             </a:extLst>
           </p:cNvPr>
@@ -7691,7 +7691,7 @@
           <p:cNvPr id="5" name="">
             <a:extLst xmlns:a="http://schemas.openxmlformats.org/drawingml/2006/main">
               <a:ext uri="{FF2B5EF4-FFF2-40B4-BE49-F238E27FC236}">
-                <a16:creationId xmlns:a16="http://schemas.microsoft.com/office/drawing/2014/main" id="{416004EF-E113-4744-83B7-7E0436574256}"/>
+                <a16:creationId xmlns:a16="http://schemas.microsoft.com/office/drawing/2014/main" id="{BF26A94A-206C-4CF7-8C9D-8D3B7AF89255}"/>
               </a:ext>
             </a:extLst>
           </p:cNvPr>
@@ -7748,7 +7748,7 @@
           <p:cNvPr id="6" name="">
             <a:extLst xmlns:a="http://schemas.openxmlformats.org/drawingml/2006/main">
               <a:ext uri="{FF2B5EF4-FFF2-40B4-BE49-F238E27FC236}">
-                <a16:creationId xmlns:a16="http://schemas.microsoft.com/office/drawing/2014/main" id="{070C18C8-73C3-4913-BB35-7BD67F46FC34}"/>
+                <a16:creationId xmlns:a16="http://schemas.microsoft.com/office/drawing/2014/main" id="{CD28701C-3341-4DD4-91F2-6C09A984B963}"/>
               </a:ext>
             </a:extLst>
           </p:cNvPr>
@@ -7878,7 +7878,7 @@
           <p:nvPr/>
         </p:nvPicPr>
         <p:blipFill>
-          <a:blip xmlns:r="http://schemas.openxmlformats.org/officeDocument/2006/relationships" xmlns:a="http://schemas.openxmlformats.org/drawingml/2006/main" r:embed="Rbadbb76633b443eb"/>
+          <a:blip xmlns:r="http://schemas.openxmlformats.org/officeDocument/2006/relationships" xmlns:a="http://schemas.openxmlformats.org/drawingml/2006/main" r:embed="R76af84791d5f4af1"/>
           <a:stretch xmlns:a="http://schemas.openxmlformats.org/drawingml/2006/main"/>
         </p:blipFill>
         <p:spPr>
@@ -7896,7 +7896,7 @@
           <p:cNvPr id="8" name="">
             <a:extLst xmlns:a="http://schemas.openxmlformats.org/drawingml/2006/main">
               <a:ext uri="{FF2B5EF4-FFF2-40B4-BE49-F238E27FC236}">
-                <a16:creationId xmlns:a16="http://schemas.microsoft.com/office/drawing/2014/main" id="{3C34F519-796D-47BD-8382-94A28DB789C5}"/>
+                <a16:creationId xmlns:a16="http://schemas.microsoft.com/office/drawing/2014/main" id="{10941210-E686-4EAB-BBCB-F8F8A91DEEDC}"/>
               </a:ext>
             </a:extLst>
           </p:cNvPr>
@@ -7951,7 +7951,7 @@
     </p:spTree>
     <p:extLst>
       <p:ext uri="{BB962C8B-B14F-4D97-AF65-F5344CB8AC3E}">
-        <p14:creationId xmlns:p14="http://schemas.microsoft.com/office/powerpoint/2010/main" val="1392059056"/>
+        <p14:creationId xmlns:p14="http://schemas.microsoft.com/office/powerpoint/2010/main" val="238117640"/>
       </p:ext>
     </p:extLst>
   </p:cSld>
@@ -7982,7 +7982,7 @@
           <p:cNvPr id="9" name="">
             <a:extLst xmlns:a="http://schemas.openxmlformats.org/drawingml/2006/main">
               <a:ext uri="{FF2B5EF4-FFF2-40B4-BE49-F238E27FC236}">
-                <a16:creationId xmlns:a16="http://schemas.microsoft.com/office/drawing/2014/main" id="{FB31E435-08D1-4093-88B7-17068AE006DD}"/>
+                <a16:creationId xmlns:a16="http://schemas.microsoft.com/office/drawing/2014/main" id="{08169E1D-1C9D-4AB2-9883-2CA2363B2B31}"/>
               </a:ext>
             </a:extLst>
           </p:cNvPr>
@@ -8039,7 +8039,7 @@
           <p:cNvPr id="2" name="">
             <a:extLst xmlns:a="http://schemas.openxmlformats.org/drawingml/2006/main">
               <a:ext uri="{FF2B5EF4-FFF2-40B4-BE49-F238E27FC236}">
-                <a16:creationId xmlns:a16="http://schemas.microsoft.com/office/drawing/2014/main" id="{D5FB80D0-7926-492E-8E0C-0A5971AA8A6C}"/>
+                <a16:creationId xmlns:a16="http://schemas.microsoft.com/office/drawing/2014/main" id="{8D471CA7-BBDD-4F4C-B8D0-1C1EB1CDA066}"/>
               </a:ext>
             </a:extLst>
           </p:cNvPr>
@@ -8096,7 +8096,7 @@
           <p:cNvPr id="3" name="">
             <a:extLst xmlns:a="http://schemas.openxmlformats.org/drawingml/2006/main">
               <a:ext uri="{FF2B5EF4-FFF2-40B4-BE49-F238E27FC236}">
-                <a16:creationId xmlns:a16="http://schemas.microsoft.com/office/drawing/2014/main" id="{A195F3FE-F08A-4E36-830E-588DD6A215C5}"/>
+                <a16:creationId xmlns:a16="http://schemas.microsoft.com/office/drawing/2014/main" id="{3D95282F-F306-4279-BF24-1A2C9DBD65D0}"/>
               </a:ext>
             </a:extLst>
           </p:cNvPr>
@@ -8153,7 +8153,7 @@
           <p:cNvPr id="4" name="">
             <a:extLst xmlns:a="http://schemas.openxmlformats.org/drawingml/2006/main">
               <a:ext uri="{FF2B5EF4-FFF2-40B4-BE49-F238E27FC236}">
-                <a16:creationId xmlns:a16="http://schemas.microsoft.com/office/drawing/2014/main" id="{C6436AC0-E9FC-4905-92F6-3583D92B56F2}"/>
+                <a16:creationId xmlns:a16="http://schemas.microsoft.com/office/drawing/2014/main" id="{A62E0469-C510-45B9-8D2F-12FEA6018B5C}"/>
               </a:ext>
             </a:extLst>
           </p:cNvPr>
@@ -8302,7 +8302,7 @@
           <p:cNvPr id="5" name="">
             <a:extLst xmlns:a="http://schemas.openxmlformats.org/drawingml/2006/main">
               <a:ext uri="{FF2B5EF4-FFF2-40B4-BE49-F238E27FC236}">
-                <a16:creationId xmlns:a16="http://schemas.microsoft.com/office/drawing/2014/main" id="{93996F12-D036-46DB-BCC6-7AD8C1D6AB31}"/>
+                <a16:creationId xmlns:a16="http://schemas.microsoft.com/office/drawing/2014/main" id="{229F1365-17A5-4771-A209-693C7050E3A0}"/>
               </a:ext>
             </a:extLst>
           </p:cNvPr>
@@ -8359,7 +8359,7 @@
           <p:cNvPr id="6" name="">
             <a:extLst xmlns:a="http://schemas.openxmlformats.org/drawingml/2006/main">
               <a:ext uri="{FF2B5EF4-FFF2-40B4-BE49-F238E27FC236}">
-                <a16:creationId xmlns:a16="http://schemas.microsoft.com/office/drawing/2014/main" id="{ADE1A026-DF79-4CC9-AF6A-71E8C11A0B3D}"/>
+                <a16:creationId xmlns:a16="http://schemas.microsoft.com/office/drawing/2014/main" id="{A6D9439D-F6A1-43D1-8406-6947DC2E1846}"/>
               </a:ext>
             </a:extLst>
           </p:cNvPr>
@@ -8466,7 +8466,7 @@
           <p:nvPr/>
         </p:nvPicPr>
         <p:blipFill>
-          <a:blip xmlns:r="http://schemas.openxmlformats.org/officeDocument/2006/relationships" xmlns:a="http://schemas.openxmlformats.org/drawingml/2006/main" r:embed="Ra79bb23f60bb42a9"/>
+          <a:blip xmlns:r="http://schemas.openxmlformats.org/officeDocument/2006/relationships" xmlns:a="http://schemas.openxmlformats.org/drawingml/2006/main" r:embed="Rb2428260d95f43f8"/>
           <a:stretch xmlns:a="http://schemas.openxmlformats.org/drawingml/2006/main"/>
         </p:blipFill>
         <p:spPr>
@@ -8484,7 +8484,7 @@
           <p:cNvPr id="8" name="">
             <a:extLst xmlns:a="http://schemas.openxmlformats.org/drawingml/2006/main">
               <a:ext uri="{FF2B5EF4-FFF2-40B4-BE49-F238E27FC236}">
-                <a16:creationId xmlns:a16="http://schemas.microsoft.com/office/drawing/2014/main" id="{4A23A1DE-7161-4D02-BC5F-C73593B1FF91}"/>
+                <a16:creationId xmlns:a16="http://schemas.microsoft.com/office/drawing/2014/main" id="{1209B750-863A-481D-8FEF-4717DDA4B873}"/>
               </a:ext>
             </a:extLst>
           </p:cNvPr>
@@ -8539,7 +8539,7 @@
     </p:spTree>
     <p:extLst>
       <p:ext uri="{BB962C8B-B14F-4D97-AF65-F5344CB8AC3E}">
-        <p14:creationId xmlns:p14="http://schemas.microsoft.com/office/powerpoint/2010/main" val="2063069813"/>
+        <p14:creationId xmlns:p14="http://schemas.microsoft.com/office/powerpoint/2010/main" val="1024916977"/>
       </p:ext>
     </p:extLst>
   </p:cSld>
@@ -8570,7 +8570,7 @@
           <p:cNvPr id="9" name="">
             <a:extLst xmlns:a="http://schemas.openxmlformats.org/drawingml/2006/main">
               <a:ext uri="{FF2B5EF4-FFF2-40B4-BE49-F238E27FC236}">
-                <a16:creationId xmlns:a16="http://schemas.microsoft.com/office/drawing/2014/main" id="{50348621-E0E2-41C2-BD79-B6676BB0A49C}"/>
+                <a16:creationId xmlns:a16="http://schemas.microsoft.com/office/drawing/2014/main" id="{138A61EE-E7FC-42D2-A8FD-85F8DFD129E4}"/>
               </a:ext>
             </a:extLst>
           </p:cNvPr>
@@ -8627,7 +8627,7 @@
           <p:cNvPr id="2" name="">
             <a:extLst xmlns:a="http://schemas.openxmlformats.org/drawingml/2006/main">
               <a:ext uri="{FF2B5EF4-FFF2-40B4-BE49-F238E27FC236}">
-                <a16:creationId xmlns:a16="http://schemas.microsoft.com/office/drawing/2014/main" id="{F0964679-2A21-4DD9-818A-4F99FDAAC7ED}"/>
+                <a16:creationId xmlns:a16="http://schemas.microsoft.com/office/drawing/2014/main" id="{A4F9AAEF-A940-4543-AEEF-3AC790B7FFB5}"/>
               </a:ext>
             </a:extLst>
           </p:cNvPr>
@@ -8684,7 +8684,7 @@
           <p:cNvPr id="3" name="">
             <a:extLst xmlns:a="http://schemas.openxmlformats.org/drawingml/2006/main">
               <a:ext uri="{FF2B5EF4-FFF2-40B4-BE49-F238E27FC236}">
-                <a16:creationId xmlns:a16="http://schemas.microsoft.com/office/drawing/2014/main" id="{19D213DE-CF09-494C-A769-7D5C31D931FF}"/>
+                <a16:creationId xmlns:a16="http://schemas.microsoft.com/office/drawing/2014/main" id="{FE355B6A-354F-45AD-B9F3-BAA20F26DCCA}"/>
               </a:ext>
             </a:extLst>
           </p:cNvPr>
@@ -8741,7 +8741,7 @@
           <p:cNvPr id="4" name="">
             <a:extLst xmlns:a="http://schemas.openxmlformats.org/drawingml/2006/main">
               <a:ext uri="{FF2B5EF4-FFF2-40B4-BE49-F238E27FC236}">
-                <a16:creationId xmlns:a16="http://schemas.microsoft.com/office/drawing/2014/main" id="{E79D0293-B61A-4B9A-AAD6-A8E0EB6BE3B0}"/>
+                <a16:creationId xmlns:a16="http://schemas.microsoft.com/office/drawing/2014/main" id="{09C88F7D-850A-469F-876C-94066547EDF5}"/>
               </a:ext>
             </a:extLst>
           </p:cNvPr>
@@ -8844,7 +8844,7 @@
           <p:cNvPr id="5" name="">
             <a:extLst xmlns:a="http://schemas.openxmlformats.org/drawingml/2006/main">
               <a:ext uri="{FF2B5EF4-FFF2-40B4-BE49-F238E27FC236}">
-                <a16:creationId xmlns:a16="http://schemas.microsoft.com/office/drawing/2014/main" id="{BF68D862-F171-429E-8696-C88EA676F47F}"/>
+                <a16:creationId xmlns:a16="http://schemas.microsoft.com/office/drawing/2014/main" id="{C9166CB8-D597-4EF1-8747-A78C92CFF7E7}"/>
               </a:ext>
             </a:extLst>
           </p:cNvPr>
@@ -8901,7 +8901,7 @@
           <p:cNvPr id="6" name="">
             <a:extLst xmlns:a="http://schemas.openxmlformats.org/drawingml/2006/main">
               <a:ext uri="{FF2B5EF4-FFF2-40B4-BE49-F238E27FC236}">
-                <a16:creationId xmlns:a16="http://schemas.microsoft.com/office/drawing/2014/main" id="{35EB572E-1B0D-47B8-AC78-A3E14590867F}"/>
+                <a16:creationId xmlns:a16="http://schemas.microsoft.com/office/drawing/2014/main" id="{E64FD1BE-3F72-4CF6-AECF-98EEB79FD57E}"/>
               </a:ext>
             </a:extLst>
           </p:cNvPr>
@@ -9008,7 +9008,7 @@
           <p:nvPr/>
         </p:nvPicPr>
         <p:blipFill>
-          <a:blip xmlns:r="http://schemas.openxmlformats.org/officeDocument/2006/relationships" xmlns:a="http://schemas.openxmlformats.org/drawingml/2006/main" r:embed="R397dfb59903844a6"/>
+          <a:blip xmlns:r="http://schemas.openxmlformats.org/officeDocument/2006/relationships" xmlns:a="http://schemas.openxmlformats.org/drawingml/2006/main" r:embed="R3a3aeafb47d44a3e"/>
           <a:stretch xmlns:a="http://schemas.openxmlformats.org/drawingml/2006/main"/>
         </p:blipFill>
         <p:spPr>
@@ -9026,7 +9026,7 @@
           <p:cNvPr id="8" name="">
             <a:extLst xmlns:a="http://schemas.openxmlformats.org/drawingml/2006/main">
               <a:ext uri="{FF2B5EF4-FFF2-40B4-BE49-F238E27FC236}">
-                <a16:creationId xmlns:a16="http://schemas.microsoft.com/office/drawing/2014/main" id="{2A603CC7-405D-4AD0-9454-7599558160D8}"/>
+                <a16:creationId xmlns:a16="http://schemas.microsoft.com/office/drawing/2014/main" id="{C3C4717D-0C3C-4744-832A-AF85565ECA25}"/>
               </a:ext>
             </a:extLst>
           </p:cNvPr>
@@ -9081,7 +9081,7 @@
     </p:spTree>
     <p:extLst>
       <p:ext uri="{BB962C8B-B14F-4D97-AF65-F5344CB8AC3E}">
-        <p14:creationId xmlns:p14="http://schemas.microsoft.com/office/powerpoint/2010/main" val="866656310"/>
+        <p14:creationId xmlns:p14="http://schemas.microsoft.com/office/powerpoint/2010/main" val="157138548"/>
       </p:ext>
     </p:extLst>
   </p:cSld>
@@ -9112,7 +9112,7 @@
           <p:cNvPr id="9" name="">
             <a:extLst xmlns:a="http://schemas.openxmlformats.org/drawingml/2006/main">
               <a:ext uri="{FF2B5EF4-FFF2-40B4-BE49-F238E27FC236}">
-                <a16:creationId xmlns:a16="http://schemas.microsoft.com/office/drawing/2014/main" id="{78C5D4D2-D1FB-41D2-8F02-D89EB4DE3569}"/>
+                <a16:creationId xmlns:a16="http://schemas.microsoft.com/office/drawing/2014/main" id="{CB6A0EC7-A915-4200-8639-BDF1E2C398FC}"/>
               </a:ext>
             </a:extLst>
           </p:cNvPr>
@@ -9169,7 +9169,7 @@
           <p:cNvPr id="2" name="">
             <a:extLst xmlns:a="http://schemas.openxmlformats.org/drawingml/2006/main">
               <a:ext uri="{FF2B5EF4-FFF2-40B4-BE49-F238E27FC236}">
-                <a16:creationId xmlns:a16="http://schemas.microsoft.com/office/drawing/2014/main" id="{968E15D8-22FA-4CBD-AFC8-21C4E73863DB}"/>
+                <a16:creationId xmlns:a16="http://schemas.microsoft.com/office/drawing/2014/main" id="{9D71814C-1321-4CD6-A5E7-0DF79782D2FA}"/>
               </a:ext>
             </a:extLst>
           </p:cNvPr>
@@ -9226,7 +9226,7 @@
           <p:cNvPr id="3" name="">
             <a:extLst xmlns:a="http://schemas.openxmlformats.org/drawingml/2006/main">
               <a:ext uri="{FF2B5EF4-FFF2-40B4-BE49-F238E27FC236}">
-                <a16:creationId xmlns:a16="http://schemas.microsoft.com/office/drawing/2014/main" id="{6B2511B0-65A7-42F3-80AE-19BFBB878EF2}"/>
+                <a16:creationId xmlns:a16="http://schemas.microsoft.com/office/drawing/2014/main" id="{AEF0055B-CE12-4A84-8DCF-9C504E00F428}"/>
               </a:ext>
             </a:extLst>
           </p:cNvPr>
@@ -9283,7 +9283,7 @@
           <p:cNvPr id="4" name="">
             <a:extLst xmlns:a="http://schemas.openxmlformats.org/drawingml/2006/main">
               <a:ext uri="{FF2B5EF4-FFF2-40B4-BE49-F238E27FC236}">
-                <a16:creationId xmlns:a16="http://schemas.microsoft.com/office/drawing/2014/main" id="{AF02AA2A-566F-4938-B3D1-8A8642AF5C31}"/>
+                <a16:creationId xmlns:a16="http://schemas.microsoft.com/office/drawing/2014/main" id="{51E8B5B6-0550-448A-8378-3CD6F9C30D04}"/>
               </a:ext>
             </a:extLst>
           </p:cNvPr>
@@ -9386,7 +9386,7 @@
           <p:cNvPr id="5" name="">
             <a:extLst xmlns:a="http://schemas.openxmlformats.org/drawingml/2006/main">
               <a:ext uri="{FF2B5EF4-FFF2-40B4-BE49-F238E27FC236}">
-                <a16:creationId xmlns:a16="http://schemas.microsoft.com/office/drawing/2014/main" id="{BB5B0DF9-2DF9-417A-A9A1-2A8E25685561}"/>
+                <a16:creationId xmlns:a16="http://schemas.microsoft.com/office/drawing/2014/main" id="{1AFEDE04-C45F-490D-825D-3DD64F75DD77}"/>
               </a:ext>
             </a:extLst>
           </p:cNvPr>
@@ -9443,7 +9443,7 @@
           <p:cNvPr id="6" name="">
             <a:extLst xmlns:a="http://schemas.openxmlformats.org/drawingml/2006/main">
               <a:ext uri="{FF2B5EF4-FFF2-40B4-BE49-F238E27FC236}">
-                <a16:creationId xmlns:a16="http://schemas.microsoft.com/office/drawing/2014/main" id="{B4951B5D-9781-49AD-AC5E-2D456BBBB82B}"/>
+                <a16:creationId xmlns:a16="http://schemas.microsoft.com/office/drawing/2014/main" id="{94B90908-61CD-49C5-BFF2-A367DD26FA4D}"/>
               </a:ext>
             </a:extLst>
           </p:cNvPr>
@@ -9573,7 +9573,7 @@
           <p:nvPr/>
         </p:nvPicPr>
         <p:blipFill>
-          <a:blip xmlns:r="http://schemas.openxmlformats.org/officeDocument/2006/relationships" xmlns:a="http://schemas.openxmlformats.org/drawingml/2006/main" r:embed="R31c54abb1311458b"/>
+          <a:blip xmlns:r="http://schemas.openxmlformats.org/officeDocument/2006/relationships" xmlns:a="http://schemas.openxmlformats.org/drawingml/2006/main" r:embed="R051df38a9e424cbe"/>
           <a:stretch xmlns:a="http://schemas.openxmlformats.org/drawingml/2006/main"/>
         </p:blipFill>
         <p:spPr>
@@ -9591,7 +9591,7 @@
           <p:cNvPr id="8" name="">
             <a:extLst xmlns:a="http://schemas.openxmlformats.org/drawingml/2006/main">
               <a:ext uri="{FF2B5EF4-FFF2-40B4-BE49-F238E27FC236}">
-                <a16:creationId xmlns:a16="http://schemas.microsoft.com/office/drawing/2014/main" id="{10443B10-C073-4B3A-90D1-D9F23766EBB5}"/>
+                <a16:creationId xmlns:a16="http://schemas.microsoft.com/office/drawing/2014/main" id="{20500B7A-58A8-4441-8794-1ED65DCE0A01}"/>
               </a:ext>
             </a:extLst>
           </p:cNvPr>
@@ -9646,7 +9646,7 @@
     </p:spTree>
     <p:extLst>
       <p:ext uri="{BB962C8B-B14F-4D97-AF65-F5344CB8AC3E}">
-        <p14:creationId xmlns:p14="http://schemas.microsoft.com/office/powerpoint/2010/main" val="344236475"/>
+        <p14:creationId xmlns:p14="http://schemas.microsoft.com/office/powerpoint/2010/main" val="50360942"/>
       </p:ext>
     </p:extLst>
   </p:cSld>
@@ -9677,7 +9677,7 @@
           <p:cNvPr id="9" name="">
             <a:extLst xmlns:a="http://schemas.openxmlformats.org/drawingml/2006/main">
               <a:ext uri="{FF2B5EF4-FFF2-40B4-BE49-F238E27FC236}">
-                <a16:creationId xmlns:a16="http://schemas.microsoft.com/office/drawing/2014/main" id="{364AB225-4680-4BAA-A208-1BEEDDA66991}"/>
+                <a16:creationId xmlns:a16="http://schemas.microsoft.com/office/drawing/2014/main" id="{0001A98F-A5C6-4265-A9EA-2119F7AB8475}"/>
               </a:ext>
             </a:extLst>
           </p:cNvPr>
@@ -9734,7 +9734,7 @@
           <p:cNvPr id="2" name="">
             <a:extLst xmlns:a="http://schemas.openxmlformats.org/drawingml/2006/main">
               <a:ext uri="{FF2B5EF4-FFF2-40B4-BE49-F238E27FC236}">
-                <a16:creationId xmlns:a16="http://schemas.microsoft.com/office/drawing/2014/main" id="{C08F6CC0-7D4A-4C34-B40E-0BDA16399D76}"/>
+                <a16:creationId xmlns:a16="http://schemas.microsoft.com/office/drawing/2014/main" id="{322E976D-B574-46B9-8755-C6FDC6A45E61}"/>
               </a:ext>
             </a:extLst>
           </p:cNvPr>
@@ -9791,7 +9791,7 @@
           <p:cNvPr id="3" name="">
             <a:extLst xmlns:a="http://schemas.openxmlformats.org/drawingml/2006/main">
               <a:ext uri="{FF2B5EF4-FFF2-40B4-BE49-F238E27FC236}">
-                <a16:creationId xmlns:a16="http://schemas.microsoft.com/office/drawing/2014/main" id="{DA38218F-8193-4228-B956-02ABB7BFA832}"/>
+                <a16:creationId xmlns:a16="http://schemas.microsoft.com/office/drawing/2014/main" id="{64A17849-9CE4-4F3E-8435-B9AB69C3DB41}"/>
               </a:ext>
             </a:extLst>
           </p:cNvPr>
@@ -9848,7 +9848,7 @@
           <p:cNvPr id="4" name="">
             <a:extLst xmlns:a="http://schemas.openxmlformats.org/drawingml/2006/main">
               <a:ext uri="{FF2B5EF4-FFF2-40B4-BE49-F238E27FC236}">
-                <a16:creationId xmlns:a16="http://schemas.microsoft.com/office/drawing/2014/main" id="{0E7E185C-1183-4767-8DCB-B255E23B2406}"/>
+                <a16:creationId xmlns:a16="http://schemas.microsoft.com/office/drawing/2014/main" id="{1DA4109E-ECFA-4BF4-8225-05595E13806A}"/>
               </a:ext>
             </a:extLst>
           </p:cNvPr>
@@ -9974,7 +9974,7 @@
           <p:cNvPr id="5" name="">
             <a:extLst xmlns:a="http://schemas.openxmlformats.org/drawingml/2006/main">
               <a:ext uri="{FF2B5EF4-FFF2-40B4-BE49-F238E27FC236}">
-                <a16:creationId xmlns:a16="http://schemas.microsoft.com/office/drawing/2014/main" id="{2492F4EB-3041-4516-9B2E-B91DDAC294FE}"/>
+                <a16:creationId xmlns:a16="http://schemas.microsoft.com/office/drawing/2014/main" id="{1C5DD2C0-D5B4-40D0-B5CB-44292D3BC484}"/>
               </a:ext>
             </a:extLst>
           </p:cNvPr>
@@ -10031,7 +10031,7 @@
           <p:cNvPr id="6" name="">
             <a:extLst xmlns:a="http://schemas.openxmlformats.org/drawingml/2006/main">
               <a:ext uri="{FF2B5EF4-FFF2-40B4-BE49-F238E27FC236}">
-                <a16:creationId xmlns:a16="http://schemas.microsoft.com/office/drawing/2014/main" id="{E15EA0DC-FCBD-41C5-8699-BCA29C0D4E6E}"/>
+                <a16:creationId xmlns:a16="http://schemas.microsoft.com/office/drawing/2014/main" id="{F38B54D3-AEA0-471E-9FF5-33A74E28D89A}"/>
               </a:ext>
             </a:extLst>
           </p:cNvPr>
@@ -10161,7 +10161,7 @@
           <p:nvPr/>
         </p:nvPicPr>
         <p:blipFill>
-          <a:blip xmlns:r="http://schemas.openxmlformats.org/officeDocument/2006/relationships" xmlns:a="http://schemas.openxmlformats.org/drawingml/2006/main" r:embed="R82c86e6455e540c4"/>
+          <a:blip xmlns:r="http://schemas.openxmlformats.org/officeDocument/2006/relationships" xmlns:a="http://schemas.openxmlformats.org/drawingml/2006/main" r:embed="Rd53a1f04f0ef448c"/>
           <a:stretch xmlns:a="http://schemas.openxmlformats.org/drawingml/2006/main"/>
         </p:blipFill>
         <p:spPr>
@@ -10179,7 +10179,7 @@
           <p:cNvPr id="8" name="">
             <a:extLst xmlns:a="http://schemas.openxmlformats.org/drawingml/2006/main">
               <a:ext uri="{FF2B5EF4-FFF2-40B4-BE49-F238E27FC236}">
-                <a16:creationId xmlns:a16="http://schemas.microsoft.com/office/drawing/2014/main" id="{A75BDC4A-965F-4D99-9095-3FB2D3379774}"/>
+                <a16:creationId xmlns:a16="http://schemas.microsoft.com/office/drawing/2014/main" id="{9A753614-6812-4CAB-8078-638D0FDD0791}"/>
               </a:ext>
             </a:extLst>
           </p:cNvPr>
@@ -10234,7 +10234,7 @@
     </p:spTree>
     <p:extLst>
       <p:ext uri="{BB962C8B-B14F-4D97-AF65-F5344CB8AC3E}">
-        <p14:creationId xmlns:p14="http://schemas.microsoft.com/office/powerpoint/2010/main" val="1570039632"/>
+        <p14:creationId xmlns:p14="http://schemas.microsoft.com/office/powerpoint/2010/main" val="845584386"/>
       </p:ext>
     </p:extLst>
   </p:cSld>
@@ -10265,7 +10265,7 @@
           <p:cNvPr id="9" name="">
             <a:extLst xmlns:a="http://schemas.openxmlformats.org/drawingml/2006/main">
               <a:ext uri="{FF2B5EF4-FFF2-40B4-BE49-F238E27FC236}">
-                <a16:creationId xmlns:a16="http://schemas.microsoft.com/office/drawing/2014/main" id="{8FCC6EB4-0250-4692-A9BE-74CBDB2AAB0D}"/>
+                <a16:creationId xmlns:a16="http://schemas.microsoft.com/office/drawing/2014/main" id="{64BCCDA6-4D3E-4168-A9DB-1E767F06BFA9}"/>
               </a:ext>
             </a:extLst>
           </p:cNvPr>
@@ -10322,7 +10322,7 @@
           <p:cNvPr id="2" name="">
             <a:extLst xmlns:a="http://schemas.openxmlformats.org/drawingml/2006/main">
               <a:ext uri="{FF2B5EF4-FFF2-40B4-BE49-F238E27FC236}">
-                <a16:creationId xmlns:a16="http://schemas.microsoft.com/office/drawing/2014/main" id="{D8B10BFE-DFD0-48D6-A673-392A45AC84C4}"/>
+                <a16:creationId xmlns:a16="http://schemas.microsoft.com/office/drawing/2014/main" id="{EBD23C16-353A-4900-A379-5DA4E343FCCE}"/>
               </a:ext>
             </a:extLst>
           </p:cNvPr>
@@ -10379,7 +10379,7 @@
           <p:cNvPr id="3" name="">
             <a:extLst xmlns:a="http://schemas.openxmlformats.org/drawingml/2006/main">
               <a:ext uri="{FF2B5EF4-FFF2-40B4-BE49-F238E27FC236}">
-                <a16:creationId xmlns:a16="http://schemas.microsoft.com/office/drawing/2014/main" id="{3D17B2A7-905F-41DC-9C67-8A6D1C71FBB2}"/>
+                <a16:creationId xmlns:a16="http://schemas.microsoft.com/office/drawing/2014/main" id="{07B63F95-B5B5-4E98-9D67-EE3CDB0C206D}"/>
               </a:ext>
             </a:extLst>
           </p:cNvPr>
@@ -10436,7 +10436,7 @@
           <p:cNvPr id="4" name="">
             <a:extLst xmlns:a="http://schemas.openxmlformats.org/drawingml/2006/main">
               <a:ext uri="{FF2B5EF4-FFF2-40B4-BE49-F238E27FC236}">
-                <a16:creationId xmlns:a16="http://schemas.microsoft.com/office/drawing/2014/main" id="{8B2E530F-2F36-4447-95CC-1FD67719A54D}"/>
+                <a16:creationId xmlns:a16="http://schemas.microsoft.com/office/drawing/2014/main" id="{6C9102E8-3F5C-4E48-A41D-183E4AD43238}"/>
               </a:ext>
             </a:extLst>
           </p:cNvPr>
@@ -10562,7 +10562,7 @@
           <p:cNvPr id="5" name="">
             <a:extLst xmlns:a="http://schemas.openxmlformats.org/drawingml/2006/main">
               <a:ext uri="{FF2B5EF4-FFF2-40B4-BE49-F238E27FC236}">
-                <a16:creationId xmlns:a16="http://schemas.microsoft.com/office/drawing/2014/main" id="{B514A46C-0115-48EE-B753-1818FE0056B8}"/>
+                <a16:creationId xmlns:a16="http://schemas.microsoft.com/office/drawing/2014/main" id="{26B64A44-DB15-4091-B608-67490FC1CF0E}"/>
               </a:ext>
             </a:extLst>
           </p:cNvPr>
@@ -10619,7 +10619,7 @@
           <p:cNvPr id="6" name="">
             <a:extLst xmlns:a="http://schemas.openxmlformats.org/drawingml/2006/main">
               <a:ext uri="{FF2B5EF4-FFF2-40B4-BE49-F238E27FC236}">
-                <a16:creationId xmlns:a16="http://schemas.microsoft.com/office/drawing/2014/main" id="{ADE06057-CBE4-4AC3-973D-A1523C052FAF}"/>
+                <a16:creationId xmlns:a16="http://schemas.microsoft.com/office/drawing/2014/main" id="{28162267-9718-4F2A-B7DC-1C583C297765}"/>
               </a:ext>
             </a:extLst>
           </p:cNvPr>
@@ -10749,7 +10749,7 @@
           <p:nvPr/>
         </p:nvPicPr>
         <p:blipFill>
-          <a:blip xmlns:r="http://schemas.openxmlformats.org/officeDocument/2006/relationships" xmlns:a="http://schemas.openxmlformats.org/drawingml/2006/main" r:embed="Rba3812fad571415c"/>
+          <a:blip xmlns:r="http://schemas.openxmlformats.org/officeDocument/2006/relationships" xmlns:a="http://schemas.openxmlformats.org/drawingml/2006/main" r:embed="R262de6c4280f4965"/>
           <a:stretch xmlns:a="http://schemas.openxmlformats.org/drawingml/2006/main"/>
         </p:blipFill>
         <p:spPr>
@@ -10767,7 +10767,7 @@
           <p:cNvPr id="8" name="">
             <a:extLst xmlns:a="http://schemas.openxmlformats.org/drawingml/2006/main">
               <a:ext uri="{FF2B5EF4-FFF2-40B4-BE49-F238E27FC236}">
-                <a16:creationId xmlns:a16="http://schemas.microsoft.com/office/drawing/2014/main" id="{E1947971-9820-45F8-9FD9-C5610EFF924C}"/>
+                <a16:creationId xmlns:a16="http://schemas.microsoft.com/office/drawing/2014/main" id="{08936293-379C-4F63-B9FE-64183238AFF2}"/>
               </a:ext>
             </a:extLst>
           </p:cNvPr>
@@ -10822,7 +10822,7 @@
     </p:spTree>
     <p:extLst>
       <p:ext uri="{BB962C8B-B14F-4D97-AF65-F5344CB8AC3E}">
-        <p14:creationId xmlns:p14="http://schemas.microsoft.com/office/powerpoint/2010/main" val="420557436"/>
+        <p14:creationId xmlns:p14="http://schemas.microsoft.com/office/powerpoint/2010/main" val="1352816821"/>
       </p:ext>
     </p:extLst>
   </p:cSld>
@@ -10853,7 +10853,7 @@
           <p:cNvPr id="9" name="">
             <a:extLst xmlns:a="http://schemas.openxmlformats.org/drawingml/2006/main">
               <a:ext uri="{FF2B5EF4-FFF2-40B4-BE49-F238E27FC236}">
-                <a16:creationId xmlns:a16="http://schemas.microsoft.com/office/drawing/2014/main" id="{A7C968E7-E6D7-4F36-92FB-D88AB51D8BC2}"/>
+                <a16:creationId xmlns:a16="http://schemas.microsoft.com/office/drawing/2014/main" id="{B9E3ACD0-4EF4-4E42-A39A-60A567BAAD93}"/>
               </a:ext>
             </a:extLst>
           </p:cNvPr>
@@ -10910,7 +10910,7 @@
           <p:cNvPr id="2" name="">
             <a:extLst xmlns:a="http://schemas.openxmlformats.org/drawingml/2006/main">
               <a:ext uri="{FF2B5EF4-FFF2-40B4-BE49-F238E27FC236}">
-                <a16:creationId xmlns:a16="http://schemas.microsoft.com/office/drawing/2014/main" id="{EAA24084-1F25-4BED-B4B6-011140E7ACDB}"/>
+                <a16:creationId xmlns:a16="http://schemas.microsoft.com/office/drawing/2014/main" id="{601278FB-F7A8-45EF-AC64-2D82145EB4CF}"/>
               </a:ext>
             </a:extLst>
           </p:cNvPr>
@@ -10967,7 +10967,7 @@
           <p:cNvPr id="3" name="">
             <a:extLst xmlns:a="http://schemas.openxmlformats.org/drawingml/2006/main">
               <a:ext uri="{FF2B5EF4-FFF2-40B4-BE49-F238E27FC236}">
-                <a16:creationId xmlns:a16="http://schemas.microsoft.com/office/drawing/2014/main" id="{5DC6F61E-2C12-46D5-9E36-D973400EAA09}"/>
+                <a16:creationId xmlns:a16="http://schemas.microsoft.com/office/drawing/2014/main" id="{EB84986E-2F74-4ADC-A78D-08C659F33AF0}"/>
               </a:ext>
             </a:extLst>
           </p:cNvPr>
@@ -11024,7 +11024,7 @@
           <p:cNvPr id="4" name="">
             <a:extLst xmlns:a="http://schemas.openxmlformats.org/drawingml/2006/main">
               <a:ext uri="{FF2B5EF4-FFF2-40B4-BE49-F238E27FC236}">
-                <a16:creationId xmlns:a16="http://schemas.microsoft.com/office/drawing/2014/main" id="{B481BCBE-C75B-4D84-838F-C442207FD45E}"/>
+                <a16:creationId xmlns:a16="http://schemas.microsoft.com/office/drawing/2014/main" id="{CE715729-9CEF-4BDB-B76A-6311EB4C4151}"/>
               </a:ext>
             </a:extLst>
           </p:cNvPr>
@@ -11150,7 +11150,7 @@
           <p:cNvPr id="5" name="">
             <a:extLst xmlns:a="http://schemas.openxmlformats.org/drawingml/2006/main">
               <a:ext uri="{FF2B5EF4-FFF2-40B4-BE49-F238E27FC236}">
-                <a16:creationId xmlns:a16="http://schemas.microsoft.com/office/drawing/2014/main" id="{B15EA7D2-5134-44D2-81D8-5377C4F25FF4}"/>
+                <a16:creationId xmlns:a16="http://schemas.microsoft.com/office/drawing/2014/main" id="{A4D0C4ED-7C87-4301-A26C-C75FB8EEE5C3}"/>
               </a:ext>
             </a:extLst>
           </p:cNvPr>
@@ -11207,7 +11207,7 @@
           <p:cNvPr id="6" name="">
             <a:extLst xmlns:a="http://schemas.openxmlformats.org/drawingml/2006/main">
               <a:ext uri="{FF2B5EF4-FFF2-40B4-BE49-F238E27FC236}">
-                <a16:creationId xmlns:a16="http://schemas.microsoft.com/office/drawing/2014/main" id="{EF97240B-E6A5-441B-BA5A-7D68C03143A1}"/>
+                <a16:creationId xmlns:a16="http://schemas.microsoft.com/office/drawing/2014/main" id="{D0F758F0-D55D-4DE1-A64F-490B7CD7DCE7}"/>
               </a:ext>
             </a:extLst>
           </p:cNvPr>
@@ -11360,7 +11360,7 @@
           <p:nvPr/>
         </p:nvPicPr>
         <p:blipFill>
-          <a:blip xmlns:r="http://schemas.openxmlformats.org/officeDocument/2006/relationships" xmlns:a="http://schemas.openxmlformats.org/drawingml/2006/main" r:embed="Rb569c74b1ea34e20"/>
+          <a:blip xmlns:r="http://schemas.openxmlformats.org/officeDocument/2006/relationships" xmlns:a="http://schemas.openxmlformats.org/drawingml/2006/main" r:embed="Rf23b3d1230694c0e"/>
           <a:stretch xmlns:a="http://schemas.openxmlformats.org/drawingml/2006/main"/>
         </p:blipFill>
         <p:spPr>
@@ -11378,7 +11378,7 @@
           <p:cNvPr id="8" name="">
             <a:extLst xmlns:a="http://schemas.openxmlformats.org/drawingml/2006/main">
               <a:ext uri="{FF2B5EF4-FFF2-40B4-BE49-F238E27FC236}">
-                <a16:creationId xmlns:a16="http://schemas.microsoft.com/office/drawing/2014/main" id="{B36AD5B8-19BE-46A0-A92C-496AAC99F841}"/>
+                <a16:creationId xmlns:a16="http://schemas.microsoft.com/office/drawing/2014/main" id="{0BC567FB-7B0D-46A5-AC34-F76BB5CAD89F}"/>
               </a:ext>
             </a:extLst>
           </p:cNvPr>
@@ -11433,7 +11433,7 @@
     </p:spTree>
     <p:extLst>
       <p:ext uri="{BB962C8B-B14F-4D97-AF65-F5344CB8AC3E}">
-        <p14:creationId xmlns:p14="http://schemas.microsoft.com/office/powerpoint/2010/main" val="1523279534"/>
+        <p14:creationId xmlns:p14="http://schemas.microsoft.com/office/powerpoint/2010/main" val="953152982"/>
       </p:ext>
     </p:extLst>
   </p:cSld>
@@ -11464,7 +11464,7 @@
           <p:cNvPr id="9" name="">
             <a:extLst xmlns:a="http://schemas.openxmlformats.org/drawingml/2006/main">
               <a:ext uri="{FF2B5EF4-FFF2-40B4-BE49-F238E27FC236}">
-                <a16:creationId xmlns:a16="http://schemas.microsoft.com/office/drawing/2014/main" id="{A4F9A4D8-3AF0-414D-821A-ECCEC695AF62}"/>
+                <a16:creationId xmlns:a16="http://schemas.microsoft.com/office/drawing/2014/main" id="{48BC787A-4A7F-48DC-BCA1-A8C0AB70D887}"/>
               </a:ext>
             </a:extLst>
           </p:cNvPr>
@@ -11521,7 +11521,7 @@
           <p:cNvPr id="2" name="">
             <a:extLst xmlns:a="http://schemas.openxmlformats.org/drawingml/2006/main">
               <a:ext uri="{FF2B5EF4-FFF2-40B4-BE49-F238E27FC236}">
-                <a16:creationId xmlns:a16="http://schemas.microsoft.com/office/drawing/2014/main" id="{2023DAA3-3A2C-4074-82A6-D47CA01E469E}"/>
+                <a16:creationId xmlns:a16="http://schemas.microsoft.com/office/drawing/2014/main" id="{279DB0A9-40A0-43EA-84DA-EBFF7C790579}"/>
               </a:ext>
             </a:extLst>
           </p:cNvPr>
@@ -11578,7 +11578,7 @@
           <p:cNvPr id="3" name="">
             <a:extLst xmlns:a="http://schemas.openxmlformats.org/drawingml/2006/main">
               <a:ext uri="{FF2B5EF4-FFF2-40B4-BE49-F238E27FC236}">
-                <a16:creationId xmlns:a16="http://schemas.microsoft.com/office/drawing/2014/main" id="{5FD4E4B7-82D0-4DE3-97B1-E6D2B7FE00BC}"/>
+                <a16:creationId xmlns:a16="http://schemas.microsoft.com/office/drawing/2014/main" id="{E311F3B5-5CD5-40EE-8421-18B52ABE33D0}"/>
               </a:ext>
             </a:extLst>
           </p:cNvPr>
@@ -11635,7 +11635,7 @@
           <p:cNvPr id="4" name="">
             <a:extLst xmlns:a="http://schemas.openxmlformats.org/drawingml/2006/main">
               <a:ext uri="{FF2B5EF4-FFF2-40B4-BE49-F238E27FC236}">
-                <a16:creationId xmlns:a16="http://schemas.microsoft.com/office/drawing/2014/main" id="{5AA880C3-5F7D-4F1D-8E9A-18344C19D92F}"/>
+                <a16:creationId xmlns:a16="http://schemas.microsoft.com/office/drawing/2014/main" id="{AFF774AE-BC8A-4F83-A2D0-EE2C86D8EC57}"/>
               </a:ext>
             </a:extLst>
           </p:cNvPr>
@@ -11738,7 +11738,7 @@
           <p:cNvPr id="5" name="">
             <a:extLst xmlns:a="http://schemas.openxmlformats.org/drawingml/2006/main">
               <a:ext uri="{FF2B5EF4-FFF2-40B4-BE49-F238E27FC236}">
-                <a16:creationId xmlns:a16="http://schemas.microsoft.com/office/drawing/2014/main" id="{A9721B7C-2C41-45C7-BA91-96980FEAD134}"/>
+                <a16:creationId xmlns:a16="http://schemas.microsoft.com/office/drawing/2014/main" id="{020B628D-7506-4E80-8A60-B1FE7277A4E9}"/>
               </a:ext>
             </a:extLst>
           </p:cNvPr>
@@ -11795,7 +11795,7 @@
           <p:cNvPr id="6" name="">
             <a:extLst xmlns:a="http://schemas.openxmlformats.org/drawingml/2006/main">
               <a:ext uri="{FF2B5EF4-FFF2-40B4-BE49-F238E27FC236}">
-                <a16:creationId xmlns:a16="http://schemas.microsoft.com/office/drawing/2014/main" id="{BDCED268-3D8F-4745-BC5E-9594ED6EB768}"/>
+                <a16:creationId xmlns:a16="http://schemas.microsoft.com/office/drawing/2014/main" id="{8F865B55-F02E-4B01-A4B0-C6EB064493E3}"/>
               </a:ext>
             </a:extLst>
           </p:cNvPr>
@@ -11925,7 +11925,7 @@
           <p:nvPr/>
         </p:nvPicPr>
         <p:blipFill>
-          <a:blip xmlns:r="http://schemas.openxmlformats.org/officeDocument/2006/relationships" xmlns:a="http://schemas.openxmlformats.org/drawingml/2006/main" r:embed="R6ecc18ed4e834f75"/>
+          <a:blip xmlns:r="http://schemas.openxmlformats.org/officeDocument/2006/relationships" xmlns:a="http://schemas.openxmlformats.org/drawingml/2006/main" r:embed="R81d3563418624d5b"/>
           <a:stretch xmlns:a="http://schemas.openxmlformats.org/drawingml/2006/main"/>
         </p:blipFill>
         <p:spPr>
@@ -11943,7 +11943,7 @@
           <p:cNvPr id="8" name="">
             <a:extLst xmlns:a="http://schemas.openxmlformats.org/drawingml/2006/main">
               <a:ext uri="{FF2B5EF4-FFF2-40B4-BE49-F238E27FC236}">
-                <a16:creationId xmlns:a16="http://schemas.microsoft.com/office/drawing/2014/main" id="{08438DC4-5C1E-4851-A9A6-727B40380344}"/>
+                <a16:creationId xmlns:a16="http://schemas.microsoft.com/office/drawing/2014/main" id="{0C063F5F-341D-4966-A261-02CF923A4886}"/>
               </a:ext>
             </a:extLst>
           </p:cNvPr>
@@ -11998,7 +11998,7 @@
     </p:spTree>
     <p:extLst>
       <p:ext uri="{BB962C8B-B14F-4D97-AF65-F5344CB8AC3E}">
-        <p14:creationId xmlns:p14="http://schemas.microsoft.com/office/powerpoint/2010/main" val="2000740456"/>
+        <p14:creationId xmlns:p14="http://schemas.microsoft.com/office/powerpoint/2010/main" val="1192179294"/>
       </p:ext>
     </p:extLst>
   </p:cSld>
@@ -12029,7 +12029,7 @@
           <p:cNvPr id="12" name="">
             <a:extLst xmlns:a="http://schemas.openxmlformats.org/drawingml/2006/main">
               <a:ext uri="{FF2B5EF4-FFF2-40B4-BE49-F238E27FC236}">
-                <a16:creationId xmlns:a16="http://schemas.microsoft.com/office/drawing/2014/main" id="{6C3A3DF2-37F9-4428-AAD6-8BBB8BD7345A}"/>
+                <a16:creationId xmlns:a16="http://schemas.microsoft.com/office/drawing/2014/main" id="{98550BBD-F920-411D-BA1C-0C7B8176D6CF}"/>
               </a:ext>
             </a:extLst>
           </p:cNvPr>
@@ -12086,7 +12086,7 @@
           <p:cNvPr id="2" name="">
             <a:extLst xmlns:a="http://schemas.openxmlformats.org/drawingml/2006/main">
               <a:ext uri="{FF2B5EF4-FFF2-40B4-BE49-F238E27FC236}">
-                <a16:creationId xmlns:a16="http://schemas.microsoft.com/office/drawing/2014/main" id="{3AF8DA37-E5FB-474A-8227-B13F5580F62A}"/>
+                <a16:creationId xmlns:a16="http://schemas.microsoft.com/office/drawing/2014/main" id="{DEBA1374-AC7A-43AF-8BAF-DE09EB3C430A}"/>
               </a:ext>
             </a:extLst>
           </p:cNvPr>
@@ -12143,7 +12143,7 @@
           <p:cNvPr id="3" name="">
             <a:extLst xmlns:a="http://schemas.openxmlformats.org/drawingml/2006/main">
               <a:ext uri="{FF2B5EF4-FFF2-40B4-BE49-F238E27FC236}">
-                <a16:creationId xmlns:a16="http://schemas.microsoft.com/office/drawing/2014/main" id="{E8AEC477-0849-4271-A18D-11CCE2C498B5}"/>
+                <a16:creationId xmlns:a16="http://schemas.microsoft.com/office/drawing/2014/main" id="{BCD93677-B8BA-4D5A-85F0-7A9F5E40CA64}"/>
               </a:ext>
             </a:extLst>
           </p:cNvPr>
@@ -12200,7 +12200,7 @@
           <p:cNvPr id="4" name="">
             <a:extLst xmlns:a="http://schemas.openxmlformats.org/drawingml/2006/main">
               <a:ext uri="{FF2B5EF4-FFF2-40B4-BE49-F238E27FC236}">
-                <a16:creationId xmlns:a16="http://schemas.microsoft.com/office/drawing/2014/main" id="{9ADCC059-7D07-4DEF-94C4-F1571A1B2BF7}"/>
+                <a16:creationId xmlns:a16="http://schemas.microsoft.com/office/drawing/2014/main" id="{E2DC8C60-E324-4A37-863B-02E13E468BF2}"/>
               </a:ext>
             </a:extLst>
           </p:cNvPr>
@@ -12280,7 +12280,7 @@
           <p:cNvPr id="5" name="">
             <a:extLst xmlns:a="http://schemas.openxmlformats.org/drawingml/2006/main">
               <a:ext uri="{FF2B5EF4-FFF2-40B4-BE49-F238E27FC236}">
-                <a16:creationId xmlns:a16="http://schemas.microsoft.com/office/drawing/2014/main" id="{E8BC6AC7-B29C-48D6-81FC-8F1341188FAB}"/>
+                <a16:creationId xmlns:a16="http://schemas.microsoft.com/office/drawing/2014/main" id="{C8A34185-092A-408B-B39D-DEE719847B94}"/>
               </a:ext>
             </a:extLst>
           </p:cNvPr>
@@ -12337,7 +12337,7 @@
           <p:cNvPr id="6" name="">
             <a:extLst xmlns:a="http://schemas.openxmlformats.org/drawingml/2006/main">
               <a:ext uri="{FF2B5EF4-FFF2-40B4-BE49-F238E27FC236}">
-                <a16:creationId xmlns:a16="http://schemas.microsoft.com/office/drawing/2014/main" id="{2931CA42-7CC6-45EB-88B8-B59DE41067A8}"/>
+                <a16:creationId xmlns:a16="http://schemas.microsoft.com/office/drawing/2014/main" id="{576EE231-D382-43BD-B969-7BE8AB0B92EC}"/>
               </a:ext>
             </a:extLst>
           </p:cNvPr>
@@ -12463,7 +12463,7 @@
           <p:cNvPr id="7" name="">
             <a:extLst xmlns:a="http://schemas.openxmlformats.org/drawingml/2006/main">
               <a:ext uri="{FF2B5EF4-FFF2-40B4-BE49-F238E27FC236}">
-                <a16:creationId xmlns:a16="http://schemas.microsoft.com/office/drawing/2014/main" id="{2CF5926F-7D21-485E-B3D0-7CD6FC17CBF0}"/>
+                <a16:creationId xmlns:a16="http://schemas.microsoft.com/office/drawing/2014/main" id="{59EB5D2F-B3CE-4987-AD56-AC3E8647D21A}"/>
               </a:ext>
             </a:extLst>
           </p:cNvPr>
@@ -12520,7 +12520,7 @@
           <p:cNvPr id="8" name="">
             <a:extLst xmlns:a="http://schemas.openxmlformats.org/drawingml/2006/main">
               <a:ext uri="{FF2B5EF4-FFF2-40B4-BE49-F238E27FC236}">
-                <a16:creationId xmlns:a16="http://schemas.microsoft.com/office/drawing/2014/main" id="{A018CB79-5FDE-41E5-A0E8-AD1E42B8CCBA}"/>
+                <a16:creationId xmlns:a16="http://schemas.microsoft.com/office/drawing/2014/main" id="{AC55894B-08D2-4CEA-B573-211A3CC0567E}"/>
               </a:ext>
             </a:extLst>
           </p:cNvPr>
@@ -12623,7 +12623,7 @@
           <p:cNvPr id="9" name="">
             <a:extLst xmlns:a="http://schemas.openxmlformats.org/drawingml/2006/main">
               <a:ext uri="{FF2B5EF4-FFF2-40B4-BE49-F238E27FC236}">
-                <a16:creationId xmlns:a16="http://schemas.microsoft.com/office/drawing/2014/main" id="{508B8F2D-2DE8-42D2-A45F-D0FFA99E9B16}"/>
+                <a16:creationId xmlns:a16="http://schemas.microsoft.com/office/drawing/2014/main" id="{91973C99-8037-4058-959C-5071E4857E5A}"/>
               </a:ext>
             </a:extLst>
           </p:cNvPr>
@@ -12680,7 +12680,7 @@
           <p:cNvPr id="10" name="">
             <a:extLst xmlns:a="http://schemas.openxmlformats.org/drawingml/2006/main">
               <a:ext uri="{FF2B5EF4-FFF2-40B4-BE49-F238E27FC236}">
-                <a16:creationId xmlns:a16="http://schemas.microsoft.com/office/drawing/2014/main" id="{5AB1911F-CC67-48BF-A3EA-56CCE66266DA}"/>
+                <a16:creationId xmlns:a16="http://schemas.microsoft.com/office/drawing/2014/main" id="{70E7D912-28CB-43B8-9590-E507256E62E5}"/>
               </a:ext>
             </a:extLst>
           </p:cNvPr>
@@ -12783,7 +12783,7 @@
           <p:cNvPr id="11" name="">
             <a:extLst xmlns:a="http://schemas.openxmlformats.org/drawingml/2006/main">
               <a:ext uri="{FF2B5EF4-FFF2-40B4-BE49-F238E27FC236}">
-                <a16:creationId xmlns:a16="http://schemas.microsoft.com/office/drawing/2014/main" id="{2B6428F7-F03F-45DA-AE32-26246EDB4E9D}"/>
+                <a16:creationId xmlns:a16="http://schemas.microsoft.com/office/drawing/2014/main" id="{2AADD109-0EB9-481E-83A0-B82CB50ADB60}"/>
               </a:ext>
             </a:extLst>
           </p:cNvPr>
@@ -12838,7 +12838,7 @@
     </p:spTree>
     <p:extLst>
       <p:ext uri="{BB962C8B-B14F-4D97-AF65-F5344CB8AC3E}">
-        <p14:creationId xmlns:p14="http://schemas.microsoft.com/office/powerpoint/2010/main" val="604859666"/>
+        <p14:creationId xmlns:p14="http://schemas.microsoft.com/office/powerpoint/2010/main" val="1951923478"/>
       </p:ext>
     </p:extLst>
   </p:cSld>
@@ -12869,7 +12869,7 @@
           <p:cNvPr id="12" name="">
             <a:extLst xmlns:a="http://schemas.openxmlformats.org/drawingml/2006/main">
               <a:ext uri="{FF2B5EF4-FFF2-40B4-BE49-F238E27FC236}">
-                <a16:creationId xmlns:a16="http://schemas.microsoft.com/office/drawing/2014/main" id="{203E9E45-2CC8-4942-B3FE-8AD5C9068487}"/>
+                <a16:creationId xmlns:a16="http://schemas.microsoft.com/office/drawing/2014/main" id="{58FF90B7-1855-4F10-93C8-66584C3B3ED8}"/>
               </a:ext>
             </a:extLst>
           </p:cNvPr>
@@ -12926,7 +12926,7 @@
           <p:cNvPr id="2" name="">
             <a:extLst xmlns:a="http://schemas.openxmlformats.org/drawingml/2006/main">
               <a:ext uri="{FF2B5EF4-FFF2-40B4-BE49-F238E27FC236}">
-                <a16:creationId xmlns:a16="http://schemas.microsoft.com/office/drawing/2014/main" id="{28DAF779-2F10-47ED-9AF4-90EE4EB595D5}"/>
+                <a16:creationId xmlns:a16="http://schemas.microsoft.com/office/drawing/2014/main" id="{BD77DED1-16C3-44A7-A930-C2B7A6CFF0C0}"/>
               </a:ext>
             </a:extLst>
           </p:cNvPr>
@@ -12983,7 +12983,7 @@
           <p:cNvPr id="3" name="">
             <a:extLst xmlns:a="http://schemas.openxmlformats.org/drawingml/2006/main">
               <a:ext uri="{FF2B5EF4-FFF2-40B4-BE49-F238E27FC236}">
-                <a16:creationId xmlns:a16="http://schemas.microsoft.com/office/drawing/2014/main" id="{37797A0D-B68C-4C91-9EC5-EFA51BB3C5FA}"/>
+                <a16:creationId xmlns:a16="http://schemas.microsoft.com/office/drawing/2014/main" id="{34A68836-00B4-4BB2-BE0D-34D7B9BCC8E3}"/>
               </a:ext>
             </a:extLst>
           </p:cNvPr>
@@ -13040,7 +13040,7 @@
           <p:cNvPr id="4" name="">
             <a:extLst xmlns:a="http://schemas.openxmlformats.org/drawingml/2006/main">
               <a:ext uri="{FF2B5EF4-FFF2-40B4-BE49-F238E27FC236}">
-                <a16:creationId xmlns:a16="http://schemas.microsoft.com/office/drawing/2014/main" id="{34CAB15F-662F-471B-88D1-20A0C75B3031}"/>
+                <a16:creationId xmlns:a16="http://schemas.microsoft.com/office/drawing/2014/main" id="{62447111-6025-4FFC-9BE7-25AF9DA72611}"/>
               </a:ext>
             </a:extLst>
           </p:cNvPr>
@@ -13120,7 +13120,7 @@
           <p:cNvPr id="5" name="">
             <a:extLst xmlns:a="http://schemas.openxmlformats.org/drawingml/2006/main">
               <a:ext uri="{FF2B5EF4-FFF2-40B4-BE49-F238E27FC236}">
-                <a16:creationId xmlns:a16="http://schemas.microsoft.com/office/drawing/2014/main" id="{F9432F5E-27FD-4420-AFBC-0721687BAEF9}"/>
+                <a16:creationId xmlns:a16="http://schemas.microsoft.com/office/drawing/2014/main" id="{157087FA-3F61-4A96-BA95-6C7401B54E59}"/>
               </a:ext>
             </a:extLst>
           </p:cNvPr>
@@ -13177,7 +13177,7 @@
           <p:cNvPr id="6" name="">
             <a:extLst xmlns:a="http://schemas.openxmlformats.org/drawingml/2006/main">
               <a:ext uri="{FF2B5EF4-FFF2-40B4-BE49-F238E27FC236}">
-                <a16:creationId xmlns:a16="http://schemas.microsoft.com/office/drawing/2014/main" id="{C61EBD33-D08E-491B-B936-1CCA8FDC5BC2}"/>
+                <a16:creationId xmlns:a16="http://schemas.microsoft.com/office/drawing/2014/main" id="{BE306784-6AE8-4B54-B5A6-8EA900479E78}"/>
               </a:ext>
             </a:extLst>
           </p:cNvPr>
@@ -13280,7 +13280,7 @@
           <p:cNvPr id="7" name="">
             <a:extLst xmlns:a="http://schemas.openxmlformats.org/drawingml/2006/main">
               <a:ext uri="{FF2B5EF4-FFF2-40B4-BE49-F238E27FC236}">
-                <a16:creationId xmlns:a16="http://schemas.microsoft.com/office/drawing/2014/main" id="{DFF88664-DE43-4512-833D-AD928FA998A3}"/>
+                <a16:creationId xmlns:a16="http://schemas.microsoft.com/office/drawing/2014/main" id="{B199AAB6-DF54-4E89-ADBC-02BA79018D74}"/>
               </a:ext>
             </a:extLst>
           </p:cNvPr>
@@ -13337,7 +13337,7 @@
           <p:cNvPr id="8" name="">
             <a:extLst xmlns:a="http://schemas.openxmlformats.org/drawingml/2006/main">
               <a:ext uri="{FF2B5EF4-FFF2-40B4-BE49-F238E27FC236}">
-                <a16:creationId xmlns:a16="http://schemas.microsoft.com/office/drawing/2014/main" id="{147F3FE2-1839-48B9-B26A-180B79538BF1}"/>
+                <a16:creationId xmlns:a16="http://schemas.microsoft.com/office/drawing/2014/main" id="{1764B72E-D085-46DB-A714-70DC9D46F620}"/>
               </a:ext>
             </a:extLst>
           </p:cNvPr>
@@ -13440,7 +13440,7 @@
           <p:cNvPr id="9" name="">
             <a:extLst xmlns:a="http://schemas.openxmlformats.org/drawingml/2006/main">
               <a:ext uri="{FF2B5EF4-FFF2-40B4-BE49-F238E27FC236}">
-                <a16:creationId xmlns:a16="http://schemas.microsoft.com/office/drawing/2014/main" id="{68A44A6C-0AE2-4AB2-A5C4-188473F1FC86}"/>
+                <a16:creationId xmlns:a16="http://schemas.microsoft.com/office/drawing/2014/main" id="{72662AFD-CF51-417D-B54E-22DE42AA41CB}"/>
               </a:ext>
             </a:extLst>
           </p:cNvPr>
@@ -13497,7 +13497,7 @@
           <p:cNvPr id="10" name="">
             <a:extLst xmlns:a="http://schemas.openxmlformats.org/drawingml/2006/main">
               <a:ext uri="{FF2B5EF4-FFF2-40B4-BE49-F238E27FC236}">
-                <a16:creationId xmlns:a16="http://schemas.microsoft.com/office/drawing/2014/main" id="{CC599DE2-3554-4046-85F9-49F91F9B69BF}"/>
+                <a16:creationId xmlns:a16="http://schemas.microsoft.com/office/drawing/2014/main" id="{071CB41D-E379-4D76-9AAA-B7FBB4B9C12F}"/>
               </a:ext>
             </a:extLst>
           </p:cNvPr>
@@ -13623,7 +13623,7 @@
           <p:cNvPr id="11" name="">
             <a:extLst xmlns:a="http://schemas.openxmlformats.org/drawingml/2006/main">
               <a:ext uri="{FF2B5EF4-FFF2-40B4-BE49-F238E27FC236}">
-                <a16:creationId xmlns:a16="http://schemas.microsoft.com/office/drawing/2014/main" id="{0432B4A5-6066-4F64-A82E-9CE62F986642}"/>
+                <a16:creationId xmlns:a16="http://schemas.microsoft.com/office/drawing/2014/main" id="{499FAF17-9AF9-4221-812C-22F2EEBCCCA4}"/>
               </a:ext>
             </a:extLst>
           </p:cNvPr>
@@ -13678,7 +13678,7 @@
     </p:spTree>
     <p:extLst>
       <p:ext uri="{BB962C8B-B14F-4D97-AF65-F5344CB8AC3E}">
-        <p14:creationId xmlns:p14="http://schemas.microsoft.com/office/powerpoint/2010/main" val="1942410304"/>
+        <p14:creationId xmlns:p14="http://schemas.microsoft.com/office/powerpoint/2010/main" val="961805587"/>
       </p:ext>
     </p:extLst>
   </p:cSld>
@@ -13709,7 +13709,7 @@
           <p:cNvPr id="9" name="">
             <a:extLst xmlns:a="http://schemas.openxmlformats.org/drawingml/2006/main">
               <a:ext uri="{FF2B5EF4-FFF2-40B4-BE49-F238E27FC236}">
-                <a16:creationId xmlns:a16="http://schemas.microsoft.com/office/drawing/2014/main" id="{F04B734A-FC94-43A3-9E32-54F556C88A93}"/>
+                <a16:creationId xmlns:a16="http://schemas.microsoft.com/office/drawing/2014/main" id="{EFA95A2D-521F-4B9A-B374-34FC2CF0C3CD}"/>
               </a:ext>
             </a:extLst>
           </p:cNvPr>
@@ -13766,7 +13766,7 @@
           <p:cNvPr id="2" name="">
             <a:extLst xmlns:a="http://schemas.openxmlformats.org/drawingml/2006/main">
               <a:ext uri="{FF2B5EF4-FFF2-40B4-BE49-F238E27FC236}">
-                <a16:creationId xmlns:a16="http://schemas.microsoft.com/office/drawing/2014/main" id="{855D0706-3F63-406F-B1BF-1B61CC97262D}"/>
+                <a16:creationId xmlns:a16="http://schemas.microsoft.com/office/drawing/2014/main" id="{47E2C4C8-726A-439A-B9D2-B1F991719BD4}"/>
               </a:ext>
             </a:extLst>
           </p:cNvPr>
@@ -13823,7 +13823,7 @@
           <p:cNvPr id="3" name="">
             <a:extLst xmlns:a="http://schemas.openxmlformats.org/drawingml/2006/main">
               <a:ext uri="{FF2B5EF4-FFF2-40B4-BE49-F238E27FC236}">
-                <a16:creationId xmlns:a16="http://schemas.microsoft.com/office/drawing/2014/main" id="{D0DEBC0A-5F18-4FE2-86A3-2480DC63073E}"/>
+                <a16:creationId xmlns:a16="http://schemas.microsoft.com/office/drawing/2014/main" id="{59CFE564-E9EA-443F-B7D4-2C5F00E684CE}"/>
               </a:ext>
             </a:extLst>
           </p:cNvPr>
@@ -13880,7 +13880,7 @@
           <p:cNvPr id="4" name="">
             <a:extLst xmlns:a="http://schemas.openxmlformats.org/drawingml/2006/main">
               <a:ext uri="{FF2B5EF4-FFF2-40B4-BE49-F238E27FC236}">
-                <a16:creationId xmlns:a16="http://schemas.microsoft.com/office/drawing/2014/main" id="{E455BEE7-6702-4621-BAF6-4BE939D08B11}"/>
+                <a16:creationId xmlns:a16="http://schemas.microsoft.com/office/drawing/2014/main" id="{9F059791-F4B5-4642-9DFE-12C57859B2F2}"/>
               </a:ext>
             </a:extLst>
           </p:cNvPr>
@@ -14006,7 +14006,7 @@
           <p:cNvPr id="5" name="">
             <a:extLst xmlns:a="http://schemas.openxmlformats.org/drawingml/2006/main">
               <a:ext uri="{FF2B5EF4-FFF2-40B4-BE49-F238E27FC236}">
-                <a16:creationId xmlns:a16="http://schemas.microsoft.com/office/drawing/2014/main" id="{BCC2EB81-E7D2-4E9E-A500-31C5A8F725EF}"/>
+                <a16:creationId xmlns:a16="http://schemas.microsoft.com/office/drawing/2014/main" id="{1A1A2144-78EB-4625-A4C8-FD9810671E1F}"/>
               </a:ext>
             </a:extLst>
           </p:cNvPr>
@@ -14063,7 +14063,7 @@
           <p:cNvPr id="6" name="">
             <a:extLst xmlns:a="http://schemas.openxmlformats.org/drawingml/2006/main">
               <a:ext uri="{FF2B5EF4-FFF2-40B4-BE49-F238E27FC236}">
-                <a16:creationId xmlns:a16="http://schemas.microsoft.com/office/drawing/2014/main" id="{85E5B29C-2302-4DC4-84AD-7A0742B9145A}"/>
+                <a16:creationId xmlns:a16="http://schemas.microsoft.com/office/drawing/2014/main" id="{F117B5D5-BC35-4001-ABFE-47400ED8A333}"/>
               </a:ext>
             </a:extLst>
           </p:cNvPr>
@@ -14216,7 +14216,7 @@
           <p:nvPr/>
         </p:nvPicPr>
         <p:blipFill>
-          <a:blip xmlns:r="http://schemas.openxmlformats.org/officeDocument/2006/relationships" xmlns:a="http://schemas.openxmlformats.org/drawingml/2006/main" r:embed="R549e7e5071f94427"/>
+          <a:blip xmlns:r="http://schemas.openxmlformats.org/officeDocument/2006/relationships" xmlns:a="http://schemas.openxmlformats.org/drawingml/2006/main" r:embed="R5b03d231678040c3"/>
           <a:stretch xmlns:a="http://schemas.openxmlformats.org/drawingml/2006/main"/>
         </p:blipFill>
         <p:spPr>
@@ -14234,7 +14234,7 @@
           <p:cNvPr id="8" name="">
             <a:extLst xmlns:a="http://schemas.openxmlformats.org/drawingml/2006/main">
               <a:ext uri="{FF2B5EF4-FFF2-40B4-BE49-F238E27FC236}">
-                <a16:creationId xmlns:a16="http://schemas.microsoft.com/office/drawing/2014/main" id="{4DEBF2A4-7A05-4786-A5D8-7CFB6F78C5BB}"/>
+                <a16:creationId xmlns:a16="http://schemas.microsoft.com/office/drawing/2014/main" id="{62F1585F-E734-47C7-8243-46DBC97E8741}"/>
               </a:ext>
             </a:extLst>
           </p:cNvPr>
@@ -14289,7 +14289,7 @@
     </p:spTree>
     <p:extLst>
       <p:ext uri="{BB962C8B-B14F-4D97-AF65-F5344CB8AC3E}">
-        <p14:creationId xmlns:p14="http://schemas.microsoft.com/office/powerpoint/2010/main" val="1845849970"/>
+        <p14:creationId xmlns:p14="http://schemas.microsoft.com/office/powerpoint/2010/main" val="1962964079"/>
       </p:ext>
     </p:extLst>
   </p:cSld>
@@ -14320,7 +14320,7 @@
           <p:cNvPr id="9" name="">
             <a:extLst xmlns:a="http://schemas.openxmlformats.org/drawingml/2006/main">
               <a:ext uri="{FF2B5EF4-FFF2-40B4-BE49-F238E27FC236}">
-                <a16:creationId xmlns:a16="http://schemas.microsoft.com/office/drawing/2014/main" id="{656A8995-54A4-4B59-B589-56CA5D299336}"/>
+                <a16:creationId xmlns:a16="http://schemas.microsoft.com/office/drawing/2014/main" id="{3B3E5CA9-0E11-4465-9B31-16523509E0A2}"/>
               </a:ext>
             </a:extLst>
           </p:cNvPr>
@@ -14377,7 +14377,7 @@
           <p:cNvPr id="2" name="">
             <a:extLst xmlns:a="http://schemas.openxmlformats.org/drawingml/2006/main">
               <a:ext uri="{FF2B5EF4-FFF2-40B4-BE49-F238E27FC236}">
-                <a16:creationId xmlns:a16="http://schemas.microsoft.com/office/drawing/2014/main" id="{48833F21-C83D-4CBE-8521-35937FC315EC}"/>
+                <a16:creationId xmlns:a16="http://schemas.microsoft.com/office/drawing/2014/main" id="{0BFDF792-883C-4402-BD0D-0529D4C22630}"/>
               </a:ext>
             </a:extLst>
           </p:cNvPr>
@@ -14434,7 +14434,7 @@
           <p:cNvPr id="3" name="">
             <a:extLst xmlns:a="http://schemas.openxmlformats.org/drawingml/2006/main">
               <a:ext uri="{FF2B5EF4-FFF2-40B4-BE49-F238E27FC236}">
-                <a16:creationId xmlns:a16="http://schemas.microsoft.com/office/drawing/2014/main" id="{7B1A79CB-79DF-4B4A-8629-F1075141BAE5}"/>
+                <a16:creationId xmlns:a16="http://schemas.microsoft.com/office/drawing/2014/main" id="{058E7A3C-78D4-4F33-80DF-BB1604C7231B}"/>
               </a:ext>
             </a:extLst>
           </p:cNvPr>
@@ -14491,7 +14491,7 @@
           <p:cNvPr id="4" name="">
             <a:extLst xmlns:a="http://schemas.openxmlformats.org/drawingml/2006/main">
               <a:ext uri="{FF2B5EF4-FFF2-40B4-BE49-F238E27FC236}">
-                <a16:creationId xmlns:a16="http://schemas.microsoft.com/office/drawing/2014/main" id="{8A2047A2-40E0-4373-A90A-AEAB780827C7}"/>
+                <a16:creationId xmlns:a16="http://schemas.microsoft.com/office/drawing/2014/main" id="{A9523638-5181-4CD9-B596-1B6F6AC5289E}"/>
               </a:ext>
             </a:extLst>
           </p:cNvPr>
@@ -14617,7 +14617,7 @@
           <p:cNvPr id="5" name="">
             <a:extLst xmlns:a="http://schemas.openxmlformats.org/drawingml/2006/main">
               <a:ext uri="{FF2B5EF4-FFF2-40B4-BE49-F238E27FC236}">
-                <a16:creationId xmlns:a16="http://schemas.microsoft.com/office/drawing/2014/main" id="{70DFFB9E-DC8B-4858-84F7-785B64B11E2F}"/>
+                <a16:creationId xmlns:a16="http://schemas.microsoft.com/office/drawing/2014/main" id="{CFEDCF55-A9C2-4088-A446-45538DB54955}"/>
               </a:ext>
             </a:extLst>
           </p:cNvPr>
@@ -14674,7 +14674,7 @@
           <p:cNvPr id="6" name="">
             <a:extLst xmlns:a="http://schemas.openxmlformats.org/drawingml/2006/main">
               <a:ext uri="{FF2B5EF4-FFF2-40B4-BE49-F238E27FC236}">
-                <a16:creationId xmlns:a16="http://schemas.microsoft.com/office/drawing/2014/main" id="{D998E998-0A99-415D-AB3A-CE50F39A8BA2}"/>
+                <a16:creationId xmlns:a16="http://schemas.microsoft.com/office/drawing/2014/main" id="{F562C373-FADC-4BC1-83BD-29B519505025}"/>
               </a:ext>
             </a:extLst>
           </p:cNvPr>
@@ -14804,7 +14804,7 @@
           <p:nvPr/>
         </p:nvPicPr>
         <p:blipFill>
-          <a:blip xmlns:r="http://schemas.openxmlformats.org/officeDocument/2006/relationships" xmlns:a="http://schemas.openxmlformats.org/drawingml/2006/main" r:embed="Re642ee09494249d5"/>
+          <a:blip xmlns:r="http://schemas.openxmlformats.org/officeDocument/2006/relationships" xmlns:a="http://schemas.openxmlformats.org/drawingml/2006/main" r:embed="R1b79aafad6c440c1"/>
           <a:stretch xmlns:a="http://schemas.openxmlformats.org/drawingml/2006/main"/>
         </p:blipFill>
         <p:spPr>
@@ -14822,7 +14822,7 @@
           <p:cNvPr id="8" name="">
             <a:extLst xmlns:a="http://schemas.openxmlformats.org/drawingml/2006/main">
               <a:ext uri="{FF2B5EF4-FFF2-40B4-BE49-F238E27FC236}">
-                <a16:creationId xmlns:a16="http://schemas.microsoft.com/office/drawing/2014/main" id="{35DDC1DC-F6E1-474C-9E58-B0A6F3003E60}"/>
+                <a16:creationId xmlns:a16="http://schemas.microsoft.com/office/drawing/2014/main" id="{FF8BD953-BFCB-41A5-9A6A-9218541A54F8}"/>
               </a:ext>
             </a:extLst>
           </p:cNvPr>
@@ -14877,7 +14877,7 @@
     </p:spTree>
     <p:extLst>
       <p:ext uri="{BB962C8B-B14F-4D97-AF65-F5344CB8AC3E}">
-        <p14:creationId xmlns:p14="http://schemas.microsoft.com/office/powerpoint/2010/main" val="849741662"/>
+        <p14:creationId xmlns:p14="http://schemas.microsoft.com/office/powerpoint/2010/main" val="1002768622"/>
       </p:ext>
     </p:extLst>
   </p:cSld>
@@ -14908,7 +14908,7 @@
           <p:cNvPr id="9" name="">
             <a:extLst xmlns:a="http://schemas.openxmlformats.org/drawingml/2006/main">
               <a:ext uri="{FF2B5EF4-FFF2-40B4-BE49-F238E27FC236}">
-                <a16:creationId xmlns:a16="http://schemas.microsoft.com/office/drawing/2014/main" id="{DA63B8AF-9765-40E3-8BF5-E91F1E355451}"/>
+                <a16:creationId xmlns:a16="http://schemas.microsoft.com/office/drawing/2014/main" id="{F1B60FAF-D34A-4B24-B54C-A4DA76520DCB}"/>
               </a:ext>
             </a:extLst>
           </p:cNvPr>
@@ -14965,7 +14965,7 @@
           <p:cNvPr id="2" name="">
             <a:extLst xmlns:a="http://schemas.openxmlformats.org/drawingml/2006/main">
               <a:ext uri="{FF2B5EF4-FFF2-40B4-BE49-F238E27FC236}">
-                <a16:creationId xmlns:a16="http://schemas.microsoft.com/office/drawing/2014/main" id="{24B7983F-F62F-4E3E-B487-7CDEC817ABC5}"/>
+                <a16:creationId xmlns:a16="http://schemas.microsoft.com/office/drawing/2014/main" id="{30345FF9-9495-44A9-A81F-3BA36C601F87}"/>
               </a:ext>
             </a:extLst>
           </p:cNvPr>
@@ -15022,7 +15022,7 @@
           <p:cNvPr id="3" name="">
             <a:extLst xmlns:a="http://schemas.openxmlformats.org/drawingml/2006/main">
               <a:ext uri="{FF2B5EF4-FFF2-40B4-BE49-F238E27FC236}">
-                <a16:creationId xmlns:a16="http://schemas.microsoft.com/office/drawing/2014/main" id="{31284DA8-8846-4859-AEB9-AF61BB16FC10}"/>
+                <a16:creationId xmlns:a16="http://schemas.microsoft.com/office/drawing/2014/main" id="{C86EE977-150C-443C-88E1-CEF220AB8EDB}"/>
               </a:ext>
             </a:extLst>
           </p:cNvPr>
@@ -15079,7 +15079,7 @@
           <p:cNvPr id="4" name="">
             <a:extLst xmlns:a="http://schemas.openxmlformats.org/drawingml/2006/main">
               <a:ext uri="{FF2B5EF4-FFF2-40B4-BE49-F238E27FC236}">
-                <a16:creationId xmlns:a16="http://schemas.microsoft.com/office/drawing/2014/main" id="{BF1B2E17-D46E-4D3B-B36E-71BD4213CA41}"/>
+                <a16:creationId xmlns:a16="http://schemas.microsoft.com/office/drawing/2014/main" id="{B2902ECB-35A9-4318-82AF-4BD9EC1AE82E}"/>
               </a:ext>
             </a:extLst>
           </p:cNvPr>
@@ -15228,7 +15228,7 @@
           <p:cNvPr id="5" name="">
             <a:extLst xmlns:a="http://schemas.openxmlformats.org/drawingml/2006/main">
               <a:ext uri="{FF2B5EF4-FFF2-40B4-BE49-F238E27FC236}">
-                <a16:creationId xmlns:a16="http://schemas.microsoft.com/office/drawing/2014/main" id="{F865A38B-09EF-45B8-86B0-F7476720E03C}"/>
+                <a16:creationId xmlns:a16="http://schemas.microsoft.com/office/drawing/2014/main" id="{1B5200A6-F7A4-4EA0-92F8-F0B7C6694E2B}"/>
               </a:ext>
             </a:extLst>
           </p:cNvPr>
@@ -15285,7 +15285,7 @@
           <p:cNvPr id="6" name="">
             <a:extLst xmlns:a="http://schemas.openxmlformats.org/drawingml/2006/main">
               <a:ext uri="{FF2B5EF4-FFF2-40B4-BE49-F238E27FC236}">
-                <a16:creationId xmlns:a16="http://schemas.microsoft.com/office/drawing/2014/main" id="{52137322-0C68-460F-BDBA-DB710AA22CAB}"/>
+                <a16:creationId xmlns:a16="http://schemas.microsoft.com/office/drawing/2014/main" id="{71B134CD-84D8-4B3A-B314-D88FDD8FC684}"/>
               </a:ext>
             </a:extLst>
           </p:cNvPr>
@@ -15415,7 +15415,7 @@
           <p:nvPr/>
         </p:nvPicPr>
         <p:blipFill>
-          <a:blip xmlns:r="http://schemas.openxmlformats.org/officeDocument/2006/relationships" xmlns:a="http://schemas.openxmlformats.org/drawingml/2006/main" r:embed="Rfa39dac858354fa5"/>
+          <a:blip xmlns:r="http://schemas.openxmlformats.org/officeDocument/2006/relationships" xmlns:a="http://schemas.openxmlformats.org/drawingml/2006/main" r:embed="R4b7fe543d6fa4758"/>
           <a:stretch xmlns:a="http://schemas.openxmlformats.org/drawingml/2006/main"/>
         </p:blipFill>
         <p:spPr>
@@ -15433,7 +15433,7 @@
           <p:cNvPr id="8" name="">
             <a:extLst xmlns:a="http://schemas.openxmlformats.org/drawingml/2006/main">
               <a:ext uri="{FF2B5EF4-FFF2-40B4-BE49-F238E27FC236}">
-                <a16:creationId xmlns:a16="http://schemas.microsoft.com/office/drawing/2014/main" id="{5056E2F3-CCEF-4930-BCB4-7899B6E0087F}"/>
+                <a16:creationId xmlns:a16="http://schemas.microsoft.com/office/drawing/2014/main" id="{77AB986D-39FE-472D-8E02-48BD647709FF}"/>
               </a:ext>
             </a:extLst>
           </p:cNvPr>
@@ -15488,7 +15488,7 @@
     </p:spTree>
     <p:extLst>
       <p:ext uri="{BB962C8B-B14F-4D97-AF65-F5344CB8AC3E}">
-        <p14:creationId xmlns:p14="http://schemas.microsoft.com/office/powerpoint/2010/main" val="1035466177"/>
+        <p14:creationId xmlns:p14="http://schemas.microsoft.com/office/powerpoint/2010/main" val="1992864623"/>
       </p:ext>
     </p:extLst>
   </p:cSld>
@@ -15519,7 +15519,7 @@
           <p:cNvPr id="9" name="">
             <a:extLst xmlns:a="http://schemas.openxmlformats.org/drawingml/2006/main">
               <a:ext uri="{FF2B5EF4-FFF2-40B4-BE49-F238E27FC236}">
-                <a16:creationId xmlns:a16="http://schemas.microsoft.com/office/drawing/2014/main" id="{AACE3B86-1795-4B00-A561-49C6FDE63AAF}"/>
+                <a16:creationId xmlns:a16="http://schemas.microsoft.com/office/drawing/2014/main" id="{8D3A2C8F-A98B-4FF0-AAC1-9140CAE4E631}"/>
               </a:ext>
             </a:extLst>
           </p:cNvPr>
@@ -15576,7 +15576,7 @@
           <p:cNvPr id="2" name="">
             <a:extLst xmlns:a="http://schemas.openxmlformats.org/drawingml/2006/main">
               <a:ext uri="{FF2B5EF4-FFF2-40B4-BE49-F238E27FC236}">
-                <a16:creationId xmlns:a16="http://schemas.microsoft.com/office/drawing/2014/main" id="{3F63C692-05DC-400F-878F-0588A111580C}"/>
+                <a16:creationId xmlns:a16="http://schemas.microsoft.com/office/drawing/2014/main" id="{60EDA12D-DD98-4947-B6B9-5B0F1DD4EC60}"/>
               </a:ext>
             </a:extLst>
           </p:cNvPr>
@@ -15633,7 +15633,7 @@
           <p:cNvPr id="3" name="">
             <a:extLst xmlns:a="http://schemas.openxmlformats.org/drawingml/2006/main">
               <a:ext uri="{FF2B5EF4-FFF2-40B4-BE49-F238E27FC236}">
-                <a16:creationId xmlns:a16="http://schemas.microsoft.com/office/drawing/2014/main" id="{0A89C697-164B-4D72-9B27-6953A282EF41}"/>
+                <a16:creationId xmlns:a16="http://schemas.microsoft.com/office/drawing/2014/main" id="{C0A028B2-B367-4DC8-B4EE-9A411C3A9FD4}"/>
               </a:ext>
             </a:extLst>
           </p:cNvPr>
@@ -15690,7 +15690,7 @@
           <p:cNvPr id="4" name="">
             <a:extLst xmlns:a="http://schemas.openxmlformats.org/drawingml/2006/main">
               <a:ext uri="{FF2B5EF4-FFF2-40B4-BE49-F238E27FC236}">
-                <a16:creationId xmlns:a16="http://schemas.microsoft.com/office/drawing/2014/main" id="{B6193EF8-7214-4389-B74B-F66E77934350}"/>
+                <a16:creationId xmlns:a16="http://schemas.microsoft.com/office/drawing/2014/main" id="{E30233F8-0B2D-48EC-B931-6CBB3252FB47}"/>
               </a:ext>
             </a:extLst>
           </p:cNvPr>
@@ -15737,7 +15737,7 @@
                 <a:ea typeface="Malgun Gothic"/>
                 <a:cs typeface="Malgun Gothic"/>
               </a:rPr>
-              <a:t>과정명과 저장 폴더를</a:t>
+              <a:t>과정마다 이름, ID, 포트와</a:t>
             </a:r>
           </a:p>
           <a:p xmlns:a="http://schemas.openxmlformats.org/drawingml/2006/main">
@@ -15760,7 +15760,7 @@
                 <a:ea typeface="Malgun Gothic"/>
                 <a:cs typeface="Malgun Gothic"/>
               </a:rPr>
-              <a:t>정합니다. 과정별로 ID,</a:t>
+              <a:t>저장 폴더를 정합니다.</a:t>
             </a:r>
           </a:p>
           <a:p xmlns:a="http://schemas.openxmlformats.org/drawingml/2006/main">
@@ -15783,7 +15783,7 @@
                 <a:ea typeface="Malgun Gothic"/>
                 <a:cs typeface="Malgun Gothic"/>
               </a:rPr>
-              <a:t>포트, 저장 폴더를</a:t>
+              <a:t>상단의 연보라색 탭이 현재</a:t>
             </a:r>
           </a:p>
           <a:p xmlns:a="http://schemas.openxmlformats.org/drawingml/2006/main">
@@ -15806,7 +15806,7 @@
                 <a:ea typeface="Malgun Gothic"/>
                 <a:cs typeface="Malgun Gothic"/>
               </a:rPr>
-              <a:t>구분합니다.</a:t>
+              <a:t>선택한 화면입니다.</a:t>
             </a:r>
           </a:p>
         </p:txBody>
@@ -15816,7 +15816,7 @@
           <p:cNvPr id="5" name="">
             <a:extLst xmlns:a="http://schemas.openxmlformats.org/drawingml/2006/main">
               <a:ext uri="{FF2B5EF4-FFF2-40B4-BE49-F238E27FC236}">
-                <a16:creationId xmlns:a16="http://schemas.microsoft.com/office/drawing/2014/main" id="{A1D10EC0-A322-46F2-A0D1-8F3275BEEF90}"/>
+                <a16:creationId xmlns:a16="http://schemas.microsoft.com/office/drawing/2014/main" id="{99272B65-9F6A-4CD4-ABD4-C2629D50F016}"/>
               </a:ext>
             </a:extLst>
           </p:cNvPr>
@@ -15873,7 +15873,7 @@
           <p:cNvPr id="6" name="">
             <a:extLst xmlns:a="http://schemas.openxmlformats.org/drawingml/2006/main">
               <a:ext uri="{FF2B5EF4-FFF2-40B4-BE49-F238E27FC236}">
-                <a16:creationId xmlns:a16="http://schemas.microsoft.com/office/drawing/2014/main" id="{C4E042C4-22ED-4C19-9887-6C174367BD7A}"/>
+                <a16:creationId xmlns:a16="http://schemas.microsoft.com/office/drawing/2014/main" id="{4FDD56EE-018B-477A-B19B-D342D2C877E1}"/>
               </a:ext>
             </a:extLst>
           </p:cNvPr>
@@ -16003,7 +16003,7 @@
           <p:nvPr/>
         </p:nvPicPr>
         <p:blipFill>
-          <a:blip xmlns:r="http://schemas.openxmlformats.org/officeDocument/2006/relationships" xmlns:a="http://schemas.openxmlformats.org/drawingml/2006/main" r:embed="Rba2d9c058aa7471d"/>
+          <a:blip xmlns:r="http://schemas.openxmlformats.org/officeDocument/2006/relationships" xmlns:a="http://schemas.openxmlformats.org/drawingml/2006/main" r:embed="Rdc9652c8b29945d3"/>
           <a:stretch xmlns:a="http://schemas.openxmlformats.org/drawingml/2006/main"/>
         </p:blipFill>
         <p:spPr>
@@ -16021,7 +16021,7 @@
           <p:cNvPr id="8" name="">
             <a:extLst xmlns:a="http://schemas.openxmlformats.org/drawingml/2006/main">
               <a:ext uri="{FF2B5EF4-FFF2-40B4-BE49-F238E27FC236}">
-                <a16:creationId xmlns:a16="http://schemas.microsoft.com/office/drawing/2014/main" id="{33AF3F4B-7C48-4B44-8554-620E69761BD5}"/>
+                <a16:creationId xmlns:a16="http://schemas.microsoft.com/office/drawing/2014/main" id="{43A3E93F-88BE-48F4-A2F9-E950CD739D59}"/>
               </a:ext>
             </a:extLst>
           </p:cNvPr>
@@ -16076,7 +16076,7 @@
     </p:spTree>
     <p:extLst>
       <p:ext uri="{BB962C8B-B14F-4D97-AF65-F5344CB8AC3E}">
-        <p14:creationId xmlns:p14="http://schemas.microsoft.com/office/powerpoint/2010/main" val="600240884"/>
+        <p14:creationId xmlns:p14="http://schemas.microsoft.com/office/powerpoint/2010/main" val="529317059"/>
       </p:ext>
     </p:extLst>
   </p:cSld>
@@ -16107,7 +16107,7 @@
           <p:cNvPr id="9" name="">
             <a:extLst xmlns:a="http://schemas.openxmlformats.org/drawingml/2006/main">
               <a:ext uri="{FF2B5EF4-FFF2-40B4-BE49-F238E27FC236}">
-                <a16:creationId xmlns:a16="http://schemas.microsoft.com/office/drawing/2014/main" id="{3CD66E98-4B1C-47A8-8595-EDF10183C43D}"/>
+                <a16:creationId xmlns:a16="http://schemas.microsoft.com/office/drawing/2014/main" id="{C00F2042-D34E-4C37-A573-21B50FA2083B}"/>
               </a:ext>
             </a:extLst>
           </p:cNvPr>
@@ -16164,7 +16164,7 @@
           <p:cNvPr id="2" name="">
             <a:extLst xmlns:a="http://schemas.openxmlformats.org/drawingml/2006/main">
               <a:ext uri="{FF2B5EF4-FFF2-40B4-BE49-F238E27FC236}">
-                <a16:creationId xmlns:a16="http://schemas.microsoft.com/office/drawing/2014/main" id="{FE502242-0808-4208-BEAF-89F06C64BF80}"/>
+                <a16:creationId xmlns:a16="http://schemas.microsoft.com/office/drawing/2014/main" id="{44F025BD-5ACE-4136-A653-F17AC3C2017D}"/>
               </a:ext>
             </a:extLst>
           </p:cNvPr>
@@ -16221,7 +16221,7 @@
           <p:cNvPr id="3" name="">
             <a:extLst xmlns:a="http://schemas.openxmlformats.org/drawingml/2006/main">
               <a:ext uri="{FF2B5EF4-FFF2-40B4-BE49-F238E27FC236}">
-                <a16:creationId xmlns:a16="http://schemas.microsoft.com/office/drawing/2014/main" id="{13447C47-B0BA-42FF-9D12-04F34F4F32D1}"/>
+                <a16:creationId xmlns:a16="http://schemas.microsoft.com/office/drawing/2014/main" id="{80D57384-C344-4141-8B62-F1BFBFECA81E}"/>
               </a:ext>
             </a:extLst>
           </p:cNvPr>
@@ -16278,7 +16278,7 @@
           <p:cNvPr id="4" name="">
             <a:extLst xmlns:a="http://schemas.openxmlformats.org/drawingml/2006/main">
               <a:ext uri="{FF2B5EF4-FFF2-40B4-BE49-F238E27FC236}">
-                <a16:creationId xmlns:a16="http://schemas.microsoft.com/office/drawing/2014/main" id="{A7973025-97B7-4032-809A-18CEBE847466}"/>
+                <a16:creationId xmlns:a16="http://schemas.microsoft.com/office/drawing/2014/main" id="{A9448A66-7BE7-4D30-B458-1621F2BF7C97}"/>
               </a:ext>
             </a:extLst>
           </p:cNvPr>
@@ -16325,7 +16325,7 @@
                 <a:ea typeface="Malgun Gothic"/>
                 <a:cs typeface="Malgun Gothic"/>
               </a:rPr>
-              <a:t>파일당 2 GiB, 학생별 누적</a:t>
+              <a:t>‘용량·전송 설정’ 탭을</a:t>
             </a:r>
           </a:p>
           <a:p xmlns:a="http://schemas.openxmlformats.org/drawingml/2006/main">
@@ -16348,7 +16348,7 @@
                 <a:ea typeface="Malgun Gothic"/>
                 <a:cs typeface="Malgun Gothic"/>
               </a:rPr>
-              <a:t>10 GiB, 최소 여유 공간</a:t>
+              <a:t>선택합니다. 기본값은 파일당</a:t>
             </a:r>
           </a:p>
           <a:p xmlns:a="http://schemas.openxmlformats.org/drawingml/2006/main">
@@ -16371,7 +16371,30 @@
                 <a:ea typeface="Malgun Gothic"/>
                 <a:cs typeface="Malgun Gothic"/>
               </a:rPr>
-              <a:t>5 GiB가 기본값입니다.</a:t>
+              <a:t>2 GiB, 학생별 누적 10 GiB,</a:t>
+            </a:r>
+          </a:p>
+          <a:p xmlns:a="http://schemas.openxmlformats.org/drawingml/2006/main">
+            <a:pPr>
+              <a:defRPr sz="2025" b="0">
+                <a:solidFill>
+                  <a:srgbClr val="202539"/>
+                </a:solidFill>
+                <a:latin typeface="Malgun Gothic"/>
+                <a:ea typeface="Malgun Gothic"/>
+                <a:cs typeface="Malgun Gothic"/>
+              </a:defRPr>
+            </a:pPr>
+            <a:r>
+              <a:rPr sz="2025" b="0">
+                <a:solidFill>
+                  <a:srgbClr val="202539"/>
+                </a:solidFill>
+                <a:latin typeface="Malgun Gothic"/>
+                <a:ea typeface="Malgun Gothic"/>
+                <a:cs typeface="Malgun Gothic"/>
+              </a:rPr>
+              <a:t>최소 여유 5 GiB입니다.</a:t>
             </a:r>
           </a:p>
         </p:txBody>
@@ -16381,7 +16404,7 @@
           <p:cNvPr id="5" name="">
             <a:extLst xmlns:a="http://schemas.openxmlformats.org/drawingml/2006/main">
               <a:ext uri="{FF2B5EF4-FFF2-40B4-BE49-F238E27FC236}">
-                <a16:creationId xmlns:a16="http://schemas.microsoft.com/office/drawing/2014/main" id="{E68177AA-EB1D-4AE3-B2F7-1A0AE5B194F7}"/>
+                <a16:creationId xmlns:a16="http://schemas.microsoft.com/office/drawing/2014/main" id="{E74E4F08-8329-4AE3-8C62-26FD7DAD259D}"/>
               </a:ext>
             </a:extLst>
           </p:cNvPr>
@@ -16438,7 +16461,7 @@
           <p:cNvPr id="6" name="">
             <a:extLst xmlns:a="http://schemas.openxmlformats.org/drawingml/2006/main">
               <a:ext uri="{FF2B5EF4-FFF2-40B4-BE49-F238E27FC236}">
-                <a16:creationId xmlns:a16="http://schemas.microsoft.com/office/drawing/2014/main" id="{C0FEBC57-686A-40E7-ADB7-5C70E07AEF1C}"/>
+                <a16:creationId xmlns:a16="http://schemas.microsoft.com/office/drawing/2014/main" id="{D92C73D4-392F-4DB4-9078-8619A52586A1}"/>
               </a:ext>
             </a:extLst>
           </p:cNvPr>
@@ -16545,7 +16568,7 @@
           <p:nvPr/>
         </p:nvPicPr>
         <p:blipFill>
-          <a:blip xmlns:r="http://schemas.openxmlformats.org/officeDocument/2006/relationships" xmlns:a="http://schemas.openxmlformats.org/drawingml/2006/main" r:embed="Rb7cd900b459145fe"/>
+          <a:blip xmlns:r="http://schemas.openxmlformats.org/officeDocument/2006/relationships" xmlns:a="http://schemas.openxmlformats.org/drawingml/2006/main" r:embed="Ra84b7ad2c40e4621"/>
           <a:stretch xmlns:a="http://schemas.openxmlformats.org/drawingml/2006/main"/>
         </p:blipFill>
         <p:spPr>
@@ -16563,7 +16586,7 @@
           <p:cNvPr id="8" name="">
             <a:extLst xmlns:a="http://schemas.openxmlformats.org/drawingml/2006/main">
               <a:ext uri="{FF2B5EF4-FFF2-40B4-BE49-F238E27FC236}">
-                <a16:creationId xmlns:a16="http://schemas.microsoft.com/office/drawing/2014/main" id="{43F13224-9F94-46B2-A458-7F74B1422913}"/>
+                <a16:creationId xmlns:a16="http://schemas.microsoft.com/office/drawing/2014/main" id="{3B4CEF4C-0F16-43B2-A836-239395B41E16}"/>
               </a:ext>
             </a:extLst>
           </p:cNvPr>
@@ -16618,7 +16641,7 @@
     </p:spTree>
     <p:extLst>
       <p:ext uri="{BB962C8B-B14F-4D97-AF65-F5344CB8AC3E}">
-        <p14:creationId xmlns:p14="http://schemas.microsoft.com/office/powerpoint/2010/main" val="378393297"/>
+        <p14:creationId xmlns:p14="http://schemas.microsoft.com/office/powerpoint/2010/main" val="486071905"/>
       </p:ext>
     </p:extLst>
   </p:cSld>
@@ -16649,7 +16672,7 @@
           <p:cNvPr id="9" name="">
             <a:extLst xmlns:a="http://schemas.openxmlformats.org/drawingml/2006/main">
               <a:ext uri="{FF2B5EF4-FFF2-40B4-BE49-F238E27FC236}">
-                <a16:creationId xmlns:a16="http://schemas.microsoft.com/office/drawing/2014/main" id="{861E22BE-A35D-4992-8ED2-F8118CDD26DE}"/>
+                <a16:creationId xmlns:a16="http://schemas.microsoft.com/office/drawing/2014/main" id="{E22B0829-3C0C-4F00-8F0A-F7164BC3B3C9}"/>
               </a:ext>
             </a:extLst>
           </p:cNvPr>
@@ -16706,7 +16729,7 @@
           <p:cNvPr id="2" name="">
             <a:extLst xmlns:a="http://schemas.openxmlformats.org/drawingml/2006/main">
               <a:ext uri="{FF2B5EF4-FFF2-40B4-BE49-F238E27FC236}">
-                <a16:creationId xmlns:a16="http://schemas.microsoft.com/office/drawing/2014/main" id="{9FF175F7-69E8-43E8-806B-4D0600A2B3EA}"/>
+                <a16:creationId xmlns:a16="http://schemas.microsoft.com/office/drawing/2014/main" id="{EDC5A1AE-2CA7-4035-80AB-843FB6ECCB58}"/>
               </a:ext>
             </a:extLst>
           </p:cNvPr>
@@ -16763,7 +16786,7 @@
           <p:cNvPr id="3" name="">
             <a:extLst xmlns:a="http://schemas.openxmlformats.org/drawingml/2006/main">
               <a:ext uri="{FF2B5EF4-FFF2-40B4-BE49-F238E27FC236}">
-                <a16:creationId xmlns:a16="http://schemas.microsoft.com/office/drawing/2014/main" id="{A92650D0-1265-487D-A344-9A3A92D54E39}"/>
+                <a16:creationId xmlns:a16="http://schemas.microsoft.com/office/drawing/2014/main" id="{720F7CAF-B819-40D1-83E0-341E671AA327}"/>
               </a:ext>
             </a:extLst>
           </p:cNvPr>
@@ -16820,7 +16843,7 @@
           <p:cNvPr id="4" name="">
             <a:extLst xmlns:a="http://schemas.openxmlformats.org/drawingml/2006/main">
               <a:ext uri="{FF2B5EF4-FFF2-40B4-BE49-F238E27FC236}">
-                <a16:creationId xmlns:a16="http://schemas.microsoft.com/office/drawing/2014/main" id="{3ACAB5A5-8F12-4C73-AE71-3DB12C665299}"/>
+                <a16:creationId xmlns:a16="http://schemas.microsoft.com/office/drawing/2014/main" id="{A8F656F7-2137-4732-85BC-3D6A92886436}"/>
               </a:ext>
             </a:extLst>
           </p:cNvPr>
@@ -16946,7 +16969,7 @@
           <p:cNvPr id="5" name="">
             <a:extLst xmlns:a="http://schemas.openxmlformats.org/drawingml/2006/main">
               <a:ext uri="{FF2B5EF4-FFF2-40B4-BE49-F238E27FC236}">
-                <a16:creationId xmlns:a16="http://schemas.microsoft.com/office/drawing/2014/main" id="{37CA4563-36BD-45A8-8655-E28DB3728CA4}"/>
+                <a16:creationId xmlns:a16="http://schemas.microsoft.com/office/drawing/2014/main" id="{D07EBA39-A1D6-44E4-A8D9-92D7EEBAF390}"/>
               </a:ext>
             </a:extLst>
           </p:cNvPr>
@@ -17003,7 +17026,7 @@
           <p:cNvPr id="6" name="">
             <a:extLst xmlns:a="http://schemas.openxmlformats.org/drawingml/2006/main">
               <a:ext uri="{FF2B5EF4-FFF2-40B4-BE49-F238E27FC236}">
-                <a16:creationId xmlns:a16="http://schemas.microsoft.com/office/drawing/2014/main" id="{C911CA72-620C-4B75-A1CE-1A761BA6CA08}"/>
+                <a16:creationId xmlns:a16="http://schemas.microsoft.com/office/drawing/2014/main" id="{136FE5BE-9F12-435C-9DB9-BE4D84A152C4}"/>
               </a:ext>
             </a:extLst>
           </p:cNvPr>
@@ -17133,7 +17156,7 @@
           <p:nvPr/>
         </p:nvPicPr>
         <p:blipFill>
-          <a:blip xmlns:r="http://schemas.openxmlformats.org/officeDocument/2006/relationships" xmlns:a="http://schemas.openxmlformats.org/drawingml/2006/main" r:embed="R1c70360813444293"/>
+          <a:blip xmlns:r="http://schemas.openxmlformats.org/officeDocument/2006/relationships" xmlns:a="http://schemas.openxmlformats.org/drawingml/2006/main" r:embed="R38ad5ff8fb7842f9"/>
           <a:stretch xmlns:a="http://schemas.openxmlformats.org/drawingml/2006/main"/>
         </p:blipFill>
         <p:spPr>
@@ -17151,7 +17174,7 @@
           <p:cNvPr id="8" name="">
             <a:extLst xmlns:a="http://schemas.openxmlformats.org/drawingml/2006/main">
               <a:ext uri="{FF2B5EF4-FFF2-40B4-BE49-F238E27FC236}">
-                <a16:creationId xmlns:a16="http://schemas.microsoft.com/office/drawing/2014/main" id="{E41F69F5-9704-4E13-8227-D978583342B7}"/>
+                <a16:creationId xmlns:a16="http://schemas.microsoft.com/office/drawing/2014/main" id="{0D95A3C7-03C9-458C-BA76-6D59B9B85085}"/>
               </a:ext>
             </a:extLst>
           </p:cNvPr>
@@ -17206,7 +17229,7 @@
     </p:spTree>
     <p:extLst>
       <p:ext uri="{BB962C8B-B14F-4D97-AF65-F5344CB8AC3E}">
-        <p14:creationId xmlns:p14="http://schemas.microsoft.com/office/powerpoint/2010/main" val="1126610412"/>
+        <p14:creationId xmlns:p14="http://schemas.microsoft.com/office/powerpoint/2010/main" val="1913357538"/>
       </p:ext>
     </p:extLst>
   </p:cSld>
@@ -17237,7 +17260,7 @@
           <p:cNvPr id="9" name="">
             <a:extLst xmlns:a="http://schemas.openxmlformats.org/drawingml/2006/main">
               <a:ext uri="{FF2B5EF4-FFF2-40B4-BE49-F238E27FC236}">
-                <a16:creationId xmlns:a16="http://schemas.microsoft.com/office/drawing/2014/main" id="{97186572-2AFA-4CE9-93B8-63E1B408C150}"/>
+                <a16:creationId xmlns:a16="http://schemas.microsoft.com/office/drawing/2014/main" id="{E5B81B9D-BC91-4A26-928C-3375EB99A498}"/>
               </a:ext>
             </a:extLst>
           </p:cNvPr>
@@ -17294,7 +17317,7 @@
           <p:cNvPr id="2" name="">
             <a:extLst xmlns:a="http://schemas.openxmlformats.org/drawingml/2006/main">
               <a:ext uri="{FF2B5EF4-FFF2-40B4-BE49-F238E27FC236}">
-                <a16:creationId xmlns:a16="http://schemas.microsoft.com/office/drawing/2014/main" id="{7F731927-6FF6-432A-A0B7-5F38B355B43D}"/>
+                <a16:creationId xmlns:a16="http://schemas.microsoft.com/office/drawing/2014/main" id="{B28AD4E6-812E-4BC3-B8BB-C914075795B8}"/>
               </a:ext>
             </a:extLst>
           </p:cNvPr>
@@ -17351,7 +17374,7 @@
           <p:cNvPr id="3" name="">
             <a:extLst xmlns:a="http://schemas.openxmlformats.org/drawingml/2006/main">
               <a:ext uri="{FF2B5EF4-FFF2-40B4-BE49-F238E27FC236}">
-                <a16:creationId xmlns:a16="http://schemas.microsoft.com/office/drawing/2014/main" id="{CEEF5D9B-E62A-485C-A404-730FD6ACB658}"/>
+                <a16:creationId xmlns:a16="http://schemas.microsoft.com/office/drawing/2014/main" id="{6B981B94-FF67-4AE0-958F-7B8DCC832A4C}"/>
               </a:ext>
             </a:extLst>
           </p:cNvPr>
@@ -17408,7 +17431,7 @@
           <p:cNvPr id="4" name="">
             <a:extLst xmlns:a="http://schemas.openxmlformats.org/drawingml/2006/main">
               <a:ext uri="{FF2B5EF4-FFF2-40B4-BE49-F238E27FC236}">
-                <a16:creationId xmlns:a16="http://schemas.microsoft.com/office/drawing/2014/main" id="{917729D8-9729-4ACE-9782-337E0D690B39}"/>
+                <a16:creationId xmlns:a16="http://schemas.microsoft.com/office/drawing/2014/main" id="{2D52C7BE-12D4-4C52-BD5A-F729B4091995}"/>
               </a:ext>
             </a:extLst>
           </p:cNvPr>
@@ -17534,7 +17557,7 @@
           <p:cNvPr id="5" name="">
             <a:extLst xmlns:a="http://schemas.openxmlformats.org/drawingml/2006/main">
               <a:ext uri="{FF2B5EF4-FFF2-40B4-BE49-F238E27FC236}">
-                <a16:creationId xmlns:a16="http://schemas.microsoft.com/office/drawing/2014/main" id="{37D00F25-23E2-4B80-905F-C4BA28AD0DB5}"/>
+                <a16:creationId xmlns:a16="http://schemas.microsoft.com/office/drawing/2014/main" id="{F5AC68E6-317D-4A9E-A74A-9863CDB788E5}"/>
               </a:ext>
             </a:extLst>
           </p:cNvPr>
@@ -17591,7 +17614,7 @@
           <p:cNvPr id="6" name="">
             <a:extLst xmlns:a="http://schemas.openxmlformats.org/drawingml/2006/main">
               <a:ext uri="{FF2B5EF4-FFF2-40B4-BE49-F238E27FC236}">
-                <a16:creationId xmlns:a16="http://schemas.microsoft.com/office/drawing/2014/main" id="{8D907AFB-9DA6-4708-8DC0-03B27761E98F}"/>
+                <a16:creationId xmlns:a16="http://schemas.microsoft.com/office/drawing/2014/main" id="{77637406-7852-4939-BEC3-4A917DA0595A}"/>
               </a:ext>
             </a:extLst>
           </p:cNvPr>
@@ -17698,7 +17721,7 @@
           <p:nvPr/>
         </p:nvPicPr>
         <p:blipFill>
-          <a:blip xmlns:r="http://schemas.openxmlformats.org/officeDocument/2006/relationships" xmlns:a="http://schemas.openxmlformats.org/drawingml/2006/main" r:embed="R0c3449c568604f68"/>
+          <a:blip xmlns:r="http://schemas.openxmlformats.org/officeDocument/2006/relationships" xmlns:a="http://schemas.openxmlformats.org/drawingml/2006/main" r:embed="R1fb74f701abc4a13"/>
           <a:stretch xmlns:a="http://schemas.openxmlformats.org/drawingml/2006/main"/>
         </p:blipFill>
         <p:spPr>
@@ -17716,7 +17739,7 @@
           <p:cNvPr id="8" name="">
             <a:extLst xmlns:a="http://schemas.openxmlformats.org/drawingml/2006/main">
               <a:ext uri="{FF2B5EF4-FFF2-40B4-BE49-F238E27FC236}">
-                <a16:creationId xmlns:a16="http://schemas.microsoft.com/office/drawing/2014/main" id="{4CB9BDB2-9293-4A9E-A9A9-7D9EA4C7D10F}"/>
+                <a16:creationId xmlns:a16="http://schemas.microsoft.com/office/drawing/2014/main" id="{9A48AF5A-3E1F-417A-B2C1-833EA572AEBE}"/>
               </a:ext>
             </a:extLst>
           </p:cNvPr>
@@ -17771,7 +17794,7 @@
     </p:spTree>
     <p:extLst>
       <p:ext uri="{BB962C8B-B14F-4D97-AF65-F5344CB8AC3E}">
-        <p14:creationId xmlns:p14="http://schemas.microsoft.com/office/powerpoint/2010/main" val="1746236026"/>
+        <p14:creationId xmlns:p14="http://schemas.microsoft.com/office/powerpoint/2010/main" val="941780909"/>
       </p:ext>
     </p:extLst>
   </p:cSld>
@@ -17802,7 +17825,7 @@
           <p:cNvPr id="9" name="">
             <a:extLst xmlns:a="http://schemas.openxmlformats.org/drawingml/2006/main">
               <a:ext uri="{FF2B5EF4-FFF2-40B4-BE49-F238E27FC236}">
-                <a16:creationId xmlns:a16="http://schemas.microsoft.com/office/drawing/2014/main" id="{130751D1-5AED-4215-A18B-87ED61EE28A9}"/>
+                <a16:creationId xmlns:a16="http://schemas.microsoft.com/office/drawing/2014/main" id="{3100BD7D-4765-4089-BABA-66464FF4455A}"/>
               </a:ext>
             </a:extLst>
           </p:cNvPr>
@@ -17859,7 +17882,7 @@
           <p:cNvPr id="2" name="">
             <a:extLst xmlns:a="http://schemas.openxmlformats.org/drawingml/2006/main">
               <a:ext uri="{FF2B5EF4-FFF2-40B4-BE49-F238E27FC236}">
-                <a16:creationId xmlns:a16="http://schemas.microsoft.com/office/drawing/2014/main" id="{C680A880-187D-4D19-B1D3-23DB6CEDFF60}"/>
+                <a16:creationId xmlns:a16="http://schemas.microsoft.com/office/drawing/2014/main" id="{7A7AE89D-CCD6-4BCC-8174-ED259CEB5AD7}"/>
               </a:ext>
             </a:extLst>
           </p:cNvPr>
@@ -17916,7 +17939,7 @@
           <p:cNvPr id="3" name="">
             <a:extLst xmlns:a="http://schemas.openxmlformats.org/drawingml/2006/main">
               <a:ext uri="{FF2B5EF4-FFF2-40B4-BE49-F238E27FC236}">
-                <a16:creationId xmlns:a16="http://schemas.microsoft.com/office/drawing/2014/main" id="{4DC811C4-0794-464A-A8A7-297A3C0420FC}"/>
+                <a16:creationId xmlns:a16="http://schemas.microsoft.com/office/drawing/2014/main" id="{106EA2E8-ACE2-47DB-866B-5C9786C1CDF0}"/>
               </a:ext>
             </a:extLst>
           </p:cNvPr>
@@ -17973,7 +17996,7 @@
           <p:cNvPr id="4" name="">
             <a:extLst xmlns:a="http://schemas.openxmlformats.org/drawingml/2006/main">
               <a:ext uri="{FF2B5EF4-FFF2-40B4-BE49-F238E27FC236}">
-                <a16:creationId xmlns:a16="http://schemas.microsoft.com/office/drawing/2014/main" id="{09EF6939-90EF-4BB1-9AE4-3B44AA15A88E}"/>
+                <a16:creationId xmlns:a16="http://schemas.microsoft.com/office/drawing/2014/main" id="{1430771B-5748-4DED-80C6-C37979B3E25A}"/>
               </a:ext>
             </a:extLst>
           </p:cNvPr>
@@ -18053,7 +18076,7 @@
           <p:cNvPr id="5" name="">
             <a:extLst xmlns:a="http://schemas.openxmlformats.org/drawingml/2006/main">
               <a:ext uri="{FF2B5EF4-FFF2-40B4-BE49-F238E27FC236}">
-                <a16:creationId xmlns:a16="http://schemas.microsoft.com/office/drawing/2014/main" id="{E4F28030-771B-42C0-86D8-49533491AD86}"/>
+                <a16:creationId xmlns:a16="http://schemas.microsoft.com/office/drawing/2014/main" id="{895B354D-7F0B-48C5-885E-3ACD51078AEC}"/>
               </a:ext>
             </a:extLst>
           </p:cNvPr>
@@ -18110,7 +18133,7 @@
           <p:cNvPr id="6" name="">
             <a:extLst xmlns:a="http://schemas.openxmlformats.org/drawingml/2006/main">
               <a:ext uri="{FF2B5EF4-FFF2-40B4-BE49-F238E27FC236}">
-                <a16:creationId xmlns:a16="http://schemas.microsoft.com/office/drawing/2014/main" id="{42C0CBD9-1051-4FE0-AFC9-8C79DEB728CE}"/>
+                <a16:creationId xmlns:a16="http://schemas.microsoft.com/office/drawing/2014/main" id="{62DEB018-F9CA-40D5-8A31-3B2458382E7C}"/>
               </a:ext>
             </a:extLst>
           </p:cNvPr>
@@ -18194,7 +18217,7 @@
           <p:nvPr/>
         </p:nvPicPr>
         <p:blipFill>
-          <a:blip xmlns:r="http://schemas.openxmlformats.org/officeDocument/2006/relationships" xmlns:a="http://schemas.openxmlformats.org/drawingml/2006/main" r:embed="Rab540b6fda1647b8"/>
+          <a:blip xmlns:r="http://schemas.openxmlformats.org/officeDocument/2006/relationships" xmlns:a="http://schemas.openxmlformats.org/drawingml/2006/main" r:embed="R106e2e4706994ced"/>
           <a:stretch xmlns:a="http://schemas.openxmlformats.org/drawingml/2006/main"/>
         </p:blipFill>
         <p:spPr>
@@ -18212,7 +18235,7 @@
           <p:cNvPr id="8" name="">
             <a:extLst xmlns:a="http://schemas.openxmlformats.org/drawingml/2006/main">
               <a:ext uri="{FF2B5EF4-FFF2-40B4-BE49-F238E27FC236}">
-                <a16:creationId xmlns:a16="http://schemas.microsoft.com/office/drawing/2014/main" id="{C2393B19-CDBE-43D4-9964-D54A3680ED6E}"/>
+                <a16:creationId xmlns:a16="http://schemas.microsoft.com/office/drawing/2014/main" id="{206E99BB-DA09-45FC-A34A-A0501C8BDD00}"/>
               </a:ext>
             </a:extLst>
           </p:cNvPr>
@@ -18267,7 +18290,7 @@
     </p:spTree>
     <p:extLst>
       <p:ext uri="{BB962C8B-B14F-4D97-AF65-F5344CB8AC3E}">
-        <p14:creationId xmlns:p14="http://schemas.microsoft.com/office/powerpoint/2010/main" val="2062969250"/>
+        <p14:creationId xmlns:p14="http://schemas.microsoft.com/office/powerpoint/2010/main" val="2004800377"/>
       </p:ext>
     </p:extLst>
   </p:cSld>
@@ -18298,7 +18321,7 @@
           <p:cNvPr id="9" name="">
             <a:extLst xmlns:a="http://schemas.openxmlformats.org/drawingml/2006/main">
               <a:ext uri="{FF2B5EF4-FFF2-40B4-BE49-F238E27FC236}">
-                <a16:creationId xmlns:a16="http://schemas.microsoft.com/office/drawing/2014/main" id="{C9831D6D-A77B-4B4C-B618-DFCBFA837763}"/>
+                <a16:creationId xmlns:a16="http://schemas.microsoft.com/office/drawing/2014/main" id="{103D4AA8-47B6-45CD-BD3B-7F999987C53F}"/>
               </a:ext>
             </a:extLst>
           </p:cNvPr>
@@ -18355,7 +18378,7 @@
           <p:cNvPr id="2" name="">
             <a:extLst xmlns:a="http://schemas.openxmlformats.org/drawingml/2006/main">
               <a:ext uri="{FF2B5EF4-FFF2-40B4-BE49-F238E27FC236}">
-                <a16:creationId xmlns:a16="http://schemas.microsoft.com/office/drawing/2014/main" id="{A4A90BF2-C0D0-492E-B767-CD55993F0F04}"/>
+                <a16:creationId xmlns:a16="http://schemas.microsoft.com/office/drawing/2014/main" id="{36D70C70-DD78-49BA-91D2-DF550F84548F}"/>
               </a:ext>
             </a:extLst>
           </p:cNvPr>
@@ -18412,7 +18435,7 @@
           <p:cNvPr id="3" name="">
             <a:extLst xmlns:a="http://schemas.openxmlformats.org/drawingml/2006/main">
               <a:ext uri="{FF2B5EF4-FFF2-40B4-BE49-F238E27FC236}">
-                <a16:creationId xmlns:a16="http://schemas.microsoft.com/office/drawing/2014/main" id="{6C0D7675-79EE-4895-8693-32545E15D981}"/>
+                <a16:creationId xmlns:a16="http://schemas.microsoft.com/office/drawing/2014/main" id="{060A368A-9DD5-4B3B-8469-FFB5B0095F2D}"/>
               </a:ext>
             </a:extLst>
           </p:cNvPr>
@@ -18469,7 +18492,7 @@
           <p:cNvPr id="4" name="">
             <a:extLst xmlns:a="http://schemas.openxmlformats.org/drawingml/2006/main">
               <a:ext uri="{FF2B5EF4-FFF2-40B4-BE49-F238E27FC236}">
-                <a16:creationId xmlns:a16="http://schemas.microsoft.com/office/drawing/2014/main" id="{E7C6AC03-1CF2-4EE7-B4F0-0F7529274E26}"/>
+                <a16:creationId xmlns:a16="http://schemas.microsoft.com/office/drawing/2014/main" id="{BC809D54-1D20-4D28-9ADD-348C41FAB17B}"/>
               </a:ext>
             </a:extLst>
           </p:cNvPr>
@@ -18572,7 +18595,7 @@
           <p:cNvPr id="5" name="">
             <a:extLst xmlns:a="http://schemas.openxmlformats.org/drawingml/2006/main">
               <a:ext uri="{FF2B5EF4-FFF2-40B4-BE49-F238E27FC236}">
-                <a16:creationId xmlns:a16="http://schemas.microsoft.com/office/drawing/2014/main" id="{C95858F5-CD42-420B-9BED-1F2BD55FEEAF}"/>
+                <a16:creationId xmlns:a16="http://schemas.microsoft.com/office/drawing/2014/main" id="{D0A5EDFD-1940-4BA5-8717-998EE9306EE4}"/>
               </a:ext>
             </a:extLst>
           </p:cNvPr>
@@ -18629,7 +18652,7 @@
           <p:cNvPr id="6" name="">
             <a:extLst xmlns:a="http://schemas.openxmlformats.org/drawingml/2006/main">
               <a:ext uri="{FF2B5EF4-FFF2-40B4-BE49-F238E27FC236}">
-                <a16:creationId xmlns:a16="http://schemas.microsoft.com/office/drawing/2014/main" id="{EBD741F4-610B-4866-B81D-96F0FE459141}"/>
+                <a16:creationId xmlns:a16="http://schemas.microsoft.com/office/drawing/2014/main" id="{DE729B37-FB74-4F60-8033-A753400E1CC8}"/>
               </a:ext>
             </a:extLst>
           </p:cNvPr>
@@ -18759,7 +18782,7 @@
           <p:nvPr/>
         </p:nvPicPr>
         <p:blipFill>
-          <a:blip xmlns:r="http://schemas.openxmlformats.org/officeDocument/2006/relationships" xmlns:a="http://schemas.openxmlformats.org/drawingml/2006/main" r:embed="Rd1d7a6fee8424c65"/>
+          <a:blip xmlns:r="http://schemas.openxmlformats.org/officeDocument/2006/relationships" xmlns:a="http://schemas.openxmlformats.org/drawingml/2006/main" r:embed="R58f8e163d68e46f3"/>
           <a:stretch xmlns:a="http://schemas.openxmlformats.org/drawingml/2006/main"/>
         </p:blipFill>
         <p:spPr>
@@ -18777,7 +18800,7 @@
           <p:cNvPr id="8" name="">
             <a:extLst xmlns:a="http://schemas.openxmlformats.org/drawingml/2006/main">
               <a:ext uri="{FF2B5EF4-FFF2-40B4-BE49-F238E27FC236}">
-                <a16:creationId xmlns:a16="http://schemas.microsoft.com/office/drawing/2014/main" id="{E8E4EEB5-4E8F-4AEC-B431-70E904E2C26F}"/>
+                <a16:creationId xmlns:a16="http://schemas.microsoft.com/office/drawing/2014/main" id="{0D2063A6-F651-40E9-AECC-8947DEBC122A}"/>
               </a:ext>
             </a:extLst>
           </p:cNvPr>
@@ -18832,7 +18855,7 @@
     </p:spTree>
     <p:extLst>
       <p:ext uri="{BB962C8B-B14F-4D97-AF65-F5344CB8AC3E}">
-        <p14:creationId xmlns:p14="http://schemas.microsoft.com/office/powerpoint/2010/main" val="823703111"/>
+        <p14:creationId xmlns:p14="http://schemas.microsoft.com/office/powerpoint/2010/main" val="1792427850"/>
       </p:ext>
     </p:extLst>
   </p:cSld>
@@ -18863,7 +18886,7 @@
           <p:cNvPr id="9" name="">
             <a:extLst xmlns:a="http://schemas.openxmlformats.org/drawingml/2006/main">
               <a:ext uri="{FF2B5EF4-FFF2-40B4-BE49-F238E27FC236}">
-                <a16:creationId xmlns:a16="http://schemas.microsoft.com/office/drawing/2014/main" id="{652FDB5B-DEB1-4DEC-9541-398F01862DB9}"/>
+                <a16:creationId xmlns:a16="http://schemas.microsoft.com/office/drawing/2014/main" id="{9EE4B26A-293E-4020-B892-CD98FA1B81BB}"/>
               </a:ext>
             </a:extLst>
           </p:cNvPr>
@@ -18920,7 +18943,7 @@
           <p:cNvPr id="2" name="">
             <a:extLst xmlns:a="http://schemas.openxmlformats.org/drawingml/2006/main">
               <a:ext uri="{FF2B5EF4-FFF2-40B4-BE49-F238E27FC236}">
-                <a16:creationId xmlns:a16="http://schemas.microsoft.com/office/drawing/2014/main" id="{A29ACB65-A036-4D75-91A7-962A941FF4D8}"/>
+                <a16:creationId xmlns:a16="http://schemas.microsoft.com/office/drawing/2014/main" id="{B398C515-6D55-4B39-9CC9-A4475C268FA8}"/>
               </a:ext>
             </a:extLst>
           </p:cNvPr>
@@ -18977,7 +19000,7 @@
           <p:cNvPr id="3" name="">
             <a:extLst xmlns:a="http://schemas.openxmlformats.org/drawingml/2006/main">
               <a:ext uri="{FF2B5EF4-FFF2-40B4-BE49-F238E27FC236}">
-                <a16:creationId xmlns:a16="http://schemas.microsoft.com/office/drawing/2014/main" id="{E98D40E5-F226-43A8-B22E-DA6E95258136}"/>
+                <a16:creationId xmlns:a16="http://schemas.microsoft.com/office/drawing/2014/main" id="{66067562-3440-4FD6-99F4-94AECFD97D46}"/>
               </a:ext>
             </a:extLst>
           </p:cNvPr>
@@ -19034,7 +19057,7 @@
           <p:cNvPr id="4" name="">
             <a:extLst xmlns:a="http://schemas.openxmlformats.org/drawingml/2006/main">
               <a:ext uri="{FF2B5EF4-FFF2-40B4-BE49-F238E27FC236}">
-                <a16:creationId xmlns:a16="http://schemas.microsoft.com/office/drawing/2014/main" id="{9BD1059D-2B55-4CBD-B54E-6C23E1917796}"/>
+                <a16:creationId xmlns:a16="http://schemas.microsoft.com/office/drawing/2014/main" id="{62416001-EE9C-4087-AA28-5B290BCD33DB}"/>
               </a:ext>
             </a:extLst>
           </p:cNvPr>
@@ -19160,7 +19183,7 @@
           <p:cNvPr id="5" name="">
             <a:extLst xmlns:a="http://schemas.openxmlformats.org/drawingml/2006/main">
               <a:ext uri="{FF2B5EF4-FFF2-40B4-BE49-F238E27FC236}">
-                <a16:creationId xmlns:a16="http://schemas.microsoft.com/office/drawing/2014/main" id="{52846E23-24DF-4125-AD67-BD3024096E2C}"/>
+                <a16:creationId xmlns:a16="http://schemas.microsoft.com/office/drawing/2014/main" id="{70321917-F231-4993-B062-51EDE917E04E}"/>
               </a:ext>
             </a:extLst>
           </p:cNvPr>
@@ -19217,7 +19240,7 @@
           <p:cNvPr id="6" name="">
             <a:extLst xmlns:a="http://schemas.openxmlformats.org/drawingml/2006/main">
               <a:ext uri="{FF2B5EF4-FFF2-40B4-BE49-F238E27FC236}">
-                <a16:creationId xmlns:a16="http://schemas.microsoft.com/office/drawing/2014/main" id="{53924896-F13E-42DD-82AA-41B95368A4B6}"/>
+                <a16:creationId xmlns:a16="http://schemas.microsoft.com/office/drawing/2014/main" id="{77C1EC70-058B-4B36-9027-19DD2A1A262F}"/>
               </a:ext>
             </a:extLst>
           </p:cNvPr>
@@ -19347,7 +19370,7 @@
           <p:nvPr/>
         </p:nvPicPr>
         <p:blipFill>
-          <a:blip xmlns:r="http://schemas.openxmlformats.org/officeDocument/2006/relationships" xmlns:a="http://schemas.openxmlformats.org/drawingml/2006/main" r:embed="R19505a7af24a44ab"/>
+          <a:blip xmlns:r="http://schemas.openxmlformats.org/officeDocument/2006/relationships" xmlns:a="http://schemas.openxmlformats.org/drawingml/2006/main" r:embed="R02fbfeabaab54726"/>
           <a:stretch xmlns:a="http://schemas.openxmlformats.org/drawingml/2006/main"/>
         </p:blipFill>
         <p:spPr>
@@ -19365,7 +19388,7 @@
           <p:cNvPr id="8" name="">
             <a:extLst xmlns:a="http://schemas.openxmlformats.org/drawingml/2006/main">
               <a:ext uri="{FF2B5EF4-FFF2-40B4-BE49-F238E27FC236}">
-                <a16:creationId xmlns:a16="http://schemas.microsoft.com/office/drawing/2014/main" id="{DB180CDC-E719-49B1-B389-4CBC4871768F}"/>
+                <a16:creationId xmlns:a16="http://schemas.microsoft.com/office/drawing/2014/main" id="{379C9F6C-EF14-4B75-B039-E428C4513515}"/>
               </a:ext>
             </a:extLst>
           </p:cNvPr>
@@ -19420,7 +19443,7 @@
     </p:spTree>
     <p:extLst>
       <p:ext uri="{BB962C8B-B14F-4D97-AF65-F5344CB8AC3E}">
-        <p14:creationId xmlns:p14="http://schemas.microsoft.com/office/powerpoint/2010/main" val="1798042688"/>
+        <p14:creationId xmlns:p14="http://schemas.microsoft.com/office/powerpoint/2010/main" val="2124287173"/>
       </p:ext>
     </p:extLst>
   </p:cSld>

</xml_diff>

<commit_message>
feat: simplify submission and configure eight-character temporary passwords
Open the uploader with the existing login and selected assignment, remove connection codes, and apply the eight-character minimum throughout the web and local manager. Add a common initial password option for new roster accounts, refresh guides, and release v1.3.0.
</commit_message>
<xml_diff>
--- a/docs/manual/AssignmentHub_사용자_매뉴얼.pptx
+++ b/docs/manual/AssignmentHub_사용자_매뉴얼.pptx
@@ -2,47 +2,47 @@
 <file path=ppt/presentation.xml><?xml version="1.0" encoding="utf-8"?>
 <p:presentation xmlns:p="http://schemas.openxmlformats.org/presentationml/2006/main">
   <p:sldMasterIdLst>
-    <p:sldMasterId xmlns:r="http://schemas.openxmlformats.org/officeDocument/2006/relationships" id="2147483648" r:id="R27d539d73e27454f"/>
+    <p:sldMasterId xmlns:r="http://schemas.openxmlformats.org/officeDocument/2006/relationships" id="2147483648" r:id="R71fecf9e82dc458f"/>
   </p:sldMasterIdLst>
   <p:notesMasterIdLst>
-    <p:notesMasterId xmlns:r="http://schemas.openxmlformats.org/officeDocument/2006/relationships" r:id="Rbe9e306f02e7402b"/>
+    <p:notesMasterId xmlns:r="http://schemas.openxmlformats.org/officeDocument/2006/relationships" r:id="R292b67e3b0794410"/>
   </p:notesMasterIdLst>
   <p:sldIdLst>
-    <p:sldId xmlns:r="http://schemas.openxmlformats.org/officeDocument/2006/relationships" id="256" r:id="Rb8701a4bae6a4656"/>
-    <p:sldId xmlns:r="http://schemas.openxmlformats.org/officeDocument/2006/relationships" id="257" r:id="R308f8ed92d944ac4"/>
-    <p:sldId xmlns:r="http://schemas.openxmlformats.org/officeDocument/2006/relationships" id="258" r:id="R6d0874e8c45e42f6"/>
-    <p:sldId xmlns:r="http://schemas.openxmlformats.org/officeDocument/2006/relationships" id="259" r:id="R2723d68dd0e543fc"/>
-    <p:sldId xmlns:r="http://schemas.openxmlformats.org/officeDocument/2006/relationships" id="260" r:id="Ra058f15837694221"/>
-    <p:sldId xmlns:r="http://schemas.openxmlformats.org/officeDocument/2006/relationships" id="261" r:id="R1aeed348b0a7463f"/>
-    <p:sldId xmlns:r="http://schemas.openxmlformats.org/officeDocument/2006/relationships" id="262" r:id="R097ed38df5fc45c7"/>
-    <p:sldId xmlns:r="http://schemas.openxmlformats.org/officeDocument/2006/relationships" id="263" r:id="R79a12cad46db4ee0"/>
-    <p:sldId xmlns:r="http://schemas.openxmlformats.org/officeDocument/2006/relationships" id="264" r:id="R87cf6ba8cfe64a74"/>
-    <p:sldId xmlns:r="http://schemas.openxmlformats.org/officeDocument/2006/relationships" id="265" r:id="R7e654ba6024440ef"/>
-    <p:sldId xmlns:r="http://schemas.openxmlformats.org/officeDocument/2006/relationships" id="266" r:id="Rb6aa6b9ca120463a"/>
-    <p:sldId xmlns:r="http://schemas.openxmlformats.org/officeDocument/2006/relationships" id="267" r:id="R3be62588cf284212"/>
-    <p:sldId xmlns:r="http://schemas.openxmlformats.org/officeDocument/2006/relationships" id="268" r:id="Rcb255da5ba484282"/>
-    <p:sldId xmlns:r="http://schemas.openxmlformats.org/officeDocument/2006/relationships" id="269" r:id="R663920dcc32e46ed"/>
-    <p:sldId xmlns:r="http://schemas.openxmlformats.org/officeDocument/2006/relationships" id="270" r:id="Rced3104c478c42d2"/>
-    <p:sldId xmlns:r="http://schemas.openxmlformats.org/officeDocument/2006/relationships" id="271" r:id="Re337558794e743ce"/>
-    <p:sldId xmlns:r="http://schemas.openxmlformats.org/officeDocument/2006/relationships" id="272" r:id="R78b302f80deb41c3"/>
-    <p:sldId xmlns:r="http://schemas.openxmlformats.org/officeDocument/2006/relationships" id="273" r:id="Rafe88409f52a49e2"/>
-    <p:sldId xmlns:r="http://schemas.openxmlformats.org/officeDocument/2006/relationships" id="274" r:id="R8d42458877944609"/>
-    <p:sldId xmlns:r="http://schemas.openxmlformats.org/officeDocument/2006/relationships" id="275" r:id="R6917168132364d13"/>
-    <p:sldId xmlns:r="http://schemas.openxmlformats.org/officeDocument/2006/relationships" id="276" r:id="Rfce16143d5404530"/>
-    <p:sldId xmlns:r="http://schemas.openxmlformats.org/officeDocument/2006/relationships" id="277" r:id="R3aaa565aa4c04e85"/>
-    <p:sldId xmlns:r="http://schemas.openxmlformats.org/officeDocument/2006/relationships" id="278" r:id="Ra00558122de24689"/>
-    <p:sldId xmlns:r="http://schemas.openxmlformats.org/officeDocument/2006/relationships" id="279" r:id="Rad6ac739b1774b54"/>
-    <p:sldId xmlns:r="http://schemas.openxmlformats.org/officeDocument/2006/relationships" id="280" r:id="R288bb640d9e04f7c"/>
-    <p:sldId xmlns:r="http://schemas.openxmlformats.org/officeDocument/2006/relationships" id="281" r:id="R74b10508600b4899"/>
-    <p:sldId xmlns:r="http://schemas.openxmlformats.org/officeDocument/2006/relationships" id="282" r:id="Rd7c8d7a9e1014ac0"/>
-    <p:sldId xmlns:r="http://schemas.openxmlformats.org/officeDocument/2006/relationships" id="283" r:id="R98c7619bab844754"/>
-    <p:sldId xmlns:r="http://schemas.openxmlformats.org/officeDocument/2006/relationships" id="284" r:id="R69dbde77b9394d5a"/>
-    <p:sldId xmlns:r="http://schemas.openxmlformats.org/officeDocument/2006/relationships" id="285" r:id="Ra2232b670af84e04"/>
-    <p:sldId xmlns:r="http://schemas.openxmlformats.org/officeDocument/2006/relationships" id="286" r:id="R7813fad6a19348ef"/>
-    <p:sldId xmlns:r="http://schemas.openxmlformats.org/officeDocument/2006/relationships" id="287" r:id="R3fec1bf597844ae0"/>
-    <p:sldId xmlns:r="http://schemas.openxmlformats.org/officeDocument/2006/relationships" id="288" r:id="Rc6fe819244fb479d"/>
-    <p:sldId xmlns:r="http://schemas.openxmlformats.org/officeDocument/2006/relationships" id="289" r:id="R1bf82d4096aa4488"/>
-    <p:sldId xmlns:r="http://schemas.openxmlformats.org/officeDocument/2006/relationships" id="290" r:id="R53c1aa59f9564a9d"/>
+    <p:sldId xmlns:r="http://schemas.openxmlformats.org/officeDocument/2006/relationships" id="256" r:id="R7beb11986eb44768"/>
+    <p:sldId xmlns:r="http://schemas.openxmlformats.org/officeDocument/2006/relationships" id="257" r:id="R58d98b1e91ce4d83"/>
+    <p:sldId xmlns:r="http://schemas.openxmlformats.org/officeDocument/2006/relationships" id="258" r:id="R7b88cffcb77f4da6"/>
+    <p:sldId xmlns:r="http://schemas.openxmlformats.org/officeDocument/2006/relationships" id="259" r:id="R96bd1dde556241c2"/>
+    <p:sldId xmlns:r="http://schemas.openxmlformats.org/officeDocument/2006/relationships" id="260" r:id="Rb1f750c24c704f8d"/>
+    <p:sldId xmlns:r="http://schemas.openxmlformats.org/officeDocument/2006/relationships" id="261" r:id="R5cc1740c265f4336"/>
+    <p:sldId xmlns:r="http://schemas.openxmlformats.org/officeDocument/2006/relationships" id="262" r:id="R7802d3dd443b4f6c"/>
+    <p:sldId xmlns:r="http://schemas.openxmlformats.org/officeDocument/2006/relationships" id="263" r:id="Rfad8597367514d29"/>
+    <p:sldId xmlns:r="http://schemas.openxmlformats.org/officeDocument/2006/relationships" id="264" r:id="R9665dc5b8e8240bd"/>
+    <p:sldId xmlns:r="http://schemas.openxmlformats.org/officeDocument/2006/relationships" id="265" r:id="R4e1172d0224a408d"/>
+    <p:sldId xmlns:r="http://schemas.openxmlformats.org/officeDocument/2006/relationships" id="266" r:id="R1b5e9a13701a4b1e"/>
+    <p:sldId xmlns:r="http://schemas.openxmlformats.org/officeDocument/2006/relationships" id="267" r:id="Rfd003bccf4b44f4d"/>
+    <p:sldId xmlns:r="http://schemas.openxmlformats.org/officeDocument/2006/relationships" id="268" r:id="R598daa79bad74d6c"/>
+    <p:sldId xmlns:r="http://schemas.openxmlformats.org/officeDocument/2006/relationships" id="269" r:id="R59c34ab7db394c40"/>
+    <p:sldId xmlns:r="http://schemas.openxmlformats.org/officeDocument/2006/relationships" id="270" r:id="R7fb60b8023c741d5"/>
+    <p:sldId xmlns:r="http://schemas.openxmlformats.org/officeDocument/2006/relationships" id="271" r:id="Rb718a03c6aa1434e"/>
+    <p:sldId xmlns:r="http://schemas.openxmlformats.org/officeDocument/2006/relationships" id="272" r:id="Rca17a371f04841c0"/>
+    <p:sldId xmlns:r="http://schemas.openxmlformats.org/officeDocument/2006/relationships" id="273" r:id="Rbbaf641060c14b12"/>
+    <p:sldId xmlns:r="http://schemas.openxmlformats.org/officeDocument/2006/relationships" id="274" r:id="R12219a12813e42ac"/>
+    <p:sldId xmlns:r="http://schemas.openxmlformats.org/officeDocument/2006/relationships" id="275" r:id="R847dce5827684517"/>
+    <p:sldId xmlns:r="http://schemas.openxmlformats.org/officeDocument/2006/relationships" id="276" r:id="Rb3db40342af848f8"/>
+    <p:sldId xmlns:r="http://schemas.openxmlformats.org/officeDocument/2006/relationships" id="277" r:id="R282b4085371a4b91"/>
+    <p:sldId xmlns:r="http://schemas.openxmlformats.org/officeDocument/2006/relationships" id="278" r:id="R6157dd03bff94b04"/>
+    <p:sldId xmlns:r="http://schemas.openxmlformats.org/officeDocument/2006/relationships" id="279" r:id="R204d35da8cb44437"/>
+    <p:sldId xmlns:r="http://schemas.openxmlformats.org/officeDocument/2006/relationships" id="280" r:id="R817ea916d747437d"/>
+    <p:sldId xmlns:r="http://schemas.openxmlformats.org/officeDocument/2006/relationships" id="281" r:id="R104ac13837d249d9"/>
+    <p:sldId xmlns:r="http://schemas.openxmlformats.org/officeDocument/2006/relationships" id="282" r:id="R4c9a66af13654609"/>
+    <p:sldId xmlns:r="http://schemas.openxmlformats.org/officeDocument/2006/relationships" id="283" r:id="R0c84691aa4a849b7"/>
+    <p:sldId xmlns:r="http://schemas.openxmlformats.org/officeDocument/2006/relationships" id="284" r:id="Rc7e45cd253b8441a"/>
+    <p:sldId xmlns:r="http://schemas.openxmlformats.org/officeDocument/2006/relationships" id="285" r:id="R56b8e040e36c409b"/>
+    <p:sldId xmlns:r="http://schemas.openxmlformats.org/officeDocument/2006/relationships" id="286" r:id="Rd1fc2446c78b4296"/>
+    <p:sldId xmlns:r="http://schemas.openxmlformats.org/officeDocument/2006/relationships" id="287" r:id="Ra2d06380f25c4068"/>
+    <p:sldId xmlns:r="http://schemas.openxmlformats.org/officeDocument/2006/relationships" id="288" r:id="R908c72fbffaa44bd"/>
+    <p:sldId xmlns:r="http://schemas.openxmlformats.org/officeDocument/2006/relationships" id="289" r:id="R1c3d372c5b0a4257"/>
+    <p:sldId xmlns:r="http://schemas.openxmlformats.org/officeDocument/2006/relationships" id="290" r:id="R592c883062504312"/>
   </p:sldIdLst>
   <p:sldSz cx="15240000" cy="8572500"/>
   <p:notesSz cx="6858000" cy="9144000"/>
@@ -651,7 +651,7 @@
           </a:p>
           <a:p xmlns:a="http://schemas.openxmlformats.org/drawingml/2006/main">
             <a:r>
-              <a:t>반영 직후 신규 사용자의 임시비밀번호가 표시됩니다. 임시비밀번호 결과 CSV를 내려받아 학생별로 전달합니다.</a:t>
+              <a:t>신규 계정의 임시비밀번호는 영문·숫자 8자리입니다. 임시비밀번호 결과 CSV를 내려받아 본인 ID와 함께 전달합니다.</a:t>
             </a:r>
           </a:p>
           <a:p xmlns:a="http://schemas.openxmlformats.org/drawingml/2006/main">
@@ -1166,7 +1166,7 @@
           </a:p>
           <a:p xmlns:a="http://schemas.openxmlformats.org/drawingml/2006/main">
             <a:r>
-              <a:t>현재 임시비밀번호와 새로운 12~128자 비밀번호를 입력합니다. 변경을 마치고 새 비밀번호로 다시 로그인합니다.</a:t>
+              <a:t>현재 임시비밀번호와 새로운 8~128자 비밀번호를 입력합니다. 변경을 마치고 새 비밀번호로 다시 로그인합니다.</a:t>
             </a:r>
           </a:p>
           <a:p xmlns:a="http://schemas.openxmlformats.org/drawingml/2006/main">
@@ -1246,12 +1246,12 @@
           <a:lstStyle xmlns:a="http://schemas.openxmlformats.org/drawingml/2006/main"/>
           <a:p xmlns:a="http://schemas.openxmlformats.org/drawingml/2006/main">
             <a:r>
-              <a:t>연결 코드 사용</a:t>
-            </a:r>
-          </a:p>
-          <a:p xmlns:a="http://schemas.openxmlformats.org/drawingml/2006/main">
-            <a:r>
-              <a:t>일회용 연결 코드 발급을 눌러 코드를 복사합니다. 파일 제출·이어 올리기 화면 열기로 제출 창을 엽니다.</a:t>
+              <a:t>제출할 과제 선택</a:t>
+            </a:r>
+          </a:p>
+          <a:p xmlns:a="http://schemas.openxmlformats.org/drawingml/2006/main">
+            <a:r>
+              <a:t>수업 화면에서 안내받은 과제를 고릅니다. 과제 설명과 접수 상태를 확인합니다.</a:t>
             </a:r>
           </a:p>
           <a:p xmlns:a="http://schemas.openxmlformats.org/drawingml/2006/main">
@@ -1261,12 +1261,12 @@
           </a:p>
           <a:p xmlns:a="http://schemas.openxmlformats.org/drawingml/2006/main">
             <a:r>
-              <a:t>접속 계정 확인</a:t>
-            </a:r>
-          </a:p>
-          <a:p xmlns:a="http://schemas.openxmlformats.org/drawingml/2006/main">
-            <a:r>
-              <a:t>제출 창에서 코드로 연결합니다. 연결 후 표시된 ID가 본인의 ID인지 확인합니다.</a:t>
+              <a:t>파일 제출 버튼</a:t>
+            </a:r>
+          </a:p>
+          <a:p xmlns:a="http://schemas.openxmlformats.org/drawingml/2006/main">
+            <a:r>
+              <a:t>파일 제출·이어 올리기를 누릅니다. 현재 로그인한 계정과 선택한 과제로 제출 창이 바로 열립니다.</a:t>
             </a:r>
           </a:p>
           <a:p xmlns:a="http://schemas.openxmlformats.org/drawingml/2006/main">
@@ -1276,7 +1276,7 @@
           </a:p>
           <a:p xmlns:a="http://schemas.openxmlformats.org/drawingml/2006/main">
             <a:r>
-              <a:t>코드는 짧은 시간 동안 한 번만 사용합니다. 예시 화면의 코드 영역은 가렸습니다.</a:t>
+              <a:t>코드 발급이나 입력 없이 제출할 수 있습니다. 수업 화면에서 로그아웃하면 열어 둔 제출 창의 로그인도 종료됩니다.</a:t>
             </a:r>
           </a:p>
         </p:txBody>
@@ -1346,12 +1346,12 @@
           <a:lstStyle xmlns:a="http://schemas.openxmlformats.org/drawingml/2006/main"/>
           <a:p xmlns:a="http://schemas.openxmlformats.org/drawingml/2006/main">
             <a:r>
-              <a:t>코드가 만료된 경우</a:t>
-            </a:r>
-          </a:p>
-          <a:p xmlns:a="http://schemas.openxmlformats.org/drawingml/2006/main">
-            <a:r>
-              <a:t>새 연결 코드를 받거나 제출 창의 ID와 비밀번호로 로그인합니다. 비밀번호는 처음 변경한 새 비밀번호입니다.</a:t>
+              <a:t>본인 계정과 과제 확인</a:t>
+            </a:r>
+          </a:p>
+          <a:p xmlns:a="http://schemas.openxmlformats.org/drawingml/2006/main">
+            <a:r>
+              <a:t>제출 창에 본인의 ID와 선택한 과제가 표시됩니다. 파일을 선택한 뒤 제출 시작을 누릅니다.</a:t>
             </a:r>
           </a:p>
           <a:p xmlns:a="http://schemas.openxmlformats.org/drawingml/2006/main">
@@ -1361,12 +1361,12 @@
           </a:p>
           <a:p xmlns:a="http://schemas.openxmlformats.org/drawingml/2006/main">
             <a:r>
-              <a:t>다시 연 창</a:t>
-            </a:r>
-          </a:p>
-          <a:p xmlns:a="http://schemas.openxmlformats.org/drawingml/2006/main">
-            <a:r>
-              <a:t>새로고침이나 브라우저 재실행 후에도 본인 계정으로 로그인할 수 있습니다. 이어 올릴 작업은 로그인 후 선택합니다.</a:t>
+              <a:t>주소로 직접 접속한 경우</a:t>
+            </a:r>
+          </a:p>
+          <a:p xmlns:a="http://schemas.openxmlformats.org/drawingml/2006/main">
+            <a:r>
+              <a:t>제출 창 주소를 직접 열었거나 로그인이 끝났다면 본인 ID와 변경한 비밀번호로 로그인합니다.</a:t>
             </a:r>
           </a:p>
           <a:p xmlns:a="http://schemas.openxmlformats.org/drawingml/2006/main">
@@ -1376,7 +1376,7 @@
           </a:p>
           <a:p xmlns:a="http://schemas.openxmlformats.org/drawingml/2006/main">
             <a:r>
-              <a:t>다른 사람의 계정으로 제출하면 그 계정의 이력에 남습니다. 본인 계정과 과제명을 확인하세요.</a:t>
+              <a:t>파일 전송이 중단되면 미완료 작업을 선택해 이어 올릴 수 있습니다. 처음 선택한 원본 파일을 그대로 보관하세요.</a:t>
             </a:r>
           </a:p>
         </p:txBody>
@@ -2631,7 +2631,7 @@
           </a:p>
           <a:p xmlns:a="http://schemas.openxmlformats.org/drawingml/2006/main">
             <a:r>
-              <a:t>v1.2.0의 Windows x64 배포 ZIP 전체를 쓰기 가능한 폴더에 풉니다. Python과 라이브러리가 포함되어 있습니다.</a:t>
+              <a:t>v1.3.0의 Windows x64 배포 ZIP 전체를 쓰기 가능한 폴더에 풉니다. Python과 라이브러리가 포함되어 있습니다.</a:t>
             </a:r>
           </a:p>
           <a:p xmlns:a="http://schemas.openxmlformats.org/drawingml/2006/main">
@@ -3246,7 +3246,7 @@
           </a:p>
           <a:p xmlns:a="http://schemas.openxmlformats.org/drawingml/2006/main">
             <a:r>
-              <a:t>문의할 때 과정명·ID·제출번호·오류 문구를 전달합니다. 비밀번호나 연결 코드는 보내지 마세요.</a:t>
+              <a:t>문의할 때 과정명·ID·제출번호·오류 문구를 전달합니다. 비밀번호는 보내지 마세요.</a:t>
             </a:r>
           </a:p>
         </p:txBody>
@@ -3466,7 +3466,7 @@
           </a:p>
           <a:p xmlns:a="http://schemas.openxmlformats.org/drawingml/2006/main">
             <a:r>
-              <a:t>과정 ID·포트·저장 폴더를 확인합니다. 관리자 ID와 12~128자의 비밀번호를 정하고 확인란에도 입력합니다.</a:t>
+              <a:t>과정 ID·포트·저장 폴더를 확인합니다. 관리자 ID와 8~128자의 비밀번호를 정하고 확인란에도 입력합니다.</a:t>
             </a:r>
           </a:p>
           <a:p xmlns:a="http://schemas.openxmlformats.org/drawingml/2006/main">
@@ -3946,12 +3946,12 @@
           <a:lstStyle xmlns:a="http://schemas.openxmlformats.org/drawingml/2006/main"/>
           <a:p xmlns:a="http://schemas.openxmlformats.org/drawingml/2006/main">
             <a:r>
-              <a:t>파일 작성</a:t>
-            </a:r>
-          </a:p>
-          <a:p xmlns:a="http://schemas.openxmlformats.org/drawingml/2006/main">
-            <a:r>
-              <a:t>명단 TSV 템플릿을 내려받거나 동봉한 01-first-roster.tsv를 수정합니다. ID는 001처럼 텍스트 그대로 작성합니다.</a:t>
+              <a:t>TSV 파일 등록</a:t>
+            </a:r>
+          </a:p>
+          <a:p xmlns:a="http://schemas.openxmlformats.org/drawingml/2006/main">
+            <a:r>
+              <a:t>명단 TSV 템플릿 또는 01-first-roster.tsv를 수정해 올립니다. 검증 후 ID·이름·그룹을 확인합니다.</a:t>
             </a:r>
           </a:p>
           <a:p xmlns:a="http://schemas.openxmlformats.org/drawingml/2006/main">
@@ -3961,12 +3961,12 @@
           </a:p>
           <a:p xmlns:a="http://schemas.openxmlformats.org/drawingml/2006/main">
             <a:r>
-              <a:t>파일 업로드</a:t>
-            </a:r>
-          </a:p>
-          <a:p xmlns:a="http://schemas.openxmlformats.org/drawingml/2006/main">
-            <a:r>
-              <a:t>TSV 파일 업로드를 선택하고 .tsv 또는 .txt 파일을 올립니다. 검증 후 미리보기를 확인해 반영합니다.</a:t>
+              <a:t>공통 비밀번호(선택)</a:t>
+            </a:r>
+          </a:p>
+          <a:p xmlns:a="http://schemas.openxmlformats.org/drawingml/2006/main">
+            <a:r>
+              <a:t>신규 수강생에게 공통 임시비밀번호 사용을 켜고 영문·숫자 8자리를 입력합니다. 이번 명단의 신규 계정에 같은 값이 적용됩니다.</a:t>
             </a:r>
           </a:p>
           <a:p xmlns:a="http://schemas.openxmlformats.org/drawingml/2006/main">
@@ -3976,7 +3976,7 @@
           </a:p>
           <a:p xmlns:a="http://schemas.openxmlformats.org/drawingml/2006/main">
             <a:r>
-              <a:t>UTF-8 또는 BOM이 있는 UTF-16을 지원합니다. 최대 5 MiB, 10,000명, 30열입니다.</a:t>
+              <a:t>기본은 개인별 임시비밀번호 8자리입니다. 공통값은 명단 등록 때 지정하며, 추가 등록 시 같은 값을 다시 입력합니다.</a:t>
             </a:r>
           </a:p>
         </p:txBody>
@@ -4044,7 +4044,7 @@
   </p:cSld>
   <p:clrMap bg1="lt1" tx1="dk1" bg2="lt2" tx2="dk2" accent1="accent1" accent2="accent2" accent3="accent3" accent4="accent4" accent5="accent5" accent6="accent6" hlink="hlink" folHlink="folHlink"/>
   <p:sldLayoutIdLst>
-    <p:sldLayoutId xmlns:r="http://schemas.openxmlformats.org/officeDocument/2006/relationships" id="2147483649" r:id="Rcc0f6133837f40a7"/>
+    <p:sldLayoutId xmlns:r="http://schemas.openxmlformats.org/officeDocument/2006/relationships" id="2147483649" r:id="Rb8a52a2883f34591"/>
   </p:sldLayoutIdLst>
   <p:txStyles>
     <p:titleStyle>
@@ -4595,7 +4595,7 @@
           <p:cNvPr id="5" name="">
             <a:extLst xmlns:a="http://schemas.openxmlformats.org/drawingml/2006/main">
               <a:ext uri="{FF2B5EF4-FFF2-40B4-BE49-F238E27FC236}">
-                <a16:creationId xmlns:a16="http://schemas.microsoft.com/office/drawing/2014/main" id="{CF77622A-BE7D-4206-AF51-BD2DF3075515}"/>
+                <a16:creationId xmlns:a16="http://schemas.microsoft.com/office/drawing/2014/main" id="{719B9C6C-39AC-4C96-AD46-E1AFD6DBBE31}"/>
               </a:ext>
             </a:extLst>
           </p:cNvPr>
@@ -4652,7 +4652,7 @@
           <p:cNvPr id="2" name="">
             <a:extLst xmlns:a="http://schemas.openxmlformats.org/drawingml/2006/main">
               <a:ext uri="{FF2B5EF4-FFF2-40B4-BE49-F238E27FC236}">
-                <a16:creationId xmlns:a16="http://schemas.microsoft.com/office/drawing/2014/main" id="{6E80D4A9-4ABC-4554-A6AD-C9B4A112B45A}"/>
+                <a16:creationId xmlns:a16="http://schemas.microsoft.com/office/drawing/2014/main" id="{28E23B4C-FCBF-4BE4-9030-5E50BF228966}"/>
               </a:ext>
             </a:extLst>
           </p:cNvPr>
@@ -4709,7 +4709,7 @@
           <p:cNvPr id="3" name="">
             <a:extLst xmlns:a="http://schemas.openxmlformats.org/drawingml/2006/main">
               <a:ext uri="{FF2B5EF4-FFF2-40B4-BE49-F238E27FC236}">
-                <a16:creationId xmlns:a16="http://schemas.microsoft.com/office/drawing/2014/main" id="{DCF87E8A-057A-4452-A416-E4FEFEEE29CB}"/>
+                <a16:creationId xmlns:a16="http://schemas.microsoft.com/office/drawing/2014/main" id="{75E08D5E-E1E8-44C8-B4C1-E7C04413F4D7}"/>
               </a:ext>
             </a:extLst>
           </p:cNvPr>
@@ -4766,7 +4766,7 @@
           <p:cNvPr id="4" name="">
             <a:extLst xmlns:a="http://schemas.openxmlformats.org/drawingml/2006/main">
               <a:ext uri="{FF2B5EF4-FFF2-40B4-BE49-F238E27FC236}">
-                <a16:creationId xmlns:a16="http://schemas.microsoft.com/office/drawing/2014/main" id="{967418E0-7317-4464-AA57-FD7B342F6D1C}"/>
+                <a16:creationId xmlns:a16="http://schemas.microsoft.com/office/drawing/2014/main" id="{A32DE6FF-2FA5-46B1-923A-D3D85A40A59C}"/>
               </a:ext>
             </a:extLst>
           </p:cNvPr>
@@ -4813,7 +4813,7 @@
                 <a:ea typeface="Malgun Gothic"/>
                 <a:cs typeface="Malgun Gothic"/>
               </a:rPr>
-              <a:t>v1.2.0</a:t>
+              <a:t>v1.3.0</a:t>
             </a:r>
           </a:p>
           <a:p xmlns:a="http://schemas.openxmlformats.org/drawingml/2006/main">
@@ -4844,7 +4844,7 @@
     </p:spTree>
     <p:extLst>
       <p:ext uri="{BB962C8B-B14F-4D97-AF65-F5344CB8AC3E}">
-        <p14:creationId xmlns:p14="http://schemas.microsoft.com/office/powerpoint/2010/main" val="1654822301"/>
+        <p14:creationId xmlns:p14="http://schemas.microsoft.com/office/powerpoint/2010/main" val="743490756"/>
       </p:ext>
     </p:extLst>
   </p:cSld>
@@ -4875,7 +4875,7 @@
           <p:cNvPr id="9" name="">
             <a:extLst xmlns:a="http://schemas.openxmlformats.org/drawingml/2006/main">
               <a:ext uri="{FF2B5EF4-FFF2-40B4-BE49-F238E27FC236}">
-                <a16:creationId xmlns:a16="http://schemas.microsoft.com/office/drawing/2014/main" id="{DB5A1855-F31D-45F4-8614-61A6150BC309}"/>
+                <a16:creationId xmlns:a16="http://schemas.microsoft.com/office/drawing/2014/main" id="{5A339501-06DF-40BF-8AA9-53C3F1778DAC}"/>
               </a:ext>
             </a:extLst>
           </p:cNvPr>
@@ -4932,7 +4932,7 @@
           <p:cNvPr id="2" name="">
             <a:extLst xmlns:a="http://schemas.openxmlformats.org/drawingml/2006/main">
               <a:ext uri="{FF2B5EF4-FFF2-40B4-BE49-F238E27FC236}">
-                <a16:creationId xmlns:a16="http://schemas.microsoft.com/office/drawing/2014/main" id="{6300468D-0E7A-4F43-B837-821B178CC2B9}"/>
+                <a16:creationId xmlns:a16="http://schemas.microsoft.com/office/drawing/2014/main" id="{2E74021E-6BA7-43A0-B51D-3D8396BB06A5}"/>
               </a:ext>
             </a:extLst>
           </p:cNvPr>
@@ -4989,7 +4989,7 @@
           <p:cNvPr id="3" name="">
             <a:extLst xmlns:a="http://schemas.openxmlformats.org/drawingml/2006/main">
               <a:ext uri="{FF2B5EF4-FFF2-40B4-BE49-F238E27FC236}">
-                <a16:creationId xmlns:a16="http://schemas.microsoft.com/office/drawing/2014/main" id="{8BB3145E-CC53-43C2-8229-EC2182E53E16}"/>
+                <a16:creationId xmlns:a16="http://schemas.microsoft.com/office/drawing/2014/main" id="{E06FA78F-02E0-4727-BBCF-5CBA1DDB28B9}"/>
               </a:ext>
             </a:extLst>
           </p:cNvPr>
@@ -5046,7 +5046,7 @@
           <p:cNvPr id="4" name="">
             <a:extLst xmlns:a="http://schemas.openxmlformats.org/drawingml/2006/main">
               <a:ext uri="{FF2B5EF4-FFF2-40B4-BE49-F238E27FC236}">
-                <a16:creationId xmlns:a16="http://schemas.microsoft.com/office/drawing/2014/main" id="{6EC21E8B-4006-4587-B020-7319E36D98B1}"/>
+                <a16:creationId xmlns:a16="http://schemas.microsoft.com/office/drawing/2014/main" id="{ECE0D474-D62F-48EE-BD8B-3E0E1353AECE}"/>
               </a:ext>
             </a:extLst>
           </p:cNvPr>
@@ -5172,7 +5172,7 @@
           <p:cNvPr id="5" name="">
             <a:extLst xmlns:a="http://schemas.openxmlformats.org/drawingml/2006/main">
               <a:ext uri="{FF2B5EF4-FFF2-40B4-BE49-F238E27FC236}">
-                <a16:creationId xmlns:a16="http://schemas.microsoft.com/office/drawing/2014/main" id="{0A2E3A50-907A-4A29-8810-95E346E8C539}"/>
+                <a16:creationId xmlns:a16="http://schemas.microsoft.com/office/drawing/2014/main" id="{5F850A17-376C-4CE6-8DB6-1728E61A78C7}"/>
               </a:ext>
             </a:extLst>
           </p:cNvPr>
@@ -5229,7 +5229,7 @@
           <p:cNvPr id="6" name="">
             <a:extLst xmlns:a="http://schemas.openxmlformats.org/drawingml/2006/main">
               <a:ext uri="{FF2B5EF4-FFF2-40B4-BE49-F238E27FC236}">
-                <a16:creationId xmlns:a16="http://schemas.microsoft.com/office/drawing/2014/main" id="{24F22DAA-A35B-42CE-B837-B119BD09809E}"/>
+                <a16:creationId xmlns:a16="http://schemas.microsoft.com/office/drawing/2014/main" id="{99BE5A73-4704-467B-8F46-3B8BF561DD5E}"/>
               </a:ext>
             </a:extLst>
           </p:cNvPr>
@@ -5359,7 +5359,7 @@
           <p:nvPr/>
         </p:nvPicPr>
         <p:blipFill>
-          <a:blip xmlns:r="http://schemas.openxmlformats.org/officeDocument/2006/relationships" xmlns:a="http://schemas.openxmlformats.org/drawingml/2006/main" r:embed="Rb6f55f393b994610"/>
+          <a:blip xmlns:r="http://schemas.openxmlformats.org/officeDocument/2006/relationships" xmlns:a="http://schemas.openxmlformats.org/drawingml/2006/main" r:embed="R8cc7d631f15f4ac8"/>
           <a:stretch xmlns:a="http://schemas.openxmlformats.org/drawingml/2006/main"/>
         </p:blipFill>
         <p:spPr>
@@ -5377,7 +5377,7 @@
           <p:cNvPr id="8" name="">
             <a:extLst xmlns:a="http://schemas.openxmlformats.org/drawingml/2006/main">
               <a:ext uri="{FF2B5EF4-FFF2-40B4-BE49-F238E27FC236}">
-                <a16:creationId xmlns:a16="http://schemas.microsoft.com/office/drawing/2014/main" id="{1368DFCC-1B74-497A-BF8A-4813D7A0B86B}"/>
+                <a16:creationId xmlns:a16="http://schemas.microsoft.com/office/drawing/2014/main" id="{342B819D-6D52-4BE0-A726-32C149A061B0}"/>
               </a:ext>
             </a:extLst>
           </p:cNvPr>
@@ -5432,7 +5432,7 @@
     </p:spTree>
     <p:extLst>
       <p:ext uri="{BB962C8B-B14F-4D97-AF65-F5344CB8AC3E}">
-        <p14:creationId xmlns:p14="http://schemas.microsoft.com/office/powerpoint/2010/main" val="1275987072"/>
+        <p14:creationId xmlns:p14="http://schemas.microsoft.com/office/powerpoint/2010/main" val="1849114845"/>
       </p:ext>
     </p:extLst>
   </p:cSld>
@@ -5463,7 +5463,7 @@
           <p:cNvPr id="9" name="">
             <a:extLst xmlns:a="http://schemas.openxmlformats.org/drawingml/2006/main">
               <a:ext uri="{FF2B5EF4-FFF2-40B4-BE49-F238E27FC236}">
-                <a16:creationId xmlns:a16="http://schemas.microsoft.com/office/drawing/2014/main" id="{8D4312B9-1443-46C5-83FA-C4A84E912DB7}"/>
+                <a16:creationId xmlns:a16="http://schemas.microsoft.com/office/drawing/2014/main" id="{8AC5FE8C-B997-4EE1-87A6-33E994837FDB}"/>
               </a:ext>
             </a:extLst>
           </p:cNvPr>
@@ -5520,7 +5520,7 @@
           <p:cNvPr id="2" name="">
             <a:extLst xmlns:a="http://schemas.openxmlformats.org/drawingml/2006/main">
               <a:ext uri="{FF2B5EF4-FFF2-40B4-BE49-F238E27FC236}">
-                <a16:creationId xmlns:a16="http://schemas.microsoft.com/office/drawing/2014/main" id="{CD491ED0-0234-4CFC-8B72-51EE327760A6}"/>
+                <a16:creationId xmlns:a16="http://schemas.microsoft.com/office/drawing/2014/main" id="{E27738E0-5945-47D5-8553-115496F7D2F9}"/>
               </a:ext>
             </a:extLst>
           </p:cNvPr>
@@ -5577,7 +5577,7 @@
           <p:cNvPr id="3" name="">
             <a:extLst xmlns:a="http://schemas.openxmlformats.org/drawingml/2006/main">
               <a:ext uri="{FF2B5EF4-FFF2-40B4-BE49-F238E27FC236}">
-                <a16:creationId xmlns:a16="http://schemas.microsoft.com/office/drawing/2014/main" id="{A9378BAB-B274-4538-AA34-B9B56C28EB3E}"/>
+                <a16:creationId xmlns:a16="http://schemas.microsoft.com/office/drawing/2014/main" id="{068049FA-03E5-4E8C-B982-BF511267A298}"/>
               </a:ext>
             </a:extLst>
           </p:cNvPr>
@@ -5634,7 +5634,7 @@
           <p:cNvPr id="4" name="">
             <a:extLst xmlns:a="http://schemas.openxmlformats.org/drawingml/2006/main">
               <a:ext uri="{FF2B5EF4-FFF2-40B4-BE49-F238E27FC236}">
-                <a16:creationId xmlns:a16="http://schemas.microsoft.com/office/drawing/2014/main" id="{194B90E9-69EA-4DBB-A049-077635731AAC}"/>
+                <a16:creationId xmlns:a16="http://schemas.microsoft.com/office/drawing/2014/main" id="{C725AE7B-6074-4497-AA26-47284382168D}"/>
               </a:ext>
             </a:extLst>
           </p:cNvPr>
@@ -5681,7 +5681,7 @@
                 <a:ea typeface="Malgun Gothic"/>
                 <a:cs typeface="Malgun Gothic"/>
               </a:rPr>
-              <a:t>반영 직후 신규 사용자의</a:t>
+              <a:t>신규 계정의 임시비밀번호는</a:t>
             </a:r>
           </a:p>
           <a:p xmlns:a="http://schemas.openxmlformats.org/drawingml/2006/main">
@@ -5704,7 +5704,7 @@
                 <a:ea typeface="Malgun Gothic"/>
                 <a:cs typeface="Malgun Gothic"/>
               </a:rPr>
-              <a:t>임시비밀번호가 표시됩니다.</a:t>
+              <a:t>영문·숫자 8자리입니다.</a:t>
             </a:r>
           </a:p>
           <a:p xmlns:a="http://schemas.openxmlformats.org/drawingml/2006/main">
@@ -5750,7 +5750,7 @@
                 <a:ea typeface="Malgun Gothic"/>
                 <a:cs typeface="Malgun Gothic"/>
               </a:rPr>
-              <a:t>내려받아 학생별로</a:t>
+              <a:t>내려받아 본인 ID와 함께</a:t>
             </a:r>
           </a:p>
           <a:p xmlns:a="http://schemas.openxmlformats.org/drawingml/2006/main">
@@ -5783,7 +5783,7 @@
           <p:cNvPr id="5" name="">
             <a:extLst xmlns:a="http://schemas.openxmlformats.org/drawingml/2006/main">
               <a:ext uri="{FF2B5EF4-FFF2-40B4-BE49-F238E27FC236}">
-                <a16:creationId xmlns:a16="http://schemas.microsoft.com/office/drawing/2014/main" id="{0D3B8509-AB2D-468E-965F-ED4B0767E041}"/>
+                <a16:creationId xmlns:a16="http://schemas.microsoft.com/office/drawing/2014/main" id="{F54EC327-DC37-4FFC-91E6-E20EF3F58D5F}"/>
               </a:ext>
             </a:extLst>
           </p:cNvPr>
@@ -5840,7 +5840,7 @@
           <p:cNvPr id="6" name="">
             <a:extLst xmlns:a="http://schemas.openxmlformats.org/drawingml/2006/main">
               <a:ext uri="{FF2B5EF4-FFF2-40B4-BE49-F238E27FC236}">
-                <a16:creationId xmlns:a16="http://schemas.microsoft.com/office/drawing/2014/main" id="{06736B7B-8A6E-48E5-9C48-285D0F8DEF1C}"/>
+                <a16:creationId xmlns:a16="http://schemas.microsoft.com/office/drawing/2014/main" id="{06B180AC-D40A-4246-8C66-666DE51ABD7A}"/>
               </a:ext>
             </a:extLst>
           </p:cNvPr>
@@ -5970,7 +5970,7 @@
           <p:nvPr/>
         </p:nvPicPr>
         <p:blipFill>
-          <a:blip xmlns:r="http://schemas.openxmlformats.org/officeDocument/2006/relationships" xmlns:a="http://schemas.openxmlformats.org/drawingml/2006/main" r:embed="R7099556a136d4933"/>
+          <a:blip xmlns:r="http://schemas.openxmlformats.org/officeDocument/2006/relationships" xmlns:a="http://schemas.openxmlformats.org/drawingml/2006/main" r:embed="R411cc790dfe848a5"/>
           <a:stretch xmlns:a="http://schemas.openxmlformats.org/drawingml/2006/main"/>
         </p:blipFill>
         <p:spPr>
@@ -5988,7 +5988,7 @@
           <p:cNvPr id="8" name="">
             <a:extLst xmlns:a="http://schemas.openxmlformats.org/drawingml/2006/main">
               <a:ext uri="{FF2B5EF4-FFF2-40B4-BE49-F238E27FC236}">
-                <a16:creationId xmlns:a16="http://schemas.microsoft.com/office/drawing/2014/main" id="{9574EFE2-9342-479E-B4FE-BF1FB03A14AD}"/>
+                <a16:creationId xmlns:a16="http://schemas.microsoft.com/office/drawing/2014/main" id="{99508940-54B0-4C06-9486-C080DEF1703F}"/>
               </a:ext>
             </a:extLst>
           </p:cNvPr>
@@ -6043,7 +6043,7 @@
     </p:spTree>
     <p:extLst>
       <p:ext uri="{BB962C8B-B14F-4D97-AF65-F5344CB8AC3E}">
-        <p14:creationId xmlns:p14="http://schemas.microsoft.com/office/powerpoint/2010/main" val="1138533600"/>
+        <p14:creationId xmlns:p14="http://schemas.microsoft.com/office/powerpoint/2010/main" val="2111589561"/>
       </p:ext>
     </p:extLst>
   </p:cSld>
@@ -6074,7 +6074,7 @@
           <p:cNvPr id="9" name="">
             <a:extLst xmlns:a="http://schemas.openxmlformats.org/drawingml/2006/main">
               <a:ext uri="{FF2B5EF4-FFF2-40B4-BE49-F238E27FC236}">
-                <a16:creationId xmlns:a16="http://schemas.microsoft.com/office/drawing/2014/main" id="{3248DBBB-E5B4-40E0-BAF0-91ACB3009724}"/>
+                <a16:creationId xmlns:a16="http://schemas.microsoft.com/office/drawing/2014/main" id="{30418FAA-FC01-4606-9ADD-C4667D55C06D}"/>
               </a:ext>
             </a:extLst>
           </p:cNvPr>
@@ -6131,7 +6131,7 @@
           <p:cNvPr id="2" name="">
             <a:extLst xmlns:a="http://schemas.openxmlformats.org/drawingml/2006/main">
               <a:ext uri="{FF2B5EF4-FFF2-40B4-BE49-F238E27FC236}">
-                <a16:creationId xmlns:a16="http://schemas.microsoft.com/office/drawing/2014/main" id="{F8ADAE77-EFA8-4B25-A71C-4BD7DA60AA09}"/>
+                <a16:creationId xmlns:a16="http://schemas.microsoft.com/office/drawing/2014/main" id="{C6E4181F-9BFB-4986-9E82-D3DB40456C7F}"/>
               </a:ext>
             </a:extLst>
           </p:cNvPr>
@@ -6188,7 +6188,7 @@
           <p:cNvPr id="3" name="">
             <a:extLst xmlns:a="http://schemas.openxmlformats.org/drawingml/2006/main">
               <a:ext uri="{FF2B5EF4-FFF2-40B4-BE49-F238E27FC236}">
-                <a16:creationId xmlns:a16="http://schemas.microsoft.com/office/drawing/2014/main" id="{F43BF385-151D-4F8E-919D-594630784EF9}"/>
+                <a16:creationId xmlns:a16="http://schemas.microsoft.com/office/drawing/2014/main" id="{F9ECF85B-CCDB-4637-A04E-EE9E5A81C26E}"/>
               </a:ext>
             </a:extLst>
           </p:cNvPr>
@@ -6245,7 +6245,7 @@
           <p:cNvPr id="4" name="">
             <a:extLst xmlns:a="http://schemas.openxmlformats.org/drawingml/2006/main">
               <a:ext uri="{FF2B5EF4-FFF2-40B4-BE49-F238E27FC236}">
-                <a16:creationId xmlns:a16="http://schemas.microsoft.com/office/drawing/2014/main" id="{D32FDBE7-3D4C-4080-96BE-68D204BB2199}"/>
+                <a16:creationId xmlns:a16="http://schemas.microsoft.com/office/drawing/2014/main" id="{1B13992C-C937-4636-A28D-5B927BDB2BF3}"/>
               </a:ext>
             </a:extLst>
           </p:cNvPr>
@@ -6394,7 +6394,7 @@
           <p:cNvPr id="5" name="">
             <a:extLst xmlns:a="http://schemas.openxmlformats.org/drawingml/2006/main">
               <a:ext uri="{FF2B5EF4-FFF2-40B4-BE49-F238E27FC236}">
-                <a16:creationId xmlns:a16="http://schemas.microsoft.com/office/drawing/2014/main" id="{392A6D1D-9754-489F-A0E4-68D72AA563EA}"/>
+                <a16:creationId xmlns:a16="http://schemas.microsoft.com/office/drawing/2014/main" id="{B9DAB39D-32E0-4D48-9DE5-00D9EFF4F278}"/>
               </a:ext>
             </a:extLst>
           </p:cNvPr>
@@ -6451,7 +6451,7 @@
           <p:cNvPr id="6" name="">
             <a:extLst xmlns:a="http://schemas.openxmlformats.org/drawingml/2006/main">
               <a:ext uri="{FF2B5EF4-FFF2-40B4-BE49-F238E27FC236}">
-                <a16:creationId xmlns:a16="http://schemas.microsoft.com/office/drawing/2014/main" id="{6396D4DF-AD9C-491B-887B-BA8DA98A49F0}"/>
+                <a16:creationId xmlns:a16="http://schemas.microsoft.com/office/drawing/2014/main" id="{C49A8B0D-1F78-4E9E-97EA-3F1EDECF8367}"/>
               </a:ext>
             </a:extLst>
           </p:cNvPr>
@@ -6581,7 +6581,7 @@
           <p:nvPr/>
         </p:nvPicPr>
         <p:blipFill>
-          <a:blip xmlns:r="http://schemas.openxmlformats.org/officeDocument/2006/relationships" xmlns:a="http://schemas.openxmlformats.org/drawingml/2006/main" r:embed="R44ed44ab2dba47de"/>
+          <a:blip xmlns:r="http://schemas.openxmlformats.org/officeDocument/2006/relationships" xmlns:a="http://schemas.openxmlformats.org/drawingml/2006/main" r:embed="R872d84ed746247b5"/>
           <a:stretch xmlns:a="http://schemas.openxmlformats.org/drawingml/2006/main"/>
         </p:blipFill>
         <p:spPr>
@@ -6599,7 +6599,7 @@
           <p:cNvPr id="8" name="">
             <a:extLst xmlns:a="http://schemas.openxmlformats.org/drawingml/2006/main">
               <a:ext uri="{FF2B5EF4-FFF2-40B4-BE49-F238E27FC236}">
-                <a16:creationId xmlns:a16="http://schemas.microsoft.com/office/drawing/2014/main" id="{62555929-6FEA-487B-B894-F08BC359744C}"/>
+                <a16:creationId xmlns:a16="http://schemas.microsoft.com/office/drawing/2014/main" id="{4381B9D4-A0EC-4330-A608-1A3C45EEADED}"/>
               </a:ext>
             </a:extLst>
           </p:cNvPr>
@@ -6654,7 +6654,7 @@
     </p:spTree>
     <p:extLst>
       <p:ext uri="{BB962C8B-B14F-4D97-AF65-F5344CB8AC3E}">
-        <p14:creationId xmlns:p14="http://schemas.microsoft.com/office/powerpoint/2010/main" val="599260248"/>
+        <p14:creationId xmlns:p14="http://schemas.microsoft.com/office/powerpoint/2010/main" val="475924255"/>
       </p:ext>
     </p:extLst>
   </p:cSld>
@@ -6685,7 +6685,7 @@
           <p:cNvPr id="9" name="">
             <a:extLst xmlns:a="http://schemas.openxmlformats.org/drawingml/2006/main">
               <a:ext uri="{FF2B5EF4-FFF2-40B4-BE49-F238E27FC236}">
-                <a16:creationId xmlns:a16="http://schemas.microsoft.com/office/drawing/2014/main" id="{79C0AFC1-C4FA-40BF-A39C-B2A676DDE63B}"/>
+                <a16:creationId xmlns:a16="http://schemas.microsoft.com/office/drawing/2014/main" id="{E719CCF2-5897-45FC-838D-27151AC367D2}"/>
               </a:ext>
             </a:extLst>
           </p:cNvPr>
@@ -6742,7 +6742,7 @@
           <p:cNvPr id="2" name="">
             <a:extLst xmlns:a="http://schemas.openxmlformats.org/drawingml/2006/main">
               <a:ext uri="{FF2B5EF4-FFF2-40B4-BE49-F238E27FC236}">
-                <a16:creationId xmlns:a16="http://schemas.microsoft.com/office/drawing/2014/main" id="{F7D6E0A7-A634-421D-A38D-8FFAC78AA8FD}"/>
+                <a16:creationId xmlns:a16="http://schemas.microsoft.com/office/drawing/2014/main" id="{3F490414-D1A3-4EBF-968F-211B6DCAB7D1}"/>
               </a:ext>
             </a:extLst>
           </p:cNvPr>
@@ -6799,7 +6799,7 @@
           <p:cNvPr id="3" name="">
             <a:extLst xmlns:a="http://schemas.openxmlformats.org/drawingml/2006/main">
               <a:ext uri="{FF2B5EF4-FFF2-40B4-BE49-F238E27FC236}">
-                <a16:creationId xmlns:a16="http://schemas.microsoft.com/office/drawing/2014/main" id="{CEAB4E96-E286-4B0F-B0B7-8B034590EE16}"/>
+                <a16:creationId xmlns:a16="http://schemas.microsoft.com/office/drawing/2014/main" id="{99E8E20A-5177-4814-9FC1-34A76C73CC95}"/>
               </a:ext>
             </a:extLst>
           </p:cNvPr>
@@ -6856,7 +6856,7 @@
           <p:cNvPr id="4" name="">
             <a:extLst xmlns:a="http://schemas.openxmlformats.org/drawingml/2006/main">
               <a:ext uri="{FF2B5EF4-FFF2-40B4-BE49-F238E27FC236}">
-                <a16:creationId xmlns:a16="http://schemas.microsoft.com/office/drawing/2014/main" id="{6FF8E896-41F3-451A-9094-E0627BB1BF0B}"/>
+                <a16:creationId xmlns:a16="http://schemas.microsoft.com/office/drawing/2014/main" id="{4BC2332A-C369-47B6-AF88-6C52846B59C0}"/>
               </a:ext>
             </a:extLst>
           </p:cNvPr>
@@ -6982,7 +6982,7 @@
           <p:cNvPr id="5" name="">
             <a:extLst xmlns:a="http://schemas.openxmlformats.org/drawingml/2006/main">
               <a:ext uri="{FF2B5EF4-FFF2-40B4-BE49-F238E27FC236}">
-                <a16:creationId xmlns:a16="http://schemas.microsoft.com/office/drawing/2014/main" id="{DB716C77-933D-46CD-9F53-D1F248BE2659}"/>
+                <a16:creationId xmlns:a16="http://schemas.microsoft.com/office/drawing/2014/main" id="{8E81A2EC-7F09-4D82-AB02-CC480CBE6C67}"/>
               </a:ext>
             </a:extLst>
           </p:cNvPr>
@@ -7039,7 +7039,7 @@
           <p:cNvPr id="6" name="">
             <a:extLst xmlns:a="http://schemas.openxmlformats.org/drawingml/2006/main">
               <a:ext uri="{FF2B5EF4-FFF2-40B4-BE49-F238E27FC236}">
-                <a16:creationId xmlns:a16="http://schemas.microsoft.com/office/drawing/2014/main" id="{26F84FF6-8F67-4524-9D79-BF0362890D71}"/>
+                <a16:creationId xmlns:a16="http://schemas.microsoft.com/office/drawing/2014/main" id="{477616F9-E03C-45FB-BE83-B801E6BE372A}"/>
               </a:ext>
             </a:extLst>
           </p:cNvPr>
@@ -7192,7 +7192,7 @@
           <p:nvPr/>
         </p:nvPicPr>
         <p:blipFill>
-          <a:blip xmlns:r="http://schemas.openxmlformats.org/officeDocument/2006/relationships" xmlns:a="http://schemas.openxmlformats.org/drawingml/2006/main" r:embed="R036341dbfb74406a"/>
+          <a:blip xmlns:r="http://schemas.openxmlformats.org/officeDocument/2006/relationships" xmlns:a="http://schemas.openxmlformats.org/drawingml/2006/main" r:embed="R37be648bc9bb412d"/>
           <a:stretch xmlns:a="http://schemas.openxmlformats.org/drawingml/2006/main"/>
         </p:blipFill>
         <p:spPr>
@@ -7210,7 +7210,7 @@
           <p:cNvPr id="8" name="">
             <a:extLst xmlns:a="http://schemas.openxmlformats.org/drawingml/2006/main">
               <a:ext uri="{FF2B5EF4-FFF2-40B4-BE49-F238E27FC236}">
-                <a16:creationId xmlns:a16="http://schemas.microsoft.com/office/drawing/2014/main" id="{1980833A-BD3A-49C1-A053-4AA245551E2E}"/>
+                <a16:creationId xmlns:a16="http://schemas.microsoft.com/office/drawing/2014/main" id="{1D0FD6A9-8298-4558-B876-2954108B0819}"/>
               </a:ext>
             </a:extLst>
           </p:cNvPr>
@@ -7265,7 +7265,7 @@
     </p:spTree>
     <p:extLst>
       <p:ext uri="{BB962C8B-B14F-4D97-AF65-F5344CB8AC3E}">
-        <p14:creationId xmlns:p14="http://schemas.microsoft.com/office/powerpoint/2010/main" val="1413086567"/>
+        <p14:creationId xmlns:p14="http://schemas.microsoft.com/office/powerpoint/2010/main" val="2073620275"/>
       </p:ext>
     </p:extLst>
   </p:cSld>
@@ -7296,7 +7296,7 @@
           <p:cNvPr id="9" name="">
             <a:extLst xmlns:a="http://schemas.openxmlformats.org/drawingml/2006/main">
               <a:ext uri="{FF2B5EF4-FFF2-40B4-BE49-F238E27FC236}">
-                <a16:creationId xmlns:a16="http://schemas.microsoft.com/office/drawing/2014/main" id="{38CADB1E-ABB9-460D-8F88-DBB3C23DC46E}"/>
+                <a16:creationId xmlns:a16="http://schemas.microsoft.com/office/drawing/2014/main" id="{6C4C1171-0A7D-4631-BBF9-FE3C3C6876A6}"/>
               </a:ext>
             </a:extLst>
           </p:cNvPr>
@@ -7353,7 +7353,7 @@
           <p:cNvPr id="2" name="">
             <a:extLst xmlns:a="http://schemas.openxmlformats.org/drawingml/2006/main">
               <a:ext uri="{FF2B5EF4-FFF2-40B4-BE49-F238E27FC236}">
-                <a16:creationId xmlns:a16="http://schemas.microsoft.com/office/drawing/2014/main" id="{0D5BAE45-A8B3-4FFE-BE07-A5E80789559F}"/>
+                <a16:creationId xmlns:a16="http://schemas.microsoft.com/office/drawing/2014/main" id="{BDA7ABB6-94E9-40ED-8B1D-A21688D994DB}"/>
               </a:ext>
             </a:extLst>
           </p:cNvPr>
@@ -7410,7 +7410,7 @@
           <p:cNvPr id="3" name="">
             <a:extLst xmlns:a="http://schemas.openxmlformats.org/drawingml/2006/main">
               <a:ext uri="{FF2B5EF4-FFF2-40B4-BE49-F238E27FC236}">
-                <a16:creationId xmlns:a16="http://schemas.microsoft.com/office/drawing/2014/main" id="{6F48A13D-AB4F-4F4D-84D0-091F9B491C8D}"/>
+                <a16:creationId xmlns:a16="http://schemas.microsoft.com/office/drawing/2014/main" id="{CC3D5E8B-EFFB-49AF-921B-9CBCBE29C283}"/>
               </a:ext>
             </a:extLst>
           </p:cNvPr>
@@ -7467,7 +7467,7 @@
           <p:cNvPr id="4" name="">
             <a:extLst xmlns:a="http://schemas.openxmlformats.org/drawingml/2006/main">
               <a:ext uri="{FF2B5EF4-FFF2-40B4-BE49-F238E27FC236}">
-                <a16:creationId xmlns:a16="http://schemas.microsoft.com/office/drawing/2014/main" id="{6E09498A-869C-4B3D-873F-364DE0DEAE95}"/>
+                <a16:creationId xmlns:a16="http://schemas.microsoft.com/office/drawing/2014/main" id="{7F4D9DA7-8CA3-4E34-9642-20A5B578D012}"/>
               </a:ext>
             </a:extLst>
           </p:cNvPr>
@@ -7616,7 +7616,7 @@
           <p:cNvPr id="5" name="">
             <a:extLst xmlns:a="http://schemas.openxmlformats.org/drawingml/2006/main">
               <a:ext uri="{FF2B5EF4-FFF2-40B4-BE49-F238E27FC236}">
-                <a16:creationId xmlns:a16="http://schemas.microsoft.com/office/drawing/2014/main" id="{0EB0E81E-8240-4CF4-8888-CB310A81229D}"/>
+                <a16:creationId xmlns:a16="http://schemas.microsoft.com/office/drawing/2014/main" id="{9882C1F0-100D-4499-82B4-C28693C44C1A}"/>
               </a:ext>
             </a:extLst>
           </p:cNvPr>
@@ -7673,7 +7673,7 @@
           <p:cNvPr id="6" name="">
             <a:extLst xmlns:a="http://schemas.openxmlformats.org/drawingml/2006/main">
               <a:ext uri="{FF2B5EF4-FFF2-40B4-BE49-F238E27FC236}">
-                <a16:creationId xmlns:a16="http://schemas.microsoft.com/office/drawing/2014/main" id="{05453BEE-F7C8-497C-B69A-2A9ABDA3C691}"/>
+                <a16:creationId xmlns:a16="http://schemas.microsoft.com/office/drawing/2014/main" id="{3E04ABCF-D880-4907-9A8A-A4CA7AE3792A}"/>
               </a:ext>
             </a:extLst>
           </p:cNvPr>
@@ -7803,7 +7803,7 @@
           <p:nvPr/>
         </p:nvPicPr>
         <p:blipFill>
-          <a:blip xmlns:r="http://schemas.openxmlformats.org/officeDocument/2006/relationships" xmlns:a="http://schemas.openxmlformats.org/drawingml/2006/main" r:embed="R66f54abd7a8e41f2"/>
+          <a:blip xmlns:r="http://schemas.openxmlformats.org/officeDocument/2006/relationships" xmlns:a="http://schemas.openxmlformats.org/drawingml/2006/main" r:embed="Ra2ac8dc84dc34542"/>
           <a:stretch xmlns:a="http://schemas.openxmlformats.org/drawingml/2006/main"/>
         </p:blipFill>
         <p:spPr>
@@ -7821,7 +7821,7 @@
           <p:cNvPr id="8" name="">
             <a:extLst xmlns:a="http://schemas.openxmlformats.org/drawingml/2006/main">
               <a:ext uri="{FF2B5EF4-FFF2-40B4-BE49-F238E27FC236}">
-                <a16:creationId xmlns:a16="http://schemas.microsoft.com/office/drawing/2014/main" id="{CD5EECF6-32F1-471A-A63E-5D65D8F7E974}"/>
+                <a16:creationId xmlns:a16="http://schemas.microsoft.com/office/drawing/2014/main" id="{D727885C-F46D-43BA-A42B-A54A80295347}"/>
               </a:ext>
             </a:extLst>
           </p:cNvPr>
@@ -7876,7 +7876,7 @@
     </p:spTree>
     <p:extLst>
       <p:ext uri="{BB962C8B-B14F-4D97-AF65-F5344CB8AC3E}">
-        <p14:creationId xmlns:p14="http://schemas.microsoft.com/office/powerpoint/2010/main" val="155153405"/>
+        <p14:creationId xmlns:p14="http://schemas.microsoft.com/office/powerpoint/2010/main" val="1207051583"/>
       </p:ext>
     </p:extLst>
   </p:cSld>
@@ -7907,7 +7907,7 @@
           <p:cNvPr id="9" name="">
             <a:extLst xmlns:a="http://schemas.openxmlformats.org/drawingml/2006/main">
               <a:ext uri="{FF2B5EF4-FFF2-40B4-BE49-F238E27FC236}">
-                <a16:creationId xmlns:a16="http://schemas.microsoft.com/office/drawing/2014/main" id="{C4B8FB12-4083-436A-835F-E3B665235990}"/>
+                <a16:creationId xmlns:a16="http://schemas.microsoft.com/office/drawing/2014/main" id="{58F0A5B4-709A-4835-8782-1ABF90AC5CC5}"/>
               </a:ext>
             </a:extLst>
           </p:cNvPr>
@@ -7964,7 +7964,7 @@
           <p:cNvPr id="2" name="">
             <a:extLst xmlns:a="http://schemas.openxmlformats.org/drawingml/2006/main">
               <a:ext uri="{FF2B5EF4-FFF2-40B4-BE49-F238E27FC236}">
-                <a16:creationId xmlns:a16="http://schemas.microsoft.com/office/drawing/2014/main" id="{F0C0BB23-6AEE-4CD0-82BD-08F1F16D12BF}"/>
+                <a16:creationId xmlns:a16="http://schemas.microsoft.com/office/drawing/2014/main" id="{D69001BB-65B1-4D36-898C-F69670C82E8C}"/>
               </a:ext>
             </a:extLst>
           </p:cNvPr>
@@ -8021,7 +8021,7 @@
           <p:cNvPr id="3" name="">
             <a:extLst xmlns:a="http://schemas.openxmlformats.org/drawingml/2006/main">
               <a:ext uri="{FF2B5EF4-FFF2-40B4-BE49-F238E27FC236}">
-                <a16:creationId xmlns:a16="http://schemas.microsoft.com/office/drawing/2014/main" id="{0444483C-5E83-4D5F-B517-2BAA64E772AF}"/>
+                <a16:creationId xmlns:a16="http://schemas.microsoft.com/office/drawing/2014/main" id="{47C89AC3-0878-4276-A68F-CBD719648B19}"/>
               </a:ext>
             </a:extLst>
           </p:cNvPr>
@@ -8078,7 +8078,7 @@
           <p:cNvPr id="4" name="">
             <a:extLst xmlns:a="http://schemas.openxmlformats.org/drawingml/2006/main">
               <a:ext uri="{FF2B5EF4-FFF2-40B4-BE49-F238E27FC236}">
-                <a16:creationId xmlns:a16="http://schemas.microsoft.com/office/drawing/2014/main" id="{C6B3F10B-96B6-4817-A2E7-C5724C81E1C3}"/>
+                <a16:creationId xmlns:a16="http://schemas.microsoft.com/office/drawing/2014/main" id="{BEB529BD-FFC5-425A-9467-6BC34ED19B94}"/>
               </a:ext>
             </a:extLst>
           </p:cNvPr>
@@ -8227,7 +8227,7 @@
           <p:cNvPr id="5" name="">
             <a:extLst xmlns:a="http://schemas.openxmlformats.org/drawingml/2006/main">
               <a:ext uri="{FF2B5EF4-FFF2-40B4-BE49-F238E27FC236}">
-                <a16:creationId xmlns:a16="http://schemas.microsoft.com/office/drawing/2014/main" id="{573441C1-D96E-4F18-8479-2695CBB0A7C0}"/>
+                <a16:creationId xmlns:a16="http://schemas.microsoft.com/office/drawing/2014/main" id="{357BF411-47A0-4786-96F0-7C3421D87F30}"/>
               </a:ext>
             </a:extLst>
           </p:cNvPr>
@@ -8284,7 +8284,7 @@
           <p:cNvPr id="6" name="">
             <a:extLst xmlns:a="http://schemas.openxmlformats.org/drawingml/2006/main">
               <a:ext uri="{FF2B5EF4-FFF2-40B4-BE49-F238E27FC236}">
-                <a16:creationId xmlns:a16="http://schemas.microsoft.com/office/drawing/2014/main" id="{C83841B3-2EE2-4F58-B23B-61F4EFB2B0D6}"/>
+                <a16:creationId xmlns:a16="http://schemas.microsoft.com/office/drawing/2014/main" id="{60D97F1D-6453-4954-B96A-175D9A80C740}"/>
               </a:ext>
             </a:extLst>
           </p:cNvPr>
@@ -8414,7 +8414,7 @@
           <p:nvPr/>
         </p:nvPicPr>
         <p:blipFill>
-          <a:blip xmlns:r="http://schemas.openxmlformats.org/officeDocument/2006/relationships" xmlns:a="http://schemas.openxmlformats.org/drawingml/2006/main" r:embed="Rfc7c974f129f40ba"/>
+          <a:blip xmlns:r="http://schemas.openxmlformats.org/officeDocument/2006/relationships" xmlns:a="http://schemas.openxmlformats.org/drawingml/2006/main" r:embed="Red3146406a9b4bcf"/>
           <a:stretch xmlns:a="http://schemas.openxmlformats.org/drawingml/2006/main"/>
         </p:blipFill>
         <p:spPr>
@@ -8432,7 +8432,7 @@
           <p:cNvPr id="8" name="">
             <a:extLst xmlns:a="http://schemas.openxmlformats.org/drawingml/2006/main">
               <a:ext uri="{FF2B5EF4-FFF2-40B4-BE49-F238E27FC236}">
-                <a16:creationId xmlns:a16="http://schemas.microsoft.com/office/drawing/2014/main" id="{350229BB-A50D-4496-A19B-80B9E20A934F}"/>
+                <a16:creationId xmlns:a16="http://schemas.microsoft.com/office/drawing/2014/main" id="{DB05A6EE-6635-4CE2-A1E8-17B8AB9D5B0C}"/>
               </a:ext>
             </a:extLst>
           </p:cNvPr>
@@ -8487,7 +8487,7 @@
     </p:spTree>
     <p:extLst>
       <p:ext uri="{BB962C8B-B14F-4D97-AF65-F5344CB8AC3E}">
-        <p14:creationId xmlns:p14="http://schemas.microsoft.com/office/powerpoint/2010/main" val="171415470"/>
+        <p14:creationId xmlns:p14="http://schemas.microsoft.com/office/powerpoint/2010/main" val="965307915"/>
       </p:ext>
     </p:extLst>
   </p:cSld>
@@ -8518,7 +8518,7 @@
           <p:cNvPr id="9" name="">
             <a:extLst xmlns:a="http://schemas.openxmlformats.org/drawingml/2006/main">
               <a:ext uri="{FF2B5EF4-FFF2-40B4-BE49-F238E27FC236}">
-                <a16:creationId xmlns:a16="http://schemas.microsoft.com/office/drawing/2014/main" id="{F59D590A-CB78-4E9D-8586-A8ED6FC180DB}"/>
+                <a16:creationId xmlns:a16="http://schemas.microsoft.com/office/drawing/2014/main" id="{C7E660E4-52A6-4EAE-83A3-DFC9D165A7F8}"/>
               </a:ext>
             </a:extLst>
           </p:cNvPr>
@@ -8575,7 +8575,7 @@
           <p:cNvPr id="2" name="">
             <a:extLst xmlns:a="http://schemas.openxmlformats.org/drawingml/2006/main">
               <a:ext uri="{FF2B5EF4-FFF2-40B4-BE49-F238E27FC236}">
-                <a16:creationId xmlns:a16="http://schemas.microsoft.com/office/drawing/2014/main" id="{D4E73670-53AA-417A-9C9D-EBD1C1DD1633}"/>
+                <a16:creationId xmlns:a16="http://schemas.microsoft.com/office/drawing/2014/main" id="{F60C14B7-9F0D-4782-86B1-17C1B06F868D}"/>
               </a:ext>
             </a:extLst>
           </p:cNvPr>
@@ -8632,7 +8632,7 @@
           <p:cNvPr id="3" name="">
             <a:extLst xmlns:a="http://schemas.openxmlformats.org/drawingml/2006/main">
               <a:ext uri="{FF2B5EF4-FFF2-40B4-BE49-F238E27FC236}">
-                <a16:creationId xmlns:a16="http://schemas.microsoft.com/office/drawing/2014/main" id="{C37F0BBF-E2A2-4302-B255-F066DF273AF5}"/>
+                <a16:creationId xmlns:a16="http://schemas.microsoft.com/office/drawing/2014/main" id="{79C431E5-3F98-43BF-888F-F2BEEE7017E6}"/>
               </a:ext>
             </a:extLst>
           </p:cNvPr>
@@ -8689,7 +8689,7 @@
           <p:cNvPr id="4" name="">
             <a:extLst xmlns:a="http://schemas.openxmlformats.org/drawingml/2006/main">
               <a:ext uri="{FF2B5EF4-FFF2-40B4-BE49-F238E27FC236}">
-                <a16:creationId xmlns:a16="http://schemas.microsoft.com/office/drawing/2014/main" id="{AC2E89AF-7A6C-43F8-B64C-AAD25FFCA300}"/>
+                <a16:creationId xmlns:a16="http://schemas.microsoft.com/office/drawing/2014/main" id="{FD44E4F0-4668-4712-95BD-933030FFDC34}"/>
               </a:ext>
             </a:extLst>
           </p:cNvPr>
@@ -8838,7 +8838,7 @@
           <p:cNvPr id="5" name="">
             <a:extLst xmlns:a="http://schemas.openxmlformats.org/drawingml/2006/main">
               <a:ext uri="{FF2B5EF4-FFF2-40B4-BE49-F238E27FC236}">
-                <a16:creationId xmlns:a16="http://schemas.microsoft.com/office/drawing/2014/main" id="{D3A9892E-DD60-4387-AB34-FCA87AB6814E}"/>
+                <a16:creationId xmlns:a16="http://schemas.microsoft.com/office/drawing/2014/main" id="{8379D5FD-F86E-4D7C-8F43-01FC3AAB560E}"/>
               </a:ext>
             </a:extLst>
           </p:cNvPr>
@@ -8895,7 +8895,7 @@
           <p:cNvPr id="6" name="">
             <a:extLst xmlns:a="http://schemas.openxmlformats.org/drawingml/2006/main">
               <a:ext uri="{FF2B5EF4-FFF2-40B4-BE49-F238E27FC236}">
-                <a16:creationId xmlns:a16="http://schemas.microsoft.com/office/drawing/2014/main" id="{C5FA96AA-68DA-41DE-A850-95D955735F8A}"/>
+                <a16:creationId xmlns:a16="http://schemas.microsoft.com/office/drawing/2014/main" id="{EF9849CB-A70F-4141-9952-033C01F8689C}"/>
               </a:ext>
             </a:extLst>
           </p:cNvPr>
@@ -8965,7 +8965,7 @@
                 <a:ea typeface="Malgun Gothic"/>
                 <a:cs typeface="Malgun Gothic"/>
               </a:rPr>
-              <a:t>12~128자 비밀번호를</a:t>
+              <a:t>8~128자 비밀번호를</a:t>
             </a:r>
           </a:p>
           <a:p xmlns:a="http://schemas.openxmlformats.org/drawingml/2006/main">
@@ -9048,7 +9048,7 @@
           <p:nvPr/>
         </p:nvPicPr>
         <p:blipFill>
-          <a:blip xmlns:r="http://schemas.openxmlformats.org/officeDocument/2006/relationships" xmlns:a="http://schemas.openxmlformats.org/drawingml/2006/main" r:embed="R1c4ccd8ab9524591"/>
+          <a:blip xmlns:r="http://schemas.openxmlformats.org/officeDocument/2006/relationships" xmlns:a="http://schemas.openxmlformats.org/drawingml/2006/main" r:embed="R388af4e762b04697"/>
           <a:stretch xmlns:a="http://schemas.openxmlformats.org/drawingml/2006/main"/>
         </p:blipFill>
         <p:spPr>
@@ -9066,7 +9066,7 @@
           <p:cNvPr id="8" name="">
             <a:extLst xmlns:a="http://schemas.openxmlformats.org/drawingml/2006/main">
               <a:ext uri="{FF2B5EF4-FFF2-40B4-BE49-F238E27FC236}">
-                <a16:creationId xmlns:a16="http://schemas.microsoft.com/office/drawing/2014/main" id="{5E8DB50E-DC02-423D-80AB-718C38BAC5F9}"/>
+                <a16:creationId xmlns:a16="http://schemas.microsoft.com/office/drawing/2014/main" id="{6774624D-213B-478A-A828-01A3C080C028}"/>
               </a:ext>
             </a:extLst>
           </p:cNvPr>
@@ -9121,7 +9121,7 @@
     </p:spTree>
     <p:extLst>
       <p:ext uri="{BB962C8B-B14F-4D97-AF65-F5344CB8AC3E}">
-        <p14:creationId xmlns:p14="http://schemas.microsoft.com/office/powerpoint/2010/main" val="1423102804"/>
+        <p14:creationId xmlns:p14="http://schemas.microsoft.com/office/powerpoint/2010/main" val="1001469416"/>
       </p:ext>
     </p:extLst>
   </p:cSld>
@@ -9152,7 +9152,7 @@
           <p:cNvPr id="9" name="">
             <a:extLst xmlns:a="http://schemas.openxmlformats.org/drawingml/2006/main">
               <a:ext uri="{FF2B5EF4-FFF2-40B4-BE49-F238E27FC236}">
-                <a16:creationId xmlns:a16="http://schemas.microsoft.com/office/drawing/2014/main" id="{22BBB7CC-A49A-4806-A7E2-60E54C2258BA}"/>
+                <a16:creationId xmlns:a16="http://schemas.microsoft.com/office/drawing/2014/main" id="{A2A2A9F8-F065-4AB2-B04E-A207DA8D90CF}"/>
               </a:ext>
             </a:extLst>
           </p:cNvPr>
@@ -9199,7 +9199,7 @@
                 <a:ea typeface="Malgun Gothic"/>
                 <a:cs typeface="Malgun Gothic"/>
               </a:rPr>
-              <a:t>파일 제출 화면 연결</a:t>
+              <a:t>과제 선택 후 바로 제출</a:t>
             </a:r>
           </a:p>
         </p:txBody>
@@ -9209,7 +9209,7 @@
           <p:cNvPr id="2" name="">
             <a:extLst xmlns:a="http://schemas.openxmlformats.org/drawingml/2006/main">
               <a:ext uri="{FF2B5EF4-FFF2-40B4-BE49-F238E27FC236}">
-                <a16:creationId xmlns:a16="http://schemas.microsoft.com/office/drawing/2014/main" id="{B7171457-6CF3-4DDF-ABD3-A81D45F1A5B9}"/>
+                <a16:creationId xmlns:a16="http://schemas.microsoft.com/office/drawing/2014/main" id="{EE2AFA1A-F13F-48DD-B74D-453D9C0A769F}"/>
               </a:ext>
             </a:extLst>
           </p:cNvPr>
@@ -9266,7 +9266,7 @@
           <p:cNvPr id="3" name="">
             <a:extLst xmlns:a="http://schemas.openxmlformats.org/drawingml/2006/main">
               <a:ext uri="{FF2B5EF4-FFF2-40B4-BE49-F238E27FC236}">
-                <a16:creationId xmlns:a16="http://schemas.microsoft.com/office/drawing/2014/main" id="{79F3F324-D767-4F28-A7E1-C126190EF76D}"/>
+                <a16:creationId xmlns:a16="http://schemas.microsoft.com/office/drawing/2014/main" id="{11B7745C-E38B-4899-BDFB-1FCA719937FD}"/>
               </a:ext>
             </a:extLst>
           </p:cNvPr>
@@ -9313,7 +9313,7 @@
                 <a:ea typeface="Malgun Gothic"/>
                 <a:cs typeface="Malgun Gothic"/>
               </a:rPr>
-              <a:t>연결 코드 사용</a:t>
+              <a:t>제출할 과제 선택</a:t>
             </a:r>
           </a:p>
         </p:txBody>
@@ -9323,7 +9323,7 @@
           <p:cNvPr id="4" name="">
             <a:extLst xmlns:a="http://schemas.openxmlformats.org/drawingml/2006/main">
               <a:ext uri="{FF2B5EF4-FFF2-40B4-BE49-F238E27FC236}">
-                <a16:creationId xmlns:a16="http://schemas.microsoft.com/office/drawing/2014/main" id="{3FD5272B-35AA-4765-99DE-86B9D8D7C619}"/>
+                <a16:creationId xmlns:a16="http://schemas.microsoft.com/office/drawing/2014/main" id="{973BFB8F-BAB2-480D-96FC-49797849651B}"/>
               </a:ext>
             </a:extLst>
           </p:cNvPr>
@@ -9370,7 +9370,7 @@
                 <a:ea typeface="Malgun Gothic"/>
                 <a:cs typeface="Malgun Gothic"/>
               </a:rPr>
-              <a:t>일회용 연결 코드 발급을 눌러</a:t>
+              <a:t>수업 화면에서 안내받은</a:t>
             </a:r>
           </a:p>
           <a:p xmlns:a="http://schemas.openxmlformats.org/drawingml/2006/main">
@@ -9393,7 +9393,7 @@
                 <a:ea typeface="Malgun Gothic"/>
                 <a:cs typeface="Malgun Gothic"/>
               </a:rPr>
-              <a:t>코드를 복사합니다. 파일</a:t>
+              <a:t>과제를 고릅니다. 과제</a:t>
             </a:r>
           </a:p>
           <a:p xmlns:a="http://schemas.openxmlformats.org/drawingml/2006/main">
@@ -9416,7 +9416,7 @@
                 <a:ea typeface="Malgun Gothic"/>
                 <a:cs typeface="Malgun Gothic"/>
               </a:rPr>
-              <a:t>제출·이어 올리기 화면</a:t>
+              <a:t>설명과 접수 상태를</a:t>
             </a:r>
           </a:p>
           <a:p xmlns:a="http://schemas.openxmlformats.org/drawingml/2006/main">
@@ -9439,7 +9439,7 @@
                 <a:ea typeface="Malgun Gothic"/>
                 <a:cs typeface="Malgun Gothic"/>
               </a:rPr>
-              <a:t>열기로 제출 창을 엽니다.</a:t>
+              <a:t>확인합니다.</a:t>
             </a:r>
           </a:p>
         </p:txBody>
@@ -9449,7 +9449,7 @@
           <p:cNvPr id="5" name="">
             <a:extLst xmlns:a="http://schemas.openxmlformats.org/drawingml/2006/main">
               <a:ext uri="{FF2B5EF4-FFF2-40B4-BE49-F238E27FC236}">
-                <a16:creationId xmlns:a16="http://schemas.microsoft.com/office/drawing/2014/main" id="{50BB8227-8DED-4395-A49E-DA5DC82886C0}"/>
+                <a16:creationId xmlns:a16="http://schemas.microsoft.com/office/drawing/2014/main" id="{0D340A05-0C2C-4BA6-8DF2-E435867BD6ED}"/>
               </a:ext>
             </a:extLst>
           </p:cNvPr>
@@ -9496,7 +9496,7 @@
                 <a:ea typeface="Malgun Gothic"/>
                 <a:cs typeface="Malgun Gothic"/>
               </a:rPr>
-              <a:t>접속 계정 확인</a:t>
+              <a:t>파일 제출 버튼</a:t>
             </a:r>
           </a:p>
         </p:txBody>
@@ -9506,7 +9506,7 @@
           <p:cNvPr id="6" name="">
             <a:extLst xmlns:a="http://schemas.openxmlformats.org/drawingml/2006/main">
               <a:ext uri="{FF2B5EF4-FFF2-40B4-BE49-F238E27FC236}">
-                <a16:creationId xmlns:a16="http://schemas.microsoft.com/office/drawing/2014/main" id="{3898DDF1-28EB-4F2A-B012-166AF62C6F8F}"/>
+                <a16:creationId xmlns:a16="http://schemas.microsoft.com/office/drawing/2014/main" id="{62B43F51-4E6A-45D2-9DE5-7DA7C8A7796A}"/>
               </a:ext>
             </a:extLst>
           </p:cNvPr>
@@ -9553,7 +9553,7 @@
                 <a:ea typeface="Malgun Gothic"/>
                 <a:cs typeface="Malgun Gothic"/>
               </a:rPr>
-              <a:t>제출 창에서 코드로</a:t>
+              <a:t>파일 제출·이어 올리기를</a:t>
             </a:r>
           </a:p>
           <a:p xmlns:a="http://schemas.openxmlformats.org/drawingml/2006/main">
@@ -9576,7 +9576,7 @@
                 <a:ea typeface="Malgun Gothic"/>
                 <a:cs typeface="Malgun Gothic"/>
               </a:rPr>
-              <a:t>연결합니다. 연결 후 표시된</a:t>
+              <a:t>누릅니다. 현재 로그인한</a:t>
             </a:r>
           </a:p>
           <a:p xmlns:a="http://schemas.openxmlformats.org/drawingml/2006/main">
@@ -9599,7 +9599,7 @@
                 <a:ea typeface="Malgun Gothic"/>
                 <a:cs typeface="Malgun Gothic"/>
               </a:rPr>
-              <a:t>ID가 본인의 ID인지</a:t>
+              <a:t>계정과 선택한 과제로 제출</a:t>
             </a:r>
           </a:p>
           <a:p xmlns:a="http://schemas.openxmlformats.org/drawingml/2006/main">
@@ -9622,7 +9622,7 @@
                 <a:ea typeface="Malgun Gothic"/>
                 <a:cs typeface="Malgun Gothic"/>
               </a:rPr>
-              <a:t>확인합니다.</a:t>
+              <a:t>창이 바로 열립니다.</a:t>
             </a:r>
           </a:p>
         </p:txBody>
@@ -9636,7 +9636,7 @@
           <p:nvPr/>
         </p:nvPicPr>
         <p:blipFill>
-          <a:blip xmlns:r="http://schemas.openxmlformats.org/officeDocument/2006/relationships" xmlns:a="http://schemas.openxmlformats.org/drawingml/2006/main" r:embed="Ra68cc6a51159447a"/>
+          <a:blip xmlns:r="http://schemas.openxmlformats.org/officeDocument/2006/relationships" xmlns:a="http://schemas.openxmlformats.org/drawingml/2006/main" r:embed="R8ad5a65dd28c42ba"/>
           <a:stretch xmlns:a="http://schemas.openxmlformats.org/drawingml/2006/main"/>
         </p:blipFill>
         <p:spPr>
@@ -9654,7 +9654,7 @@
           <p:cNvPr id="8" name="">
             <a:extLst xmlns:a="http://schemas.openxmlformats.org/drawingml/2006/main">
               <a:ext uri="{FF2B5EF4-FFF2-40B4-BE49-F238E27FC236}">
-                <a16:creationId xmlns:a16="http://schemas.microsoft.com/office/drawing/2014/main" id="{25589939-81CC-474E-90E9-A514E3CA55A3}"/>
+                <a16:creationId xmlns:a16="http://schemas.microsoft.com/office/drawing/2014/main" id="{AAD258E5-39FF-4FB8-8640-DB8CE1C0DB15}"/>
               </a:ext>
             </a:extLst>
           </p:cNvPr>
@@ -9701,7 +9701,7 @@
                 <a:ea typeface="Malgun Gothic"/>
                 <a:cs typeface="Malgun Gothic"/>
               </a:rPr>
-              <a:t>코드는 짧은 시간 동안 한 번만 사용합니다. 예시 화면의 코드 영역은 가렸습니다.</a:t>
+              <a:t>코드 발급이나 입력 없이 제출할 수 있습니다. 수업 화면에서 로그아웃하면 열어 둔 제출 창의 로그인도 종료됩니다.</a:t>
             </a:r>
           </a:p>
         </p:txBody>
@@ -9709,7 +9709,7 @@
     </p:spTree>
     <p:extLst>
       <p:ext uri="{BB962C8B-B14F-4D97-AF65-F5344CB8AC3E}">
-        <p14:creationId xmlns:p14="http://schemas.microsoft.com/office/powerpoint/2010/main" val="2106929480"/>
+        <p14:creationId xmlns:p14="http://schemas.microsoft.com/office/powerpoint/2010/main" val="858077516"/>
       </p:ext>
     </p:extLst>
   </p:cSld>
@@ -9740,7 +9740,7 @@
           <p:cNvPr id="9" name="">
             <a:extLst xmlns:a="http://schemas.openxmlformats.org/drawingml/2006/main">
               <a:ext uri="{FF2B5EF4-FFF2-40B4-BE49-F238E27FC236}">
-                <a16:creationId xmlns:a16="http://schemas.microsoft.com/office/drawing/2014/main" id="{34CBD2A3-3AB8-4B33-9B7E-B20C472B9F4B}"/>
+                <a16:creationId xmlns:a16="http://schemas.microsoft.com/office/drawing/2014/main" id="{6828C687-3E99-419B-90AE-A59842F0C4BC}"/>
               </a:ext>
             </a:extLst>
           </p:cNvPr>
@@ -9787,7 +9787,7 @@
                 <a:ea typeface="Malgun Gothic"/>
                 <a:cs typeface="Malgun Gothic"/>
               </a:rPr>
-              <a:t>제출 창에서 직접 로그인</a:t>
+              <a:t>파일 선택 화면 확인</a:t>
             </a:r>
           </a:p>
         </p:txBody>
@@ -9797,7 +9797,7 @@
           <p:cNvPr id="2" name="">
             <a:extLst xmlns:a="http://schemas.openxmlformats.org/drawingml/2006/main">
               <a:ext uri="{FF2B5EF4-FFF2-40B4-BE49-F238E27FC236}">
-                <a16:creationId xmlns:a16="http://schemas.microsoft.com/office/drawing/2014/main" id="{00381EBF-5F87-4CDC-9CEB-FB1532AC0999}"/>
+                <a16:creationId xmlns:a16="http://schemas.microsoft.com/office/drawing/2014/main" id="{F212F065-C3A1-45AA-82C6-8323C6B68BDE}"/>
               </a:ext>
             </a:extLst>
           </p:cNvPr>
@@ -9854,7 +9854,7 @@
           <p:cNvPr id="3" name="">
             <a:extLst xmlns:a="http://schemas.openxmlformats.org/drawingml/2006/main">
               <a:ext uri="{FF2B5EF4-FFF2-40B4-BE49-F238E27FC236}">
-                <a16:creationId xmlns:a16="http://schemas.microsoft.com/office/drawing/2014/main" id="{DCE5EC8C-7C98-451B-B38B-66A31B68909B}"/>
+                <a16:creationId xmlns:a16="http://schemas.microsoft.com/office/drawing/2014/main" id="{22CB8735-46FF-4DAD-9DEA-437FBA641F27}"/>
               </a:ext>
             </a:extLst>
           </p:cNvPr>
@@ -9901,7 +9901,7 @@
                 <a:ea typeface="Malgun Gothic"/>
                 <a:cs typeface="Malgun Gothic"/>
               </a:rPr>
-              <a:t>코드가 만료된 경우</a:t>
+              <a:t>본인 계정과 과제 확인</a:t>
             </a:r>
           </a:p>
         </p:txBody>
@@ -9911,7 +9911,7 @@
           <p:cNvPr id="4" name="">
             <a:extLst xmlns:a="http://schemas.openxmlformats.org/drawingml/2006/main">
               <a:ext uri="{FF2B5EF4-FFF2-40B4-BE49-F238E27FC236}">
-                <a16:creationId xmlns:a16="http://schemas.microsoft.com/office/drawing/2014/main" id="{CF71EF05-E666-4249-95F7-13D840036170}"/>
+                <a16:creationId xmlns:a16="http://schemas.microsoft.com/office/drawing/2014/main" id="{60CC17DA-2582-4889-A4AE-58BB635419E9}"/>
               </a:ext>
             </a:extLst>
           </p:cNvPr>
@@ -9958,7 +9958,7 @@
                 <a:ea typeface="Malgun Gothic"/>
                 <a:cs typeface="Malgun Gothic"/>
               </a:rPr>
-              <a:t>새 연결 코드를 받거나 제출</a:t>
+              <a:t>제출 창에 본인의 ID와 선택한</a:t>
             </a:r>
           </a:p>
           <a:p xmlns:a="http://schemas.openxmlformats.org/drawingml/2006/main">
@@ -9981,7 +9981,7 @@
                 <a:ea typeface="Malgun Gothic"/>
                 <a:cs typeface="Malgun Gothic"/>
               </a:rPr>
-              <a:t>창의 ID와 비밀번호로</a:t>
+              <a:t>과제가 표시됩니다. 파일을</a:t>
             </a:r>
           </a:p>
           <a:p xmlns:a="http://schemas.openxmlformats.org/drawingml/2006/main">
@@ -10004,7 +10004,7 @@
                 <a:ea typeface="Malgun Gothic"/>
                 <a:cs typeface="Malgun Gothic"/>
               </a:rPr>
-              <a:t>로그인합니다. 비밀번호는</a:t>
+              <a:t>선택한 뒤 제출 시작을</a:t>
             </a:r>
           </a:p>
           <a:p xmlns:a="http://schemas.openxmlformats.org/drawingml/2006/main">
@@ -10027,30 +10027,7 @@
                 <a:ea typeface="Malgun Gothic"/>
                 <a:cs typeface="Malgun Gothic"/>
               </a:rPr>
-              <a:t>처음 변경한 새</a:t>
-            </a:r>
-          </a:p>
-          <a:p xmlns:a="http://schemas.openxmlformats.org/drawingml/2006/main">
-            <a:pPr>
-              <a:defRPr sz="2025" b="0">
-                <a:solidFill>
-                  <a:srgbClr val="202539"/>
-                </a:solidFill>
-                <a:latin typeface="Malgun Gothic"/>
-                <a:ea typeface="Malgun Gothic"/>
-                <a:cs typeface="Malgun Gothic"/>
-              </a:defRPr>
-            </a:pPr>
-            <a:r>
-              <a:rPr sz="2025" b="0">
-                <a:solidFill>
-                  <a:srgbClr val="202539"/>
-                </a:solidFill>
-                <a:latin typeface="Malgun Gothic"/>
-                <a:ea typeface="Malgun Gothic"/>
-                <a:cs typeface="Malgun Gothic"/>
-              </a:rPr>
-              <a:t>비밀번호입니다.</a:t>
+              <a:t>누릅니다.</a:t>
             </a:r>
           </a:p>
         </p:txBody>
@@ -10060,7 +10037,7 @@
           <p:cNvPr id="5" name="">
             <a:extLst xmlns:a="http://schemas.openxmlformats.org/drawingml/2006/main">
               <a:ext uri="{FF2B5EF4-FFF2-40B4-BE49-F238E27FC236}">
-                <a16:creationId xmlns:a16="http://schemas.microsoft.com/office/drawing/2014/main" id="{12DC8DE8-874F-434E-B515-8B97617A71D1}"/>
+                <a16:creationId xmlns:a16="http://schemas.microsoft.com/office/drawing/2014/main" id="{2B2B1B2D-5003-4F15-B52D-CC36ED261A84}"/>
               </a:ext>
             </a:extLst>
           </p:cNvPr>
@@ -10107,7 +10084,7 @@
                 <a:ea typeface="Malgun Gothic"/>
                 <a:cs typeface="Malgun Gothic"/>
               </a:rPr>
-              <a:t>다시 연 창</a:t>
+              <a:t>주소로 직접 접속한 경우</a:t>
             </a:r>
           </a:p>
         </p:txBody>
@@ -10117,7 +10094,7 @@
           <p:cNvPr id="6" name="">
             <a:extLst xmlns:a="http://schemas.openxmlformats.org/drawingml/2006/main">
               <a:ext uri="{FF2B5EF4-FFF2-40B4-BE49-F238E27FC236}">
-                <a16:creationId xmlns:a16="http://schemas.microsoft.com/office/drawing/2014/main" id="{29A1EA0A-39A8-4F22-A961-269B6F1BCC80}"/>
+                <a16:creationId xmlns:a16="http://schemas.microsoft.com/office/drawing/2014/main" id="{B5DCB2A3-04AF-4444-96D1-870D111D4BE6}"/>
               </a:ext>
             </a:extLst>
           </p:cNvPr>
@@ -10164,7 +10141,7 @@
                 <a:ea typeface="Malgun Gothic"/>
                 <a:cs typeface="Malgun Gothic"/>
               </a:rPr>
-              <a:t>새로고침이나 브라우저</a:t>
+              <a:t>제출 창 주소를 직접 열었거나</a:t>
             </a:r>
           </a:p>
           <a:p xmlns:a="http://schemas.openxmlformats.org/drawingml/2006/main">
@@ -10187,7 +10164,7 @@
                 <a:ea typeface="Malgun Gothic"/>
                 <a:cs typeface="Malgun Gothic"/>
               </a:rPr>
-              <a:t>재실행 후에도 본인 계정으로</a:t>
+              <a:t>로그인이 끝났다면 본인 ID와</a:t>
             </a:r>
           </a:p>
           <a:p xmlns:a="http://schemas.openxmlformats.org/drawingml/2006/main">
@@ -10210,7 +10187,7 @@
                 <a:ea typeface="Malgun Gothic"/>
                 <a:cs typeface="Malgun Gothic"/>
               </a:rPr>
-              <a:t>로그인할 수 있습니다. 이어</a:t>
+              <a:t>변경한 비밀번호로</a:t>
             </a:r>
           </a:p>
           <a:p xmlns:a="http://schemas.openxmlformats.org/drawingml/2006/main">
@@ -10233,30 +10210,7 @@
                 <a:ea typeface="Malgun Gothic"/>
                 <a:cs typeface="Malgun Gothic"/>
               </a:rPr>
-              <a:t>올릴 작업은 로그인 후</a:t>
-            </a:r>
-          </a:p>
-          <a:p xmlns:a="http://schemas.openxmlformats.org/drawingml/2006/main">
-            <a:pPr>
-              <a:defRPr sz="2025" b="0">
-                <a:solidFill>
-                  <a:srgbClr val="202539"/>
-                </a:solidFill>
-                <a:latin typeface="Malgun Gothic"/>
-                <a:ea typeface="Malgun Gothic"/>
-                <a:cs typeface="Malgun Gothic"/>
-              </a:defRPr>
-            </a:pPr>
-            <a:r>
-              <a:rPr sz="2025" b="0">
-                <a:solidFill>
-                  <a:srgbClr val="202539"/>
-                </a:solidFill>
-                <a:latin typeface="Malgun Gothic"/>
-                <a:ea typeface="Malgun Gothic"/>
-                <a:cs typeface="Malgun Gothic"/>
-              </a:rPr>
-              <a:t>선택합니다.</a:t>
+              <a:t>로그인합니다.</a:t>
             </a:r>
           </a:p>
         </p:txBody>
@@ -10270,7 +10224,7 @@
           <p:nvPr/>
         </p:nvPicPr>
         <p:blipFill>
-          <a:blip xmlns:r="http://schemas.openxmlformats.org/officeDocument/2006/relationships" xmlns:a="http://schemas.openxmlformats.org/drawingml/2006/main" r:embed="Rb9f383c6ee274c74"/>
+          <a:blip xmlns:r="http://schemas.openxmlformats.org/officeDocument/2006/relationships" xmlns:a="http://schemas.openxmlformats.org/drawingml/2006/main" r:embed="R20b41e061f174505"/>
           <a:stretch xmlns:a="http://schemas.openxmlformats.org/drawingml/2006/main"/>
         </p:blipFill>
         <p:spPr>
@@ -10288,7 +10242,7 @@
           <p:cNvPr id="8" name="">
             <a:extLst xmlns:a="http://schemas.openxmlformats.org/drawingml/2006/main">
               <a:ext uri="{FF2B5EF4-FFF2-40B4-BE49-F238E27FC236}">
-                <a16:creationId xmlns:a16="http://schemas.microsoft.com/office/drawing/2014/main" id="{CAD07815-1ED3-41F9-8AFA-353B4312B51B}"/>
+                <a16:creationId xmlns:a16="http://schemas.microsoft.com/office/drawing/2014/main" id="{2562E19A-4377-4C53-8226-1AC57200341C}"/>
               </a:ext>
             </a:extLst>
           </p:cNvPr>
@@ -10335,7 +10289,7 @@
                 <a:ea typeface="Malgun Gothic"/>
                 <a:cs typeface="Malgun Gothic"/>
               </a:rPr>
-              <a:t>다른 사람의 계정으로 제출하면 그 계정의 이력에 남습니다. 본인 계정과 과제명을 확인하세요.</a:t>
+              <a:t>파일 전송이 중단되면 미완료 작업을 선택해 이어 올릴 수 있습니다. 처음 선택한 원본 파일을 그대로 보관하세요.</a:t>
             </a:r>
           </a:p>
         </p:txBody>
@@ -10343,7 +10297,7 @@
     </p:spTree>
     <p:extLst>
       <p:ext uri="{BB962C8B-B14F-4D97-AF65-F5344CB8AC3E}">
-        <p14:creationId xmlns:p14="http://schemas.microsoft.com/office/powerpoint/2010/main" val="2121320877"/>
+        <p14:creationId xmlns:p14="http://schemas.microsoft.com/office/powerpoint/2010/main" val="1149510551"/>
       </p:ext>
     </p:extLst>
   </p:cSld>
@@ -10374,7 +10328,7 @@
           <p:cNvPr id="9" name="">
             <a:extLst xmlns:a="http://schemas.openxmlformats.org/drawingml/2006/main">
               <a:ext uri="{FF2B5EF4-FFF2-40B4-BE49-F238E27FC236}">
-                <a16:creationId xmlns:a16="http://schemas.microsoft.com/office/drawing/2014/main" id="{C928AC0B-DDDE-47D4-AE30-EC3A06D25151}"/>
+                <a16:creationId xmlns:a16="http://schemas.microsoft.com/office/drawing/2014/main" id="{1EB8028B-AF85-43D1-9A91-7BCA54C3FD5F}"/>
               </a:ext>
             </a:extLst>
           </p:cNvPr>
@@ -10431,7 +10385,7 @@
           <p:cNvPr id="2" name="">
             <a:extLst xmlns:a="http://schemas.openxmlformats.org/drawingml/2006/main">
               <a:ext uri="{FF2B5EF4-FFF2-40B4-BE49-F238E27FC236}">
-                <a16:creationId xmlns:a16="http://schemas.microsoft.com/office/drawing/2014/main" id="{CC439083-8F98-4293-8268-AF343A4146EC}"/>
+                <a16:creationId xmlns:a16="http://schemas.microsoft.com/office/drawing/2014/main" id="{510FD19C-B02F-47DE-A0D9-9418FF647B26}"/>
               </a:ext>
             </a:extLst>
           </p:cNvPr>
@@ -10488,7 +10442,7 @@
           <p:cNvPr id="3" name="">
             <a:extLst xmlns:a="http://schemas.openxmlformats.org/drawingml/2006/main">
               <a:ext uri="{FF2B5EF4-FFF2-40B4-BE49-F238E27FC236}">
-                <a16:creationId xmlns:a16="http://schemas.microsoft.com/office/drawing/2014/main" id="{A248FD84-A943-4406-AC00-DC3FA90DE573}"/>
+                <a16:creationId xmlns:a16="http://schemas.microsoft.com/office/drawing/2014/main" id="{2C143137-5507-46F1-A519-CC05C6DC48B6}"/>
               </a:ext>
             </a:extLst>
           </p:cNvPr>
@@ -10545,7 +10499,7 @@
           <p:cNvPr id="4" name="">
             <a:extLst xmlns:a="http://schemas.openxmlformats.org/drawingml/2006/main">
               <a:ext uri="{FF2B5EF4-FFF2-40B4-BE49-F238E27FC236}">
-                <a16:creationId xmlns:a16="http://schemas.microsoft.com/office/drawing/2014/main" id="{F735E758-04C7-485A-A717-A169A895F830}"/>
+                <a16:creationId xmlns:a16="http://schemas.microsoft.com/office/drawing/2014/main" id="{1454B5DE-312C-477F-93D2-4BE48174DC2F}"/>
               </a:ext>
             </a:extLst>
           </p:cNvPr>
@@ -10694,7 +10648,7 @@
           <p:cNvPr id="5" name="">
             <a:extLst xmlns:a="http://schemas.openxmlformats.org/drawingml/2006/main">
               <a:ext uri="{FF2B5EF4-FFF2-40B4-BE49-F238E27FC236}">
-                <a16:creationId xmlns:a16="http://schemas.microsoft.com/office/drawing/2014/main" id="{5E180FC0-3814-4FF1-A41E-4D6381C6DC6F}"/>
+                <a16:creationId xmlns:a16="http://schemas.microsoft.com/office/drawing/2014/main" id="{7CD9C9C6-A9CC-4DB5-BCFE-5EBBF09D23C9}"/>
               </a:ext>
             </a:extLst>
           </p:cNvPr>
@@ -10751,7 +10705,7 @@
           <p:cNvPr id="6" name="">
             <a:extLst xmlns:a="http://schemas.openxmlformats.org/drawingml/2006/main">
               <a:ext uri="{FF2B5EF4-FFF2-40B4-BE49-F238E27FC236}">
-                <a16:creationId xmlns:a16="http://schemas.microsoft.com/office/drawing/2014/main" id="{99E34C48-15AE-4572-89EA-A9C1D54B1EF0}"/>
+                <a16:creationId xmlns:a16="http://schemas.microsoft.com/office/drawing/2014/main" id="{A204C7C1-26DF-4DB8-B7FD-E5407B865301}"/>
               </a:ext>
             </a:extLst>
           </p:cNvPr>
@@ -10904,7 +10858,7 @@
           <p:nvPr/>
         </p:nvPicPr>
         <p:blipFill>
-          <a:blip xmlns:r="http://schemas.openxmlformats.org/officeDocument/2006/relationships" xmlns:a="http://schemas.openxmlformats.org/drawingml/2006/main" r:embed="Ra3b53f7d3bee4a22"/>
+          <a:blip xmlns:r="http://schemas.openxmlformats.org/officeDocument/2006/relationships" xmlns:a="http://schemas.openxmlformats.org/drawingml/2006/main" r:embed="R8ec70a97785c486a"/>
           <a:stretch xmlns:a="http://schemas.openxmlformats.org/drawingml/2006/main"/>
         </p:blipFill>
         <p:spPr>
@@ -10922,7 +10876,7 @@
           <p:cNvPr id="8" name="">
             <a:extLst xmlns:a="http://schemas.openxmlformats.org/drawingml/2006/main">
               <a:ext uri="{FF2B5EF4-FFF2-40B4-BE49-F238E27FC236}">
-                <a16:creationId xmlns:a16="http://schemas.microsoft.com/office/drawing/2014/main" id="{9110DC69-32EB-42A6-95AE-643DEF555ED4}"/>
+                <a16:creationId xmlns:a16="http://schemas.microsoft.com/office/drawing/2014/main" id="{9AE6E7B6-B0D5-40D4-AF16-FE312F3C3A34}"/>
               </a:ext>
             </a:extLst>
           </p:cNvPr>
@@ -10977,7 +10931,7 @@
     </p:spTree>
     <p:extLst>
       <p:ext uri="{BB962C8B-B14F-4D97-AF65-F5344CB8AC3E}">
-        <p14:creationId xmlns:p14="http://schemas.microsoft.com/office/powerpoint/2010/main" val="1270593424"/>
+        <p14:creationId xmlns:p14="http://schemas.microsoft.com/office/powerpoint/2010/main" val="1867662129"/>
       </p:ext>
     </p:extLst>
   </p:cSld>
@@ -11008,7 +10962,7 @@
           <p:cNvPr id="28" name="">
             <a:extLst xmlns:a="http://schemas.openxmlformats.org/drawingml/2006/main">
               <a:ext uri="{FF2B5EF4-FFF2-40B4-BE49-F238E27FC236}">
-                <a16:creationId xmlns:a16="http://schemas.microsoft.com/office/drawing/2014/main" id="{68EDC016-CBF5-4E09-81C1-EE687FE3D55A}"/>
+                <a16:creationId xmlns:a16="http://schemas.microsoft.com/office/drawing/2014/main" id="{104AC25F-14DD-43AB-8A26-4ED1A05022CC}"/>
               </a:ext>
             </a:extLst>
           </p:cNvPr>
@@ -11065,7 +11019,7 @@
           <p:cNvPr id="2" name="">
             <a:extLst xmlns:a="http://schemas.openxmlformats.org/drawingml/2006/main">
               <a:ext uri="{FF2B5EF4-FFF2-40B4-BE49-F238E27FC236}">
-                <a16:creationId xmlns:a16="http://schemas.microsoft.com/office/drawing/2014/main" id="{4782CE0E-4409-455A-BEE1-1CF6D819896C}"/>
+                <a16:creationId xmlns:a16="http://schemas.microsoft.com/office/drawing/2014/main" id="{C8B3D24B-D664-4EE2-BB86-C77B101D57B2}"/>
               </a:ext>
             </a:extLst>
           </p:cNvPr>
@@ -11122,7 +11076,7 @@
           <p:cNvPr id="3" name="">
             <a:extLst xmlns:a="http://schemas.openxmlformats.org/drawingml/2006/main">
               <a:ext uri="{FF2B5EF4-FFF2-40B4-BE49-F238E27FC236}">
-                <a16:creationId xmlns:a16="http://schemas.microsoft.com/office/drawing/2014/main" id="{7B48CD06-36FC-4808-8CBB-DB6FFB717BA0}"/>
+                <a16:creationId xmlns:a16="http://schemas.microsoft.com/office/drawing/2014/main" id="{B2136E72-5711-4049-B791-1FF5F4D473E4}"/>
               </a:ext>
             </a:extLst>
           </p:cNvPr>
@@ -11179,7 +11133,7 @@
           <p:cNvPr id="4" name="">
             <a:extLst xmlns:a="http://schemas.openxmlformats.org/drawingml/2006/main">
               <a:ext uri="{FF2B5EF4-FFF2-40B4-BE49-F238E27FC236}">
-                <a16:creationId xmlns:a16="http://schemas.microsoft.com/office/drawing/2014/main" id="{BF5FB3EF-A866-4603-B7F0-7A0FC75B9B16}"/>
+                <a16:creationId xmlns:a16="http://schemas.microsoft.com/office/drawing/2014/main" id="{AC9851DF-F42B-43EE-B276-E2B67E6FCAF2}"/>
               </a:ext>
             </a:extLst>
           </p:cNvPr>
@@ -11236,7 +11190,7 @@
           <p:cNvPr id="5" name="">
             <a:extLst xmlns:a="http://schemas.openxmlformats.org/drawingml/2006/main">
               <a:ext uri="{FF2B5EF4-FFF2-40B4-BE49-F238E27FC236}">
-                <a16:creationId xmlns:a16="http://schemas.microsoft.com/office/drawing/2014/main" id="{9F8C10AF-9F7A-42F8-B4EA-A4584C9486ED}"/>
+                <a16:creationId xmlns:a16="http://schemas.microsoft.com/office/drawing/2014/main" id="{20DB27FE-A0AC-4D8B-967E-1E8439459A6E}"/>
               </a:ext>
             </a:extLst>
           </p:cNvPr>
@@ -11293,7 +11247,7 @@
           <p:cNvPr id="6" name="">
             <a:extLst xmlns:a="http://schemas.openxmlformats.org/drawingml/2006/main">
               <a:ext uri="{FF2B5EF4-FFF2-40B4-BE49-F238E27FC236}">
-                <a16:creationId xmlns:a16="http://schemas.microsoft.com/office/drawing/2014/main" id="{C06A2D56-3CC8-4592-B1F3-F2434EC2B635}"/>
+                <a16:creationId xmlns:a16="http://schemas.microsoft.com/office/drawing/2014/main" id="{D8D69A3C-6A9D-4C4E-A966-8C6066210893}"/>
               </a:ext>
             </a:extLst>
           </p:cNvPr>
@@ -11350,7 +11304,7 @@
           <p:cNvPr id="7" name="">
             <a:extLst xmlns:a="http://schemas.openxmlformats.org/drawingml/2006/main">
               <a:ext uri="{FF2B5EF4-FFF2-40B4-BE49-F238E27FC236}">
-                <a16:creationId xmlns:a16="http://schemas.microsoft.com/office/drawing/2014/main" id="{4943F903-B961-477C-9372-FFC91802735A}"/>
+                <a16:creationId xmlns:a16="http://schemas.microsoft.com/office/drawing/2014/main" id="{0FED5B1D-D973-4D1F-A370-CFAB40675BAE}"/>
               </a:ext>
             </a:extLst>
           </p:cNvPr>
@@ -11407,7 +11361,7 @@
           <p:cNvPr id="8" name="">
             <a:extLst xmlns:a="http://schemas.openxmlformats.org/drawingml/2006/main">
               <a:ext uri="{FF2B5EF4-FFF2-40B4-BE49-F238E27FC236}">
-                <a16:creationId xmlns:a16="http://schemas.microsoft.com/office/drawing/2014/main" id="{A9CEAE43-AFC2-4B06-854D-A8E2AA391AD5}"/>
+                <a16:creationId xmlns:a16="http://schemas.microsoft.com/office/drawing/2014/main" id="{52A84C7D-8949-4731-9495-0967E2A5576D}"/>
               </a:ext>
             </a:extLst>
           </p:cNvPr>
@@ -11464,7 +11418,7 @@
           <p:cNvPr id="9" name="">
             <a:extLst xmlns:a="http://schemas.openxmlformats.org/drawingml/2006/main">
               <a:ext uri="{FF2B5EF4-FFF2-40B4-BE49-F238E27FC236}">
-                <a16:creationId xmlns:a16="http://schemas.microsoft.com/office/drawing/2014/main" id="{686C3BC8-2C8A-43EA-8935-086177CEBF83}"/>
+                <a16:creationId xmlns:a16="http://schemas.microsoft.com/office/drawing/2014/main" id="{1BBA39DD-7A7C-4E0C-A398-A2FC87BE1C3E}"/>
               </a:ext>
             </a:extLst>
           </p:cNvPr>
@@ -11521,7 +11475,7 @@
           <p:cNvPr id="10" name="">
             <a:extLst xmlns:a="http://schemas.openxmlformats.org/drawingml/2006/main">
               <a:ext uri="{FF2B5EF4-FFF2-40B4-BE49-F238E27FC236}">
-                <a16:creationId xmlns:a16="http://schemas.microsoft.com/office/drawing/2014/main" id="{954022F1-2A40-4A47-872C-9C895BB5C0CE}"/>
+                <a16:creationId xmlns:a16="http://schemas.microsoft.com/office/drawing/2014/main" id="{B2A1CD78-5657-4838-BE93-E69732D2899A}"/>
               </a:ext>
             </a:extLst>
           </p:cNvPr>
@@ -11578,7 +11532,7 @@
           <p:cNvPr id="11" name="">
             <a:extLst xmlns:a="http://schemas.openxmlformats.org/drawingml/2006/main">
               <a:ext uri="{FF2B5EF4-FFF2-40B4-BE49-F238E27FC236}">
-                <a16:creationId xmlns:a16="http://schemas.microsoft.com/office/drawing/2014/main" id="{058AD1A6-1AA5-4364-A6C5-4746CAB2CA85}"/>
+                <a16:creationId xmlns:a16="http://schemas.microsoft.com/office/drawing/2014/main" id="{4BD971B3-C94B-40A8-BCA5-DBB32C2D2923}"/>
               </a:ext>
             </a:extLst>
           </p:cNvPr>
@@ -11625,7 +11579,7 @@
                 <a:ea typeface="Malgun Gothic"/>
                 <a:cs typeface="Malgun Gothic"/>
               </a:rPr>
-              <a:t>05. 첫 로그인과 제출 창 연결</a:t>
+              <a:t>05. 첫 로그인과 바로 제출</a:t>
             </a:r>
           </a:p>
         </p:txBody>
@@ -11635,7 +11589,7 @@
           <p:cNvPr id="12" name="">
             <a:extLst xmlns:a="http://schemas.openxmlformats.org/drawingml/2006/main">
               <a:ext uri="{FF2B5EF4-FFF2-40B4-BE49-F238E27FC236}">
-                <a16:creationId xmlns:a16="http://schemas.microsoft.com/office/drawing/2014/main" id="{2001CF80-05BC-4AB5-9BE3-8685556CE62C}"/>
+                <a16:creationId xmlns:a16="http://schemas.microsoft.com/office/drawing/2014/main" id="{FA7C0FFF-841B-4E62-B606-497E6322D9D8}"/>
               </a:ext>
             </a:extLst>
           </p:cNvPr>
@@ -11692,7 +11646,7 @@
           <p:cNvPr id="13" name="">
             <a:extLst xmlns:a="http://schemas.openxmlformats.org/drawingml/2006/main">
               <a:ext uri="{FF2B5EF4-FFF2-40B4-BE49-F238E27FC236}">
-                <a16:creationId xmlns:a16="http://schemas.microsoft.com/office/drawing/2014/main" id="{3A60B9E0-86E7-4CB9-830A-48D54A3CB9CA}"/>
+                <a16:creationId xmlns:a16="http://schemas.microsoft.com/office/drawing/2014/main" id="{160BA2DD-FE11-4219-A5D8-689DA8D89882}"/>
               </a:ext>
             </a:extLst>
           </p:cNvPr>
@@ -11749,7 +11703,7 @@
           <p:cNvPr id="14" name="">
             <a:extLst xmlns:a="http://schemas.openxmlformats.org/drawingml/2006/main">
               <a:ext uri="{FF2B5EF4-FFF2-40B4-BE49-F238E27FC236}">
-                <a16:creationId xmlns:a16="http://schemas.microsoft.com/office/drawing/2014/main" id="{8805CA45-A6D4-4A5B-9DDD-1570AA9C8F22}"/>
+                <a16:creationId xmlns:a16="http://schemas.microsoft.com/office/drawing/2014/main" id="{FBB6653E-0C15-4A30-8B13-8BD27C7F2F4E}"/>
               </a:ext>
             </a:extLst>
           </p:cNvPr>
@@ -11806,7 +11760,7 @@
           <p:cNvPr id="15" name="">
             <a:extLst xmlns:a="http://schemas.openxmlformats.org/drawingml/2006/main">
               <a:ext uri="{FF2B5EF4-FFF2-40B4-BE49-F238E27FC236}">
-                <a16:creationId xmlns:a16="http://schemas.microsoft.com/office/drawing/2014/main" id="{35B9ACAF-8096-4140-B738-ACA45009237E}"/>
+                <a16:creationId xmlns:a16="http://schemas.microsoft.com/office/drawing/2014/main" id="{D71FCCF4-E34A-47EB-82EE-EF0EC3659EB7}"/>
               </a:ext>
             </a:extLst>
           </p:cNvPr>
@@ -11863,7 +11817,7 @@
           <p:cNvPr id="16" name="">
             <a:extLst xmlns:a="http://schemas.openxmlformats.org/drawingml/2006/main">
               <a:ext uri="{FF2B5EF4-FFF2-40B4-BE49-F238E27FC236}">
-                <a16:creationId xmlns:a16="http://schemas.microsoft.com/office/drawing/2014/main" id="{9732D61A-AD05-4195-ADEC-B6C99694091E}"/>
+                <a16:creationId xmlns:a16="http://schemas.microsoft.com/office/drawing/2014/main" id="{E2EA793D-0A3C-4BFB-97D8-AD14FB7F3857}"/>
               </a:ext>
             </a:extLst>
           </p:cNvPr>
@@ -11920,7 +11874,7 @@
           <p:cNvPr id="17" name="">
             <a:extLst xmlns:a="http://schemas.openxmlformats.org/drawingml/2006/main">
               <a:ext uri="{FF2B5EF4-FFF2-40B4-BE49-F238E27FC236}">
-                <a16:creationId xmlns:a16="http://schemas.microsoft.com/office/drawing/2014/main" id="{4646F60B-F66E-43BB-A494-F962791B032A}"/>
+                <a16:creationId xmlns:a16="http://schemas.microsoft.com/office/drawing/2014/main" id="{9F435A54-26B2-4F99-AFBF-04868D36D7C1}"/>
               </a:ext>
             </a:extLst>
           </p:cNvPr>
@@ -11977,7 +11931,7 @@
           <p:cNvPr id="18" name="">
             <a:extLst xmlns:a="http://schemas.openxmlformats.org/drawingml/2006/main">
               <a:ext uri="{FF2B5EF4-FFF2-40B4-BE49-F238E27FC236}">
-                <a16:creationId xmlns:a16="http://schemas.microsoft.com/office/drawing/2014/main" id="{ED18983D-60C9-44B2-8C03-34BBF4893EFE}"/>
+                <a16:creationId xmlns:a16="http://schemas.microsoft.com/office/drawing/2014/main" id="{5AA3B591-C2EA-4344-9C70-EF09E340F597}"/>
               </a:ext>
             </a:extLst>
           </p:cNvPr>
@@ -12034,7 +11988,7 @@
           <p:cNvPr id="19" name="">
             <a:extLst xmlns:a="http://schemas.openxmlformats.org/drawingml/2006/main">
               <a:ext uri="{FF2B5EF4-FFF2-40B4-BE49-F238E27FC236}">
-                <a16:creationId xmlns:a16="http://schemas.microsoft.com/office/drawing/2014/main" id="{32001AAF-FEA7-4B3D-B2A8-547923AC1AAF}"/>
+                <a16:creationId xmlns:a16="http://schemas.microsoft.com/office/drawing/2014/main" id="{EA618C44-3DFC-43CF-BA3E-421A0A52D434}"/>
               </a:ext>
             </a:extLst>
           </p:cNvPr>
@@ -12091,7 +12045,7 @@
           <p:cNvPr id="20" name="">
             <a:extLst xmlns:a="http://schemas.openxmlformats.org/drawingml/2006/main">
               <a:ext uri="{FF2B5EF4-FFF2-40B4-BE49-F238E27FC236}">
-                <a16:creationId xmlns:a16="http://schemas.microsoft.com/office/drawing/2014/main" id="{7BEC2578-2443-433B-AF12-34CFF1E6239B}"/>
+                <a16:creationId xmlns:a16="http://schemas.microsoft.com/office/drawing/2014/main" id="{72D4B685-853A-4997-B7BE-7827E18E4F08}"/>
               </a:ext>
             </a:extLst>
           </p:cNvPr>
@@ -12148,7 +12102,7 @@
           <p:cNvPr id="21" name="">
             <a:extLst xmlns:a="http://schemas.openxmlformats.org/drawingml/2006/main">
               <a:ext uri="{FF2B5EF4-FFF2-40B4-BE49-F238E27FC236}">
-                <a16:creationId xmlns:a16="http://schemas.microsoft.com/office/drawing/2014/main" id="{64C95CC2-3D67-469B-99E8-F24F28B774DA}"/>
+                <a16:creationId xmlns:a16="http://schemas.microsoft.com/office/drawing/2014/main" id="{82DB93F0-A205-4B23-AADE-EDA616063D2B}"/>
               </a:ext>
             </a:extLst>
           </p:cNvPr>
@@ -12205,7 +12159,7 @@
           <p:cNvPr id="22" name="">
             <a:extLst xmlns:a="http://schemas.openxmlformats.org/drawingml/2006/main">
               <a:ext uri="{FF2B5EF4-FFF2-40B4-BE49-F238E27FC236}">
-                <a16:creationId xmlns:a16="http://schemas.microsoft.com/office/drawing/2014/main" id="{B6ADA160-A7EB-46EA-8BB2-D9CBEE2580D3}"/>
+                <a16:creationId xmlns:a16="http://schemas.microsoft.com/office/drawing/2014/main" id="{533A17DB-D59E-4534-A52E-96636C06330E}"/>
               </a:ext>
             </a:extLst>
           </p:cNvPr>
@@ -12262,7 +12216,7 @@
           <p:cNvPr id="23" name="">
             <a:extLst xmlns:a="http://schemas.openxmlformats.org/drawingml/2006/main">
               <a:ext uri="{FF2B5EF4-FFF2-40B4-BE49-F238E27FC236}">
-                <a16:creationId xmlns:a16="http://schemas.microsoft.com/office/drawing/2014/main" id="{6770E73A-1F88-420D-89AD-292DB3A4A3F6}"/>
+                <a16:creationId xmlns:a16="http://schemas.microsoft.com/office/drawing/2014/main" id="{E854B549-9A5E-4309-B7C2-9CE304E5FE29}"/>
               </a:ext>
             </a:extLst>
           </p:cNvPr>
@@ -12319,7 +12273,7 @@
           <p:cNvPr id="24" name="">
             <a:extLst xmlns:a="http://schemas.openxmlformats.org/drawingml/2006/main">
               <a:ext uri="{FF2B5EF4-FFF2-40B4-BE49-F238E27FC236}">
-                <a16:creationId xmlns:a16="http://schemas.microsoft.com/office/drawing/2014/main" id="{2537DBEE-EE00-45C8-8B5A-8E7532F40508}"/>
+                <a16:creationId xmlns:a16="http://schemas.microsoft.com/office/drawing/2014/main" id="{2EC7865B-5D5F-443D-9EE3-69B4472C0207}"/>
               </a:ext>
             </a:extLst>
           </p:cNvPr>
@@ -12376,7 +12330,7 @@
           <p:cNvPr id="25" name="">
             <a:extLst xmlns:a="http://schemas.openxmlformats.org/drawingml/2006/main">
               <a:ext uri="{FF2B5EF4-FFF2-40B4-BE49-F238E27FC236}">
-                <a16:creationId xmlns:a16="http://schemas.microsoft.com/office/drawing/2014/main" id="{D284E4A5-25A7-4313-8EF1-DA920C168492}"/>
+                <a16:creationId xmlns:a16="http://schemas.microsoft.com/office/drawing/2014/main" id="{D4CCD0E9-37D7-41E6-904C-4C085B13C7E9}"/>
               </a:ext>
             </a:extLst>
           </p:cNvPr>
@@ -12433,7 +12387,7 @@
           <p:cNvPr id="26" name="">
             <a:extLst xmlns:a="http://schemas.openxmlformats.org/drawingml/2006/main">
               <a:ext uri="{FF2B5EF4-FFF2-40B4-BE49-F238E27FC236}">
-                <a16:creationId xmlns:a16="http://schemas.microsoft.com/office/drawing/2014/main" id="{0411FCEF-0051-4FC9-B8A0-699ADE8A081E}"/>
+                <a16:creationId xmlns:a16="http://schemas.microsoft.com/office/drawing/2014/main" id="{23413C3E-3A0C-404F-8689-54D028B388A7}"/>
               </a:ext>
             </a:extLst>
           </p:cNvPr>
@@ -12490,7 +12444,7 @@
           <p:cNvPr id="27" name="">
             <a:extLst xmlns:a="http://schemas.openxmlformats.org/drawingml/2006/main">
               <a:ext uri="{FF2B5EF4-FFF2-40B4-BE49-F238E27FC236}">
-                <a16:creationId xmlns:a16="http://schemas.microsoft.com/office/drawing/2014/main" id="{BD40DFDC-E594-47B0-9BCF-EADC26DA2A67}"/>
+                <a16:creationId xmlns:a16="http://schemas.microsoft.com/office/drawing/2014/main" id="{2D1278D8-A35B-44F2-8D3B-F78413D671DC}"/>
               </a:ext>
             </a:extLst>
           </p:cNvPr>
@@ -12545,7 +12499,7 @@
     </p:spTree>
     <p:extLst>
       <p:ext uri="{BB962C8B-B14F-4D97-AF65-F5344CB8AC3E}">
-        <p14:creationId xmlns:p14="http://schemas.microsoft.com/office/powerpoint/2010/main" val="1185551759"/>
+        <p14:creationId xmlns:p14="http://schemas.microsoft.com/office/powerpoint/2010/main" val="810354482"/>
       </p:ext>
     </p:extLst>
   </p:cSld>
@@ -12576,7 +12530,7 @@
           <p:cNvPr id="9" name="">
             <a:extLst xmlns:a="http://schemas.openxmlformats.org/drawingml/2006/main">
               <a:ext uri="{FF2B5EF4-FFF2-40B4-BE49-F238E27FC236}">
-                <a16:creationId xmlns:a16="http://schemas.microsoft.com/office/drawing/2014/main" id="{7FA36617-F19F-4FFB-AF30-25D149B27C1E}"/>
+                <a16:creationId xmlns:a16="http://schemas.microsoft.com/office/drawing/2014/main" id="{859C176E-4D36-439A-B1BA-BE3AD0D3257D}"/>
               </a:ext>
             </a:extLst>
           </p:cNvPr>
@@ -12633,7 +12587,7 @@
           <p:cNvPr id="2" name="">
             <a:extLst xmlns:a="http://schemas.openxmlformats.org/drawingml/2006/main">
               <a:ext uri="{FF2B5EF4-FFF2-40B4-BE49-F238E27FC236}">
-                <a16:creationId xmlns:a16="http://schemas.microsoft.com/office/drawing/2014/main" id="{631A5DD7-B3F5-4EF4-8C7E-433F6F5E1528}"/>
+                <a16:creationId xmlns:a16="http://schemas.microsoft.com/office/drawing/2014/main" id="{BDC12B8F-7AD6-4277-B4F7-BC87367C5894}"/>
               </a:ext>
             </a:extLst>
           </p:cNvPr>
@@ -12690,7 +12644,7 @@
           <p:cNvPr id="3" name="">
             <a:extLst xmlns:a="http://schemas.openxmlformats.org/drawingml/2006/main">
               <a:ext uri="{FF2B5EF4-FFF2-40B4-BE49-F238E27FC236}">
-                <a16:creationId xmlns:a16="http://schemas.microsoft.com/office/drawing/2014/main" id="{94B716EE-5183-4F2E-A4F5-CA502CD6B5D2}"/>
+                <a16:creationId xmlns:a16="http://schemas.microsoft.com/office/drawing/2014/main" id="{13FD9379-4165-4D6C-BD5E-BE7CB6D5133A}"/>
               </a:ext>
             </a:extLst>
           </p:cNvPr>
@@ -12747,7 +12701,7 @@
           <p:cNvPr id="4" name="">
             <a:extLst xmlns:a="http://schemas.openxmlformats.org/drawingml/2006/main">
               <a:ext uri="{FF2B5EF4-FFF2-40B4-BE49-F238E27FC236}">
-                <a16:creationId xmlns:a16="http://schemas.microsoft.com/office/drawing/2014/main" id="{C45FB93E-2261-4565-8CAB-7FFB2FDB28EF}"/>
+                <a16:creationId xmlns:a16="http://schemas.microsoft.com/office/drawing/2014/main" id="{B4C8C112-8E87-4FC8-AB99-F64B54B7CA82}"/>
               </a:ext>
             </a:extLst>
           </p:cNvPr>
@@ -12896,7 +12850,7 @@
           <p:cNvPr id="5" name="">
             <a:extLst xmlns:a="http://schemas.openxmlformats.org/drawingml/2006/main">
               <a:ext uri="{FF2B5EF4-FFF2-40B4-BE49-F238E27FC236}">
-                <a16:creationId xmlns:a16="http://schemas.microsoft.com/office/drawing/2014/main" id="{0A4EF06A-878C-49B6-923D-B7434FF5BEFC}"/>
+                <a16:creationId xmlns:a16="http://schemas.microsoft.com/office/drawing/2014/main" id="{4DC35DB2-21A7-4F69-9546-5963750FBC39}"/>
               </a:ext>
             </a:extLst>
           </p:cNvPr>
@@ -12953,7 +12907,7 @@
           <p:cNvPr id="6" name="">
             <a:extLst xmlns:a="http://schemas.openxmlformats.org/drawingml/2006/main">
               <a:ext uri="{FF2B5EF4-FFF2-40B4-BE49-F238E27FC236}">
-                <a16:creationId xmlns:a16="http://schemas.microsoft.com/office/drawing/2014/main" id="{0BCACB3F-4128-4A39-BBDD-79F1124EE348}"/>
+                <a16:creationId xmlns:a16="http://schemas.microsoft.com/office/drawing/2014/main" id="{92135C78-4C70-4764-97B8-FB1B43710D76}"/>
               </a:ext>
             </a:extLst>
           </p:cNvPr>
@@ -13106,7 +13060,7 @@
           <p:nvPr/>
         </p:nvPicPr>
         <p:blipFill>
-          <a:blip xmlns:r="http://schemas.openxmlformats.org/officeDocument/2006/relationships" xmlns:a="http://schemas.openxmlformats.org/drawingml/2006/main" r:embed="R1fe9dba9880a49cc"/>
+          <a:blip xmlns:r="http://schemas.openxmlformats.org/officeDocument/2006/relationships" xmlns:a="http://schemas.openxmlformats.org/drawingml/2006/main" r:embed="Rb813d1eef7744026"/>
           <a:stretch xmlns:a="http://schemas.openxmlformats.org/drawingml/2006/main"/>
         </p:blipFill>
         <p:spPr>
@@ -13124,7 +13078,7 @@
           <p:cNvPr id="8" name="">
             <a:extLst xmlns:a="http://schemas.openxmlformats.org/drawingml/2006/main">
               <a:ext uri="{FF2B5EF4-FFF2-40B4-BE49-F238E27FC236}">
-                <a16:creationId xmlns:a16="http://schemas.microsoft.com/office/drawing/2014/main" id="{0D5E191E-536F-4F69-A5D1-53B5EA2F1A79}"/>
+                <a16:creationId xmlns:a16="http://schemas.microsoft.com/office/drawing/2014/main" id="{F9BA4FFE-F1A0-4139-ABC2-070B01D4125C}"/>
               </a:ext>
             </a:extLst>
           </p:cNvPr>
@@ -13179,7 +13133,7 @@
     </p:spTree>
     <p:extLst>
       <p:ext uri="{BB962C8B-B14F-4D97-AF65-F5344CB8AC3E}">
-        <p14:creationId xmlns:p14="http://schemas.microsoft.com/office/powerpoint/2010/main" val="1403367884"/>
+        <p14:creationId xmlns:p14="http://schemas.microsoft.com/office/powerpoint/2010/main" val="1047052843"/>
       </p:ext>
     </p:extLst>
   </p:cSld>
@@ -13210,7 +13164,7 @@
           <p:cNvPr id="9" name="">
             <a:extLst xmlns:a="http://schemas.openxmlformats.org/drawingml/2006/main">
               <a:ext uri="{FF2B5EF4-FFF2-40B4-BE49-F238E27FC236}">
-                <a16:creationId xmlns:a16="http://schemas.microsoft.com/office/drawing/2014/main" id="{5173014D-2026-4EE4-A92C-A62C83E6506C}"/>
+                <a16:creationId xmlns:a16="http://schemas.microsoft.com/office/drawing/2014/main" id="{BE8136BF-B7D5-4305-BB24-02F35507475A}"/>
               </a:ext>
             </a:extLst>
           </p:cNvPr>
@@ -13267,7 +13221,7 @@
           <p:cNvPr id="2" name="">
             <a:extLst xmlns:a="http://schemas.openxmlformats.org/drawingml/2006/main">
               <a:ext uri="{FF2B5EF4-FFF2-40B4-BE49-F238E27FC236}">
-                <a16:creationId xmlns:a16="http://schemas.microsoft.com/office/drawing/2014/main" id="{E0C6E8CA-F7E0-4941-BFD3-48FFE01EC6E0}"/>
+                <a16:creationId xmlns:a16="http://schemas.microsoft.com/office/drawing/2014/main" id="{9CCE9466-EA39-44F4-AE10-8E33D6EF7BA6}"/>
               </a:ext>
             </a:extLst>
           </p:cNvPr>
@@ -13324,7 +13278,7 @@
           <p:cNvPr id="3" name="">
             <a:extLst xmlns:a="http://schemas.openxmlformats.org/drawingml/2006/main">
               <a:ext uri="{FF2B5EF4-FFF2-40B4-BE49-F238E27FC236}">
-                <a16:creationId xmlns:a16="http://schemas.microsoft.com/office/drawing/2014/main" id="{53A959F8-F980-485A-B20C-783A7368E7BE}"/>
+                <a16:creationId xmlns:a16="http://schemas.microsoft.com/office/drawing/2014/main" id="{D864BD5B-4B3B-4D96-8E84-48D3F7B7F2CD}"/>
               </a:ext>
             </a:extLst>
           </p:cNvPr>
@@ -13381,7 +13335,7 @@
           <p:cNvPr id="4" name="">
             <a:extLst xmlns:a="http://schemas.openxmlformats.org/drawingml/2006/main">
               <a:ext uri="{FF2B5EF4-FFF2-40B4-BE49-F238E27FC236}">
-                <a16:creationId xmlns:a16="http://schemas.microsoft.com/office/drawing/2014/main" id="{33D91520-7233-4042-8253-4E5127791222}"/>
+                <a16:creationId xmlns:a16="http://schemas.microsoft.com/office/drawing/2014/main" id="{53F41060-0EAA-485B-981A-C40AC3565BD8}"/>
               </a:ext>
             </a:extLst>
           </p:cNvPr>
@@ -13530,7 +13484,7 @@
           <p:cNvPr id="5" name="">
             <a:extLst xmlns:a="http://schemas.openxmlformats.org/drawingml/2006/main">
               <a:ext uri="{FF2B5EF4-FFF2-40B4-BE49-F238E27FC236}">
-                <a16:creationId xmlns:a16="http://schemas.microsoft.com/office/drawing/2014/main" id="{88AC04D1-1726-4F4A-A991-0B158CA4AC14}"/>
+                <a16:creationId xmlns:a16="http://schemas.microsoft.com/office/drawing/2014/main" id="{CCFA59F5-81A1-4ABA-92E4-3FDEED7C8C20}"/>
               </a:ext>
             </a:extLst>
           </p:cNvPr>
@@ -13587,7 +13541,7 @@
           <p:cNvPr id="6" name="">
             <a:extLst xmlns:a="http://schemas.openxmlformats.org/drawingml/2006/main">
               <a:ext uri="{FF2B5EF4-FFF2-40B4-BE49-F238E27FC236}">
-                <a16:creationId xmlns:a16="http://schemas.microsoft.com/office/drawing/2014/main" id="{182CD3D3-3828-46EF-84D8-5614FACF2E0B}"/>
+                <a16:creationId xmlns:a16="http://schemas.microsoft.com/office/drawing/2014/main" id="{C51A4E71-3FEC-47EC-8016-C89227C71D9A}"/>
               </a:ext>
             </a:extLst>
           </p:cNvPr>
@@ -13740,7 +13694,7 @@
           <p:nvPr/>
         </p:nvPicPr>
         <p:blipFill>
-          <a:blip xmlns:r="http://schemas.openxmlformats.org/officeDocument/2006/relationships" xmlns:a="http://schemas.openxmlformats.org/drawingml/2006/main" r:embed="R75fddf64ade347db"/>
+          <a:blip xmlns:r="http://schemas.openxmlformats.org/officeDocument/2006/relationships" xmlns:a="http://schemas.openxmlformats.org/drawingml/2006/main" r:embed="Rce9a15668ae64901"/>
           <a:stretch xmlns:a="http://schemas.openxmlformats.org/drawingml/2006/main"/>
         </p:blipFill>
         <p:spPr>
@@ -13758,7 +13712,7 @@
           <p:cNvPr id="8" name="">
             <a:extLst xmlns:a="http://schemas.openxmlformats.org/drawingml/2006/main">
               <a:ext uri="{FF2B5EF4-FFF2-40B4-BE49-F238E27FC236}">
-                <a16:creationId xmlns:a16="http://schemas.microsoft.com/office/drawing/2014/main" id="{23CD7E0A-234E-4554-BECF-E581F3851AA5}"/>
+                <a16:creationId xmlns:a16="http://schemas.microsoft.com/office/drawing/2014/main" id="{BB31FEDB-3B43-4498-9CAF-8FCCEBACE133}"/>
               </a:ext>
             </a:extLst>
           </p:cNvPr>
@@ -13813,7 +13767,7 @@
     </p:spTree>
     <p:extLst>
       <p:ext uri="{BB962C8B-B14F-4D97-AF65-F5344CB8AC3E}">
-        <p14:creationId xmlns:p14="http://schemas.microsoft.com/office/powerpoint/2010/main" val="423728642"/>
+        <p14:creationId xmlns:p14="http://schemas.microsoft.com/office/powerpoint/2010/main" val="376874638"/>
       </p:ext>
     </p:extLst>
   </p:cSld>
@@ -13844,7 +13798,7 @@
           <p:cNvPr id="9" name="">
             <a:extLst xmlns:a="http://schemas.openxmlformats.org/drawingml/2006/main">
               <a:ext uri="{FF2B5EF4-FFF2-40B4-BE49-F238E27FC236}">
-                <a16:creationId xmlns:a16="http://schemas.microsoft.com/office/drawing/2014/main" id="{1FD07188-52B0-43FE-89BD-EF412908DAC6}"/>
+                <a16:creationId xmlns:a16="http://schemas.microsoft.com/office/drawing/2014/main" id="{D52CBC88-23C2-4C32-ADF9-9E5950C424C9}"/>
               </a:ext>
             </a:extLst>
           </p:cNvPr>
@@ -13901,7 +13855,7 @@
           <p:cNvPr id="2" name="">
             <a:extLst xmlns:a="http://schemas.openxmlformats.org/drawingml/2006/main">
               <a:ext uri="{FF2B5EF4-FFF2-40B4-BE49-F238E27FC236}">
-                <a16:creationId xmlns:a16="http://schemas.microsoft.com/office/drawing/2014/main" id="{142EDC74-F724-49F9-9122-C215A6AFB9D4}"/>
+                <a16:creationId xmlns:a16="http://schemas.microsoft.com/office/drawing/2014/main" id="{43B20E0F-F064-46B2-B0A1-FB4EA93101A6}"/>
               </a:ext>
             </a:extLst>
           </p:cNvPr>
@@ -13958,7 +13912,7 @@
           <p:cNvPr id="3" name="">
             <a:extLst xmlns:a="http://schemas.openxmlformats.org/drawingml/2006/main">
               <a:ext uri="{FF2B5EF4-FFF2-40B4-BE49-F238E27FC236}">
-                <a16:creationId xmlns:a16="http://schemas.microsoft.com/office/drawing/2014/main" id="{2EA36150-7B2E-40D5-8E9E-BE3F3B931FFE}"/>
+                <a16:creationId xmlns:a16="http://schemas.microsoft.com/office/drawing/2014/main" id="{2DFAD56D-D5E1-488F-AB4F-FC753A5708AD}"/>
               </a:ext>
             </a:extLst>
           </p:cNvPr>
@@ -14015,7 +13969,7 @@
           <p:cNvPr id="4" name="">
             <a:extLst xmlns:a="http://schemas.openxmlformats.org/drawingml/2006/main">
               <a:ext uri="{FF2B5EF4-FFF2-40B4-BE49-F238E27FC236}">
-                <a16:creationId xmlns:a16="http://schemas.microsoft.com/office/drawing/2014/main" id="{E4E15386-2A40-4FD0-BCD0-EA659D85D016}"/>
+                <a16:creationId xmlns:a16="http://schemas.microsoft.com/office/drawing/2014/main" id="{C659958B-3FCC-44BA-B76D-39861D134474}"/>
               </a:ext>
             </a:extLst>
           </p:cNvPr>
@@ -14164,7 +14118,7 @@
           <p:cNvPr id="5" name="">
             <a:extLst xmlns:a="http://schemas.openxmlformats.org/drawingml/2006/main">
               <a:ext uri="{FF2B5EF4-FFF2-40B4-BE49-F238E27FC236}">
-                <a16:creationId xmlns:a16="http://schemas.microsoft.com/office/drawing/2014/main" id="{50CA30B3-956D-47B5-B662-893E66DCEEDC}"/>
+                <a16:creationId xmlns:a16="http://schemas.microsoft.com/office/drawing/2014/main" id="{0CD09B3C-11B0-4E39-84C6-020095199B9C}"/>
               </a:ext>
             </a:extLst>
           </p:cNvPr>
@@ -14221,7 +14175,7 @@
           <p:cNvPr id="6" name="">
             <a:extLst xmlns:a="http://schemas.openxmlformats.org/drawingml/2006/main">
               <a:ext uri="{FF2B5EF4-FFF2-40B4-BE49-F238E27FC236}">
-                <a16:creationId xmlns:a16="http://schemas.microsoft.com/office/drawing/2014/main" id="{A7302D58-9DAB-46ED-BD19-91FDE5E2DA4C}"/>
+                <a16:creationId xmlns:a16="http://schemas.microsoft.com/office/drawing/2014/main" id="{2C8B78BE-7603-4A3F-92B3-B0FA77A56278}"/>
               </a:ext>
             </a:extLst>
           </p:cNvPr>
@@ -14374,7 +14328,7 @@
           <p:nvPr/>
         </p:nvPicPr>
         <p:blipFill>
-          <a:blip xmlns:r="http://schemas.openxmlformats.org/officeDocument/2006/relationships" xmlns:a="http://schemas.openxmlformats.org/drawingml/2006/main" r:embed="R2db539e50e5a48fc"/>
+          <a:blip xmlns:r="http://schemas.openxmlformats.org/officeDocument/2006/relationships" xmlns:a="http://schemas.openxmlformats.org/drawingml/2006/main" r:embed="R7bc0642dfa694896"/>
           <a:stretch xmlns:a="http://schemas.openxmlformats.org/drawingml/2006/main"/>
         </p:blipFill>
         <p:spPr>
@@ -14392,7 +14346,7 @@
           <p:cNvPr id="8" name="">
             <a:extLst xmlns:a="http://schemas.openxmlformats.org/drawingml/2006/main">
               <a:ext uri="{FF2B5EF4-FFF2-40B4-BE49-F238E27FC236}">
-                <a16:creationId xmlns:a16="http://schemas.microsoft.com/office/drawing/2014/main" id="{4FCA67E6-0FB4-4F24-9C3F-526C93573CDD}"/>
+                <a16:creationId xmlns:a16="http://schemas.microsoft.com/office/drawing/2014/main" id="{BA623458-942F-43DF-9E82-61656B3808A2}"/>
               </a:ext>
             </a:extLst>
           </p:cNvPr>
@@ -14447,7 +14401,7 @@
     </p:spTree>
     <p:extLst>
       <p:ext uri="{BB962C8B-B14F-4D97-AF65-F5344CB8AC3E}">
-        <p14:creationId xmlns:p14="http://schemas.microsoft.com/office/powerpoint/2010/main" val="294893494"/>
+        <p14:creationId xmlns:p14="http://schemas.microsoft.com/office/powerpoint/2010/main" val="1158297561"/>
       </p:ext>
     </p:extLst>
   </p:cSld>
@@ -14478,7 +14432,7 @@
           <p:cNvPr id="9" name="">
             <a:extLst xmlns:a="http://schemas.openxmlformats.org/drawingml/2006/main">
               <a:ext uri="{FF2B5EF4-FFF2-40B4-BE49-F238E27FC236}">
-                <a16:creationId xmlns:a16="http://schemas.microsoft.com/office/drawing/2014/main" id="{D14FF03A-F6D6-42C6-AEEA-200DF3977F02}"/>
+                <a16:creationId xmlns:a16="http://schemas.microsoft.com/office/drawing/2014/main" id="{5CE3C0FE-222F-418A-9F6A-E8B2B64F6768}"/>
               </a:ext>
             </a:extLst>
           </p:cNvPr>
@@ -14535,7 +14489,7 @@
           <p:cNvPr id="2" name="">
             <a:extLst xmlns:a="http://schemas.openxmlformats.org/drawingml/2006/main">
               <a:ext uri="{FF2B5EF4-FFF2-40B4-BE49-F238E27FC236}">
-                <a16:creationId xmlns:a16="http://schemas.microsoft.com/office/drawing/2014/main" id="{7F2EA46F-D3FF-4EFC-B8DF-6EB66992F149}"/>
+                <a16:creationId xmlns:a16="http://schemas.microsoft.com/office/drawing/2014/main" id="{F0C0AE97-12DD-4760-85B7-B78188F3E3CC}"/>
               </a:ext>
             </a:extLst>
           </p:cNvPr>
@@ -14592,7 +14546,7 @@
           <p:cNvPr id="3" name="">
             <a:extLst xmlns:a="http://schemas.openxmlformats.org/drawingml/2006/main">
               <a:ext uri="{FF2B5EF4-FFF2-40B4-BE49-F238E27FC236}">
-                <a16:creationId xmlns:a16="http://schemas.microsoft.com/office/drawing/2014/main" id="{220F515F-5E5C-431D-8605-CA31E21DC95D}"/>
+                <a16:creationId xmlns:a16="http://schemas.microsoft.com/office/drawing/2014/main" id="{DB39C5B3-57CC-462D-BCB2-EB2BCF3D2F4A}"/>
               </a:ext>
             </a:extLst>
           </p:cNvPr>
@@ -14649,7 +14603,7 @@
           <p:cNvPr id="4" name="">
             <a:extLst xmlns:a="http://schemas.openxmlformats.org/drawingml/2006/main">
               <a:ext uri="{FF2B5EF4-FFF2-40B4-BE49-F238E27FC236}">
-                <a16:creationId xmlns:a16="http://schemas.microsoft.com/office/drawing/2014/main" id="{5DF3B4F7-2E5D-4EE6-AE65-39C2C8E500A7}"/>
+                <a16:creationId xmlns:a16="http://schemas.microsoft.com/office/drawing/2014/main" id="{C91F1837-896D-4503-9A95-F1A4E35A0422}"/>
               </a:ext>
             </a:extLst>
           </p:cNvPr>
@@ -14798,7 +14752,7 @@
           <p:cNvPr id="5" name="">
             <a:extLst xmlns:a="http://schemas.openxmlformats.org/drawingml/2006/main">
               <a:ext uri="{FF2B5EF4-FFF2-40B4-BE49-F238E27FC236}">
-                <a16:creationId xmlns:a16="http://schemas.microsoft.com/office/drawing/2014/main" id="{3B4541AE-E538-44E6-A344-75CD2879F996}"/>
+                <a16:creationId xmlns:a16="http://schemas.microsoft.com/office/drawing/2014/main" id="{11A9AD95-BF6C-46C6-BFB3-6D2E0F998739}"/>
               </a:ext>
             </a:extLst>
           </p:cNvPr>
@@ -14855,7 +14809,7 @@
           <p:cNvPr id="6" name="">
             <a:extLst xmlns:a="http://schemas.openxmlformats.org/drawingml/2006/main">
               <a:ext uri="{FF2B5EF4-FFF2-40B4-BE49-F238E27FC236}">
-                <a16:creationId xmlns:a16="http://schemas.microsoft.com/office/drawing/2014/main" id="{7001EAD8-2331-4E21-BE57-C4CBBE715178}"/>
+                <a16:creationId xmlns:a16="http://schemas.microsoft.com/office/drawing/2014/main" id="{4791E2CB-C563-4C2B-90BD-852D341A2987}"/>
               </a:ext>
             </a:extLst>
           </p:cNvPr>
@@ -14985,7 +14939,7 @@
           <p:nvPr/>
         </p:nvPicPr>
         <p:blipFill>
-          <a:blip xmlns:r="http://schemas.openxmlformats.org/officeDocument/2006/relationships" xmlns:a="http://schemas.openxmlformats.org/drawingml/2006/main" r:embed="R7e47f37639614958"/>
+          <a:blip xmlns:r="http://schemas.openxmlformats.org/officeDocument/2006/relationships" xmlns:a="http://schemas.openxmlformats.org/drawingml/2006/main" r:embed="Ra62d33bf4763403c"/>
           <a:stretch xmlns:a="http://schemas.openxmlformats.org/drawingml/2006/main"/>
         </p:blipFill>
         <p:spPr>
@@ -15003,7 +14957,7 @@
           <p:cNvPr id="8" name="">
             <a:extLst xmlns:a="http://schemas.openxmlformats.org/drawingml/2006/main">
               <a:ext uri="{FF2B5EF4-FFF2-40B4-BE49-F238E27FC236}">
-                <a16:creationId xmlns:a16="http://schemas.microsoft.com/office/drawing/2014/main" id="{B434ECAC-F38F-4A73-ADA5-1F2E82FEB3A9}"/>
+                <a16:creationId xmlns:a16="http://schemas.microsoft.com/office/drawing/2014/main" id="{E29D21C5-D3C6-4CE0-A3E8-ADCB2B156525}"/>
               </a:ext>
             </a:extLst>
           </p:cNvPr>
@@ -15058,7 +15012,7 @@
     </p:spTree>
     <p:extLst>
       <p:ext uri="{BB962C8B-B14F-4D97-AF65-F5344CB8AC3E}">
-        <p14:creationId xmlns:p14="http://schemas.microsoft.com/office/powerpoint/2010/main" val="521325615"/>
+        <p14:creationId xmlns:p14="http://schemas.microsoft.com/office/powerpoint/2010/main" val="521644184"/>
       </p:ext>
     </p:extLst>
   </p:cSld>
@@ -15089,7 +15043,7 @@
           <p:cNvPr id="9" name="">
             <a:extLst xmlns:a="http://schemas.openxmlformats.org/drawingml/2006/main">
               <a:ext uri="{FF2B5EF4-FFF2-40B4-BE49-F238E27FC236}">
-                <a16:creationId xmlns:a16="http://schemas.microsoft.com/office/drawing/2014/main" id="{9BC87F60-360F-40AC-91DF-89F8DDD7912F}"/>
+                <a16:creationId xmlns:a16="http://schemas.microsoft.com/office/drawing/2014/main" id="{D00EE5CF-F4D2-4100-8312-52BA9D4DB4B6}"/>
               </a:ext>
             </a:extLst>
           </p:cNvPr>
@@ -15146,7 +15100,7 @@
           <p:cNvPr id="2" name="">
             <a:extLst xmlns:a="http://schemas.openxmlformats.org/drawingml/2006/main">
               <a:ext uri="{FF2B5EF4-FFF2-40B4-BE49-F238E27FC236}">
-                <a16:creationId xmlns:a16="http://schemas.microsoft.com/office/drawing/2014/main" id="{E84CFE2D-4CF7-4DE7-8E02-FA0507DD20A9}"/>
+                <a16:creationId xmlns:a16="http://schemas.microsoft.com/office/drawing/2014/main" id="{C14C8448-1AE5-4790-B7F0-277A2903FF67}"/>
               </a:ext>
             </a:extLst>
           </p:cNvPr>
@@ -15203,7 +15157,7 @@
           <p:cNvPr id="3" name="">
             <a:extLst xmlns:a="http://schemas.openxmlformats.org/drawingml/2006/main">
               <a:ext uri="{FF2B5EF4-FFF2-40B4-BE49-F238E27FC236}">
-                <a16:creationId xmlns:a16="http://schemas.microsoft.com/office/drawing/2014/main" id="{576B7458-6669-452F-AE8E-3C1D78D071F2}"/>
+                <a16:creationId xmlns:a16="http://schemas.microsoft.com/office/drawing/2014/main" id="{675E5E7F-E8C0-4B0E-A895-8CD91099AB0C}"/>
               </a:ext>
             </a:extLst>
           </p:cNvPr>
@@ -15260,7 +15214,7 @@
           <p:cNvPr id="4" name="">
             <a:extLst xmlns:a="http://schemas.openxmlformats.org/drawingml/2006/main">
               <a:ext uri="{FF2B5EF4-FFF2-40B4-BE49-F238E27FC236}">
-                <a16:creationId xmlns:a16="http://schemas.microsoft.com/office/drawing/2014/main" id="{B62664E1-90D7-4DD2-95F4-3B32BDF94AE5}"/>
+                <a16:creationId xmlns:a16="http://schemas.microsoft.com/office/drawing/2014/main" id="{78BB6B54-9951-48AC-8DBC-4A94B0DC444F}"/>
               </a:ext>
             </a:extLst>
           </p:cNvPr>
@@ -15386,7 +15340,7 @@
           <p:cNvPr id="5" name="">
             <a:extLst xmlns:a="http://schemas.openxmlformats.org/drawingml/2006/main">
               <a:ext uri="{FF2B5EF4-FFF2-40B4-BE49-F238E27FC236}">
-                <a16:creationId xmlns:a16="http://schemas.microsoft.com/office/drawing/2014/main" id="{0568548C-D5AE-4530-BE94-58778171A8E9}"/>
+                <a16:creationId xmlns:a16="http://schemas.microsoft.com/office/drawing/2014/main" id="{FD0A4EAC-20A3-492C-820D-968DDCD7BFE1}"/>
               </a:ext>
             </a:extLst>
           </p:cNvPr>
@@ -15443,7 +15397,7 @@
           <p:cNvPr id="6" name="">
             <a:extLst xmlns:a="http://schemas.openxmlformats.org/drawingml/2006/main">
               <a:ext uri="{FF2B5EF4-FFF2-40B4-BE49-F238E27FC236}">
-                <a16:creationId xmlns:a16="http://schemas.microsoft.com/office/drawing/2014/main" id="{ED3BA7C1-5A20-4C5E-8F94-D337CA861067}"/>
+                <a16:creationId xmlns:a16="http://schemas.microsoft.com/office/drawing/2014/main" id="{505492D4-77D6-422A-AFCB-574DFAC90A01}"/>
               </a:ext>
             </a:extLst>
           </p:cNvPr>
@@ -15573,7 +15527,7 @@
           <p:nvPr/>
         </p:nvPicPr>
         <p:blipFill>
-          <a:blip xmlns:r="http://schemas.openxmlformats.org/officeDocument/2006/relationships" xmlns:a="http://schemas.openxmlformats.org/drawingml/2006/main" r:embed="Rfe087b6c036c4844"/>
+          <a:blip xmlns:r="http://schemas.openxmlformats.org/officeDocument/2006/relationships" xmlns:a="http://schemas.openxmlformats.org/drawingml/2006/main" r:embed="Ra6c793cac2b34fa3"/>
           <a:stretch xmlns:a="http://schemas.openxmlformats.org/drawingml/2006/main"/>
         </p:blipFill>
         <p:spPr>
@@ -15591,7 +15545,7 @@
           <p:cNvPr id="8" name="">
             <a:extLst xmlns:a="http://schemas.openxmlformats.org/drawingml/2006/main">
               <a:ext uri="{FF2B5EF4-FFF2-40B4-BE49-F238E27FC236}">
-                <a16:creationId xmlns:a16="http://schemas.microsoft.com/office/drawing/2014/main" id="{280E3C33-83A7-4ABB-9A36-9F40B29AE411}"/>
+                <a16:creationId xmlns:a16="http://schemas.microsoft.com/office/drawing/2014/main" id="{DAB71C43-EEA5-429B-B130-75C5DABD4CD1}"/>
               </a:ext>
             </a:extLst>
           </p:cNvPr>
@@ -15646,7 +15600,7 @@
     </p:spTree>
     <p:extLst>
       <p:ext uri="{BB962C8B-B14F-4D97-AF65-F5344CB8AC3E}">
-        <p14:creationId xmlns:p14="http://schemas.microsoft.com/office/powerpoint/2010/main" val="482496036"/>
+        <p14:creationId xmlns:p14="http://schemas.microsoft.com/office/powerpoint/2010/main" val="19260086"/>
       </p:ext>
     </p:extLst>
   </p:cSld>
@@ -15677,7 +15631,7 @@
           <p:cNvPr id="9" name="">
             <a:extLst xmlns:a="http://schemas.openxmlformats.org/drawingml/2006/main">
               <a:ext uri="{FF2B5EF4-FFF2-40B4-BE49-F238E27FC236}">
-                <a16:creationId xmlns:a16="http://schemas.microsoft.com/office/drawing/2014/main" id="{233AB4FF-6C8F-42AF-A5CB-90177FDBE2DC}"/>
+                <a16:creationId xmlns:a16="http://schemas.microsoft.com/office/drawing/2014/main" id="{5C0A2B21-5329-4301-A9F8-AC4FA16F75DD}"/>
               </a:ext>
             </a:extLst>
           </p:cNvPr>
@@ -15734,7 +15688,7 @@
           <p:cNvPr id="2" name="">
             <a:extLst xmlns:a="http://schemas.openxmlformats.org/drawingml/2006/main">
               <a:ext uri="{FF2B5EF4-FFF2-40B4-BE49-F238E27FC236}">
-                <a16:creationId xmlns:a16="http://schemas.microsoft.com/office/drawing/2014/main" id="{25239D99-B243-4D86-BFC8-DADAC5308C8E}"/>
+                <a16:creationId xmlns:a16="http://schemas.microsoft.com/office/drawing/2014/main" id="{59D26AAD-9D50-4931-9A84-EFF1159CA983}"/>
               </a:ext>
             </a:extLst>
           </p:cNvPr>
@@ -15791,7 +15745,7 @@
           <p:cNvPr id="3" name="">
             <a:extLst xmlns:a="http://schemas.openxmlformats.org/drawingml/2006/main">
               <a:ext uri="{FF2B5EF4-FFF2-40B4-BE49-F238E27FC236}">
-                <a16:creationId xmlns:a16="http://schemas.microsoft.com/office/drawing/2014/main" id="{5FA0FC58-B7B5-4FE7-9DCF-03513F66DCFC}"/>
+                <a16:creationId xmlns:a16="http://schemas.microsoft.com/office/drawing/2014/main" id="{B3FBD9C4-634B-4DFB-95FE-C3D2B4C60B9D}"/>
               </a:ext>
             </a:extLst>
           </p:cNvPr>
@@ -15848,7 +15802,7 @@
           <p:cNvPr id="4" name="">
             <a:extLst xmlns:a="http://schemas.openxmlformats.org/drawingml/2006/main">
               <a:ext uri="{FF2B5EF4-FFF2-40B4-BE49-F238E27FC236}">
-                <a16:creationId xmlns:a16="http://schemas.microsoft.com/office/drawing/2014/main" id="{A8A3E5F1-53F2-4107-A4B0-E6AB421FD09A}"/>
+                <a16:creationId xmlns:a16="http://schemas.microsoft.com/office/drawing/2014/main" id="{1CE723E7-5A51-4A88-A150-D7FDEB3AD88B}"/>
               </a:ext>
             </a:extLst>
           </p:cNvPr>
@@ -15974,7 +15928,7 @@
           <p:cNvPr id="5" name="">
             <a:extLst xmlns:a="http://schemas.openxmlformats.org/drawingml/2006/main">
               <a:ext uri="{FF2B5EF4-FFF2-40B4-BE49-F238E27FC236}">
-                <a16:creationId xmlns:a16="http://schemas.microsoft.com/office/drawing/2014/main" id="{1B3D7355-7C51-4859-9158-0FFB2FD94DCE}"/>
+                <a16:creationId xmlns:a16="http://schemas.microsoft.com/office/drawing/2014/main" id="{88069D7A-1010-4864-8E22-F9A732FB23A7}"/>
               </a:ext>
             </a:extLst>
           </p:cNvPr>
@@ -16031,7 +15985,7 @@
           <p:cNvPr id="6" name="">
             <a:extLst xmlns:a="http://schemas.openxmlformats.org/drawingml/2006/main">
               <a:ext uri="{FF2B5EF4-FFF2-40B4-BE49-F238E27FC236}">
-                <a16:creationId xmlns:a16="http://schemas.microsoft.com/office/drawing/2014/main" id="{FCBB2E7D-EBBE-4ABA-8440-7D9D1736D6AA}"/>
+                <a16:creationId xmlns:a16="http://schemas.microsoft.com/office/drawing/2014/main" id="{207608F1-4D25-419C-B6A1-DBF09CCBADE2}"/>
               </a:ext>
             </a:extLst>
           </p:cNvPr>
@@ -16161,7 +16115,7 @@
           <p:nvPr/>
         </p:nvPicPr>
         <p:blipFill>
-          <a:blip xmlns:r="http://schemas.openxmlformats.org/officeDocument/2006/relationships" xmlns:a="http://schemas.openxmlformats.org/drawingml/2006/main" r:embed="Rfc7e35c8e9eb4e83"/>
+          <a:blip xmlns:r="http://schemas.openxmlformats.org/officeDocument/2006/relationships" xmlns:a="http://schemas.openxmlformats.org/drawingml/2006/main" r:embed="R616a3b4bbd0c4706"/>
           <a:stretch xmlns:a="http://schemas.openxmlformats.org/drawingml/2006/main"/>
         </p:blipFill>
         <p:spPr>
@@ -16179,7 +16133,7 @@
           <p:cNvPr id="8" name="">
             <a:extLst xmlns:a="http://schemas.openxmlformats.org/drawingml/2006/main">
               <a:ext uri="{FF2B5EF4-FFF2-40B4-BE49-F238E27FC236}">
-                <a16:creationId xmlns:a16="http://schemas.microsoft.com/office/drawing/2014/main" id="{8DCF8A45-0E51-4F59-8C0E-33FC809CB0CC}"/>
+                <a16:creationId xmlns:a16="http://schemas.microsoft.com/office/drawing/2014/main" id="{78BA1E32-1BD9-4858-A199-8E79EB54DEE6}"/>
               </a:ext>
             </a:extLst>
           </p:cNvPr>
@@ -16234,7 +16188,7 @@
     </p:spTree>
     <p:extLst>
       <p:ext uri="{BB962C8B-B14F-4D97-AF65-F5344CB8AC3E}">
-        <p14:creationId xmlns:p14="http://schemas.microsoft.com/office/powerpoint/2010/main" val="459515953"/>
+        <p14:creationId xmlns:p14="http://schemas.microsoft.com/office/powerpoint/2010/main" val="409662476"/>
       </p:ext>
     </p:extLst>
   </p:cSld>
@@ -16265,7 +16219,7 @@
           <p:cNvPr id="9" name="">
             <a:extLst xmlns:a="http://schemas.openxmlformats.org/drawingml/2006/main">
               <a:ext uri="{FF2B5EF4-FFF2-40B4-BE49-F238E27FC236}">
-                <a16:creationId xmlns:a16="http://schemas.microsoft.com/office/drawing/2014/main" id="{D3668FEB-88B3-46AE-8B11-E399234EAD15}"/>
+                <a16:creationId xmlns:a16="http://schemas.microsoft.com/office/drawing/2014/main" id="{CBE462F1-EBDF-4E34-BA97-AE3593BAA721}"/>
               </a:ext>
             </a:extLst>
           </p:cNvPr>
@@ -16322,7 +16276,7 @@
           <p:cNvPr id="2" name="">
             <a:extLst xmlns:a="http://schemas.openxmlformats.org/drawingml/2006/main">
               <a:ext uri="{FF2B5EF4-FFF2-40B4-BE49-F238E27FC236}">
-                <a16:creationId xmlns:a16="http://schemas.microsoft.com/office/drawing/2014/main" id="{979462AD-AB5B-4A8F-A51E-9658018258CF}"/>
+                <a16:creationId xmlns:a16="http://schemas.microsoft.com/office/drawing/2014/main" id="{85FDBFE6-E95E-4B5D-AA1F-27C8C28C2098}"/>
               </a:ext>
             </a:extLst>
           </p:cNvPr>
@@ -16379,7 +16333,7 @@
           <p:cNvPr id="3" name="">
             <a:extLst xmlns:a="http://schemas.openxmlformats.org/drawingml/2006/main">
               <a:ext uri="{FF2B5EF4-FFF2-40B4-BE49-F238E27FC236}">
-                <a16:creationId xmlns:a16="http://schemas.microsoft.com/office/drawing/2014/main" id="{B39F3EB8-C7F1-4002-A3F9-910C050BF06D}"/>
+                <a16:creationId xmlns:a16="http://schemas.microsoft.com/office/drawing/2014/main" id="{CD4FF79D-3B06-4310-ADFF-1567CBDC9604}"/>
               </a:ext>
             </a:extLst>
           </p:cNvPr>
@@ -16436,7 +16390,7 @@
           <p:cNvPr id="4" name="">
             <a:extLst xmlns:a="http://schemas.openxmlformats.org/drawingml/2006/main">
               <a:ext uri="{FF2B5EF4-FFF2-40B4-BE49-F238E27FC236}">
-                <a16:creationId xmlns:a16="http://schemas.microsoft.com/office/drawing/2014/main" id="{4FE7228E-B38D-435F-A595-5215D511DBA8}"/>
+                <a16:creationId xmlns:a16="http://schemas.microsoft.com/office/drawing/2014/main" id="{478308C3-6344-45C1-9DD6-10ACD4AFC4A1}"/>
               </a:ext>
             </a:extLst>
           </p:cNvPr>
@@ -16562,7 +16516,7 @@
           <p:cNvPr id="5" name="">
             <a:extLst xmlns:a="http://schemas.openxmlformats.org/drawingml/2006/main">
               <a:ext uri="{FF2B5EF4-FFF2-40B4-BE49-F238E27FC236}">
-                <a16:creationId xmlns:a16="http://schemas.microsoft.com/office/drawing/2014/main" id="{73F9A7B5-6950-4DEF-9B53-AC356028DB5A}"/>
+                <a16:creationId xmlns:a16="http://schemas.microsoft.com/office/drawing/2014/main" id="{901680EF-B5C6-409B-A13E-C9AC53CE71E5}"/>
               </a:ext>
             </a:extLst>
           </p:cNvPr>
@@ -16619,7 +16573,7 @@
           <p:cNvPr id="6" name="">
             <a:extLst xmlns:a="http://schemas.openxmlformats.org/drawingml/2006/main">
               <a:ext uri="{FF2B5EF4-FFF2-40B4-BE49-F238E27FC236}">
-                <a16:creationId xmlns:a16="http://schemas.microsoft.com/office/drawing/2014/main" id="{D7ADE9F1-E7D4-4C95-B297-C9DE8CDA8153}"/>
+                <a16:creationId xmlns:a16="http://schemas.microsoft.com/office/drawing/2014/main" id="{3247094F-593E-4A6C-A9D0-AA89C6D08ACB}"/>
               </a:ext>
             </a:extLst>
           </p:cNvPr>
@@ -16772,7 +16726,7 @@
           <p:nvPr/>
         </p:nvPicPr>
         <p:blipFill>
-          <a:blip xmlns:r="http://schemas.openxmlformats.org/officeDocument/2006/relationships" xmlns:a="http://schemas.openxmlformats.org/drawingml/2006/main" r:embed="R9d6a2b654ecb454e"/>
+          <a:blip xmlns:r="http://schemas.openxmlformats.org/officeDocument/2006/relationships" xmlns:a="http://schemas.openxmlformats.org/drawingml/2006/main" r:embed="Raf24335bca0846d6"/>
           <a:stretch xmlns:a="http://schemas.openxmlformats.org/drawingml/2006/main"/>
         </p:blipFill>
         <p:spPr>
@@ -16790,7 +16744,7 @@
           <p:cNvPr id="8" name="">
             <a:extLst xmlns:a="http://schemas.openxmlformats.org/drawingml/2006/main">
               <a:ext uri="{FF2B5EF4-FFF2-40B4-BE49-F238E27FC236}">
-                <a16:creationId xmlns:a16="http://schemas.microsoft.com/office/drawing/2014/main" id="{3BD9F9B7-2517-47F9-9E2B-308C71744223}"/>
+                <a16:creationId xmlns:a16="http://schemas.microsoft.com/office/drawing/2014/main" id="{16E291BB-C105-4F32-841F-9BA7FA3BFF4A}"/>
               </a:ext>
             </a:extLst>
           </p:cNvPr>
@@ -16845,7 +16799,7 @@
     </p:spTree>
     <p:extLst>
       <p:ext uri="{BB962C8B-B14F-4D97-AF65-F5344CB8AC3E}">
-        <p14:creationId xmlns:p14="http://schemas.microsoft.com/office/powerpoint/2010/main" val="198506776"/>
+        <p14:creationId xmlns:p14="http://schemas.microsoft.com/office/powerpoint/2010/main" val="1570120584"/>
       </p:ext>
     </p:extLst>
   </p:cSld>
@@ -16876,7 +16830,7 @@
           <p:cNvPr id="9" name="">
             <a:extLst xmlns:a="http://schemas.openxmlformats.org/drawingml/2006/main">
               <a:ext uri="{FF2B5EF4-FFF2-40B4-BE49-F238E27FC236}">
-                <a16:creationId xmlns:a16="http://schemas.microsoft.com/office/drawing/2014/main" id="{97539F2F-1258-441A-A298-E19AF8B057A4}"/>
+                <a16:creationId xmlns:a16="http://schemas.microsoft.com/office/drawing/2014/main" id="{78ED674B-A7B2-4A71-9678-61EF2204E441}"/>
               </a:ext>
             </a:extLst>
           </p:cNvPr>
@@ -16933,7 +16887,7 @@
           <p:cNvPr id="2" name="">
             <a:extLst xmlns:a="http://schemas.openxmlformats.org/drawingml/2006/main">
               <a:ext uri="{FF2B5EF4-FFF2-40B4-BE49-F238E27FC236}">
-                <a16:creationId xmlns:a16="http://schemas.microsoft.com/office/drawing/2014/main" id="{C3F18D45-23CC-496C-8A83-5F8B979EB71A}"/>
+                <a16:creationId xmlns:a16="http://schemas.microsoft.com/office/drawing/2014/main" id="{3B1EBFA6-A992-46D6-89FB-69843EC9CD65}"/>
               </a:ext>
             </a:extLst>
           </p:cNvPr>
@@ -16990,7 +16944,7 @@
           <p:cNvPr id="3" name="">
             <a:extLst xmlns:a="http://schemas.openxmlformats.org/drawingml/2006/main">
               <a:ext uri="{FF2B5EF4-FFF2-40B4-BE49-F238E27FC236}">
-                <a16:creationId xmlns:a16="http://schemas.microsoft.com/office/drawing/2014/main" id="{AD152FEE-51FF-45BF-9F0F-BCAD30D96686}"/>
+                <a16:creationId xmlns:a16="http://schemas.microsoft.com/office/drawing/2014/main" id="{B0C6C014-57B6-4869-B36D-F81C26DD9AA8}"/>
               </a:ext>
             </a:extLst>
           </p:cNvPr>
@@ -17047,7 +17001,7 @@
           <p:cNvPr id="4" name="">
             <a:extLst xmlns:a="http://schemas.openxmlformats.org/drawingml/2006/main">
               <a:ext uri="{FF2B5EF4-FFF2-40B4-BE49-F238E27FC236}">
-                <a16:creationId xmlns:a16="http://schemas.microsoft.com/office/drawing/2014/main" id="{470DB746-EE24-41C0-9947-0EF00463A9E0}"/>
+                <a16:creationId xmlns:a16="http://schemas.microsoft.com/office/drawing/2014/main" id="{92FBFF9C-4BA6-4CBF-88F1-1E4A1278B227}"/>
               </a:ext>
             </a:extLst>
           </p:cNvPr>
@@ -17196,7 +17150,7 @@
           <p:cNvPr id="5" name="">
             <a:extLst xmlns:a="http://schemas.openxmlformats.org/drawingml/2006/main">
               <a:ext uri="{FF2B5EF4-FFF2-40B4-BE49-F238E27FC236}">
-                <a16:creationId xmlns:a16="http://schemas.microsoft.com/office/drawing/2014/main" id="{1CE9CCD8-2873-4827-9D80-0DDE061986FA}"/>
+                <a16:creationId xmlns:a16="http://schemas.microsoft.com/office/drawing/2014/main" id="{532E1911-C579-4B08-8175-2DE289F94180}"/>
               </a:ext>
             </a:extLst>
           </p:cNvPr>
@@ -17253,7 +17207,7 @@
           <p:cNvPr id="6" name="">
             <a:extLst xmlns:a="http://schemas.openxmlformats.org/drawingml/2006/main">
               <a:ext uri="{FF2B5EF4-FFF2-40B4-BE49-F238E27FC236}">
-                <a16:creationId xmlns:a16="http://schemas.microsoft.com/office/drawing/2014/main" id="{E2F3D58D-1D22-41BF-A9A1-27B363FA5786}"/>
+                <a16:creationId xmlns:a16="http://schemas.microsoft.com/office/drawing/2014/main" id="{4E0ECC28-97B6-4760-B1CF-7D45408B6C27}"/>
               </a:ext>
             </a:extLst>
           </p:cNvPr>
@@ -17406,7 +17360,7 @@
           <p:nvPr/>
         </p:nvPicPr>
         <p:blipFill>
-          <a:blip xmlns:r="http://schemas.openxmlformats.org/officeDocument/2006/relationships" xmlns:a="http://schemas.openxmlformats.org/drawingml/2006/main" r:embed="Rcf7a50c8385a4c97"/>
+          <a:blip xmlns:r="http://schemas.openxmlformats.org/officeDocument/2006/relationships" xmlns:a="http://schemas.openxmlformats.org/drawingml/2006/main" r:embed="Ra1f782332c1d4a2e"/>
           <a:stretch xmlns:a="http://schemas.openxmlformats.org/drawingml/2006/main"/>
         </p:blipFill>
         <p:spPr>
@@ -17424,7 +17378,7 @@
           <p:cNvPr id="8" name="">
             <a:extLst xmlns:a="http://schemas.openxmlformats.org/drawingml/2006/main">
               <a:ext uri="{FF2B5EF4-FFF2-40B4-BE49-F238E27FC236}">
-                <a16:creationId xmlns:a16="http://schemas.microsoft.com/office/drawing/2014/main" id="{46FA302A-4377-4BBD-86FC-2C9796B864E0}"/>
+                <a16:creationId xmlns:a16="http://schemas.microsoft.com/office/drawing/2014/main" id="{516BDADE-7A99-451C-A3D1-9231ED611E63}"/>
               </a:ext>
             </a:extLst>
           </p:cNvPr>
@@ -17479,7 +17433,7 @@
     </p:spTree>
     <p:extLst>
       <p:ext uri="{BB962C8B-B14F-4D97-AF65-F5344CB8AC3E}">
-        <p14:creationId xmlns:p14="http://schemas.microsoft.com/office/powerpoint/2010/main" val="620121448"/>
+        <p14:creationId xmlns:p14="http://schemas.microsoft.com/office/powerpoint/2010/main" val="471868083"/>
       </p:ext>
     </p:extLst>
   </p:cSld>
@@ -17510,7 +17464,7 @@
           <p:cNvPr id="9" name="">
             <a:extLst xmlns:a="http://schemas.openxmlformats.org/drawingml/2006/main">
               <a:ext uri="{FF2B5EF4-FFF2-40B4-BE49-F238E27FC236}">
-                <a16:creationId xmlns:a16="http://schemas.microsoft.com/office/drawing/2014/main" id="{A8285CAF-B6D3-48AB-88AE-EA1EBF009145}"/>
+                <a16:creationId xmlns:a16="http://schemas.microsoft.com/office/drawing/2014/main" id="{7BE77470-DB77-4942-806A-25C0C800EA44}"/>
               </a:ext>
             </a:extLst>
           </p:cNvPr>
@@ -17567,7 +17521,7 @@
           <p:cNvPr id="2" name="">
             <a:extLst xmlns:a="http://schemas.openxmlformats.org/drawingml/2006/main">
               <a:ext uri="{FF2B5EF4-FFF2-40B4-BE49-F238E27FC236}">
-                <a16:creationId xmlns:a16="http://schemas.microsoft.com/office/drawing/2014/main" id="{8FF56537-2F21-4E2F-8810-49DA201577B2}"/>
+                <a16:creationId xmlns:a16="http://schemas.microsoft.com/office/drawing/2014/main" id="{ED6A3C86-194A-4BB4-ABC0-CEA058D18692}"/>
               </a:ext>
             </a:extLst>
           </p:cNvPr>
@@ -17624,7 +17578,7 @@
           <p:cNvPr id="3" name="">
             <a:extLst xmlns:a="http://schemas.openxmlformats.org/drawingml/2006/main">
               <a:ext uri="{FF2B5EF4-FFF2-40B4-BE49-F238E27FC236}">
-                <a16:creationId xmlns:a16="http://schemas.microsoft.com/office/drawing/2014/main" id="{D69E4376-DA8B-4686-B2C5-986557D8BC23}"/>
+                <a16:creationId xmlns:a16="http://schemas.microsoft.com/office/drawing/2014/main" id="{F0271AD0-E861-4DAC-BCB5-EE262BA46C6A}"/>
               </a:ext>
             </a:extLst>
           </p:cNvPr>
@@ -17681,7 +17635,7 @@
           <p:cNvPr id="4" name="">
             <a:extLst xmlns:a="http://schemas.openxmlformats.org/drawingml/2006/main">
               <a:ext uri="{FF2B5EF4-FFF2-40B4-BE49-F238E27FC236}">
-                <a16:creationId xmlns:a16="http://schemas.microsoft.com/office/drawing/2014/main" id="{B1B6F073-0B89-4F38-8E28-BC0B39EC603D}"/>
+                <a16:creationId xmlns:a16="http://schemas.microsoft.com/office/drawing/2014/main" id="{8FACAE04-16C8-402D-A145-DC06059A83F9}"/>
               </a:ext>
             </a:extLst>
           </p:cNvPr>
@@ -17807,7 +17761,7 @@
           <p:cNvPr id="5" name="">
             <a:extLst xmlns:a="http://schemas.openxmlformats.org/drawingml/2006/main">
               <a:ext uri="{FF2B5EF4-FFF2-40B4-BE49-F238E27FC236}">
-                <a16:creationId xmlns:a16="http://schemas.microsoft.com/office/drawing/2014/main" id="{B1E8B10B-8C5E-45F0-AE4F-E65FA544F673}"/>
+                <a16:creationId xmlns:a16="http://schemas.microsoft.com/office/drawing/2014/main" id="{F6E28E9C-A963-4A1E-A834-F34C2B0A0D64}"/>
               </a:ext>
             </a:extLst>
           </p:cNvPr>
@@ -17864,7 +17818,7 @@
           <p:cNvPr id="6" name="">
             <a:extLst xmlns:a="http://schemas.openxmlformats.org/drawingml/2006/main">
               <a:ext uri="{FF2B5EF4-FFF2-40B4-BE49-F238E27FC236}">
-                <a16:creationId xmlns:a16="http://schemas.microsoft.com/office/drawing/2014/main" id="{E25EE411-36E0-4180-896D-720CC866444A}"/>
+                <a16:creationId xmlns:a16="http://schemas.microsoft.com/office/drawing/2014/main" id="{4D31BD69-A4D5-40D4-B7AD-2D0C05148277}"/>
               </a:ext>
             </a:extLst>
           </p:cNvPr>
@@ -18017,7 +17971,7 @@
           <p:nvPr/>
         </p:nvPicPr>
         <p:blipFill>
-          <a:blip xmlns:r="http://schemas.openxmlformats.org/officeDocument/2006/relationships" xmlns:a="http://schemas.openxmlformats.org/drawingml/2006/main" r:embed="R9499e957c2714942"/>
+          <a:blip xmlns:r="http://schemas.openxmlformats.org/officeDocument/2006/relationships" xmlns:a="http://schemas.openxmlformats.org/drawingml/2006/main" r:embed="R544d1e2638624593"/>
           <a:stretch xmlns:a="http://schemas.openxmlformats.org/drawingml/2006/main"/>
         </p:blipFill>
         <p:spPr>
@@ -18035,7 +17989,7 @@
           <p:cNvPr id="8" name="">
             <a:extLst xmlns:a="http://schemas.openxmlformats.org/drawingml/2006/main">
               <a:ext uri="{FF2B5EF4-FFF2-40B4-BE49-F238E27FC236}">
-                <a16:creationId xmlns:a16="http://schemas.microsoft.com/office/drawing/2014/main" id="{26A89DFE-A082-41ED-85CF-63F91B8A6380}"/>
+                <a16:creationId xmlns:a16="http://schemas.microsoft.com/office/drawing/2014/main" id="{0C46FB25-D650-4116-ADEF-DAC0DE26A073}"/>
               </a:ext>
             </a:extLst>
           </p:cNvPr>
@@ -18090,7 +18044,7 @@
     </p:spTree>
     <p:extLst>
       <p:ext uri="{BB962C8B-B14F-4D97-AF65-F5344CB8AC3E}">
-        <p14:creationId xmlns:p14="http://schemas.microsoft.com/office/powerpoint/2010/main" val="1822267526"/>
+        <p14:creationId xmlns:p14="http://schemas.microsoft.com/office/powerpoint/2010/main" val="2101351032"/>
       </p:ext>
     </p:extLst>
   </p:cSld>
@@ -18121,7 +18075,7 @@
           <p:cNvPr id="9" name="">
             <a:extLst xmlns:a="http://schemas.openxmlformats.org/drawingml/2006/main">
               <a:ext uri="{FF2B5EF4-FFF2-40B4-BE49-F238E27FC236}">
-                <a16:creationId xmlns:a16="http://schemas.microsoft.com/office/drawing/2014/main" id="{27E5A0EE-080D-46DA-8BED-C54BB9ADE07D}"/>
+                <a16:creationId xmlns:a16="http://schemas.microsoft.com/office/drawing/2014/main" id="{FFCD0AA2-D7F3-4EDA-90E5-CC2F832DB24F}"/>
               </a:ext>
             </a:extLst>
           </p:cNvPr>
@@ -18178,7 +18132,7 @@
           <p:cNvPr id="2" name="">
             <a:extLst xmlns:a="http://schemas.openxmlformats.org/drawingml/2006/main">
               <a:ext uri="{FF2B5EF4-FFF2-40B4-BE49-F238E27FC236}">
-                <a16:creationId xmlns:a16="http://schemas.microsoft.com/office/drawing/2014/main" id="{E841399F-38A6-4C95-81DD-3D8FD98DDED0}"/>
+                <a16:creationId xmlns:a16="http://schemas.microsoft.com/office/drawing/2014/main" id="{CDE744EE-EA76-48BE-89A5-763BC994ACE3}"/>
               </a:ext>
             </a:extLst>
           </p:cNvPr>
@@ -18235,7 +18189,7 @@
           <p:cNvPr id="3" name="">
             <a:extLst xmlns:a="http://schemas.openxmlformats.org/drawingml/2006/main">
               <a:ext uri="{FF2B5EF4-FFF2-40B4-BE49-F238E27FC236}">
-                <a16:creationId xmlns:a16="http://schemas.microsoft.com/office/drawing/2014/main" id="{B25C058A-D989-43A4-AEBA-DFD7A93E6841}"/>
+                <a16:creationId xmlns:a16="http://schemas.microsoft.com/office/drawing/2014/main" id="{B89BC7F9-AB55-4DB5-8567-7876ACA8B402}"/>
               </a:ext>
             </a:extLst>
           </p:cNvPr>
@@ -18292,7 +18246,7 @@
           <p:cNvPr id="4" name="">
             <a:extLst xmlns:a="http://schemas.openxmlformats.org/drawingml/2006/main">
               <a:ext uri="{FF2B5EF4-FFF2-40B4-BE49-F238E27FC236}">
-                <a16:creationId xmlns:a16="http://schemas.microsoft.com/office/drawing/2014/main" id="{5E443678-8C06-4502-AD16-35468F06C636}"/>
+                <a16:creationId xmlns:a16="http://schemas.microsoft.com/office/drawing/2014/main" id="{8261F30E-AE67-4116-8C8D-FA680366E490}"/>
               </a:ext>
             </a:extLst>
           </p:cNvPr>
@@ -18441,7 +18395,7 @@
           <p:cNvPr id="5" name="">
             <a:extLst xmlns:a="http://schemas.openxmlformats.org/drawingml/2006/main">
               <a:ext uri="{FF2B5EF4-FFF2-40B4-BE49-F238E27FC236}">
-                <a16:creationId xmlns:a16="http://schemas.microsoft.com/office/drawing/2014/main" id="{467C7A39-14B8-409F-A117-33E562A53067}"/>
+                <a16:creationId xmlns:a16="http://schemas.microsoft.com/office/drawing/2014/main" id="{9F03B85D-4F98-4946-AD60-B460DDD1B62A}"/>
               </a:ext>
             </a:extLst>
           </p:cNvPr>
@@ -18498,7 +18452,7 @@
           <p:cNvPr id="6" name="">
             <a:extLst xmlns:a="http://schemas.openxmlformats.org/drawingml/2006/main">
               <a:ext uri="{FF2B5EF4-FFF2-40B4-BE49-F238E27FC236}">
-                <a16:creationId xmlns:a16="http://schemas.microsoft.com/office/drawing/2014/main" id="{E38CACB4-9B40-4845-95BB-A7E947B105F0}"/>
+                <a16:creationId xmlns:a16="http://schemas.microsoft.com/office/drawing/2014/main" id="{7D8BEFF5-B418-4617-8386-9CF5D7E0B32D}"/>
               </a:ext>
             </a:extLst>
           </p:cNvPr>
@@ -18628,7 +18582,7 @@
           <p:nvPr/>
         </p:nvPicPr>
         <p:blipFill>
-          <a:blip xmlns:r="http://schemas.openxmlformats.org/officeDocument/2006/relationships" xmlns:a="http://schemas.openxmlformats.org/drawingml/2006/main" r:embed="Rc03d0f9b4924417b"/>
+          <a:blip xmlns:r="http://schemas.openxmlformats.org/officeDocument/2006/relationships" xmlns:a="http://schemas.openxmlformats.org/drawingml/2006/main" r:embed="R8c88f6423865471d"/>
           <a:stretch xmlns:a="http://schemas.openxmlformats.org/drawingml/2006/main"/>
         </p:blipFill>
         <p:spPr>
@@ -18646,7 +18600,7 @@
           <p:cNvPr id="8" name="">
             <a:extLst xmlns:a="http://schemas.openxmlformats.org/drawingml/2006/main">
               <a:ext uri="{FF2B5EF4-FFF2-40B4-BE49-F238E27FC236}">
-                <a16:creationId xmlns:a16="http://schemas.microsoft.com/office/drawing/2014/main" id="{308A24AD-BFBE-4DB5-9103-D8D5DEFC7609}"/>
+                <a16:creationId xmlns:a16="http://schemas.microsoft.com/office/drawing/2014/main" id="{3CC3BC84-CEFF-46BD-94BB-4268BE6BDCCE}"/>
               </a:ext>
             </a:extLst>
           </p:cNvPr>
@@ -18701,7 +18655,7 @@
     </p:spTree>
     <p:extLst>
       <p:ext uri="{BB962C8B-B14F-4D97-AF65-F5344CB8AC3E}">
-        <p14:creationId xmlns:p14="http://schemas.microsoft.com/office/powerpoint/2010/main" val="1063263725"/>
+        <p14:creationId xmlns:p14="http://schemas.microsoft.com/office/powerpoint/2010/main" val="1961795370"/>
       </p:ext>
     </p:extLst>
   </p:cSld>
@@ -18732,7 +18686,7 @@
           <p:cNvPr id="9" name="">
             <a:extLst xmlns:a="http://schemas.openxmlformats.org/drawingml/2006/main">
               <a:ext uri="{FF2B5EF4-FFF2-40B4-BE49-F238E27FC236}">
-                <a16:creationId xmlns:a16="http://schemas.microsoft.com/office/drawing/2014/main" id="{62313E9C-45FD-42E6-B5CA-C70B503B8354}"/>
+                <a16:creationId xmlns:a16="http://schemas.microsoft.com/office/drawing/2014/main" id="{2283AE3D-BC93-4876-80FA-300928C940B3}"/>
               </a:ext>
             </a:extLst>
           </p:cNvPr>
@@ -18789,7 +18743,7 @@
           <p:cNvPr id="2" name="">
             <a:extLst xmlns:a="http://schemas.openxmlformats.org/drawingml/2006/main">
               <a:ext uri="{FF2B5EF4-FFF2-40B4-BE49-F238E27FC236}">
-                <a16:creationId xmlns:a16="http://schemas.microsoft.com/office/drawing/2014/main" id="{D218613A-2049-41F0-B90C-A696388519A4}"/>
+                <a16:creationId xmlns:a16="http://schemas.microsoft.com/office/drawing/2014/main" id="{1DDA79D1-6A5F-437B-BAF2-C051F2C2A7F6}"/>
               </a:ext>
             </a:extLst>
           </p:cNvPr>
@@ -18846,7 +18800,7 @@
           <p:cNvPr id="3" name="">
             <a:extLst xmlns:a="http://schemas.openxmlformats.org/drawingml/2006/main">
               <a:ext uri="{FF2B5EF4-FFF2-40B4-BE49-F238E27FC236}">
-                <a16:creationId xmlns:a16="http://schemas.microsoft.com/office/drawing/2014/main" id="{028DA581-1D99-4F8E-AB42-066D19988C97}"/>
+                <a16:creationId xmlns:a16="http://schemas.microsoft.com/office/drawing/2014/main" id="{CE2F4A22-4A66-4AA6-8463-33B5BFF38C5E}"/>
               </a:ext>
             </a:extLst>
           </p:cNvPr>
@@ -18903,7 +18857,7 @@
           <p:cNvPr id="4" name="">
             <a:extLst xmlns:a="http://schemas.openxmlformats.org/drawingml/2006/main">
               <a:ext uri="{FF2B5EF4-FFF2-40B4-BE49-F238E27FC236}">
-                <a16:creationId xmlns:a16="http://schemas.microsoft.com/office/drawing/2014/main" id="{56A3ACC8-3508-4A53-B883-70FB7436ECDA}"/>
+                <a16:creationId xmlns:a16="http://schemas.microsoft.com/office/drawing/2014/main" id="{287325AD-7B5C-48C3-9C36-79BB05E4C3B9}"/>
               </a:ext>
             </a:extLst>
           </p:cNvPr>
@@ -18950,7 +18904,7 @@
                 <a:ea typeface="Malgun Gothic"/>
                 <a:cs typeface="Malgun Gothic"/>
               </a:rPr>
-              <a:t>v1.2.0의 Windows x64 배포</a:t>
+              <a:t>v1.3.0의 Windows x64 배포</a:t>
             </a:r>
           </a:p>
           <a:p xmlns:a="http://schemas.openxmlformats.org/drawingml/2006/main">
@@ -19052,7 +19006,7 @@
           <p:cNvPr id="5" name="">
             <a:extLst xmlns:a="http://schemas.openxmlformats.org/drawingml/2006/main">
               <a:ext uri="{FF2B5EF4-FFF2-40B4-BE49-F238E27FC236}">
-                <a16:creationId xmlns:a16="http://schemas.microsoft.com/office/drawing/2014/main" id="{7A78A324-DA30-4DD6-AFCC-486AB2FD475E}"/>
+                <a16:creationId xmlns:a16="http://schemas.microsoft.com/office/drawing/2014/main" id="{3CF46B83-F8BE-4D81-A5CF-DCA24E1CFC63}"/>
               </a:ext>
             </a:extLst>
           </p:cNvPr>
@@ -19109,7 +19063,7 @@
           <p:cNvPr id="6" name="">
             <a:extLst xmlns:a="http://schemas.openxmlformats.org/drawingml/2006/main">
               <a:ext uri="{FF2B5EF4-FFF2-40B4-BE49-F238E27FC236}">
-                <a16:creationId xmlns:a16="http://schemas.microsoft.com/office/drawing/2014/main" id="{7C655395-651A-40C9-AEF9-933304EF28EE}"/>
+                <a16:creationId xmlns:a16="http://schemas.microsoft.com/office/drawing/2014/main" id="{C81B928D-96C4-4478-886C-F5859BFBBCE5}"/>
               </a:ext>
             </a:extLst>
           </p:cNvPr>
@@ -19239,7 +19193,7 @@
           <p:nvPr/>
         </p:nvPicPr>
         <p:blipFill>
-          <a:blip xmlns:r="http://schemas.openxmlformats.org/officeDocument/2006/relationships" xmlns:a="http://schemas.openxmlformats.org/drawingml/2006/main" r:embed="Rf889f5f623e1466d"/>
+          <a:blip xmlns:r="http://schemas.openxmlformats.org/officeDocument/2006/relationships" xmlns:a="http://schemas.openxmlformats.org/drawingml/2006/main" r:embed="Rafbebacb28b64512"/>
           <a:stretch xmlns:a="http://schemas.openxmlformats.org/drawingml/2006/main"/>
         </p:blipFill>
         <p:spPr>
@@ -19257,7 +19211,7 @@
           <p:cNvPr id="8" name="">
             <a:extLst xmlns:a="http://schemas.openxmlformats.org/drawingml/2006/main">
               <a:ext uri="{FF2B5EF4-FFF2-40B4-BE49-F238E27FC236}">
-                <a16:creationId xmlns:a16="http://schemas.microsoft.com/office/drawing/2014/main" id="{9716F1CD-CDF2-41F0-BA33-9603B47B865D}"/>
+                <a16:creationId xmlns:a16="http://schemas.microsoft.com/office/drawing/2014/main" id="{B439A87F-DD47-434B-B3F5-432CD4A3F964}"/>
               </a:ext>
             </a:extLst>
           </p:cNvPr>
@@ -19312,7 +19266,7 @@
     </p:spTree>
     <p:extLst>
       <p:ext uri="{BB962C8B-B14F-4D97-AF65-F5344CB8AC3E}">
-        <p14:creationId xmlns:p14="http://schemas.microsoft.com/office/powerpoint/2010/main" val="410402936"/>
+        <p14:creationId xmlns:p14="http://schemas.microsoft.com/office/powerpoint/2010/main" val="1255407277"/>
       </p:ext>
     </p:extLst>
   </p:cSld>
@@ -19343,7 +19297,7 @@
           <p:cNvPr id="9" name="">
             <a:extLst xmlns:a="http://schemas.openxmlformats.org/drawingml/2006/main">
               <a:ext uri="{FF2B5EF4-FFF2-40B4-BE49-F238E27FC236}">
-                <a16:creationId xmlns:a16="http://schemas.microsoft.com/office/drawing/2014/main" id="{0D96508E-655B-4DC7-92D0-61460C2DE513}"/>
+                <a16:creationId xmlns:a16="http://schemas.microsoft.com/office/drawing/2014/main" id="{594C475F-A78A-4AB2-93DA-77E9EAC73B8B}"/>
               </a:ext>
             </a:extLst>
           </p:cNvPr>
@@ -19400,7 +19354,7 @@
           <p:cNvPr id="2" name="">
             <a:extLst xmlns:a="http://schemas.openxmlformats.org/drawingml/2006/main">
               <a:ext uri="{FF2B5EF4-FFF2-40B4-BE49-F238E27FC236}">
-                <a16:creationId xmlns:a16="http://schemas.microsoft.com/office/drawing/2014/main" id="{4EA0751D-9289-409C-B49C-34F4F7C3D964}"/>
+                <a16:creationId xmlns:a16="http://schemas.microsoft.com/office/drawing/2014/main" id="{681D5DB8-A1B8-4816-A1EC-5F6B335C3ADE}"/>
               </a:ext>
             </a:extLst>
           </p:cNvPr>
@@ -19457,7 +19411,7 @@
           <p:cNvPr id="3" name="">
             <a:extLst xmlns:a="http://schemas.openxmlformats.org/drawingml/2006/main">
               <a:ext uri="{FF2B5EF4-FFF2-40B4-BE49-F238E27FC236}">
-                <a16:creationId xmlns:a16="http://schemas.microsoft.com/office/drawing/2014/main" id="{AB8AFAD7-834D-4B34-9145-7045E6B690E7}"/>
+                <a16:creationId xmlns:a16="http://schemas.microsoft.com/office/drawing/2014/main" id="{CE5CA4E2-FD75-41AE-9A23-4A2B173D37A9}"/>
               </a:ext>
             </a:extLst>
           </p:cNvPr>
@@ -19514,7 +19468,7 @@
           <p:cNvPr id="4" name="">
             <a:extLst xmlns:a="http://schemas.openxmlformats.org/drawingml/2006/main">
               <a:ext uri="{FF2B5EF4-FFF2-40B4-BE49-F238E27FC236}">
-                <a16:creationId xmlns:a16="http://schemas.microsoft.com/office/drawing/2014/main" id="{D2CAFC98-351F-4479-BF54-F930D4F82C06}"/>
+                <a16:creationId xmlns:a16="http://schemas.microsoft.com/office/drawing/2014/main" id="{148C08CA-439D-4313-8AB3-344C34E9ADF7}"/>
               </a:ext>
             </a:extLst>
           </p:cNvPr>
@@ -19663,7 +19617,7 @@
           <p:cNvPr id="5" name="">
             <a:extLst xmlns:a="http://schemas.openxmlformats.org/drawingml/2006/main">
               <a:ext uri="{FF2B5EF4-FFF2-40B4-BE49-F238E27FC236}">
-                <a16:creationId xmlns:a16="http://schemas.microsoft.com/office/drawing/2014/main" id="{475CCC96-E25A-4243-A770-772F85176E47}"/>
+                <a16:creationId xmlns:a16="http://schemas.microsoft.com/office/drawing/2014/main" id="{BD172F17-21C0-444A-872B-8F804E984BA4}"/>
               </a:ext>
             </a:extLst>
           </p:cNvPr>
@@ -19720,7 +19674,7 @@
           <p:cNvPr id="6" name="">
             <a:extLst xmlns:a="http://schemas.openxmlformats.org/drawingml/2006/main">
               <a:ext uri="{FF2B5EF4-FFF2-40B4-BE49-F238E27FC236}">
-                <a16:creationId xmlns:a16="http://schemas.microsoft.com/office/drawing/2014/main" id="{95A017DC-53C3-4085-8A86-D250C126AE7B}"/>
+                <a16:creationId xmlns:a16="http://schemas.microsoft.com/office/drawing/2014/main" id="{500D3672-2CDA-4763-8C90-5B47AAEB7B5C}"/>
               </a:ext>
             </a:extLst>
           </p:cNvPr>
@@ -19873,7 +19827,7 @@
           <p:nvPr/>
         </p:nvPicPr>
         <p:blipFill>
-          <a:blip xmlns:r="http://schemas.openxmlformats.org/officeDocument/2006/relationships" xmlns:a="http://schemas.openxmlformats.org/drawingml/2006/main" r:embed="R587acac177074cda"/>
+          <a:blip xmlns:r="http://schemas.openxmlformats.org/officeDocument/2006/relationships" xmlns:a="http://schemas.openxmlformats.org/drawingml/2006/main" r:embed="Ra4940e08029b4a3d"/>
           <a:stretch xmlns:a="http://schemas.openxmlformats.org/drawingml/2006/main"/>
         </p:blipFill>
         <p:spPr>
@@ -19891,7 +19845,7 @@
           <p:cNvPr id="8" name="">
             <a:extLst xmlns:a="http://schemas.openxmlformats.org/drawingml/2006/main">
               <a:ext uri="{FF2B5EF4-FFF2-40B4-BE49-F238E27FC236}">
-                <a16:creationId xmlns:a16="http://schemas.microsoft.com/office/drawing/2014/main" id="{32A93BD4-4592-4422-89EA-858830A92473}"/>
+                <a16:creationId xmlns:a16="http://schemas.microsoft.com/office/drawing/2014/main" id="{0FDD5B11-58D8-4D42-9668-DD71F0941ED5}"/>
               </a:ext>
             </a:extLst>
           </p:cNvPr>
@@ -19946,7 +19900,7 @@
     </p:spTree>
     <p:extLst>
       <p:ext uri="{BB962C8B-B14F-4D97-AF65-F5344CB8AC3E}">
-        <p14:creationId xmlns:p14="http://schemas.microsoft.com/office/powerpoint/2010/main" val="1844747899"/>
+        <p14:creationId xmlns:p14="http://schemas.microsoft.com/office/powerpoint/2010/main" val="1315819662"/>
       </p:ext>
     </p:extLst>
   </p:cSld>
@@ -19977,7 +19931,7 @@
           <p:cNvPr id="12" name="">
             <a:extLst xmlns:a="http://schemas.openxmlformats.org/drawingml/2006/main">
               <a:ext uri="{FF2B5EF4-FFF2-40B4-BE49-F238E27FC236}">
-                <a16:creationId xmlns:a16="http://schemas.microsoft.com/office/drawing/2014/main" id="{F17E82EE-01C2-4541-8A7E-A9E980369B1F}"/>
+                <a16:creationId xmlns:a16="http://schemas.microsoft.com/office/drawing/2014/main" id="{1EAE9431-15B0-4880-902D-9C16F6BF8528}"/>
               </a:ext>
             </a:extLst>
           </p:cNvPr>
@@ -20034,7 +19988,7 @@
           <p:cNvPr id="2" name="">
             <a:extLst xmlns:a="http://schemas.openxmlformats.org/drawingml/2006/main">
               <a:ext uri="{FF2B5EF4-FFF2-40B4-BE49-F238E27FC236}">
-                <a16:creationId xmlns:a16="http://schemas.microsoft.com/office/drawing/2014/main" id="{B083A0EB-43FE-4414-B770-84888BF70478}"/>
+                <a16:creationId xmlns:a16="http://schemas.microsoft.com/office/drawing/2014/main" id="{EBCB026F-1F94-4E8F-827A-771B9A8DC0C9}"/>
               </a:ext>
             </a:extLst>
           </p:cNvPr>
@@ -20091,7 +20045,7 @@
           <p:cNvPr id="3" name="">
             <a:extLst xmlns:a="http://schemas.openxmlformats.org/drawingml/2006/main">
               <a:ext uri="{FF2B5EF4-FFF2-40B4-BE49-F238E27FC236}">
-                <a16:creationId xmlns:a16="http://schemas.microsoft.com/office/drawing/2014/main" id="{12E0FDA8-301B-4D20-86F2-08537E3F0284}"/>
+                <a16:creationId xmlns:a16="http://schemas.microsoft.com/office/drawing/2014/main" id="{626F68A4-BCAB-4680-AAF0-89355AB9D867}"/>
               </a:ext>
             </a:extLst>
           </p:cNvPr>
@@ -20148,7 +20102,7 @@
           <p:cNvPr id="4" name="">
             <a:extLst xmlns:a="http://schemas.openxmlformats.org/drawingml/2006/main">
               <a:ext uri="{FF2B5EF4-FFF2-40B4-BE49-F238E27FC236}">
-                <a16:creationId xmlns:a16="http://schemas.microsoft.com/office/drawing/2014/main" id="{7435D77A-136F-4896-8548-2734252DD2F1}"/>
+                <a16:creationId xmlns:a16="http://schemas.microsoft.com/office/drawing/2014/main" id="{DBE29E49-8E97-4A8C-89E5-D114F3DCFC91}"/>
               </a:ext>
             </a:extLst>
           </p:cNvPr>
@@ -20228,7 +20182,7 @@
           <p:cNvPr id="5" name="">
             <a:extLst xmlns:a="http://schemas.openxmlformats.org/drawingml/2006/main">
               <a:ext uri="{FF2B5EF4-FFF2-40B4-BE49-F238E27FC236}">
-                <a16:creationId xmlns:a16="http://schemas.microsoft.com/office/drawing/2014/main" id="{F5BA5F65-B0F0-46F3-A981-0F0FDF5EBB49}"/>
+                <a16:creationId xmlns:a16="http://schemas.microsoft.com/office/drawing/2014/main" id="{6CA2763E-9B11-41F6-B46E-44064F82D3F3}"/>
               </a:ext>
             </a:extLst>
           </p:cNvPr>
@@ -20285,7 +20239,7 @@
           <p:cNvPr id="6" name="">
             <a:extLst xmlns:a="http://schemas.openxmlformats.org/drawingml/2006/main">
               <a:ext uri="{FF2B5EF4-FFF2-40B4-BE49-F238E27FC236}">
-                <a16:creationId xmlns:a16="http://schemas.microsoft.com/office/drawing/2014/main" id="{79CA7DB4-7D40-4B63-8166-73507602724D}"/>
+                <a16:creationId xmlns:a16="http://schemas.microsoft.com/office/drawing/2014/main" id="{3E7777DC-ABAB-463E-B420-F11578B8AE22}"/>
               </a:ext>
             </a:extLst>
           </p:cNvPr>
@@ -20388,7 +20342,7 @@
           <p:cNvPr id="7" name="">
             <a:extLst xmlns:a="http://schemas.openxmlformats.org/drawingml/2006/main">
               <a:ext uri="{FF2B5EF4-FFF2-40B4-BE49-F238E27FC236}">
-                <a16:creationId xmlns:a16="http://schemas.microsoft.com/office/drawing/2014/main" id="{E2B1644C-B740-4C12-9FC4-B89481B9FBC1}"/>
+                <a16:creationId xmlns:a16="http://schemas.microsoft.com/office/drawing/2014/main" id="{CE6A5154-4F1E-4288-B4F8-6B59443F0D5B}"/>
               </a:ext>
             </a:extLst>
           </p:cNvPr>
@@ -20445,7 +20399,7 @@
           <p:cNvPr id="8" name="">
             <a:extLst xmlns:a="http://schemas.openxmlformats.org/drawingml/2006/main">
               <a:ext uri="{FF2B5EF4-FFF2-40B4-BE49-F238E27FC236}">
-                <a16:creationId xmlns:a16="http://schemas.microsoft.com/office/drawing/2014/main" id="{4CE184FC-88DA-4A4F-837F-62D7DFDF76AF}"/>
+                <a16:creationId xmlns:a16="http://schemas.microsoft.com/office/drawing/2014/main" id="{32A3AE88-4DC4-4A23-A2E7-39B41E84150F}"/>
               </a:ext>
             </a:extLst>
           </p:cNvPr>
@@ -20548,7 +20502,7 @@
           <p:cNvPr id="9" name="">
             <a:extLst xmlns:a="http://schemas.openxmlformats.org/drawingml/2006/main">
               <a:ext uri="{FF2B5EF4-FFF2-40B4-BE49-F238E27FC236}">
-                <a16:creationId xmlns:a16="http://schemas.microsoft.com/office/drawing/2014/main" id="{639570CD-2407-4A37-8727-80E2924AC621}"/>
+                <a16:creationId xmlns:a16="http://schemas.microsoft.com/office/drawing/2014/main" id="{155312A5-398E-4A1E-B1B4-CFE3117134FC}"/>
               </a:ext>
             </a:extLst>
           </p:cNvPr>
@@ -20605,7 +20559,7 @@
           <p:cNvPr id="10" name="">
             <a:extLst xmlns:a="http://schemas.openxmlformats.org/drawingml/2006/main">
               <a:ext uri="{FF2B5EF4-FFF2-40B4-BE49-F238E27FC236}">
-                <a16:creationId xmlns:a16="http://schemas.microsoft.com/office/drawing/2014/main" id="{476A9F8A-FE64-415B-9385-DE5960699F88}"/>
+                <a16:creationId xmlns:a16="http://schemas.microsoft.com/office/drawing/2014/main" id="{40FB606B-24EA-40C6-88D4-8F0940D3A700}"/>
               </a:ext>
             </a:extLst>
           </p:cNvPr>
@@ -20708,7 +20662,7 @@
           <p:cNvPr id="11" name="">
             <a:extLst xmlns:a="http://schemas.openxmlformats.org/drawingml/2006/main">
               <a:ext uri="{FF2B5EF4-FFF2-40B4-BE49-F238E27FC236}">
-                <a16:creationId xmlns:a16="http://schemas.microsoft.com/office/drawing/2014/main" id="{4E794B88-1254-43C5-BECC-5F55D23F68B2}"/>
+                <a16:creationId xmlns:a16="http://schemas.microsoft.com/office/drawing/2014/main" id="{76218815-4FDA-4D49-9AA5-6DC63E75495F}"/>
               </a:ext>
             </a:extLst>
           </p:cNvPr>
@@ -20763,7 +20717,7 @@
     </p:spTree>
     <p:extLst>
       <p:ext uri="{BB962C8B-B14F-4D97-AF65-F5344CB8AC3E}">
-        <p14:creationId xmlns:p14="http://schemas.microsoft.com/office/powerpoint/2010/main" val="1423759115"/>
+        <p14:creationId xmlns:p14="http://schemas.microsoft.com/office/powerpoint/2010/main" val="815248147"/>
       </p:ext>
     </p:extLst>
   </p:cSld>
@@ -20794,7 +20748,7 @@
           <p:cNvPr id="12" name="">
             <a:extLst xmlns:a="http://schemas.openxmlformats.org/drawingml/2006/main">
               <a:ext uri="{FF2B5EF4-FFF2-40B4-BE49-F238E27FC236}">
-                <a16:creationId xmlns:a16="http://schemas.microsoft.com/office/drawing/2014/main" id="{FA3A11D3-AA31-4217-A140-CFCEE6E743B4}"/>
+                <a16:creationId xmlns:a16="http://schemas.microsoft.com/office/drawing/2014/main" id="{96C1674C-0A8C-4207-A81C-C34134941221}"/>
               </a:ext>
             </a:extLst>
           </p:cNvPr>
@@ -20851,7 +20805,7 @@
           <p:cNvPr id="2" name="">
             <a:extLst xmlns:a="http://schemas.openxmlformats.org/drawingml/2006/main">
               <a:ext uri="{FF2B5EF4-FFF2-40B4-BE49-F238E27FC236}">
-                <a16:creationId xmlns:a16="http://schemas.microsoft.com/office/drawing/2014/main" id="{6380F644-AF6F-4AAD-9623-E99D72B96D10}"/>
+                <a16:creationId xmlns:a16="http://schemas.microsoft.com/office/drawing/2014/main" id="{9389DB60-ABED-42A2-B786-93B250DA1F42}"/>
               </a:ext>
             </a:extLst>
           </p:cNvPr>
@@ -20908,7 +20862,7 @@
           <p:cNvPr id="3" name="">
             <a:extLst xmlns:a="http://schemas.openxmlformats.org/drawingml/2006/main">
               <a:ext uri="{FF2B5EF4-FFF2-40B4-BE49-F238E27FC236}">
-                <a16:creationId xmlns:a16="http://schemas.microsoft.com/office/drawing/2014/main" id="{801CBF1E-954C-49A7-BBF6-C20B7BB851C1}"/>
+                <a16:creationId xmlns:a16="http://schemas.microsoft.com/office/drawing/2014/main" id="{65FCC5C7-8BB8-42E7-81B0-72B08F511791}"/>
               </a:ext>
             </a:extLst>
           </p:cNvPr>
@@ -20965,7 +20919,7 @@
           <p:cNvPr id="4" name="">
             <a:extLst xmlns:a="http://schemas.openxmlformats.org/drawingml/2006/main">
               <a:ext uri="{FF2B5EF4-FFF2-40B4-BE49-F238E27FC236}">
-                <a16:creationId xmlns:a16="http://schemas.microsoft.com/office/drawing/2014/main" id="{B8453FA1-C89B-4F6B-89B4-ABA17C14BA28}"/>
+                <a16:creationId xmlns:a16="http://schemas.microsoft.com/office/drawing/2014/main" id="{596F1D91-2A5D-4FC5-9636-B91F99D60234}"/>
               </a:ext>
             </a:extLst>
           </p:cNvPr>
@@ -21045,7 +20999,7 @@
           <p:cNvPr id="5" name="">
             <a:extLst xmlns:a="http://schemas.openxmlformats.org/drawingml/2006/main">
               <a:ext uri="{FF2B5EF4-FFF2-40B4-BE49-F238E27FC236}">
-                <a16:creationId xmlns:a16="http://schemas.microsoft.com/office/drawing/2014/main" id="{B97E5650-5145-47EF-8764-9D93802DFD6E}"/>
+                <a16:creationId xmlns:a16="http://schemas.microsoft.com/office/drawing/2014/main" id="{5F4EA273-C818-47DD-82AB-9B643F79E962}"/>
               </a:ext>
             </a:extLst>
           </p:cNvPr>
@@ -21102,7 +21056,7 @@
           <p:cNvPr id="6" name="">
             <a:extLst xmlns:a="http://schemas.openxmlformats.org/drawingml/2006/main">
               <a:ext uri="{FF2B5EF4-FFF2-40B4-BE49-F238E27FC236}">
-                <a16:creationId xmlns:a16="http://schemas.microsoft.com/office/drawing/2014/main" id="{7CEE0981-1DD3-4F11-959A-21D138DBCB61}"/>
+                <a16:creationId xmlns:a16="http://schemas.microsoft.com/office/drawing/2014/main" id="{168F985F-CAE6-4385-9902-62E0C1875978}"/>
               </a:ext>
             </a:extLst>
           </p:cNvPr>
@@ -21205,7 +21159,7 @@
           <p:cNvPr id="7" name="">
             <a:extLst xmlns:a="http://schemas.openxmlformats.org/drawingml/2006/main">
               <a:ext uri="{FF2B5EF4-FFF2-40B4-BE49-F238E27FC236}">
-                <a16:creationId xmlns:a16="http://schemas.microsoft.com/office/drawing/2014/main" id="{BCE47F03-90B9-4B9A-9419-E3F9768B472B}"/>
+                <a16:creationId xmlns:a16="http://schemas.microsoft.com/office/drawing/2014/main" id="{8B5E560E-777B-4C9D-BFBA-7F965666216F}"/>
               </a:ext>
             </a:extLst>
           </p:cNvPr>
@@ -21262,7 +21216,7 @@
           <p:cNvPr id="8" name="">
             <a:extLst xmlns:a="http://schemas.openxmlformats.org/drawingml/2006/main">
               <a:ext uri="{FF2B5EF4-FFF2-40B4-BE49-F238E27FC236}">
-                <a16:creationId xmlns:a16="http://schemas.microsoft.com/office/drawing/2014/main" id="{5B397B14-D608-42F6-A6B4-B19FCBE70970}"/>
+                <a16:creationId xmlns:a16="http://schemas.microsoft.com/office/drawing/2014/main" id="{8355E555-45DA-454B-BB5D-7FBC2EC66013}"/>
               </a:ext>
             </a:extLst>
           </p:cNvPr>
@@ -21365,7 +21319,7 @@
           <p:cNvPr id="9" name="">
             <a:extLst xmlns:a="http://schemas.openxmlformats.org/drawingml/2006/main">
               <a:ext uri="{FF2B5EF4-FFF2-40B4-BE49-F238E27FC236}">
-                <a16:creationId xmlns:a16="http://schemas.microsoft.com/office/drawing/2014/main" id="{103DF4B7-ACAE-4E83-976A-CEBC8059A773}"/>
+                <a16:creationId xmlns:a16="http://schemas.microsoft.com/office/drawing/2014/main" id="{63348ECD-5F30-44D6-B1AD-9ACA1A96782D}"/>
               </a:ext>
             </a:extLst>
           </p:cNvPr>
@@ -21422,7 +21376,7 @@
           <p:cNvPr id="10" name="">
             <a:extLst xmlns:a="http://schemas.openxmlformats.org/drawingml/2006/main">
               <a:ext uri="{FF2B5EF4-FFF2-40B4-BE49-F238E27FC236}">
-                <a16:creationId xmlns:a16="http://schemas.microsoft.com/office/drawing/2014/main" id="{5615C682-F354-4BE2-963A-EF40A625A34F}"/>
+                <a16:creationId xmlns:a16="http://schemas.microsoft.com/office/drawing/2014/main" id="{BCAD7EF4-9DF3-4AAF-A1FC-14D702C2E92E}"/>
               </a:ext>
             </a:extLst>
           </p:cNvPr>
@@ -21525,7 +21479,7 @@
           <p:cNvPr id="11" name="">
             <a:extLst xmlns:a="http://schemas.openxmlformats.org/drawingml/2006/main">
               <a:ext uri="{FF2B5EF4-FFF2-40B4-BE49-F238E27FC236}">
-                <a16:creationId xmlns:a16="http://schemas.microsoft.com/office/drawing/2014/main" id="{C46D219C-6D8B-4CA1-98B5-88BB3EC771BF}"/>
+                <a16:creationId xmlns:a16="http://schemas.microsoft.com/office/drawing/2014/main" id="{1842874A-2157-4A93-9FCF-10ACC62E596E}"/>
               </a:ext>
             </a:extLst>
           </p:cNvPr>
@@ -21580,7 +21534,7 @@
     </p:spTree>
     <p:extLst>
       <p:ext uri="{BB962C8B-B14F-4D97-AF65-F5344CB8AC3E}">
-        <p14:creationId xmlns:p14="http://schemas.microsoft.com/office/powerpoint/2010/main" val="388029531"/>
+        <p14:creationId xmlns:p14="http://schemas.microsoft.com/office/powerpoint/2010/main" val="347326676"/>
       </p:ext>
     </p:extLst>
   </p:cSld>
@@ -21611,7 +21565,7 @@
           <p:cNvPr id="9" name="">
             <a:extLst xmlns:a="http://schemas.openxmlformats.org/drawingml/2006/main">
               <a:ext uri="{FF2B5EF4-FFF2-40B4-BE49-F238E27FC236}">
-                <a16:creationId xmlns:a16="http://schemas.microsoft.com/office/drawing/2014/main" id="{182C378B-FF07-4A05-A707-52DFB8BFEB7A}"/>
+                <a16:creationId xmlns:a16="http://schemas.microsoft.com/office/drawing/2014/main" id="{8474B962-D9A7-45D5-852B-A9685E4B82B9}"/>
               </a:ext>
             </a:extLst>
           </p:cNvPr>
@@ -21668,7 +21622,7 @@
           <p:cNvPr id="2" name="">
             <a:extLst xmlns:a="http://schemas.openxmlformats.org/drawingml/2006/main">
               <a:ext uri="{FF2B5EF4-FFF2-40B4-BE49-F238E27FC236}">
-                <a16:creationId xmlns:a16="http://schemas.microsoft.com/office/drawing/2014/main" id="{54705586-2F1A-47AB-97FF-EF0CFDB08A94}"/>
+                <a16:creationId xmlns:a16="http://schemas.microsoft.com/office/drawing/2014/main" id="{B6FB148C-B558-45CE-AF06-1869B724FAAE}"/>
               </a:ext>
             </a:extLst>
           </p:cNvPr>
@@ -21725,7 +21679,7 @@
           <p:cNvPr id="3" name="">
             <a:extLst xmlns:a="http://schemas.openxmlformats.org/drawingml/2006/main">
               <a:ext uri="{FF2B5EF4-FFF2-40B4-BE49-F238E27FC236}">
-                <a16:creationId xmlns:a16="http://schemas.microsoft.com/office/drawing/2014/main" id="{15E39B5D-9B48-4425-80FB-8408E66499D4}"/>
+                <a16:creationId xmlns:a16="http://schemas.microsoft.com/office/drawing/2014/main" id="{C8E86B29-5A0D-40D9-9116-D774E246C91C}"/>
               </a:ext>
             </a:extLst>
           </p:cNvPr>
@@ -21782,7 +21736,7 @@
           <p:cNvPr id="4" name="">
             <a:extLst xmlns:a="http://schemas.openxmlformats.org/drawingml/2006/main">
               <a:ext uri="{FF2B5EF4-FFF2-40B4-BE49-F238E27FC236}">
-                <a16:creationId xmlns:a16="http://schemas.microsoft.com/office/drawing/2014/main" id="{D1882F38-32E8-4CD0-BBAF-7D4348729223}"/>
+                <a16:creationId xmlns:a16="http://schemas.microsoft.com/office/drawing/2014/main" id="{F2B1A4B5-FE5D-484E-8608-412A3A4D426A}"/>
               </a:ext>
             </a:extLst>
           </p:cNvPr>
@@ -21931,7 +21885,7 @@
           <p:cNvPr id="5" name="">
             <a:extLst xmlns:a="http://schemas.openxmlformats.org/drawingml/2006/main">
               <a:ext uri="{FF2B5EF4-FFF2-40B4-BE49-F238E27FC236}">
-                <a16:creationId xmlns:a16="http://schemas.microsoft.com/office/drawing/2014/main" id="{0F506D5A-73B8-4551-BD24-B2CDD1A96BD3}"/>
+                <a16:creationId xmlns:a16="http://schemas.microsoft.com/office/drawing/2014/main" id="{29073AF6-FBA4-4320-9FF2-FF302BA5F194}"/>
               </a:ext>
             </a:extLst>
           </p:cNvPr>
@@ -21988,7 +21942,7 @@
           <p:cNvPr id="6" name="">
             <a:extLst xmlns:a="http://schemas.openxmlformats.org/drawingml/2006/main">
               <a:ext uri="{FF2B5EF4-FFF2-40B4-BE49-F238E27FC236}">
-                <a16:creationId xmlns:a16="http://schemas.microsoft.com/office/drawing/2014/main" id="{14E63810-BE04-4323-BDF5-BCB64847A6CA}"/>
+                <a16:creationId xmlns:a16="http://schemas.microsoft.com/office/drawing/2014/main" id="{95D4E26E-8E03-4400-A27D-EB6994B5E3CB}"/>
               </a:ext>
             </a:extLst>
           </p:cNvPr>
@@ -22164,7 +22118,7 @@
           <p:nvPr/>
         </p:nvPicPr>
         <p:blipFill>
-          <a:blip xmlns:r="http://schemas.openxmlformats.org/officeDocument/2006/relationships" xmlns:a="http://schemas.openxmlformats.org/drawingml/2006/main" r:embed="R57d3bef029f940fd"/>
+          <a:blip xmlns:r="http://schemas.openxmlformats.org/officeDocument/2006/relationships" xmlns:a="http://schemas.openxmlformats.org/drawingml/2006/main" r:embed="R359a082708fd4493"/>
           <a:stretch xmlns:a="http://schemas.openxmlformats.org/drawingml/2006/main"/>
         </p:blipFill>
         <p:spPr>
@@ -22182,7 +22136,7 @@
           <p:cNvPr id="8" name="">
             <a:extLst xmlns:a="http://schemas.openxmlformats.org/drawingml/2006/main">
               <a:ext uri="{FF2B5EF4-FFF2-40B4-BE49-F238E27FC236}">
-                <a16:creationId xmlns:a16="http://schemas.microsoft.com/office/drawing/2014/main" id="{3E235C0F-939E-4CBB-946E-438FE2B9DD01}"/>
+                <a16:creationId xmlns:a16="http://schemas.microsoft.com/office/drawing/2014/main" id="{05DFDD7A-B7FB-4E0B-AA24-2965FADA56E5}"/>
               </a:ext>
             </a:extLst>
           </p:cNvPr>
@@ -22237,7 +22191,7 @@
     </p:spTree>
     <p:extLst>
       <p:ext uri="{BB962C8B-B14F-4D97-AF65-F5344CB8AC3E}">
-        <p14:creationId xmlns:p14="http://schemas.microsoft.com/office/powerpoint/2010/main" val="152801173"/>
+        <p14:creationId xmlns:p14="http://schemas.microsoft.com/office/powerpoint/2010/main" val="1488564472"/>
       </p:ext>
     </p:extLst>
   </p:cSld>
@@ -22268,7 +22222,7 @@
           <p:cNvPr id="12" name="">
             <a:extLst xmlns:a="http://schemas.openxmlformats.org/drawingml/2006/main">
               <a:ext uri="{FF2B5EF4-FFF2-40B4-BE49-F238E27FC236}">
-                <a16:creationId xmlns:a16="http://schemas.microsoft.com/office/drawing/2014/main" id="{CA1E569E-1D87-4768-9565-1905DCDE071F}"/>
+                <a16:creationId xmlns:a16="http://schemas.microsoft.com/office/drawing/2014/main" id="{2795BEF0-789E-4D08-9177-5A862FCFA679}"/>
               </a:ext>
             </a:extLst>
           </p:cNvPr>
@@ -22325,7 +22279,7 @@
           <p:cNvPr id="2" name="">
             <a:extLst xmlns:a="http://schemas.openxmlformats.org/drawingml/2006/main">
               <a:ext uri="{FF2B5EF4-FFF2-40B4-BE49-F238E27FC236}">
-                <a16:creationId xmlns:a16="http://schemas.microsoft.com/office/drawing/2014/main" id="{CF17A513-F1EB-45CE-B23E-A0B9DA3241C6}"/>
+                <a16:creationId xmlns:a16="http://schemas.microsoft.com/office/drawing/2014/main" id="{71D7B3A6-D4B1-476D-A87A-900257A9539F}"/>
               </a:ext>
             </a:extLst>
           </p:cNvPr>
@@ -22382,7 +22336,7 @@
           <p:cNvPr id="3" name="">
             <a:extLst xmlns:a="http://schemas.openxmlformats.org/drawingml/2006/main">
               <a:ext uri="{FF2B5EF4-FFF2-40B4-BE49-F238E27FC236}">
-                <a16:creationId xmlns:a16="http://schemas.microsoft.com/office/drawing/2014/main" id="{8E0B3827-90F2-4843-918D-A6FCCEDBABFB}"/>
+                <a16:creationId xmlns:a16="http://schemas.microsoft.com/office/drawing/2014/main" id="{B96D5D53-5A85-4400-8907-22E4BC260E2E}"/>
               </a:ext>
             </a:extLst>
           </p:cNvPr>
@@ -22439,7 +22393,7 @@
           <p:cNvPr id="4" name="">
             <a:extLst xmlns:a="http://schemas.openxmlformats.org/drawingml/2006/main">
               <a:ext uri="{FF2B5EF4-FFF2-40B4-BE49-F238E27FC236}">
-                <a16:creationId xmlns:a16="http://schemas.microsoft.com/office/drawing/2014/main" id="{73731111-6818-4A43-938D-90EBF90E4447}"/>
+                <a16:creationId xmlns:a16="http://schemas.microsoft.com/office/drawing/2014/main" id="{2E531FB8-A243-4FFE-91C6-D8B5C17F6DED}"/>
               </a:ext>
             </a:extLst>
           </p:cNvPr>
@@ -22542,7 +22496,7 @@
           <p:cNvPr id="5" name="">
             <a:extLst xmlns:a="http://schemas.openxmlformats.org/drawingml/2006/main">
               <a:ext uri="{FF2B5EF4-FFF2-40B4-BE49-F238E27FC236}">
-                <a16:creationId xmlns:a16="http://schemas.microsoft.com/office/drawing/2014/main" id="{14DCD33B-A5BA-463A-873E-6C93BAA58EB3}"/>
+                <a16:creationId xmlns:a16="http://schemas.microsoft.com/office/drawing/2014/main" id="{CAF470F7-43FF-49D7-90A8-A8866832DF63}"/>
               </a:ext>
             </a:extLst>
           </p:cNvPr>
@@ -22599,7 +22553,7 @@
           <p:cNvPr id="6" name="">
             <a:extLst xmlns:a="http://schemas.openxmlformats.org/drawingml/2006/main">
               <a:ext uri="{FF2B5EF4-FFF2-40B4-BE49-F238E27FC236}">
-                <a16:creationId xmlns:a16="http://schemas.microsoft.com/office/drawing/2014/main" id="{4BA5C9D4-C628-4427-A101-F4340ED5EB4A}"/>
+                <a16:creationId xmlns:a16="http://schemas.microsoft.com/office/drawing/2014/main" id="{C92C2E28-EF0C-476E-8E83-33A9FAE8BA88}"/>
               </a:ext>
             </a:extLst>
           </p:cNvPr>
@@ -22702,7 +22656,7 @@
           <p:cNvPr id="7" name="">
             <a:extLst xmlns:a="http://schemas.openxmlformats.org/drawingml/2006/main">
               <a:ext uri="{FF2B5EF4-FFF2-40B4-BE49-F238E27FC236}">
-                <a16:creationId xmlns:a16="http://schemas.microsoft.com/office/drawing/2014/main" id="{C03FED68-3052-4E3D-AB32-65BD274927A7}"/>
+                <a16:creationId xmlns:a16="http://schemas.microsoft.com/office/drawing/2014/main" id="{E02A917D-3F79-4ABA-998A-BD5433ED0262}"/>
               </a:ext>
             </a:extLst>
           </p:cNvPr>
@@ -22759,7 +22713,7 @@
           <p:cNvPr id="8" name="">
             <a:extLst xmlns:a="http://schemas.openxmlformats.org/drawingml/2006/main">
               <a:ext uri="{FF2B5EF4-FFF2-40B4-BE49-F238E27FC236}">
-                <a16:creationId xmlns:a16="http://schemas.microsoft.com/office/drawing/2014/main" id="{40D405E7-86B0-42AB-A1D0-172D2FB2C020}"/>
+                <a16:creationId xmlns:a16="http://schemas.microsoft.com/office/drawing/2014/main" id="{C3885122-8B3D-44C1-996F-4AD1F804D2BB}"/>
               </a:ext>
             </a:extLst>
           </p:cNvPr>
@@ -22862,7 +22816,7 @@
           <p:cNvPr id="9" name="">
             <a:extLst xmlns:a="http://schemas.openxmlformats.org/drawingml/2006/main">
               <a:ext uri="{FF2B5EF4-FFF2-40B4-BE49-F238E27FC236}">
-                <a16:creationId xmlns:a16="http://schemas.microsoft.com/office/drawing/2014/main" id="{2DD88933-72AB-4DDE-9885-B64DCF5C9AA9}"/>
+                <a16:creationId xmlns:a16="http://schemas.microsoft.com/office/drawing/2014/main" id="{832B9E31-F3D9-4057-9E3F-5C0B753442DC}"/>
               </a:ext>
             </a:extLst>
           </p:cNvPr>
@@ -22919,7 +22873,7 @@
           <p:cNvPr id="10" name="">
             <a:extLst xmlns:a="http://schemas.openxmlformats.org/drawingml/2006/main">
               <a:ext uri="{FF2B5EF4-FFF2-40B4-BE49-F238E27FC236}">
-                <a16:creationId xmlns:a16="http://schemas.microsoft.com/office/drawing/2014/main" id="{39148C18-7EA7-4C83-AFD6-02A6337EC61E}"/>
+                <a16:creationId xmlns:a16="http://schemas.microsoft.com/office/drawing/2014/main" id="{F14BDA65-1F95-48D6-8DB1-201296B2052C}"/>
               </a:ext>
             </a:extLst>
           </p:cNvPr>
@@ -23045,7 +22999,7 @@
           <p:cNvPr id="11" name="">
             <a:extLst xmlns:a="http://schemas.openxmlformats.org/drawingml/2006/main">
               <a:ext uri="{FF2B5EF4-FFF2-40B4-BE49-F238E27FC236}">
-                <a16:creationId xmlns:a16="http://schemas.microsoft.com/office/drawing/2014/main" id="{E2E28B47-E5A9-4DEA-8C94-95DE5DE645FE}"/>
+                <a16:creationId xmlns:a16="http://schemas.microsoft.com/office/drawing/2014/main" id="{25FE9797-1400-453F-97F8-15151E6FFD56}"/>
               </a:ext>
             </a:extLst>
           </p:cNvPr>
@@ -23092,7 +23046,7 @@
                 <a:ea typeface="Malgun Gothic"/>
                 <a:cs typeface="Malgun Gothic"/>
               </a:rPr>
-              <a:t>문의할 때 과정명·ID·제출번호·오류 문구를 전달합니다. 비밀번호나 연결 코드는 보내지 마세요.</a:t>
+              <a:t>문의할 때 과정명·ID·제출번호·오류 문구를 전달합니다. 비밀번호는 보내지 마세요.</a:t>
             </a:r>
           </a:p>
         </p:txBody>
@@ -23100,7 +23054,7 @@
     </p:spTree>
     <p:extLst>
       <p:ext uri="{BB962C8B-B14F-4D97-AF65-F5344CB8AC3E}">
-        <p14:creationId xmlns:p14="http://schemas.microsoft.com/office/powerpoint/2010/main" val="52966458"/>
+        <p14:creationId xmlns:p14="http://schemas.microsoft.com/office/powerpoint/2010/main" val="27749019"/>
       </p:ext>
     </p:extLst>
   </p:cSld>
@@ -23131,7 +23085,7 @@
           <p:cNvPr id="12" name="">
             <a:extLst xmlns:a="http://schemas.openxmlformats.org/drawingml/2006/main">
               <a:ext uri="{FF2B5EF4-FFF2-40B4-BE49-F238E27FC236}">
-                <a16:creationId xmlns:a16="http://schemas.microsoft.com/office/drawing/2014/main" id="{CC78BD5B-0CF2-43B2-8CCB-E6620202C66A}"/>
+                <a16:creationId xmlns:a16="http://schemas.microsoft.com/office/drawing/2014/main" id="{FE6245D5-4989-4087-B4E0-5242C4A3120E}"/>
               </a:ext>
             </a:extLst>
           </p:cNvPr>
@@ -23188,7 +23142,7 @@
           <p:cNvPr id="2" name="">
             <a:extLst xmlns:a="http://schemas.openxmlformats.org/drawingml/2006/main">
               <a:ext uri="{FF2B5EF4-FFF2-40B4-BE49-F238E27FC236}">
-                <a16:creationId xmlns:a16="http://schemas.microsoft.com/office/drawing/2014/main" id="{AF63D212-3CBC-4230-B4AE-B0F96B4C6EF1}"/>
+                <a16:creationId xmlns:a16="http://schemas.microsoft.com/office/drawing/2014/main" id="{A697A870-1D2F-4955-9A26-76E9222CE82E}"/>
               </a:ext>
             </a:extLst>
           </p:cNvPr>
@@ -23245,7 +23199,7 @@
           <p:cNvPr id="3" name="">
             <a:extLst xmlns:a="http://schemas.openxmlformats.org/drawingml/2006/main">
               <a:ext uri="{FF2B5EF4-FFF2-40B4-BE49-F238E27FC236}">
-                <a16:creationId xmlns:a16="http://schemas.microsoft.com/office/drawing/2014/main" id="{6308947A-BD49-4FFD-8D22-5E02503D0C9F}"/>
+                <a16:creationId xmlns:a16="http://schemas.microsoft.com/office/drawing/2014/main" id="{162AF714-F3D7-4473-8C31-C77DAE888431}"/>
               </a:ext>
             </a:extLst>
           </p:cNvPr>
@@ -23302,7 +23256,7 @@
           <p:cNvPr id="4" name="">
             <a:extLst xmlns:a="http://schemas.openxmlformats.org/drawingml/2006/main">
               <a:ext uri="{FF2B5EF4-FFF2-40B4-BE49-F238E27FC236}">
-                <a16:creationId xmlns:a16="http://schemas.microsoft.com/office/drawing/2014/main" id="{7A8902E3-47F1-47FF-A8D5-4AE5A11308F4}"/>
+                <a16:creationId xmlns:a16="http://schemas.microsoft.com/office/drawing/2014/main" id="{77010F8E-2617-40F2-9755-03702D77064B}"/>
               </a:ext>
             </a:extLst>
           </p:cNvPr>
@@ -23405,7 +23359,7 @@
           <p:cNvPr id="5" name="">
             <a:extLst xmlns:a="http://schemas.openxmlformats.org/drawingml/2006/main">
               <a:ext uri="{FF2B5EF4-FFF2-40B4-BE49-F238E27FC236}">
-                <a16:creationId xmlns:a16="http://schemas.microsoft.com/office/drawing/2014/main" id="{39EC2AA3-2807-499E-9B3A-36C30A7FB67B}"/>
+                <a16:creationId xmlns:a16="http://schemas.microsoft.com/office/drawing/2014/main" id="{51966BAC-8E23-4722-BDD4-F26A3B6B02A6}"/>
               </a:ext>
             </a:extLst>
           </p:cNvPr>
@@ -23462,7 +23416,7 @@
           <p:cNvPr id="6" name="">
             <a:extLst xmlns:a="http://schemas.openxmlformats.org/drawingml/2006/main">
               <a:ext uri="{FF2B5EF4-FFF2-40B4-BE49-F238E27FC236}">
-                <a16:creationId xmlns:a16="http://schemas.microsoft.com/office/drawing/2014/main" id="{7C635B9F-24A2-4D49-9946-7D9EC1E5E98E}"/>
+                <a16:creationId xmlns:a16="http://schemas.microsoft.com/office/drawing/2014/main" id="{FD111FD0-FCAE-4DF4-8DA2-D4D53206FDCC}"/>
               </a:ext>
             </a:extLst>
           </p:cNvPr>
@@ -23565,7 +23519,7 @@
           <p:cNvPr id="7" name="">
             <a:extLst xmlns:a="http://schemas.openxmlformats.org/drawingml/2006/main">
               <a:ext uri="{FF2B5EF4-FFF2-40B4-BE49-F238E27FC236}">
-                <a16:creationId xmlns:a16="http://schemas.microsoft.com/office/drawing/2014/main" id="{47D189EA-1B29-4FB6-93BA-7123D1C67397}"/>
+                <a16:creationId xmlns:a16="http://schemas.microsoft.com/office/drawing/2014/main" id="{15FDD1FD-83BF-449B-96E2-2B1BD0AFB7D4}"/>
               </a:ext>
             </a:extLst>
           </p:cNvPr>
@@ -23622,7 +23576,7 @@
           <p:cNvPr id="8" name="">
             <a:extLst xmlns:a="http://schemas.openxmlformats.org/drawingml/2006/main">
               <a:ext uri="{FF2B5EF4-FFF2-40B4-BE49-F238E27FC236}">
-                <a16:creationId xmlns:a16="http://schemas.microsoft.com/office/drawing/2014/main" id="{031B074E-FCA8-41B2-B9E4-1F682465B402}"/>
+                <a16:creationId xmlns:a16="http://schemas.microsoft.com/office/drawing/2014/main" id="{1A396F44-FC08-4E34-A91F-0F60E9BB8FCA}"/>
               </a:ext>
             </a:extLst>
           </p:cNvPr>
@@ -23725,7 +23679,7 @@
           <p:cNvPr id="9" name="">
             <a:extLst xmlns:a="http://schemas.openxmlformats.org/drawingml/2006/main">
               <a:ext uri="{FF2B5EF4-FFF2-40B4-BE49-F238E27FC236}">
-                <a16:creationId xmlns:a16="http://schemas.microsoft.com/office/drawing/2014/main" id="{6F33EFF4-56F1-4FCB-9170-DD63F1B0772F}"/>
+                <a16:creationId xmlns:a16="http://schemas.microsoft.com/office/drawing/2014/main" id="{BE60C7D6-6B2D-4898-A35A-EAFC70A16CB3}"/>
               </a:ext>
             </a:extLst>
           </p:cNvPr>
@@ -23782,7 +23736,7 @@
           <p:cNvPr id="10" name="">
             <a:extLst xmlns:a="http://schemas.openxmlformats.org/drawingml/2006/main">
               <a:ext uri="{FF2B5EF4-FFF2-40B4-BE49-F238E27FC236}">
-                <a16:creationId xmlns:a16="http://schemas.microsoft.com/office/drawing/2014/main" id="{B2C6AF00-1D6D-4C50-9D23-5B7A79E473FD}"/>
+                <a16:creationId xmlns:a16="http://schemas.microsoft.com/office/drawing/2014/main" id="{7E2C6D6D-34B4-4FA1-BB94-2F3A7C16AAE4}"/>
               </a:ext>
             </a:extLst>
           </p:cNvPr>
@@ -23885,7 +23839,7 @@
           <p:cNvPr id="11" name="">
             <a:extLst xmlns:a="http://schemas.openxmlformats.org/drawingml/2006/main">
               <a:ext uri="{FF2B5EF4-FFF2-40B4-BE49-F238E27FC236}">
-                <a16:creationId xmlns:a16="http://schemas.microsoft.com/office/drawing/2014/main" id="{AAEE603E-A29A-417E-BC90-B557A5890661}"/>
+                <a16:creationId xmlns:a16="http://schemas.microsoft.com/office/drawing/2014/main" id="{51B6E9DD-7B16-4D0D-9F74-94A4756DA567}"/>
               </a:ext>
             </a:extLst>
           </p:cNvPr>
@@ -23940,7 +23894,7 @@
     </p:spTree>
     <p:extLst>
       <p:ext uri="{BB962C8B-B14F-4D97-AF65-F5344CB8AC3E}">
-        <p14:creationId xmlns:p14="http://schemas.microsoft.com/office/powerpoint/2010/main" val="607647835"/>
+        <p14:creationId xmlns:p14="http://schemas.microsoft.com/office/powerpoint/2010/main" val="1841917288"/>
       </p:ext>
     </p:extLst>
   </p:cSld>
@@ -23971,7 +23925,7 @@
           <p:cNvPr id="9" name="">
             <a:extLst xmlns:a="http://schemas.openxmlformats.org/drawingml/2006/main">
               <a:ext uri="{FF2B5EF4-FFF2-40B4-BE49-F238E27FC236}">
-                <a16:creationId xmlns:a16="http://schemas.microsoft.com/office/drawing/2014/main" id="{AD2900B5-A231-4342-A33C-13734899D962}"/>
+                <a16:creationId xmlns:a16="http://schemas.microsoft.com/office/drawing/2014/main" id="{8EBE4CB4-6A3E-4BD9-85BC-35BE29C23FC9}"/>
               </a:ext>
             </a:extLst>
           </p:cNvPr>
@@ -24028,7 +23982,7 @@
           <p:cNvPr id="2" name="">
             <a:extLst xmlns:a="http://schemas.openxmlformats.org/drawingml/2006/main">
               <a:ext uri="{FF2B5EF4-FFF2-40B4-BE49-F238E27FC236}">
-                <a16:creationId xmlns:a16="http://schemas.microsoft.com/office/drawing/2014/main" id="{662F06E7-1506-4A4D-8ECF-327BE2F52059}"/>
+                <a16:creationId xmlns:a16="http://schemas.microsoft.com/office/drawing/2014/main" id="{6260E378-B80F-4699-A0F1-D9DA852F3618}"/>
               </a:ext>
             </a:extLst>
           </p:cNvPr>
@@ -24085,7 +24039,7 @@
           <p:cNvPr id="3" name="">
             <a:extLst xmlns:a="http://schemas.openxmlformats.org/drawingml/2006/main">
               <a:ext uri="{FF2B5EF4-FFF2-40B4-BE49-F238E27FC236}">
-                <a16:creationId xmlns:a16="http://schemas.microsoft.com/office/drawing/2014/main" id="{EB2C018C-6C79-4EF9-9521-EFA01F0EC152}"/>
+                <a16:creationId xmlns:a16="http://schemas.microsoft.com/office/drawing/2014/main" id="{5D7AD407-7FC0-4246-AF2F-4483BD294F68}"/>
               </a:ext>
             </a:extLst>
           </p:cNvPr>
@@ -24142,7 +24096,7 @@
           <p:cNvPr id="4" name="">
             <a:extLst xmlns:a="http://schemas.openxmlformats.org/drawingml/2006/main">
               <a:ext uri="{FF2B5EF4-FFF2-40B4-BE49-F238E27FC236}">
-                <a16:creationId xmlns:a16="http://schemas.microsoft.com/office/drawing/2014/main" id="{BD4E4DB7-57DC-4442-91BB-08D0A59F8951}"/>
+                <a16:creationId xmlns:a16="http://schemas.microsoft.com/office/drawing/2014/main" id="{4FF53182-821D-4028-9C1A-9F95C2773574}"/>
               </a:ext>
             </a:extLst>
           </p:cNvPr>
@@ -24268,7 +24222,7 @@
           <p:cNvPr id="5" name="">
             <a:extLst xmlns:a="http://schemas.openxmlformats.org/drawingml/2006/main">
               <a:ext uri="{FF2B5EF4-FFF2-40B4-BE49-F238E27FC236}">
-                <a16:creationId xmlns:a16="http://schemas.microsoft.com/office/drawing/2014/main" id="{F96C5DFF-25C7-471B-95EC-AC0E1BC43CD5}"/>
+                <a16:creationId xmlns:a16="http://schemas.microsoft.com/office/drawing/2014/main" id="{AEC9FEBD-B3BF-418B-BDC3-B6C630CDEDF8}"/>
               </a:ext>
             </a:extLst>
           </p:cNvPr>
@@ -24325,7 +24279,7 @@
           <p:cNvPr id="6" name="">
             <a:extLst xmlns:a="http://schemas.openxmlformats.org/drawingml/2006/main">
               <a:ext uri="{FF2B5EF4-FFF2-40B4-BE49-F238E27FC236}">
-                <a16:creationId xmlns:a16="http://schemas.microsoft.com/office/drawing/2014/main" id="{08365FFC-0557-426E-8265-75AFCE64D17D}"/>
+                <a16:creationId xmlns:a16="http://schemas.microsoft.com/office/drawing/2014/main" id="{CD5F96FA-44CD-4220-9063-058CFFF6CF82}"/>
               </a:ext>
             </a:extLst>
           </p:cNvPr>
@@ -24418,7 +24372,7 @@
                 <a:ea typeface="Malgun Gothic"/>
                 <a:cs typeface="Malgun Gothic"/>
               </a:rPr>
-              <a:t>12~128자의 비밀번호를</a:t>
+              <a:t>8~128자의 비밀번호를 정하고</a:t>
             </a:r>
           </a:p>
           <a:p xmlns:a="http://schemas.openxmlformats.org/drawingml/2006/main">
@@ -24441,30 +24395,7 @@
                 <a:ea typeface="Malgun Gothic"/>
                 <a:cs typeface="Malgun Gothic"/>
               </a:rPr>
-              <a:t>정하고 확인란에도</a:t>
-            </a:r>
-          </a:p>
-          <a:p xmlns:a="http://schemas.openxmlformats.org/drawingml/2006/main">
-            <a:pPr>
-              <a:defRPr sz="2025" b="0">
-                <a:solidFill>
-                  <a:srgbClr val="202539"/>
-                </a:solidFill>
-                <a:latin typeface="Malgun Gothic"/>
-                <a:ea typeface="Malgun Gothic"/>
-                <a:cs typeface="Malgun Gothic"/>
-              </a:defRPr>
-            </a:pPr>
-            <a:r>
-              <a:rPr sz="2025" b="0">
-                <a:solidFill>
-                  <a:srgbClr val="202539"/>
-                </a:solidFill>
-                <a:latin typeface="Malgun Gothic"/>
-                <a:ea typeface="Malgun Gothic"/>
-                <a:cs typeface="Malgun Gothic"/>
-              </a:rPr>
-              <a:t>입력합니다.</a:t>
+              <a:t>확인란에도 입력합니다.</a:t>
             </a:r>
           </a:p>
         </p:txBody>
@@ -24478,7 +24409,7 @@
           <p:nvPr/>
         </p:nvPicPr>
         <p:blipFill>
-          <a:blip xmlns:r="http://schemas.openxmlformats.org/officeDocument/2006/relationships" xmlns:a="http://schemas.openxmlformats.org/drawingml/2006/main" r:embed="R093eff4130614faa"/>
+          <a:blip xmlns:r="http://schemas.openxmlformats.org/officeDocument/2006/relationships" xmlns:a="http://schemas.openxmlformats.org/drawingml/2006/main" r:embed="R1bd786783c274b1c"/>
           <a:stretch xmlns:a="http://schemas.openxmlformats.org/drawingml/2006/main"/>
         </p:blipFill>
         <p:spPr>
@@ -24496,7 +24427,7 @@
           <p:cNvPr id="8" name="">
             <a:extLst xmlns:a="http://schemas.openxmlformats.org/drawingml/2006/main">
               <a:ext uri="{FF2B5EF4-FFF2-40B4-BE49-F238E27FC236}">
-                <a16:creationId xmlns:a16="http://schemas.microsoft.com/office/drawing/2014/main" id="{CBA898C6-FCD4-4808-B24B-639D28094959}"/>
+                <a16:creationId xmlns:a16="http://schemas.microsoft.com/office/drawing/2014/main" id="{B1E1CB21-A322-4AD2-A467-90CD84874C0F}"/>
               </a:ext>
             </a:extLst>
           </p:cNvPr>
@@ -24551,7 +24482,7 @@
     </p:spTree>
     <p:extLst>
       <p:ext uri="{BB962C8B-B14F-4D97-AF65-F5344CB8AC3E}">
-        <p14:creationId xmlns:p14="http://schemas.microsoft.com/office/powerpoint/2010/main" val="1514098697"/>
+        <p14:creationId xmlns:p14="http://schemas.microsoft.com/office/powerpoint/2010/main" val="51821555"/>
       </p:ext>
     </p:extLst>
   </p:cSld>
@@ -24582,7 +24513,7 @@
           <p:cNvPr id="9" name="">
             <a:extLst xmlns:a="http://schemas.openxmlformats.org/drawingml/2006/main">
               <a:ext uri="{FF2B5EF4-FFF2-40B4-BE49-F238E27FC236}">
-                <a16:creationId xmlns:a16="http://schemas.microsoft.com/office/drawing/2014/main" id="{F8021B71-13B0-4693-95AA-0AD3CAD510D2}"/>
+                <a16:creationId xmlns:a16="http://schemas.microsoft.com/office/drawing/2014/main" id="{DE7C6E19-FE96-4CBD-A806-72B059CC04CD}"/>
               </a:ext>
             </a:extLst>
           </p:cNvPr>
@@ -24639,7 +24570,7 @@
           <p:cNvPr id="2" name="">
             <a:extLst xmlns:a="http://schemas.openxmlformats.org/drawingml/2006/main">
               <a:ext uri="{FF2B5EF4-FFF2-40B4-BE49-F238E27FC236}">
-                <a16:creationId xmlns:a16="http://schemas.microsoft.com/office/drawing/2014/main" id="{2C0C8DD2-8761-4D76-8F19-C20A30399F8B}"/>
+                <a16:creationId xmlns:a16="http://schemas.microsoft.com/office/drawing/2014/main" id="{907D1800-A568-4D49-8A62-02D8A472E280}"/>
               </a:ext>
             </a:extLst>
           </p:cNvPr>
@@ -24696,7 +24627,7 @@
           <p:cNvPr id="3" name="">
             <a:extLst xmlns:a="http://schemas.openxmlformats.org/drawingml/2006/main">
               <a:ext uri="{FF2B5EF4-FFF2-40B4-BE49-F238E27FC236}">
-                <a16:creationId xmlns:a16="http://schemas.microsoft.com/office/drawing/2014/main" id="{D33B9B73-B8B1-43B9-B8A8-2609BD8738D7}"/>
+                <a16:creationId xmlns:a16="http://schemas.microsoft.com/office/drawing/2014/main" id="{5D41812F-DA6F-401C-AAAE-AD7A2FD23463}"/>
               </a:ext>
             </a:extLst>
           </p:cNvPr>
@@ -24753,7 +24684,7 @@
           <p:cNvPr id="4" name="">
             <a:extLst xmlns:a="http://schemas.openxmlformats.org/drawingml/2006/main">
               <a:ext uri="{FF2B5EF4-FFF2-40B4-BE49-F238E27FC236}">
-                <a16:creationId xmlns:a16="http://schemas.microsoft.com/office/drawing/2014/main" id="{7D066403-D3F2-40B3-996E-9DCA51ABA445}"/>
+                <a16:creationId xmlns:a16="http://schemas.microsoft.com/office/drawing/2014/main" id="{1380CE55-C4BC-41F3-8861-9771DAEA274A}"/>
               </a:ext>
             </a:extLst>
           </p:cNvPr>
@@ -24879,7 +24810,7 @@
           <p:cNvPr id="5" name="">
             <a:extLst xmlns:a="http://schemas.openxmlformats.org/drawingml/2006/main">
               <a:ext uri="{FF2B5EF4-FFF2-40B4-BE49-F238E27FC236}">
-                <a16:creationId xmlns:a16="http://schemas.microsoft.com/office/drawing/2014/main" id="{36486E47-9F8D-46BD-88A2-8E1AE65AC745}"/>
+                <a16:creationId xmlns:a16="http://schemas.microsoft.com/office/drawing/2014/main" id="{63A8CE50-78B8-420A-AAB1-EB39FDA7E234}"/>
               </a:ext>
             </a:extLst>
           </p:cNvPr>
@@ -24936,7 +24867,7 @@
           <p:cNvPr id="6" name="">
             <a:extLst xmlns:a="http://schemas.openxmlformats.org/drawingml/2006/main">
               <a:ext uri="{FF2B5EF4-FFF2-40B4-BE49-F238E27FC236}">
-                <a16:creationId xmlns:a16="http://schemas.microsoft.com/office/drawing/2014/main" id="{8F1D9B85-C515-4BBA-9A02-9CDC35E6821A}"/>
+                <a16:creationId xmlns:a16="http://schemas.microsoft.com/office/drawing/2014/main" id="{52D8CB05-200A-44A3-89B7-E3CE9876C101}"/>
               </a:ext>
             </a:extLst>
           </p:cNvPr>
@@ -25066,7 +24997,7 @@
           <p:nvPr/>
         </p:nvPicPr>
         <p:blipFill>
-          <a:blip xmlns:r="http://schemas.openxmlformats.org/officeDocument/2006/relationships" xmlns:a="http://schemas.openxmlformats.org/drawingml/2006/main" r:embed="R5c6b1ad68b6e4dcc"/>
+          <a:blip xmlns:r="http://schemas.openxmlformats.org/officeDocument/2006/relationships" xmlns:a="http://schemas.openxmlformats.org/drawingml/2006/main" r:embed="R26d504930cbb4ca0"/>
           <a:stretch xmlns:a="http://schemas.openxmlformats.org/drawingml/2006/main"/>
         </p:blipFill>
         <p:spPr>
@@ -25084,7 +25015,7 @@
           <p:cNvPr id="8" name="">
             <a:extLst xmlns:a="http://schemas.openxmlformats.org/drawingml/2006/main">
               <a:ext uri="{FF2B5EF4-FFF2-40B4-BE49-F238E27FC236}">
-                <a16:creationId xmlns:a16="http://schemas.microsoft.com/office/drawing/2014/main" id="{190AD445-1066-4994-BDE9-30B5DD1A1DF4}"/>
+                <a16:creationId xmlns:a16="http://schemas.microsoft.com/office/drawing/2014/main" id="{F240FFC3-5B04-40B3-AA45-575B32702183}"/>
               </a:ext>
             </a:extLst>
           </p:cNvPr>
@@ -25139,7 +25070,7 @@
     </p:spTree>
     <p:extLst>
       <p:ext uri="{BB962C8B-B14F-4D97-AF65-F5344CB8AC3E}">
-        <p14:creationId xmlns:p14="http://schemas.microsoft.com/office/powerpoint/2010/main" val="1945080674"/>
+        <p14:creationId xmlns:p14="http://schemas.microsoft.com/office/powerpoint/2010/main" val="53482901"/>
       </p:ext>
     </p:extLst>
   </p:cSld>
@@ -25170,7 +25101,7 @@
           <p:cNvPr id="9" name="">
             <a:extLst xmlns:a="http://schemas.openxmlformats.org/drawingml/2006/main">
               <a:ext uri="{FF2B5EF4-FFF2-40B4-BE49-F238E27FC236}">
-                <a16:creationId xmlns:a16="http://schemas.microsoft.com/office/drawing/2014/main" id="{2410DEB5-2E3A-4E90-9782-2AB80411448E}"/>
+                <a16:creationId xmlns:a16="http://schemas.microsoft.com/office/drawing/2014/main" id="{6A9141CC-C67B-4F7A-A3BD-CF951D52B7BA}"/>
               </a:ext>
             </a:extLst>
           </p:cNvPr>
@@ -25227,7 +25158,7 @@
           <p:cNvPr id="2" name="">
             <a:extLst xmlns:a="http://schemas.openxmlformats.org/drawingml/2006/main">
               <a:ext uri="{FF2B5EF4-FFF2-40B4-BE49-F238E27FC236}">
-                <a16:creationId xmlns:a16="http://schemas.microsoft.com/office/drawing/2014/main" id="{6B61599B-5EDE-440D-B119-BA404F54BAAC}"/>
+                <a16:creationId xmlns:a16="http://schemas.microsoft.com/office/drawing/2014/main" id="{1F2F1345-0937-4FBF-8F27-D621DF696802}"/>
               </a:ext>
             </a:extLst>
           </p:cNvPr>
@@ -25284,7 +25215,7 @@
           <p:cNvPr id="3" name="">
             <a:extLst xmlns:a="http://schemas.openxmlformats.org/drawingml/2006/main">
               <a:ext uri="{FF2B5EF4-FFF2-40B4-BE49-F238E27FC236}">
-                <a16:creationId xmlns:a16="http://schemas.microsoft.com/office/drawing/2014/main" id="{10A79576-3CF4-4127-8279-FCCC60BB9BB3}"/>
+                <a16:creationId xmlns:a16="http://schemas.microsoft.com/office/drawing/2014/main" id="{E499F46C-F087-4B54-A942-446C771684A5}"/>
               </a:ext>
             </a:extLst>
           </p:cNvPr>
@@ -25341,7 +25272,7 @@
           <p:cNvPr id="4" name="">
             <a:extLst xmlns:a="http://schemas.openxmlformats.org/drawingml/2006/main">
               <a:ext uri="{FF2B5EF4-FFF2-40B4-BE49-F238E27FC236}">
-                <a16:creationId xmlns:a16="http://schemas.microsoft.com/office/drawing/2014/main" id="{630C04F3-6C3F-4AF7-AF46-CD8C5B2FC72E}"/>
+                <a16:creationId xmlns:a16="http://schemas.microsoft.com/office/drawing/2014/main" id="{40A46CA2-F2DD-4EA2-BD10-13654F16D492}"/>
               </a:ext>
             </a:extLst>
           </p:cNvPr>
@@ -25467,7 +25398,7 @@
           <p:cNvPr id="5" name="">
             <a:extLst xmlns:a="http://schemas.openxmlformats.org/drawingml/2006/main">
               <a:ext uri="{FF2B5EF4-FFF2-40B4-BE49-F238E27FC236}">
-                <a16:creationId xmlns:a16="http://schemas.microsoft.com/office/drawing/2014/main" id="{69E59B7F-5C49-4F62-AA29-17AF57EA016C}"/>
+                <a16:creationId xmlns:a16="http://schemas.microsoft.com/office/drawing/2014/main" id="{7253D1E2-F1C8-40F8-945C-43BE1FD9CCDB}"/>
               </a:ext>
             </a:extLst>
           </p:cNvPr>
@@ -25524,7 +25455,7 @@
           <p:cNvPr id="6" name="">
             <a:extLst xmlns:a="http://schemas.openxmlformats.org/drawingml/2006/main">
               <a:ext uri="{FF2B5EF4-FFF2-40B4-BE49-F238E27FC236}">
-                <a16:creationId xmlns:a16="http://schemas.microsoft.com/office/drawing/2014/main" id="{5FDDA48D-34C9-4BC4-82EB-80FCDB176BB6}"/>
+                <a16:creationId xmlns:a16="http://schemas.microsoft.com/office/drawing/2014/main" id="{FE6B902B-B4D5-4A67-8D30-15A85D7EFF63}"/>
               </a:ext>
             </a:extLst>
           </p:cNvPr>
@@ -25677,7 +25608,7 @@
           <p:nvPr/>
         </p:nvPicPr>
         <p:blipFill>
-          <a:blip xmlns:r="http://schemas.openxmlformats.org/officeDocument/2006/relationships" xmlns:a="http://schemas.openxmlformats.org/drawingml/2006/main" r:embed="R8f9bfe91a5ef4cfc"/>
+          <a:blip xmlns:r="http://schemas.openxmlformats.org/officeDocument/2006/relationships" xmlns:a="http://schemas.openxmlformats.org/drawingml/2006/main" r:embed="R016dcb785f524100"/>
           <a:stretch xmlns:a="http://schemas.openxmlformats.org/drawingml/2006/main"/>
         </p:blipFill>
         <p:spPr>
@@ -25695,7 +25626,7 @@
           <p:cNvPr id="8" name="">
             <a:extLst xmlns:a="http://schemas.openxmlformats.org/drawingml/2006/main">
               <a:ext uri="{FF2B5EF4-FFF2-40B4-BE49-F238E27FC236}">
-                <a16:creationId xmlns:a16="http://schemas.microsoft.com/office/drawing/2014/main" id="{159BADEE-A339-4D99-9E5F-01077F4B9B24}"/>
+                <a16:creationId xmlns:a16="http://schemas.microsoft.com/office/drawing/2014/main" id="{9DF7AF78-E355-4DFB-969E-D38DE9CFFB53}"/>
               </a:ext>
             </a:extLst>
           </p:cNvPr>
@@ -25750,7 +25681,7 @@
     </p:spTree>
     <p:extLst>
       <p:ext uri="{BB962C8B-B14F-4D97-AF65-F5344CB8AC3E}">
-        <p14:creationId xmlns:p14="http://schemas.microsoft.com/office/powerpoint/2010/main" val="1224256193"/>
+        <p14:creationId xmlns:p14="http://schemas.microsoft.com/office/powerpoint/2010/main" val="1128364678"/>
       </p:ext>
     </p:extLst>
   </p:cSld>
@@ -25781,7 +25712,7 @@
           <p:cNvPr id="9" name="">
             <a:extLst xmlns:a="http://schemas.openxmlformats.org/drawingml/2006/main">
               <a:ext uri="{FF2B5EF4-FFF2-40B4-BE49-F238E27FC236}">
-                <a16:creationId xmlns:a16="http://schemas.microsoft.com/office/drawing/2014/main" id="{F93F6CAB-8D22-4817-A981-BCE6F2363403}"/>
+                <a16:creationId xmlns:a16="http://schemas.microsoft.com/office/drawing/2014/main" id="{D19440BA-5A13-47C2-9639-D6D922F3D5C8}"/>
               </a:ext>
             </a:extLst>
           </p:cNvPr>
@@ -25838,7 +25769,7 @@
           <p:cNvPr id="2" name="">
             <a:extLst xmlns:a="http://schemas.openxmlformats.org/drawingml/2006/main">
               <a:ext uri="{FF2B5EF4-FFF2-40B4-BE49-F238E27FC236}">
-                <a16:creationId xmlns:a16="http://schemas.microsoft.com/office/drawing/2014/main" id="{586BA9F8-5B17-4392-97B4-E7AAD619AAC1}"/>
+                <a16:creationId xmlns:a16="http://schemas.microsoft.com/office/drawing/2014/main" id="{F576169D-2619-4E49-9A33-57ACE33BC571}"/>
               </a:ext>
             </a:extLst>
           </p:cNvPr>
@@ -25895,7 +25826,7 @@
           <p:cNvPr id="3" name="">
             <a:extLst xmlns:a="http://schemas.openxmlformats.org/drawingml/2006/main">
               <a:ext uri="{FF2B5EF4-FFF2-40B4-BE49-F238E27FC236}">
-                <a16:creationId xmlns:a16="http://schemas.microsoft.com/office/drawing/2014/main" id="{DEFF72F1-FC24-4107-87F2-2D537B10CFB6}"/>
+                <a16:creationId xmlns:a16="http://schemas.microsoft.com/office/drawing/2014/main" id="{F324AF66-3882-4B8B-AAF8-8B832FAA48BD}"/>
               </a:ext>
             </a:extLst>
           </p:cNvPr>
@@ -25952,7 +25883,7 @@
           <p:cNvPr id="4" name="">
             <a:extLst xmlns:a="http://schemas.openxmlformats.org/drawingml/2006/main">
               <a:ext uri="{FF2B5EF4-FFF2-40B4-BE49-F238E27FC236}">
-                <a16:creationId xmlns:a16="http://schemas.microsoft.com/office/drawing/2014/main" id="{F5F289E0-E226-4CCC-A0ED-6E7FC1F8B59B}"/>
+                <a16:creationId xmlns:a16="http://schemas.microsoft.com/office/drawing/2014/main" id="{394DE30D-FED3-4602-86C4-88AAAB562EA2}"/>
               </a:ext>
             </a:extLst>
           </p:cNvPr>
@@ -26078,7 +26009,7 @@
           <p:cNvPr id="5" name="">
             <a:extLst xmlns:a="http://schemas.openxmlformats.org/drawingml/2006/main">
               <a:ext uri="{FF2B5EF4-FFF2-40B4-BE49-F238E27FC236}">
-                <a16:creationId xmlns:a16="http://schemas.microsoft.com/office/drawing/2014/main" id="{5B1D7679-A7BC-4DC1-93D4-AF42869AC043}"/>
+                <a16:creationId xmlns:a16="http://schemas.microsoft.com/office/drawing/2014/main" id="{B1A4DB37-6E7C-499E-ACA4-22AE1852715A}"/>
               </a:ext>
             </a:extLst>
           </p:cNvPr>
@@ -26135,7 +26066,7 @@
           <p:cNvPr id="6" name="">
             <a:extLst xmlns:a="http://schemas.openxmlformats.org/drawingml/2006/main">
               <a:ext uri="{FF2B5EF4-FFF2-40B4-BE49-F238E27FC236}">
-                <a16:creationId xmlns:a16="http://schemas.microsoft.com/office/drawing/2014/main" id="{1F23BD11-7890-4FB2-AC6B-38A30CB811F6}"/>
+                <a16:creationId xmlns:a16="http://schemas.microsoft.com/office/drawing/2014/main" id="{277B9DD0-E788-416B-8755-BE6119E8AAED}"/>
               </a:ext>
             </a:extLst>
           </p:cNvPr>
@@ -26288,7 +26219,7 @@
           <p:nvPr/>
         </p:nvPicPr>
         <p:blipFill>
-          <a:blip xmlns:r="http://schemas.openxmlformats.org/officeDocument/2006/relationships" xmlns:a="http://schemas.openxmlformats.org/drawingml/2006/main" r:embed="R586a0a5ad1cf4eac"/>
+          <a:blip xmlns:r="http://schemas.openxmlformats.org/officeDocument/2006/relationships" xmlns:a="http://schemas.openxmlformats.org/drawingml/2006/main" r:embed="R9ecdb12ea08b4e23"/>
           <a:stretch xmlns:a="http://schemas.openxmlformats.org/drawingml/2006/main"/>
         </p:blipFill>
         <p:spPr>
@@ -26306,7 +26237,7 @@
           <p:cNvPr id="8" name="">
             <a:extLst xmlns:a="http://schemas.openxmlformats.org/drawingml/2006/main">
               <a:ext uri="{FF2B5EF4-FFF2-40B4-BE49-F238E27FC236}">
-                <a16:creationId xmlns:a16="http://schemas.microsoft.com/office/drawing/2014/main" id="{D77CF684-4833-4149-A742-EFC8CB19A1F9}"/>
+                <a16:creationId xmlns:a16="http://schemas.microsoft.com/office/drawing/2014/main" id="{1F474C45-9B02-4913-8AAB-3661CC9A57ED}"/>
               </a:ext>
             </a:extLst>
           </p:cNvPr>
@@ -26361,7 +26292,7 @@
     </p:spTree>
     <p:extLst>
       <p:ext uri="{BB962C8B-B14F-4D97-AF65-F5344CB8AC3E}">
-        <p14:creationId xmlns:p14="http://schemas.microsoft.com/office/powerpoint/2010/main" val="592371760"/>
+        <p14:creationId xmlns:p14="http://schemas.microsoft.com/office/powerpoint/2010/main" val="1924820580"/>
       </p:ext>
     </p:extLst>
   </p:cSld>
@@ -26392,7 +26323,7 @@
           <p:cNvPr id="9" name="">
             <a:extLst xmlns:a="http://schemas.openxmlformats.org/drawingml/2006/main">
               <a:ext uri="{FF2B5EF4-FFF2-40B4-BE49-F238E27FC236}">
-                <a16:creationId xmlns:a16="http://schemas.microsoft.com/office/drawing/2014/main" id="{340EFB93-23C6-4669-9B80-09F756BA7E1F}"/>
+                <a16:creationId xmlns:a16="http://schemas.microsoft.com/office/drawing/2014/main" id="{10328DD9-581C-4613-8A09-434BC867B5C3}"/>
               </a:ext>
             </a:extLst>
           </p:cNvPr>
@@ -26449,7 +26380,7 @@
           <p:cNvPr id="2" name="">
             <a:extLst xmlns:a="http://schemas.openxmlformats.org/drawingml/2006/main">
               <a:ext uri="{FF2B5EF4-FFF2-40B4-BE49-F238E27FC236}">
-                <a16:creationId xmlns:a16="http://schemas.microsoft.com/office/drawing/2014/main" id="{98FF4E73-72BB-4D9E-9157-ADF4C1196AD7}"/>
+                <a16:creationId xmlns:a16="http://schemas.microsoft.com/office/drawing/2014/main" id="{490D5E80-D3CF-419E-BBDD-7D7643485453}"/>
               </a:ext>
             </a:extLst>
           </p:cNvPr>
@@ -26506,7 +26437,7 @@
           <p:cNvPr id="3" name="">
             <a:extLst xmlns:a="http://schemas.openxmlformats.org/drawingml/2006/main">
               <a:ext uri="{FF2B5EF4-FFF2-40B4-BE49-F238E27FC236}">
-                <a16:creationId xmlns:a16="http://schemas.microsoft.com/office/drawing/2014/main" id="{7DBFA8DB-7D07-4B17-B8AF-91B8F3240E36}"/>
+                <a16:creationId xmlns:a16="http://schemas.microsoft.com/office/drawing/2014/main" id="{C124E095-7A1E-42CF-8AB8-18DA116CC4D8}"/>
               </a:ext>
             </a:extLst>
           </p:cNvPr>
@@ -26563,7 +26494,7 @@
           <p:cNvPr id="4" name="">
             <a:extLst xmlns:a="http://schemas.openxmlformats.org/drawingml/2006/main">
               <a:ext uri="{FF2B5EF4-FFF2-40B4-BE49-F238E27FC236}">
-                <a16:creationId xmlns:a16="http://schemas.microsoft.com/office/drawing/2014/main" id="{AF462C50-DE37-4D77-8985-F014BAC0FEA4}"/>
+                <a16:creationId xmlns:a16="http://schemas.microsoft.com/office/drawing/2014/main" id="{CC211B87-7C6F-4A66-815A-AD5CC9603359}"/>
               </a:ext>
             </a:extLst>
           </p:cNvPr>
@@ -26689,7 +26620,7 @@
           <p:cNvPr id="5" name="">
             <a:extLst xmlns:a="http://schemas.openxmlformats.org/drawingml/2006/main">
               <a:ext uri="{FF2B5EF4-FFF2-40B4-BE49-F238E27FC236}">
-                <a16:creationId xmlns:a16="http://schemas.microsoft.com/office/drawing/2014/main" id="{D38493F9-2DDE-48ED-82E2-22FAB2658DA8}"/>
+                <a16:creationId xmlns:a16="http://schemas.microsoft.com/office/drawing/2014/main" id="{D7ABCE23-1ADE-43CD-8AE6-7BC64699ABFC}"/>
               </a:ext>
             </a:extLst>
           </p:cNvPr>
@@ -26746,7 +26677,7 @@
           <p:cNvPr id="6" name="">
             <a:extLst xmlns:a="http://schemas.openxmlformats.org/drawingml/2006/main">
               <a:ext uri="{FF2B5EF4-FFF2-40B4-BE49-F238E27FC236}">
-                <a16:creationId xmlns:a16="http://schemas.microsoft.com/office/drawing/2014/main" id="{CB6454D7-1F6A-480E-A591-DECC0477C88F}"/>
+                <a16:creationId xmlns:a16="http://schemas.microsoft.com/office/drawing/2014/main" id="{72558899-0238-4ACB-8675-83C08EDDF2B1}"/>
               </a:ext>
             </a:extLst>
           </p:cNvPr>
@@ -26899,7 +26830,7 @@
           <p:nvPr/>
         </p:nvPicPr>
         <p:blipFill>
-          <a:blip xmlns:r="http://schemas.openxmlformats.org/officeDocument/2006/relationships" xmlns:a="http://schemas.openxmlformats.org/drawingml/2006/main" r:embed="R36fbe51f3953498d"/>
+          <a:blip xmlns:r="http://schemas.openxmlformats.org/officeDocument/2006/relationships" xmlns:a="http://schemas.openxmlformats.org/drawingml/2006/main" r:embed="R105c0495e2a74505"/>
           <a:stretch xmlns:a="http://schemas.openxmlformats.org/drawingml/2006/main"/>
         </p:blipFill>
         <p:spPr>
@@ -26917,7 +26848,7 @@
           <p:cNvPr id="8" name="">
             <a:extLst xmlns:a="http://schemas.openxmlformats.org/drawingml/2006/main">
               <a:ext uri="{FF2B5EF4-FFF2-40B4-BE49-F238E27FC236}">
-                <a16:creationId xmlns:a16="http://schemas.microsoft.com/office/drawing/2014/main" id="{79627BE1-55D9-45A5-B77C-7717A9313C62}"/>
+                <a16:creationId xmlns:a16="http://schemas.microsoft.com/office/drawing/2014/main" id="{076FD836-E794-4BF6-B557-DFF4C79DF8A2}"/>
               </a:ext>
             </a:extLst>
           </p:cNvPr>
@@ -26972,7 +26903,7 @@
     </p:spTree>
     <p:extLst>
       <p:ext uri="{BB962C8B-B14F-4D97-AF65-F5344CB8AC3E}">
-        <p14:creationId xmlns:p14="http://schemas.microsoft.com/office/powerpoint/2010/main" val="1945457199"/>
+        <p14:creationId xmlns:p14="http://schemas.microsoft.com/office/powerpoint/2010/main" val="1308742911"/>
       </p:ext>
     </p:extLst>
   </p:cSld>
@@ -27003,7 +26934,7 @@
           <p:cNvPr id="9" name="">
             <a:extLst xmlns:a="http://schemas.openxmlformats.org/drawingml/2006/main">
               <a:ext uri="{FF2B5EF4-FFF2-40B4-BE49-F238E27FC236}">
-                <a16:creationId xmlns:a16="http://schemas.microsoft.com/office/drawing/2014/main" id="{22CB71DF-6FC0-44C6-85A2-64A0ADE03EA0}"/>
+                <a16:creationId xmlns:a16="http://schemas.microsoft.com/office/drawing/2014/main" id="{34580C04-C7AC-4E28-8077-F2DB8F8E5C80}"/>
               </a:ext>
             </a:extLst>
           </p:cNvPr>
@@ -27050,7 +26981,7 @@
                 <a:ea typeface="Malgun Gothic"/>
                 <a:cs typeface="Malgun Gothic"/>
               </a:rPr>
-              <a:t>TSV 파일로 명단 등록</a:t>
+              <a:t>TSV 파일과 공통 임시비밀번호</a:t>
             </a:r>
           </a:p>
         </p:txBody>
@@ -27060,7 +26991,7 @@
           <p:cNvPr id="2" name="">
             <a:extLst xmlns:a="http://schemas.openxmlformats.org/drawingml/2006/main">
               <a:ext uri="{FF2B5EF4-FFF2-40B4-BE49-F238E27FC236}">
-                <a16:creationId xmlns:a16="http://schemas.microsoft.com/office/drawing/2014/main" id="{9AFF83F6-950C-4FE6-96C1-8B23CD371816}"/>
+                <a16:creationId xmlns:a16="http://schemas.microsoft.com/office/drawing/2014/main" id="{F6E5720F-21A6-4378-AA85-4B6667830CA3}"/>
               </a:ext>
             </a:extLst>
           </p:cNvPr>
@@ -27117,7 +27048,7 @@
           <p:cNvPr id="3" name="">
             <a:extLst xmlns:a="http://schemas.openxmlformats.org/drawingml/2006/main">
               <a:ext uri="{FF2B5EF4-FFF2-40B4-BE49-F238E27FC236}">
-                <a16:creationId xmlns:a16="http://schemas.microsoft.com/office/drawing/2014/main" id="{27BF9F80-3B71-49F8-8576-8329870BB8FA}"/>
+                <a16:creationId xmlns:a16="http://schemas.microsoft.com/office/drawing/2014/main" id="{3BB8082D-2AD9-46CB-8AB4-93B96979E381}"/>
               </a:ext>
             </a:extLst>
           </p:cNvPr>
@@ -27164,7 +27095,7 @@
                 <a:ea typeface="Malgun Gothic"/>
                 <a:cs typeface="Malgun Gothic"/>
               </a:rPr>
-              <a:t>파일 작성</a:t>
+              <a:t>TSV 파일 등록</a:t>
             </a:r>
           </a:p>
         </p:txBody>
@@ -27174,7 +27105,7 @@
           <p:cNvPr id="4" name="">
             <a:extLst xmlns:a="http://schemas.openxmlformats.org/drawingml/2006/main">
               <a:ext uri="{FF2B5EF4-FFF2-40B4-BE49-F238E27FC236}">
-                <a16:creationId xmlns:a16="http://schemas.microsoft.com/office/drawing/2014/main" id="{5E88F2E5-8F5C-4D18-94D2-4135489676C3}"/>
+                <a16:creationId xmlns:a16="http://schemas.microsoft.com/office/drawing/2014/main" id="{CB61CF41-EEC4-4EC1-94B2-80ADDD8DF324}"/>
               </a:ext>
             </a:extLst>
           </p:cNvPr>
@@ -27221,7 +27152,7 @@
                 <a:ea typeface="Malgun Gothic"/>
                 <a:cs typeface="Malgun Gothic"/>
               </a:rPr>
-              <a:t>명단 TSV 템플릿을</a:t>
+              <a:t>명단 TSV 템플릿 또는</a:t>
             </a:r>
           </a:p>
           <a:p xmlns:a="http://schemas.openxmlformats.org/drawingml/2006/main">
@@ -27244,7 +27175,7 @@
                 <a:ea typeface="Malgun Gothic"/>
                 <a:cs typeface="Malgun Gothic"/>
               </a:rPr>
-              <a:t>내려받거나 동봉한</a:t>
+              <a:t>01-first-roster.tsv를</a:t>
             </a:r>
           </a:p>
           <a:p xmlns:a="http://schemas.openxmlformats.org/drawingml/2006/main">
@@ -27267,7 +27198,7 @@
                 <a:ea typeface="Malgun Gothic"/>
                 <a:cs typeface="Malgun Gothic"/>
               </a:rPr>
-              <a:t>01-first-roster.tsv를</a:t>
+              <a:t>수정해 올립니다. 검증 후</a:t>
             </a:r>
           </a:p>
           <a:p xmlns:a="http://schemas.openxmlformats.org/drawingml/2006/main">
@@ -27290,30 +27221,7 @@
                 <a:ea typeface="Malgun Gothic"/>
                 <a:cs typeface="Malgun Gothic"/>
               </a:rPr>
-              <a:t>수정합니다. ID는 001처럼</a:t>
-            </a:r>
-          </a:p>
-          <a:p xmlns:a="http://schemas.openxmlformats.org/drawingml/2006/main">
-            <a:pPr>
-              <a:defRPr sz="2025" b="0">
-                <a:solidFill>
-                  <a:srgbClr val="202539"/>
-                </a:solidFill>
-                <a:latin typeface="Malgun Gothic"/>
-                <a:ea typeface="Malgun Gothic"/>
-                <a:cs typeface="Malgun Gothic"/>
-              </a:defRPr>
-            </a:pPr>
-            <a:r>
-              <a:rPr sz="2025" b="0">
-                <a:solidFill>
-                  <a:srgbClr val="202539"/>
-                </a:solidFill>
-                <a:latin typeface="Malgun Gothic"/>
-                <a:ea typeface="Malgun Gothic"/>
-                <a:cs typeface="Malgun Gothic"/>
-              </a:rPr>
-              <a:t>텍스트 그대로 작성합니다.</a:t>
+              <a:t>ID·이름·그룹을 확인합니다.</a:t>
             </a:r>
           </a:p>
         </p:txBody>
@@ -27323,7 +27231,7 @@
           <p:cNvPr id="5" name="">
             <a:extLst xmlns:a="http://schemas.openxmlformats.org/drawingml/2006/main">
               <a:ext uri="{FF2B5EF4-FFF2-40B4-BE49-F238E27FC236}">
-                <a16:creationId xmlns:a16="http://schemas.microsoft.com/office/drawing/2014/main" id="{EDC67DE9-A3FC-4574-A51C-F65983991522}"/>
+                <a16:creationId xmlns:a16="http://schemas.microsoft.com/office/drawing/2014/main" id="{9D67A92F-F55A-43DF-8EFA-49024A9E6F9A}"/>
               </a:ext>
             </a:extLst>
           </p:cNvPr>
@@ -27370,7 +27278,7 @@
                 <a:ea typeface="Malgun Gothic"/>
                 <a:cs typeface="Malgun Gothic"/>
               </a:rPr>
-              <a:t>파일 업로드</a:t>
+              <a:t>공통 비밀번호(선택)</a:t>
             </a:r>
           </a:p>
         </p:txBody>
@@ -27380,7 +27288,7 @@
           <p:cNvPr id="6" name="">
             <a:extLst xmlns:a="http://schemas.openxmlformats.org/drawingml/2006/main">
               <a:ext uri="{FF2B5EF4-FFF2-40B4-BE49-F238E27FC236}">
-                <a16:creationId xmlns:a16="http://schemas.microsoft.com/office/drawing/2014/main" id="{2AF16D96-DDFE-4B2F-B1E6-8DE5FCF87364}"/>
+                <a16:creationId xmlns:a16="http://schemas.microsoft.com/office/drawing/2014/main" id="{C2842D57-8F10-4A3A-8649-8ECEF33EC1CA}"/>
               </a:ext>
             </a:extLst>
           </p:cNvPr>
@@ -27427,7 +27335,7 @@
                 <a:ea typeface="Malgun Gothic"/>
                 <a:cs typeface="Malgun Gothic"/>
               </a:rPr>
-              <a:t>TSV 파일 업로드를 선택하고</a:t>
+              <a:t>신규 수강생에게 공통</a:t>
             </a:r>
           </a:p>
           <a:p xmlns:a="http://schemas.openxmlformats.org/drawingml/2006/main">
@@ -27450,7 +27358,7 @@
                 <a:ea typeface="Malgun Gothic"/>
                 <a:cs typeface="Malgun Gothic"/>
               </a:rPr>
-              <a:t>.tsv 또는 .txt 파일을</a:t>
+              <a:t>임시비밀번호 사용을 켜고</a:t>
             </a:r>
           </a:p>
           <a:p xmlns:a="http://schemas.openxmlformats.org/drawingml/2006/main">
@@ -27473,7 +27381,7 @@
                 <a:ea typeface="Malgun Gothic"/>
                 <a:cs typeface="Malgun Gothic"/>
               </a:rPr>
-              <a:t>올립니다. 검증 후</a:t>
+              <a:t>영문·숫자 8자리를</a:t>
             </a:r>
           </a:p>
           <a:p xmlns:a="http://schemas.openxmlformats.org/drawingml/2006/main">
@@ -27496,7 +27404,7 @@
                 <a:ea typeface="Malgun Gothic"/>
                 <a:cs typeface="Malgun Gothic"/>
               </a:rPr>
-              <a:t>미리보기를 확인해</a:t>
+              <a:t>입력합니다. 이번 명단의</a:t>
             </a:r>
           </a:p>
           <a:p xmlns:a="http://schemas.openxmlformats.org/drawingml/2006/main">
@@ -27519,7 +27427,30 @@
                 <a:ea typeface="Malgun Gothic"/>
                 <a:cs typeface="Malgun Gothic"/>
               </a:rPr>
-              <a:t>반영합니다.</a:t>
+              <a:t>신규 계정에 같은 값이</a:t>
+            </a:r>
+          </a:p>
+          <a:p xmlns:a="http://schemas.openxmlformats.org/drawingml/2006/main">
+            <a:pPr>
+              <a:defRPr sz="2025" b="0">
+                <a:solidFill>
+                  <a:srgbClr val="202539"/>
+                </a:solidFill>
+                <a:latin typeface="Malgun Gothic"/>
+                <a:ea typeface="Malgun Gothic"/>
+                <a:cs typeface="Malgun Gothic"/>
+              </a:defRPr>
+            </a:pPr>
+            <a:r>
+              <a:rPr sz="2025" b="0">
+                <a:solidFill>
+                  <a:srgbClr val="202539"/>
+                </a:solidFill>
+                <a:latin typeface="Malgun Gothic"/>
+                <a:ea typeface="Malgun Gothic"/>
+                <a:cs typeface="Malgun Gothic"/>
+              </a:rPr>
+              <a:t>적용됩니다.</a:t>
             </a:r>
           </a:p>
         </p:txBody>
@@ -27533,7 +27464,7 @@
           <p:nvPr/>
         </p:nvPicPr>
         <p:blipFill>
-          <a:blip xmlns:r="http://schemas.openxmlformats.org/officeDocument/2006/relationships" xmlns:a="http://schemas.openxmlformats.org/drawingml/2006/main" r:embed="R0b612cea12a14239"/>
+          <a:blip xmlns:r="http://schemas.openxmlformats.org/officeDocument/2006/relationships" xmlns:a="http://schemas.openxmlformats.org/drawingml/2006/main" r:embed="Re0a92e43ad6f474b"/>
           <a:stretch xmlns:a="http://schemas.openxmlformats.org/drawingml/2006/main"/>
         </p:blipFill>
         <p:spPr>
@@ -27551,7 +27482,7 @@
           <p:cNvPr id="8" name="">
             <a:extLst xmlns:a="http://schemas.openxmlformats.org/drawingml/2006/main">
               <a:ext uri="{FF2B5EF4-FFF2-40B4-BE49-F238E27FC236}">
-                <a16:creationId xmlns:a16="http://schemas.microsoft.com/office/drawing/2014/main" id="{3D89D6F5-6371-41BC-9D34-73E47D432C36}"/>
+                <a16:creationId xmlns:a16="http://schemas.microsoft.com/office/drawing/2014/main" id="{6B4EF92C-1062-4B33-B287-2324FDACAE2E}"/>
               </a:ext>
             </a:extLst>
           </p:cNvPr>
@@ -27598,7 +27529,7 @@
                 <a:ea typeface="Malgun Gothic"/>
                 <a:cs typeface="Malgun Gothic"/>
               </a:rPr>
-              <a:t>UTF-8 또는 BOM이 있는 UTF-16을 지원합니다. 최대 5 MiB, 10,000명, 30열입니다.</a:t>
+              <a:t>기본은 개인별 임시비밀번호 8자리입니다. 공통값은 명단 등록 때 지정하며, 추가 등록 시 같은 값을 다시 입력합니다.</a:t>
             </a:r>
           </a:p>
         </p:txBody>
@@ -27606,7 +27537,7 @@
     </p:spTree>
     <p:extLst>
       <p:ext uri="{BB962C8B-B14F-4D97-AF65-F5344CB8AC3E}">
-        <p14:creationId xmlns:p14="http://schemas.microsoft.com/office/powerpoint/2010/main" val="2134927710"/>
+        <p14:creationId xmlns:p14="http://schemas.microsoft.com/office/powerpoint/2010/main" val="1321308900"/>
       </p:ext>
     </p:extLst>
   </p:cSld>

</xml_diff>